<commit_message>
Livrables alignes sur le produit fige: chiffres, pitchs, fiche, deck, Q&R
Co-Authored-By: Claude Sonnet 5.5 <noreply@anthropic.com>
</commit_message>
<xml_diff>
--- a/livrables/deck/holdup.pptx
+++ b/livrables/deck/holdup.pptx
@@ -13,9 +13,10 @@
     <p:sldId id="261" r:id="rId7"/>
     <p:sldId id="262" r:id="rId8"/>
     <p:sldId id="263" r:id="rId9"/>
+    <p:sldId id="264" r:id="rId10"/>
   </p:sldIdLst>
   <p:notesMasterIdLst>
-    <p:notesMasterId r:id="rId10"/>
+    <p:notesMasterId r:id="rId11"/>
   </p:notesMasterIdLst>
   <p:sldSz cx="9144000" cy="5143500"/>
   <p:notesSz cx="5143500" cy="9144000"/>
@@ -509,7 +510,7 @@
           <a:p>
             <a:r>
               <a:rPr lang="en-US" dirty="0"/>
-              <a:t>Camille a un wallet normal. Un message promet une récompense. Le site lui fait signer un message gratuit, sans frais, et son USDC part. En 2025, 106 106 victimes et 83,85 M$ perdus par hameçonnage de signatures, selon ScamSniffer.</a:t>
+              <a:t>Le site lui demande un droit sur tout son USDC. En 2025, 106 106 adresses ont perdu 83,85 millions de dollars en signant sur un site de phishing. Chiffre d'un éditeur (ScamSniffer), chaînes EVM, borne basse. Aucun chiffre propre à Avalanche. Source : livrables/CHIFFRES.md B3.</a:t>
             </a:r>
             <a:endParaRPr lang="en-US" dirty="0"/>
           </a:p>
@@ -597,7 +598,7 @@
           <a:p>
             <a:r>
               <a:rPr lang="en-US" dirty="0"/>
-              <a:t>Cible : le particulier avec un wallet normal, atteint par le wallet ou la plateforme. Pas de témoignage d'utilisateur : la douleur vient des pertes publiées, pas d'entretiens.</a:t>
+              <a:t>L'utilisateur écrit ce qu'il veut faire avant de voir la demande. Montant, jeton et adresse sont lus par du code. Le modèle Clef lit la phrase. Correspond : le portefeuille s'ouvre seul après une seconde. Ne correspond pas : alerte, Annuler visible. Pas pu vérifier : on le dit. Les signaux que le portefeuille donne déjà sont gardés. MetaMask affiche illimité sans alerte et ne sait ni combien tu voulais donner ni à qui, d'après son code public lu le 11 oct. 2026, pour une adresse non listée comme malveillante.</a:t>
             </a:r>
             <a:endParaRPr lang="en-US" dirty="0"/>
           </a:p>
@@ -685,7 +686,7 @@
           <a:p>
             <a:r>
               <a:rPr lang="en-US" dirty="0"/>
-              <a:t>Pas de score de risque : une phrase de chaque côté. Annuler est toujours visible. Hold up ne dit jamais protégé ni vert, il avertit, ralentit et explique. Le verdict vient de règles écrites en code.</a:t>
+              <a:t>Bybit, février 2025 : l'interface affichait une transaction légitime, une autre charge allait aux signataires (analyses NCC Group, BlockSec, Check Point, Cyfrin). Notre scène est synthétique, adresses factices, rejeu du moteur sans portefeuille (demo_typologie/safe_signataire.mjs). Elle montre le décodage, pas l'attaque de bout en bout. Une extension ne voit que ce qui passe par window.ethereum : si la page parle au matériel en direct, elle ne voit rien. Les analyses publiques ne confirment pas ce qu'affichait l'écran du matériel : ne pas l'affirmer.</a:t>
             </a:r>
             <a:endParaRPr lang="en-US" dirty="0"/>
           </a:p>
@@ -773,7 +774,7 @@
           <a:p>
             <a:r>
               <a:rPr lang="en-US" dirty="0"/>
-              <a:t>Chaîne locale répliquant Avalanche : gratuite, rejouable. Plus de 30 scénarios prévus, la moitié honnêtes, donc des fausses alertes visibles. Fuji : pas déployé quand ce deck est écrit, on ne le montre pas.</a:t>
+              <a:t>Scénario S6 (X_scenarios_hors_metamask.md). MetaMask décode un Permit en demande de plafond de dépense (lu dans son code public) : il informe, mais il ne compare pas avec « me connecter ». Les messages de connexion valides ne passent pas par l'analyse Blockaid. Démo : site Glacier Rewards, en local. Le silence de MetaMask sur une chaîne locale ne prouve rien.</a:t>
             </a:r>
             <a:endParaRPr lang="en-US" dirty="0"/>
           </a:p>
@@ -861,7 +862,7 @@
           <a:p>
             <a:r>
               <a:rPr lang="en-US" dirty="0"/>
-              <a:t>Notre taux de fausses alertes critiques est trop haut, on le dit. Le chiffre qui compte est celui du jeu aveugle, hash publié avant le test, résultat à mesurer. Latence du verdict : 30 à 50 ms en local sur 8 requêtes types, sans réseau. Un temps de détection d'incident n'existe pas : le moteur juge une requête avant signature.</a:t>
+              <a:t>Tout vient de cas écrits par nous, jeux de réglage. Le 228 sur 228 est un test de couverture. Le jeu aveugle (250 cas, hash publié) n'est pas passé. La grille de 1 500 paires est en cours. Clef n'est pas mesuré par nous (pas de clé). Latence locale : médiane 18,39 ms, p95 34,08 ms. Source : livrables/CHIFFRES.md A3, A4, A5, A6, A9.</a:t>
             </a:r>
             <a:endParaRPr lang="en-US" dirty="0"/>
           </a:p>
@@ -949,7 +950,7 @@
           <a:p>
             <a:r>
               <a:rPr lang="en-US" dirty="0"/>
-              <a:t>Si le modèle se trompe, qui est responsable ? Le verdict vient de règles versionnées, la personne décide, le journal garde la version des règles. L'ancrage sur Fuji n'est pas déployé : on ne l'affirme pas.</a:t>
+              <a:t>Annuler est toujours visible. Transaction : la ligne dit comment ramener le droit au montant écrit (correction automatique : décision Q17, en cours, non vérifiée). Signature : le droit ne peut pas être limité, on le dit. Durée de retenue : non tranchée (Q16), ne pas citer de durée. Journal chaîné par hachage, fiche d'incident sur demande, retrait de droits testé sur chaîne locale.</a:t>
             </a:r>
             <a:endParaRPr lang="en-US" dirty="0"/>
           </a:p>
@@ -1037,7 +1038,7 @@
           <a:p>
             <a:r>
               <a:rPr lang="en-US" dirty="0"/>
-              <a:t>Pas de taille de marché : aucune source dans le dépôt. Des scanners existent (Blockaid dans Core, Pocket Universe, Rabby). Notre différence : l'intention déclarée et le ralentissement, pas la réputation d'adresse.</a:t>
+              <a:t>Contenu complet : livrables/SLIDE_CONFORMITE.md. Un particulier n'est pas une entité régulée ; la plateforme qui intègre Hold up l'est. Nous ne nous déclarons conformes à aucun texte. Si le modèle se trompe : voir QR_JURY question 2. L'ancrage sur Fuji n'est pas déployé : on ne l'affirme pas.</a:t>
             </a:r>
             <a:endParaRPr lang="en-US" dirty="0"/>
           </a:p>
@@ -1125,7 +1126,7 @@
           <a:p>
             <a:r>
               <a:rPr lang="en-US" dirty="0"/>
-              <a:t>Pas de biographie : deux ingénieurs, le code est dans le dépôt. Ce qu'on demande : un test avec un vrai wallet et un jeu d'attaques écrit par quelqu'un d'autre.</a:t>
+              <a:t>Fraude consentie : la demande correspond à ce que la personne veut faire, rien à comparer (la fraude à l'investissement pèse 7,2 Md$ de plaintes en 2025 selon l'IC3, hors périmètre). Intention vague : une relance, puis « je n'ai pas pu vérifier ». Contrat qui change à l'exécution : Added Protection de MetaMask le traite mieux. Ledger direct : une extension ne voit que window.ethereum.</a:t>
             </a:r>
             <a:endParaRPr lang="en-US" dirty="0"/>
           </a:p>
@@ -1149,6 +1150,94 @@
             <a:fld id="{F7021451-1387-4CA6-816F-3879F97B5CBC}" type="slidenum">
               <a:rPr lang="en-US"/>
               <a:t>8</a:t>
+            </a:fld>
+            <a:endParaRPr lang="en-US"/>
+          </a:p>
+        </p:txBody>
+      </p:sp>
+    </p:spTree>
+    <p:extLst>
+      <p:ext uri="{BB962C8B-B14F-4D97-AF65-F5344CB8AC3E}">
+        <p14:creationId xmlns:p14="http://schemas.microsoft.com/office/powerpoint/2010/main" val="1024086991"/>
+      </p:ext>
+    </p:extLst>
+  </p:cSld>
+  <p:clrMapOvr>
+    <a:masterClrMapping/>
+  </p:clrMapOvr>
+</p:notes>
+</file>
+
+<file path=ppt/notesSlides/notesSlide9.xml><?xml version="1.0" encoding="utf-8"?>
+<p:notes xmlns:a="http://schemas.openxmlformats.org/drawingml/2006/main" xmlns:r="http://schemas.openxmlformats.org/officeDocument/2006/relationships" xmlns:p="http://schemas.openxmlformats.org/presentationml/2006/main">
+  <p:cSld>
+    <p:spTree>
+      <p:nvGrpSpPr>
+        <p:cNvPr id="1" name=""/>
+        <p:cNvGrpSpPr/>
+        <p:nvPr/>
+      </p:nvGrpSpPr>
+      <p:grpSpPr>
+        <a:xfrm>
+          <a:off x="0" y="0"/>
+          <a:ext cx="0" cy="0"/>
+          <a:chOff x="0" y="0"/>
+          <a:chExt cx="0" cy="0"/>
+        </a:xfrm>
+      </p:grpSpPr>
+      <p:sp>
+        <p:nvSpPr>
+          <p:cNvPr id="2" name="Slide Image Placeholder 1"/>
+          <p:cNvSpPr>
+            <a:spLocks noGrp="1" noRot="1" noChangeAspect="1"/>
+          </p:cNvSpPr>
+          <p:nvPr>
+            <p:ph type="sldImg"/>
+          </p:nvPr>
+        </p:nvSpPr>
+        <p:spPr/>
+      </p:sp>
+      <p:sp>
+        <p:nvSpPr>
+          <p:cNvPr id="3" name="Notes Placeholder 2"/>
+          <p:cNvSpPr>
+            <a:spLocks noGrp="1"/>
+          </p:cNvSpPr>
+          <p:nvPr>
+            <p:ph type="body" idx="1"/>
+          </p:nvPr>
+        </p:nvSpPr>
+        <p:spPr/>
+        <p:txBody>
+          <a:bodyPr/>
+          <a:lstStyle/>
+          <a:p>
+            <a:r>
+              <a:rPr lang="en-US" dirty="0"/>
+              <a:t>Gratuit pour les personnes, des partenaires ensuite, sans prix fixé ni client. Harpie et Wallet Guard ont fermé en mars 2025 : le modèle reste une question ouverte. Pas de biographie. Ce qu'on demande : un test avec un vrai portefeuille et un jeu de cas écrit par quelqu'un d'autre.</a:t>
+            </a:r>
+            <a:endParaRPr lang="en-US" dirty="0"/>
+          </a:p>
+        </p:txBody>
+      </p:sp>
+      <p:sp>
+        <p:nvSpPr>
+          <p:cNvPr id="4" name="Slide Number Placeholder 3"/>
+          <p:cNvSpPr>
+            <a:spLocks noGrp="1"/>
+          </p:cNvSpPr>
+          <p:nvPr>
+            <p:ph type="sldNum" sz="quarter" idx="10"/>
+          </p:nvPr>
+        </p:nvSpPr>
+        <p:spPr/>
+        <p:txBody>
+          <a:bodyPr/>
+          <a:lstStyle/>
+          <a:p>
+            <a:fld id="{F7021451-1387-4CA6-816F-3879F97B5CBC}" type="slidenum">
+              <a:rPr lang="en-US"/>
+              <a:t>9</a:t>
             </a:fld>
             <a:endParaRPr lang="en-US"/>
           </a:p>
@@ -1692,7 +1781,7 @@
                 <a:ea typeface="Arial" pitchFamily="34" charset="-122"/>
                 <a:cs typeface="Arial" pitchFamily="34" charset="-120"/>
               </a:rPr>
-              <a:t>Une signature gratuite a vidé le compte</a:t>
+              <a:t>Camille veut échanger 50 USDC</a:t>
             </a:r>
             <a:endParaRPr lang="en-US" sz="3000" dirty="0"/>
           </a:p>
@@ -1756,7 +1845,7 @@
                 <a:ea typeface="Arial" pitchFamily="34" charset="-122"/>
                 <a:cs typeface="Arial" pitchFamily="34" charset="-120"/>
               </a:rPr>
-              <a:t>Glacier Rewards (site fictif)</a:t>
+              <a:t>Neve (site fictif)</a:t>
             </a:r>
             <a:endParaRPr lang="en-US" sz="1200" dirty="0"/>
           </a:p>
@@ -1771,7 +1860,7 @@
         <p:spPr>
           <a:xfrm>
             <a:off x="685800" y="1920240"/>
-            <a:ext cx="3474720" cy="365760"/>
+            <a:ext cx="3474720" cy="640080"/>
           </a:xfrm>
           <a:prstGeom prst="rect">
             <a:avLst/>
@@ -1795,7 +1884,7 @@
                 <a:ea typeface="Arial" pitchFamily="34" charset="-122"/>
                 <a:cs typeface="Arial" pitchFamily="34" charset="-120"/>
               </a:rPr>
-              <a:t>Ta récompense est prête</a:t>
+              <a:t>Échanger 50 USDC contre AVAX</a:t>
             </a:r>
             <a:endParaRPr lang="en-US" sz="2000" dirty="0"/>
           </a:p>
@@ -1809,7 +1898,7 @@
         </p:nvSpPr>
         <p:spPr>
           <a:xfrm>
-            <a:off x="685800" y="2423160"/>
+            <a:off x="685800" y="2697480"/>
             <a:ext cx="3474720" cy="640080"/>
           </a:xfrm>
           <a:prstGeom prst="rect">
@@ -1834,7 +1923,7 @@
                 <a:ea typeface="Arial" pitchFamily="34" charset="-122"/>
                 <a:cs typeface="Arial" pitchFamily="34" charset="-120"/>
               </a:rPr>
-              <a:t>Signe ce message pour vérifier ton compte. Aucun frais.</a:t>
+              <a:t>Étape 1 : autoriser le routeur à dépenser votre USDC.</a:t>
             </a:r>
             <a:endParaRPr lang="en-US" sz="1400" dirty="0"/>
           </a:p>
@@ -1848,7 +1937,7 @@
         </p:nvSpPr>
         <p:spPr>
           <a:xfrm>
-            <a:off x="685800" y="3429000"/>
+            <a:off x="685800" y="3520440"/>
             <a:ext cx="2377440" cy="502920"/>
           </a:xfrm>
           <a:prstGeom prst="roundRect">
@@ -1875,7 +1964,7 @@
         </p:nvSpPr>
         <p:spPr>
           <a:xfrm>
-            <a:off x="685800" y="3429000"/>
+            <a:off x="685800" y="3520440"/>
             <a:ext cx="2377440" cy="502920"/>
           </a:xfrm>
           <a:prstGeom prst="rect">
@@ -1900,7 +1989,7 @@
                 <a:ea typeface="Arial" pitchFamily="34" charset="-122"/>
                 <a:cs typeface="Arial" pitchFamily="34" charset="-120"/>
               </a:rPr>
-              <a:t>Réclamer</a:t>
+              <a:t>Autoriser</a:t>
             </a:r>
             <a:endParaRPr lang="en-US" sz="1400" dirty="0"/>
           </a:p>
@@ -1978,7 +2067,7 @@
                 <a:ea typeface="Arial" pitchFamily="34" charset="-122"/>
                 <a:cs typeface="Arial" pitchFamily="34" charset="-120"/>
               </a:rPr>
-              <a:t>volés à 106 106 victimes en 2025 par hameçonnage de signatures (ScamSniffer)</a:t>
+              <a:t>perdus par 106 106 adresses en 2025 en signant sur un site de phishing</a:t>
             </a:r>
             <a:endParaRPr lang="en-US" sz="1600" dirty="0"/>
           </a:p>
@@ -2009,7 +2098,7 @@
               <a:buNone/>
             </a:pPr>
             <a:r>
-              <a:rPr lang="en-US" sz="1400" dirty="0">
+              <a:rPr lang="en-US" sz="1300" dirty="0">
                 <a:solidFill>
                   <a:srgbClr val="595959"/>
                 </a:solidFill>
@@ -2017,9 +2106,9 @@
                 <a:ea typeface="Arial" pitchFamily="34" charset="-122"/>
                 <a:cs typeface="Arial" pitchFamily="34" charset="-120"/>
               </a:rPr>
-              <a:t>Permit et Permit2 : environ 38 % des pertes des cas supérieurs à 1 M$.</a:t>
-            </a:r>
-            <a:endParaRPr lang="en-US" sz="1400" dirty="0"/>
+              <a:t>Chiffre ScamSniffer (éditeur), chaînes EVM, borne basse.</a:t>
+            </a:r>
+            <a:endParaRPr lang="en-US" sz="1300" dirty="0"/>
           </a:p>
         </p:txBody>
       </p:sp>
@@ -2129,7 +2218,7 @@
                 <a:ea typeface="Arial" pitchFamily="34" charset="-122"/>
                 <a:cs typeface="Arial" pitchFamily="34" charset="-120"/>
               </a:rPr>
-              <a:t>Un particulier avec un wallet normal</a:t>
+              <a:t>Tu écris. Hold up compare.</a:t>
             </a:r>
             <a:endParaRPr lang="en-US" sz="3000" dirty="0"/>
           </a:p>
@@ -2143,8 +2232,8 @@
         </p:nvSpPr>
         <p:spPr>
           <a:xfrm>
-            <a:off x="457200" y="1463040"/>
-            <a:ext cx="2606040" cy="2468880"/>
+            <a:off x="457200" y="1371600"/>
+            <a:ext cx="2560320" cy="1097280"/>
           </a:xfrm>
           <a:prstGeom prst="rect">
             <a:avLst/>
@@ -2168,8 +2257,8 @@
         </p:nvSpPr>
         <p:spPr>
           <a:xfrm>
-            <a:off x="640080" y="1645920"/>
-            <a:ext cx="2240280" cy="365760"/>
+            <a:off x="594360" y="1463040"/>
+            <a:ext cx="2286000" cy="274320"/>
           </a:xfrm>
           <a:prstGeom prst="rect">
             <a:avLst/>
@@ -2185,7 +2274,7 @@
               <a:buNone/>
             </a:pPr>
             <a:r>
-              <a:rPr lang="en-US" sz="2000" b="1" dirty="0">
+              <a:rPr lang="en-US" sz="1300" b="1" dirty="0">
                 <a:solidFill>
                   <a:srgbClr val="000000"/>
                 </a:solidFill>
@@ -2193,9 +2282,9 @@
                 <a:ea typeface="Arial" pitchFamily="34" charset="-122"/>
                 <a:cs typeface="Arial" pitchFamily="34" charset="-120"/>
               </a:rPr>
-              <a:t>Qui</a:t>
-            </a:r>
-            <a:endParaRPr lang="en-US" sz="2000" dirty="0"/>
+              <a:t>1. J'écris</a:t>
+            </a:r>
+            <a:endParaRPr lang="en-US" sz="1300" dirty="0"/>
           </a:p>
         </p:txBody>
       </p:sp>
@@ -2207,8 +2296,8 @@
         </p:nvSpPr>
         <p:spPr>
           <a:xfrm>
-            <a:off x="640080" y="2148840"/>
-            <a:ext cx="2240280" cy="1645920"/>
+            <a:off x="594360" y="1828800"/>
+            <a:ext cx="2286000" cy="548640"/>
           </a:xfrm>
           <a:prstGeom prst="rect">
             <a:avLst/>
@@ -2224,7 +2313,7 @@
               <a:buNone/>
             </a:pPr>
             <a:r>
-              <a:rPr lang="en-US" sz="1500" dirty="0">
+              <a:rPr lang="en-US" sz="1400" dirty="0">
                 <a:solidFill>
                   <a:srgbClr val="000000"/>
                 </a:solidFill>
@@ -2232,9 +2321,9 @@
                 <a:ea typeface="Arial" pitchFamily="34" charset="-122"/>
                 <a:cs typeface="Arial" pitchFamily="34" charset="-120"/>
               </a:rPr>
-              <a:t>MetaMask, Rabby, Core. Pas technique, parfois sous la pression d'un faux support.</a:t>
-            </a:r>
-            <a:endParaRPr lang="en-US" sz="1500" dirty="0"/>
+              <a:t>échanger 50 USDC contre AVAX</a:t>
+            </a:r>
+            <a:endParaRPr lang="en-US" sz="1400" dirty="0"/>
           </a:p>
         </p:txBody>
       </p:sp>
@@ -2246,8 +2335,8 @@
         </p:nvSpPr>
         <p:spPr>
           <a:xfrm>
-            <a:off x="3246120" y="1463040"/>
-            <a:ext cx="2606040" cy="2468880"/>
+            <a:off x="3291840" y="1371600"/>
+            <a:ext cx="2560320" cy="1097280"/>
           </a:xfrm>
           <a:prstGeom prst="rect">
             <a:avLst/>
@@ -2271,8 +2360,8 @@
         </p:nvSpPr>
         <p:spPr>
           <a:xfrm>
-            <a:off x="3429000" y="1645920"/>
-            <a:ext cx="2240280" cy="365760"/>
+            <a:off x="3429000" y="1463040"/>
+            <a:ext cx="2286000" cy="274320"/>
           </a:xfrm>
           <a:prstGeom prst="rect">
             <a:avLst/>
@@ -2288,7 +2377,7 @@
               <a:buNone/>
             </a:pPr>
             <a:r>
-              <a:rPr lang="en-US" sz="2000" b="1" dirty="0">
+              <a:rPr lang="en-US" sz="1300" b="1" dirty="0">
                 <a:solidFill>
                   <a:srgbClr val="000000"/>
                 </a:solidFill>
@@ -2296,9 +2385,9 @@
                 <a:ea typeface="Arial" pitchFamily="34" charset="-122"/>
                 <a:cs typeface="Arial" pitchFamily="34" charset="-120"/>
               </a:rPr>
-              <a:t>Quand</a:t>
-            </a:r>
-            <a:endParaRPr lang="en-US" sz="2000" dirty="0"/>
+              <a:t>2. La demande arrive</a:t>
+            </a:r>
+            <a:endParaRPr lang="en-US" sz="1300" dirty="0"/>
           </a:p>
         </p:txBody>
       </p:sp>
@@ -2310,8 +2399,8 @@
         </p:nvSpPr>
         <p:spPr>
           <a:xfrm>
-            <a:off x="3429000" y="2148840"/>
-            <a:ext cx="2240280" cy="1645920"/>
+            <a:off x="3429000" y="1828800"/>
+            <a:ext cx="2286000" cy="548640"/>
           </a:xfrm>
           <a:prstGeom prst="rect">
             <a:avLst/>
@@ -2327,7 +2416,7 @@
               <a:buNone/>
             </a:pPr>
             <a:r>
-              <a:rPr lang="en-US" sz="1500" dirty="0">
+              <a:rPr lang="en-US" sz="1400" dirty="0">
                 <a:solidFill>
                   <a:srgbClr val="000000"/>
                 </a:solidFill>
@@ -2335,9 +2424,9 @@
                 <a:ea typeface="Arial" pitchFamily="34" charset="-122"/>
                 <a:cs typeface="Arial" pitchFamily="34" charset="-120"/>
               </a:rPr>
-              <a:t>Juste avant de signer ou d'envoyer, souvent pendant un appel ou une conversation.</a:t>
-            </a:r>
-            <a:endParaRPr lang="en-US" sz="1500" dirty="0"/>
+              <a:t>droit de dépense illimité sur l'USDC</a:t>
+            </a:r>
+            <a:endParaRPr lang="en-US" sz="1400" dirty="0"/>
           </a:p>
         </p:txBody>
       </p:sp>
@@ -2349,18 +2438,18 @@
         </p:nvSpPr>
         <p:spPr>
           <a:xfrm>
-            <a:off x="6035040" y="1463040"/>
-            <a:ext cx="2606040" cy="2468880"/>
+            <a:off x="6126480" y="1371600"/>
+            <a:ext cx="2560320" cy="1097280"/>
           </a:xfrm>
           <a:prstGeom prst="rect">
             <a:avLst/>
           </a:prstGeom>
           <a:solidFill>
-            <a:srgbClr val="F5F5F5"/>
+            <a:srgbClr val="FFFFFF"/>
           </a:solidFill>
           <a:ln w="9525">
             <a:solidFill>
-              <a:srgbClr val="E2E2E2"/>
+              <a:srgbClr val="D92D20"/>
             </a:solidFill>
             <a:prstDash val="solid"/>
           </a:ln>
@@ -2374,8 +2463,8 @@
         </p:nvSpPr>
         <p:spPr>
           <a:xfrm>
-            <a:off x="6217920" y="1645920"/>
-            <a:ext cx="2240280" cy="365760"/>
+            <a:off x="6263640" y="1463040"/>
+            <a:ext cx="2286000" cy="274320"/>
           </a:xfrm>
           <a:prstGeom prst="rect">
             <a:avLst/>
@@ -2391,17 +2480,17 @@
               <a:buNone/>
             </a:pPr>
             <a:r>
-              <a:rPr lang="en-US" sz="2000" b="1" dirty="0">
-                <a:solidFill>
-                  <a:srgbClr val="000000"/>
-                </a:solidFill>
-                <a:latin typeface="Arial" pitchFamily="34" charset="0"/>
-                <a:ea typeface="Arial" pitchFamily="34" charset="-122"/>
-                <a:cs typeface="Arial" pitchFamily="34" charset="-120"/>
-              </a:rPr>
-              <a:t>Douleur</a:t>
-            </a:r>
-            <a:endParaRPr lang="en-US" sz="2000" dirty="0"/>
+              <a:rPr lang="en-US" sz="1300" b="1" dirty="0">
+                <a:solidFill>
+                  <a:srgbClr val="D92D20"/>
+                </a:solidFill>
+                <a:latin typeface="Arial" pitchFamily="34" charset="0"/>
+                <a:ea typeface="Arial" pitchFamily="34" charset="-122"/>
+                <a:cs typeface="Arial" pitchFamily="34" charset="-120"/>
+              </a:rPr>
+              <a:t>3. Hold up</a:t>
+            </a:r>
+            <a:endParaRPr lang="en-US" sz="1300" dirty="0"/>
           </a:p>
         </p:txBody>
       </p:sp>
@@ -2413,8 +2502,8 @@
         </p:nvSpPr>
         <p:spPr>
           <a:xfrm>
-            <a:off x="6217920" y="2148840"/>
-            <a:ext cx="2240280" cy="1645920"/>
+            <a:off x="6263640" y="1828800"/>
+            <a:ext cx="2286000" cy="548640"/>
           </a:xfrm>
           <a:prstGeom prst="rect">
             <a:avLst/>
@@ -2430,17 +2519,17 @@
               <a:buNone/>
             </a:pPr>
             <a:r>
-              <a:rPr lang="en-US" sz="1500" dirty="0">
-                <a:solidFill>
-                  <a:srgbClr val="000000"/>
-                </a:solidFill>
-                <a:latin typeface="Arial" pitchFamily="34" charset="0"/>
-                <a:ea typeface="Arial" pitchFamily="34" charset="-122"/>
-                <a:cs typeface="Arial" pitchFamily="34" charset="-120"/>
-              </a:rPr>
-              <a:t>Elle lit « Signer » et ne voit pas le droit qu'elle donne.</a:t>
-            </a:r>
-            <a:endParaRPr lang="en-US" sz="1500" dirty="0"/>
+              <a:rPr lang="en-US" sz="1400" b="1" dirty="0">
+                <a:solidFill>
+                  <a:srgbClr val="D92D20"/>
+                </a:solidFill>
+                <a:latin typeface="Arial" pitchFamily="34" charset="0"/>
+                <a:ea typeface="Arial" pitchFamily="34" charset="-122"/>
+                <a:cs typeface="Arial" pitchFamily="34" charset="-120"/>
+              </a:rPr>
+              <a:t>Ça ne correspond pas à ce que tu as écrit.</a:t>
+            </a:r>
+            <a:endParaRPr lang="en-US" sz="1400" dirty="0"/>
           </a:p>
         </p:txBody>
       </p:sp>
@@ -2452,8 +2541,8 @@
         </p:nvSpPr>
         <p:spPr>
           <a:xfrm>
-            <a:off x="457200" y="4160520"/>
-            <a:ext cx="8229600" cy="365760"/>
+            <a:off x="457200" y="2834640"/>
+            <a:ext cx="8229600" cy="1371600"/>
           </a:xfrm>
           <a:prstGeom prst="rect">
             <a:avLst/>
@@ -2465,11 +2554,96 @@
           <a:bodyPr wrap="square" lIns="0" tIns="0" rIns="0" bIns="0" rtlCol="0" anchor="t"/>
           <a:lstStyle/>
           <a:p>
+            <a:pPr marL="342900" indent="-342900">
+              <a:spcAft>
+                <a:spcPts val="600"/>
+              </a:spcAft>
+              <a:buSzPct val="100000"/>
+              <a:buChar char="•"/>
+            </a:pPr>
+            <a:r>
+              <a:rPr lang="en-US" sz="1500" dirty="0">
+                <a:solidFill>
+                  <a:srgbClr val="000000"/>
+                </a:solidFill>
+                <a:latin typeface="Arial" pitchFamily="34" charset="0"/>
+                <a:ea typeface="Arial" pitchFamily="34" charset="-122"/>
+                <a:cs typeface="Arial" pitchFamily="34" charset="-120"/>
+              </a:rPr>
+              <a:t>Ça correspond : le portefeuille s’ouvre seul après une seconde.</a:t>
+            </a:r>
+            <a:endParaRPr lang="en-US" sz="1500" dirty="0"/>
+          </a:p>
+          <a:p>
+            <a:pPr marL="342900" indent="-342900">
+              <a:spcAft>
+                <a:spcPts val="600"/>
+              </a:spcAft>
+              <a:buSzPct val="100000"/>
+              <a:buChar char="•"/>
+            </a:pPr>
+            <a:r>
+              <a:rPr lang="en-US" sz="1500" dirty="0">
+                <a:solidFill>
+                  <a:srgbClr val="000000"/>
+                </a:solidFill>
+                <a:latin typeface="Arial" pitchFamily="34" charset="0"/>
+                <a:ea typeface="Arial" pitchFamily="34" charset="-122"/>
+                <a:cs typeface="Arial" pitchFamily="34" charset="-120"/>
+              </a:rPr>
+              <a:t>Ça ne correspond pas : alerte, Annuler visible.</a:t>
+            </a:r>
+            <a:endParaRPr lang="en-US" sz="1500" dirty="0"/>
+          </a:p>
+          <a:p>
+            <a:pPr marL="342900" indent="-342900">
+              <a:spcAft>
+                <a:spcPts val="600"/>
+              </a:spcAft>
+              <a:buSzPct val="100000"/>
+              <a:buChar char="•"/>
+            </a:pPr>
+            <a:r>
+              <a:rPr lang="en-US" sz="1500" dirty="0">
+                <a:solidFill>
+                  <a:srgbClr val="000000"/>
+                </a:solidFill>
+                <a:latin typeface="Arial" pitchFamily="34" charset="0"/>
+                <a:ea typeface="Arial" pitchFamily="34" charset="-122"/>
+                <a:cs typeface="Arial" pitchFamily="34" charset="-120"/>
+              </a:rPr>
+              <a:t>Pas pu vérifier : la fenêtre le dit, jamais « correspond » par défaut.</a:t>
+            </a:r>
+            <a:endParaRPr lang="en-US" sz="1500" dirty="0"/>
+          </a:p>
+        </p:txBody>
+      </p:sp>
+      <p:sp>
+        <p:nvSpPr>
+          <p:cNvPr id="14" name="Text 11"/>
+          <p:cNvSpPr txBox="1"/>
+          <p:nvPr/>
+        </p:nvSpPr>
+        <p:spPr>
+          <a:xfrm>
+            <a:off x="457200" y="4343400"/>
+            <a:ext cx="8229600" cy="274320"/>
+          </a:xfrm>
+          <a:prstGeom prst="rect">
+            <a:avLst/>
+          </a:prstGeom>
+          <a:noFill/>
+          <a:ln/>
+        </p:spPr>
+        <p:txBody>
+          <a:bodyPr wrap="square" lIns="0" tIns="0" rIns="0" bIns="0" rtlCol="0" anchor="t"/>
+          <a:lstStyle/>
+          <a:p>
             <a:pPr indent="0" marL="0">
               <a:buNone/>
             </a:pPr>
             <a:r>
-              <a:rPr lang="en-US" sz="1400" dirty="0">
+              <a:rPr lang="en-US" sz="1200" dirty="0">
                 <a:solidFill>
                   <a:srgbClr val="595959"/>
                 </a:solidFill>
@@ -2477,9 +2651,9 @@
                 <a:ea typeface="Arial" pitchFamily="34" charset="-122"/>
                 <a:cs typeface="Arial" pitchFamily="34" charset="-120"/>
               </a:rPr>
-              <a:t>Pas de Safe, pas d'EIP-7702, pas de matériel dédié : le wallet que la personne a déjà.</a:t>
-            </a:r>
-            <a:endParaRPr lang="en-US" sz="1400" dirty="0"/>
+              <a:t>On garde aussi les signaux que le portefeuille donne déjà.</a:t>
+            </a:r>
+            <a:endParaRPr lang="en-US" sz="1200" dirty="0"/>
           </a:p>
         </p:txBody>
       </p:sp>
@@ -2589,7 +2763,7 @@
                 <a:ea typeface="Arial" pitchFamily="34" charset="-122"/>
                 <a:cs typeface="Arial" pitchFamily="34" charset="-120"/>
               </a:rPr>
-              <a:t>Tu crois / En vrai</a:t>
+              <a:t>Le signataire aveugle (cas Bybit)</a:t>
             </a:r>
             <a:endParaRPr lang="en-US" sz="3000" dirty="0"/>
           </a:p>
@@ -2603,45 +2777,119 @@
         </p:nvSpPr>
         <p:spPr>
           <a:xfrm>
-            <a:off x="457200" y="1325880"/>
-            <a:ext cx="8229600" cy="3154680"/>
-          </a:xfrm>
-          <a:prstGeom prst="roundRect">
-            <a:avLst>
-              <a:gd name="adj" fmla="val 4348"/>
-            </a:avLst>
+            <a:off x="457200" y="1371600"/>
+            <a:ext cx="4023360" cy="2011680"/>
+          </a:xfrm>
+          <a:prstGeom prst="rect">
+            <a:avLst/>
+          </a:prstGeom>
+          <a:solidFill>
+            <a:srgbClr val="F5F5F5"/>
+          </a:solidFill>
+          <a:ln w="9525">
+            <a:solidFill>
+              <a:srgbClr val="E2E2E2"/>
+            </a:solidFill>
+            <a:prstDash val="solid"/>
+          </a:ln>
+        </p:spPr>
+      </p:sp>
+      <p:sp>
+        <p:nvSpPr>
+          <p:cNvPr id="5" name="Text 2"/>
+          <p:cNvSpPr txBox="1"/>
+          <p:nvPr/>
+        </p:nvSpPr>
+        <p:spPr>
+          <a:xfrm>
+            <a:off x="640080" y="1463040"/>
+            <a:ext cx="3657600" cy="274320"/>
+          </a:xfrm>
+          <a:prstGeom prst="rect">
+            <a:avLst/>
+          </a:prstGeom>
+          <a:noFill/>
+          <a:ln/>
+        </p:spPr>
+        <p:txBody>
+          <a:bodyPr wrap="square" lIns="0" tIns="0" rIns="0" bIns="0" rtlCol="0" anchor="t"/>
+          <a:lstStyle/>
+          <a:p>
+            <a:pPr indent="0" marL="0">
+              <a:buNone/>
+            </a:pPr>
+            <a:r>
+              <a:rPr lang="en-US" sz="1300" b="1" dirty="0">
+                <a:solidFill>
+                  <a:srgbClr val="595959"/>
+                </a:solidFill>
+                <a:latin typeface="Arial" pitchFamily="34" charset="0"/>
+                <a:ea typeface="Arial" pitchFamily="34" charset="-122"/>
+                <a:cs typeface="Arial" pitchFamily="34" charset="-120"/>
+              </a:rPr>
+              <a:t>J'ai écrit</a:t>
+            </a:r>
+            <a:endParaRPr lang="en-US" sz="1300" dirty="0"/>
+          </a:p>
+        </p:txBody>
+      </p:sp>
+      <p:sp>
+        <p:nvSpPr>
+          <p:cNvPr id="6" name="Text 3"/>
+          <p:cNvSpPr txBox="1"/>
+          <p:nvPr/>
+        </p:nvSpPr>
+        <p:spPr>
+          <a:xfrm>
+            <a:off x="640080" y="1783080"/>
+            <a:ext cx="3657600" cy="457200"/>
+          </a:xfrm>
+          <a:prstGeom prst="rect">
+            <a:avLst/>
+          </a:prstGeom>
+          <a:noFill/>
+          <a:ln/>
+        </p:spPr>
+        <p:txBody>
+          <a:bodyPr wrap="square" lIns="0" tIns="0" rIns="0" bIns="0" rtlCol="0" anchor="t"/>
+          <a:lstStyle/>
+          <a:p>
+            <a:pPr indent="0" marL="0">
+              <a:buNone/>
+            </a:pPr>
+            <a:r>
+              <a:rPr lang="en-US" sz="2000" b="1" dirty="0">
+                <a:solidFill>
+                  <a:srgbClr val="000000"/>
+                </a:solidFill>
+                <a:latin typeface="Arial" pitchFamily="34" charset="0"/>
+                <a:ea typeface="Arial" pitchFamily="34" charset="-122"/>
+                <a:cs typeface="Arial" pitchFamily="34" charset="-120"/>
+              </a:rPr>
+              <a:t>virer 20 USDC à Paul</a:t>
+            </a:r>
+            <a:endParaRPr lang="en-US" sz="2000" dirty="0"/>
+          </a:p>
+        </p:txBody>
+      </p:sp>
+      <p:sp>
+        <p:nvSpPr>
+          <p:cNvPr id="7" name="Shape 4"/>
+          <p:cNvSpPr/>
+          <p:nvPr/>
+        </p:nvSpPr>
+        <p:spPr>
+          <a:xfrm>
+            <a:off x="4663440" y="1371600"/>
+            <a:ext cx="4023360" cy="2011680"/>
+          </a:xfrm>
+          <a:prstGeom prst="rect">
+            <a:avLst/>
           </a:prstGeom>
           <a:solidFill>
             <a:srgbClr val="FFFFFF"/>
           </a:solidFill>
-          <a:ln w="19050">
-            <a:solidFill>
-              <a:srgbClr val="000000"/>
-            </a:solidFill>
-            <a:prstDash val="solid"/>
-          </a:ln>
-        </p:spPr>
-      </p:sp>
-      <p:sp>
-        <p:nvSpPr>
-          <p:cNvPr id="5" name="Shape 2"/>
-          <p:cNvSpPr/>
-          <p:nvPr/>
-        </p:nvSpPr>
-        <p:spPr>
-          <a:xfrm>
-            <a:off x="731520" y="1508760"/>
-            <a:ext cx="1188720" cy="347472"/>
-          </a:xfrm>
-          <a:prstGeom prst="roundRect">
-            <a:avLst>
-              <a:gd name="adj" fmla="val 26316"/>
-            </a:avLst>
-          </a:prstGeom>
-          <a:solidFill>
-            <a:srgbClr val="D92D20"/>
-          </a:solidFill>
-          <a:ln w="12700">
+          <a:ln w="9525">
             <a:solidFill>
               <a:srgbClr val="D92D20"/>
             </a:solidFill>
@@ -2651,14 +2899,14 @@
       </p:sp>
       <p:sp>
         <p:nvSpPr>
-          <p:cNvPr id="6" name="Text 3"/>
+          <p:cNvPr id="8" name="Text 5"/>
           <p:cNvSpPr txBox="1"/>
           <p:nvPr/>
         </p:nvSpPr>
         <p:spPr>
           <a:xfrm>
-            <a:off x="731520" y="1508760"/>
-            <a:ext cx="1188720" cy="347472"/>
+            <a:off x="4846320" y="1463040"/>
+            <a:ext cx="3657600" cy="274320"/>
           </a:xfrm>
           <a:prstGeom prst="rect">
             <a:avLst/>
@@ -2667,22 +2915,22 @@
           <a:ln/>
         </p:spPr>
         <p:txBody>
-          <a:bodyPr wrap="square" lIns="0" tIns="0" rIns="0" bIns="0" rtlCol="0" anchor="ctr"/>
-          <a:lstStyle/>
-          <a:p>
-            <a:pPr algn="ctr" indent="0" marL="0">
+          <a:bodyPr wrap="square" lIns="0" tIns="0" rIns="0" bIns="0" rtlCol="0" anchor="t"/>
+          <a:lstStyle/>
+          <a:p>
+            <a:pPr indent="0" marL="0">
               <a:buNone/>
             </a:pPr>
             <a:r>
               <a:rPr lang="en-US" sz="1300" b="1" dirty="0">
                 <a:solidFill>
-                  <a:srgbClr val="FFFFFF"/>
-                </a:solidFill>
-                <a:latin typeface="Arial" pitchFamily="34" charset="0"/>
-                <a:ea typeface="Arial" pitchFamily="34" charset="-122"/>
-                <a:cs typeface="Arial" pitchFamily="34" charset="-120"/>
-              </a:rPr>
-              <a:t>Danger</a:t>
+                  <a:srgbClr val="D92D20"/>
+                </a:solidFill>
+                <a:latin typeface="Arial" pitchFamily="34" charset="0"/>
+                <a:ea typeface="Arial" pitchFamily="34" charset="-122"/>
+                <a:cs typeface="Arial" pitchFamily="34" charset="-120"/>
+              </a:rPr>
+              <a:t>La demande est</a:t>
             </a:r>
             <a:endParaRPr lang="en-US" sz="1300" dirty="0"/>
           </a:p>
@@ -2690,14 +2938,14 @@
       </p:sp>
       <p:sp>
         <p:nvSpPr>
-          <p:cNvPr id="7" name="Text 4"/>
+          <p:cNvPr id="9" name="Text 6"/>
           <p:cNvSpPr txBox="1"/>
           <p:nvPr/>
         </p:nvSpPr>
         <p:spPr>
           <a:xfrm>
-            <a:off x="731520" y="2011680"/>
-            <a:ext cx="3657600" cy="274320"/>
+            <a:off x="4846320" y="1783080"/>
+            <a:ext cx="3657600" cy="1280160"/>
           </a:xfrm>
           <a:prstGeom prst="rect">
             <a:avLst/>
@@ -2713,30 +2961,30 @@
               <a:buNone/>
             </a:pPr>
             <a:r>
-              <a:rPr lang="en-US" sz="1300" b="1" dirty="0">
-                <a:solidFill>
-                  <a:srgbClr val="595959"/>
-                </a:solidFill>
-                <a:latin typeface="Arial" pitchFamily="34" charset="0"/>
-                <a:ea typeface="Arial" pitchFamily="34" charset="-122"/>
-                <a:cs typeface="Arial" pitchFamily="34" charset="-120"/>
-              </a:rPr>
-              <a:t>Tu crois</a:t>
-            </a:r>
-            <a:endParaRPr lang="en-US" sz="1300" dirty="0"/>
-          </a:p>
-        </p:txBody>
-      </p:sp>
-      <p:sp>
-        <p:nvSpPr>
-          <p:cNvPr id="8" name="Text 5"/>
+              <a:rPr lang="en-US" sz="1700" b="1" dirty="0">
+                <a:solidFill>
+                  <a:srgbClr val="D92D20"/>
+                </a:solidFill>
+                <a:latin typeface="Arial" pitchFamily="34" charset="0"/>
+                <a:ea typeface="Arial" pitchFamily="34" charset="-122"/>
+                <a:cs typeface="Arial" pitchFamily="34" charset="-120"/>
+              </a:rPr>
+              <a:t>un appel délégué vers un contrat inconnu, qui change le code du coffre</a:t>
+            </a:r>
+            <a:endParaRPr lang="en-US" sz="1700" dirty="0"/>
+          </a:p>
+        </p:txBody>
+      </p:sp>
+      <p:sp>
+        <p:nvSpPr>
+          <p:cNvPr id="10" name="Text 7"/>
           <p:cNvSpPr txBox="1"/>
           <p:nvPr/>
         </p:nvSpPr>
         <p:spPr>
           <a:xfrm>
-            <a:off x="731520" y="2286000"/>
-            <a:ext cx="3566160" cy="822960"/>
+            <a:off x="457200" y="3657600"/>
+            <a:ext cx="8229600" cy="365760"/>
           </a:xfrm>
           <a:prstGeom prst="rect">
             <a:avLst/>
@@ -2760,7 +3008,7 @@
                 <a:ea typeface="Arial" pitchFamily="34" charset="-122"/>
                 <a:cs typeface="Arial" pitchFamily="34" charset="-120"/>
               </a:rPr>
-              <a:t>Je signe un simple message, sans payer de frais.</a:t>
+              <a:t>Ça ne correspond pas.</a:t>
             </a:r>
             <a:endParaRPr lang="en-US" sz="2000" dirty="0"/>
           </a:p>
@@ -2768,14 +3016,14 @@
       </p:sp>
       <p:sp>
         <p:nvSpPr>
-          <p:cNvPr id="9" name="Text 6"/>
+          <p:cNvPr id="11" name="Text 8"/>
           <p:cNvSpPr txBox="1"/>
           <p:nvPr/>
         </p:nvSpPr>
         <p:spPr>
           <a:xfrm>
-            <a:off x="4663440" y="2011680"/>
-            <a:ext cx="3657600" cy="274320"/>
+            <a:off x="457200" y="4114800"/>
+            <a:ext cx="8229600" cy="365760"/>
           </a:xfrm>
           <a:prstGeom prst="rect">
             <a:avLst/>
@@ -2791,188 +3039,17 @@
               <a:buNone/>
             </a:pPr>
             <a:r>
-              <a:rPr lang="en-US" sz="1300" b="1" dirty="0">
-                <a:solidFill>
-                  <a:srgbClr val="D92D20"/>
-                </a:solidFill>
-                <a:latin typeface="Arial" pitchFamily="34" charset="0"/>
-                <a:ea typeface="Arial" pitchFamily="34" charset="-122"/>
-                <a:cs typeface="Arial" pitchFamily="34" charset="-120"/>
-              </a:rPr>
-              <a:t>En vrai</a:t>
+              <a:rPr lang="en-US" sz="1300" dirty="0">
+                <a:solidFill>
+                  <a:srgbClr val="595959"/>
+                </a:solidFill>
+                <a:latin typeface="Arial" pitchFamily="34" charset="0"/>
+                <a:ea typeface="Arial" pitchFamily="34" charset="-122"/>
+                <a:cs typeface="Arial" pitchFamily="34" charset="-120"/>
+              </a:rPr>
+              <a:t>Scène synthétique, adresses factices. Elle montre le décodage, pas l’attaque.</a:t>
             </a:r>
             <a:endParaRPr lang="en-US" sz="1300" dirty="0"/>
-          </a:p>
-        </p:txBody>
-      </p:sp>
-      <p:sp>
-        <p:nvSpPr>
-          <p:cNvPr id="10" name="Text 7"/>
-          <p:cNvSpPr txBox="1"/>
-          <p:nvPr/>
-        </p:nvSpPr>
-        <p:spPr>
-          <a:xfrm>
-            <a:off x="4663440" y="2286000"/>
-            <a:ext cx="3749040" cy="1097280"/>
-          </a:xfrm>
-          <a:prstGeom prst="rect">
-            <a:avLst/>
-          </a:prstGeom>
-          <a:noFill/>
-          <a:ln/>
-        </p:spPr>
-        <p:txBody>
-          <a:bodyPr wrap="square" lIns="0" tIns="0" rIns="0" bIns="0" rtlCol="0" anchor="t"/>
-          <a:lstStyle/>
-          <a:p>
-            <a:pPr indent="0" marL="0">
-              <a:buNone/>
-            </a:pPr>
-            <a:r>
-              <a:rPr lang="en-US" sz="2000" b="1" dirty="0">
-                <a:solidFill>
-                  <a:srgbClr val="D92D20"/>
-                </a:solidFill>
-                <a:latin typeface="Arial" pitchFamily="34" charset="0"/>
-                <a:ea typeface="Arial" pitchFamily="34" charset="-122"/>
-                <a:cs typeface="Arial" pitchFamily="34" charset="-120"/>
-              </a:rPr>
-              <a:t>Cette signature gratuite laisse le site prendre tes jetons.</a:t>
-            </a:r>
-            <a:endParaRPr lang="en-US" sz="2000" dirty="0"/>
-          </a:p>
-        </p:txBody>
-      </p:sp>
-      <p:sp>
-        <p:nvSpPr>
-          <p:cNvPr id="11" name="Shape 8"/>
-          <p:cNvSpPr/>
-          <p:nvPr/>
-        </p:nvSpPr>
-        <p:spPr>
-          <a:xfrm>
-            <a:off x="731520" y="3749040"/>
-            <a:ext cx="2194560" cy="457200"/>
-          </a:xfrm>
-          <a:prstGeom prst="roundRect">
-            <a:avLst>
-              <a:gd name="adj" fmla="val 20000"/>
-            </a:avLst>
-          </a:prstGeom>
-          <a:solidFill>
-            <a:srgbClr val="000000"/>
-          </a:solidFill>
-          <a:ln w="12700">
-            <a:solidFill>
-              <a:srgbClr val="000000"/>
-            </a:solidFill>
-            <a:prstDash val="solid"/>
-          </a:ln>
-        </p:spPr>
-      </p:sp>
-      <p:sp>
-        <p:nvSpPr>
-          <p:cNvPr id="12" name="Text 9"/>
-          <p:cNvSpPr txBox="1"/>
-          <p:nvPr/>
-        </p:nvSpPr>
-        <p:spPr>
-          <a:xfrm>
-            <a:off x="731520" y="3749040"/>
-            <a:ext cx="2194560" cy="457200"/>
-          </a:xfrm>
-          <a:prstGeom prst="rect">
-            <a:avLst/>
-          </a:prstGeom>
-          <a:noFill/>
-          <a:ln/>
-        </p:spPr>
-        <p:txBody>
-          <a:bodyPr wrap="square" lIns="0" tIns="0" rIns="0" bIns="0" rtlCol="0" anchor="ctr"/>
-          <a:lstStyle/>
-          <a:p>
-            <a:pPr algn="ctr" indent="0" marL="0">
-              <a:buNone/>
-            </a:pPr>
-            <a:r>
-              <a:rPr lang="en-US" sz="1400" b="1" dirty="0">
-                <a:solidFill>
-                  <a:srgbClr val="FFFFFF"/>
-                </a:solidFill>
-                <a:latin typeface="Arial" pitchFamily="34" charset="0"/>
-                <a:ea typeface="Arial" pitchFamily="34" charset="-122"/>
-                <a:cs typeface="Arial" pitchFamily="34" charset="-120"/>
-              </a:rPr>
-              <a:t>Annuler</a:t>
-            </a:r>
-            <a:endParaRPr lang="en-US" sz="1400" dirty="0"/>
-          </a:p>
-        </p:txBody>
-      </p:sp>
-      <p:sp>
-        <p:nvSpPr>
-          <p:cNvPr id="13" name="Shape 10"/>
-          <p:cNvSpPr/>
-          <p:nvPr/>
-        </p:nvSpPr>
-        <p:spPr>
-          <a:xfrm>
-            <a:off x="3108960" y="3749040"/>
-            <a:ext cx="2926080" cy="457200"/>
-          </a:xfrm>
-          <a:prstGeom prst="roundRect">
-            <a:avLst>
-              <a:gd name="adj" fmla="val 20000"/>
-            </a:avLst>
-          </a:prstGeom>
-          <a:solidFill>
-            <a:srgbClr val="FFFFFF"/>
-          </a:solidFill>
-          <a:ln w="12700">
-            <a:solidFill>
-              <a:srgbClr val="E2E2E2"/>
-            </a:solidFill>
-            <a:prstDash val="solid"/>
-          </a:ln>
-        </p:spPr>
-      </p:sp>
-      <p:sp>
-        <p:nvSpPr>
-          <p:cNvPr id="14" name="Text 11"/>
-          <p:cNvSpPr txBox="1"/>
-          <p:nvPr/>
-        </p:nvSpPr>
-        <p:spPr>
-          <a:xfrm>
-            <a:off x="3108960" y="3749040"/>
-            <a:ext cx="2926080" cy="457200"/>
-          </a:xfrm>
-          <a:prstGeom prst="rect">
-            <a:avLst/>
-          </a:prstGeom>
-          <a:noFill/>
-          <a:ln/>
-        </p:spPr>
-        <p:txBody>
-          <a:bodyPr wrap="square" lIns="0" tIns="0" rIns="0" bIns="0" rtlCol="0" anchor="ctr"/>
-          <a:lstStyle/>
-          <a:p>
-            <a:pPr algn="ctr" indent="0" marL="0">
-              <a:buNone/>
-            </a:pPr>
-            <a:r>
-              <a:rPr lang="en-US" sz="1200" b="1" dirty="0">
-                <a:solidFill>
-                  <a:srgbClr val="595959"/>
-                </a:solidFill>
-                <a:latin typeface="Arial" pitchFamily="34" charset="0"/>
-                <a:ea typeface="Arial" pitchFamily="34" charset="-122"/>
-                <a:cs typeface="Arial" pitchFamily="34" charset="-120"/>
-              </a:rPr>
-              <a:t>Continuer quand même (retardé)</a:t>
-            </a:r>
-            <a:endParaRPr lang="en-US" sz="1200" dirty="0"/>
           </a:p>
         </p:txBody>
       </p:sp>
@@ -3082,7 +3159,7 @@
                 <a:ea typeface="Arial" pitchFamily="34" charset="-122"/>
                 <a:cs typeface="Arial" pitchFamily="34" charset="-120"/>
               </a:rPr>
-              <a:t>Démo : le Hold up Lab</a:t>
+              <a:t>« Me connecter » qui signe un droit</a:t>
             </a:r>
             <a:endParaRPr lang="en-US" sz="3000" dirty="0"/>
           </a:p>
@@ -3096,8 +3173,8 @@
         </p:nvSpPr>
         <p:spPr>
           <a:xfrm>
-            <a:off x="457200" y="1325880"/>
-            <a:ext cx="2011680" cy="914400"/>
+            <a:off x="457200" y="1371600"/>
+            <a:ext cx="4023360" cy="2377440"/>
           </a:xfrm>
           <a:prstGeom prst="rect">
             <a:avLst/>
@@ -3121,8 +3198,8 @@
         </p:nvSpPr>
         <p:spPr>
           <a:xfrm>
-            <a:off x="594360" y="1417320"/>
-            <a:ext cx="1737360" cy="731520"/>
+            <a:off x="640080" y="1463040"/>
+            <a:ext cx="3657600" cy="274320"/>
           </a:xfrm>
           <a:prstGeom prst="rect">
             <a:avLst/>
@@ -3140,13 +3217,13 @@
             <a:r>
               <a:rPr lang="en-US" sz="1300" b="1" dirty="0">
                 <a:solidFill>
-                  <a:srgbClr val="000000"/>
-                </a:solidFill>
-                <a:latin typeface="Arial" pitchFamily="34" charset="0"/>
-                <a:ea typeface="Arial" pitchFamily="34" charset="-122"/>
-                <a:cs typeface="Arial" pitchFamily="34" charset="-120"/>
-              </a:rPr>
-              <a:t>Une attaque, construite par le jury</a:t>
+                  <a:srgbClr val="595959"/>
+                </a:solidFill>
+                <a:latin typeface="Arial" pitchFamily="34" charset="0"/>
+                <a:ea typeface="Arial" pitchFamily="34" charset="-122"/>
+                <a:cs typeface="Arial" pitchFamily="34" charset="-120"/>
+              </a:rPr>
+              <a:t>MetaMask affiche</a:t>
             </a:r>
             <a:endParaRPr lang="en-US" sz="1300" dirty="0"/>
           </a:p>
@@ -3154,39 +3231,14 @@
       </p:sp>
       <p:sp>
         <p:nvSpPr>
-          <p:cNvPr id="6" name="Shape 3"/>
-          <p:cNvSpPr/>
-          <p:nvPr/>
-        </p:nvSpPr>
-        <p:spPr>
-          <a:xfrm>
-            <a:off x="3108960" y="1325880"/>
-            <a:ext cx="2743200" cy="914400"/>
-          </a:xfrm>
-          <a:prstGeom prst="rect">
-            <a:avLst/>
-          </a:prstGeom>
-          <a:solidFill>
-            <a:srgbClr val="FFFFFF"/>
-          </a:solidFill>
-          <a:ln w="9525">
-            <a:solidFill>
-              <a:srgbClr val="000000"/>
-            </a:solidFill>
-            <a:prstDash val="solid"/>
-          </a:ln>
-        </p:spPr>
-      </p:sp>
-      <p:sp>
-        <p:nvSpPr>
-          <p:cNvPr id="7" name="Text 4"/>
+          <p:cNvPr id="6" name="Text 3"/>
           <p:cNvSpPr txBox="1"/>
           <p:nvPr/>
         </p:nvSpPr>
         <p:spPr>
           <a:xfrm>
-            <a:off x="3246120" y="1417320"/>
-            <a:ext cx="2468880" cy="731520"/>
+            <a:off x="640080" y="1828800"/>
+            <a:ext cx="3657600" cy="1645920"/>
           </a:xfrm>
           <a:prstGeom prst="rect">
             <a:avLst/>
@@ -3202,7 +3254,7 @@
               <a:buNone/>
             </a:pPr>
             <a:r>
-              <a:rPr lang="en-US" sz="1400" b="1" dirty="0">
+              <a:rPr lang="en-US" sz="1700" dirty="0">
                 <a:solidFill>
                   <a:srgbClr val="000000"/>
                 </a:solidFill>
@@ -3210,22 +3262,22 @@
                 <a:ea typeface="Arial" pitchFamily="34" charset="-122"/>
                 <a:cs typeface="Arial" pitchFamily="34" charset="-120"/>
               </a:rPr>
-              <a:t>Ce que Hold up dit</a:t>
-            </a:r>
-            <a:endParaRPr lang="en-US" sz="1400" dirty="0"/>
-          </a:p>
-        </p:txBody>
-      </p:sp>
-      <p:sp>
-        <p:nvSpPr>
-          <p:cNvPr id="8" name="Shape 5"/>
+              <a:t>Une demande de plafond de dépense. Il ne sait pas que tu voulais seulement te connecter.</a:t>
+            </a:r>
+            <a:endParaRPr lang="en-US" sz="1700" dirty="0"/>
+          </a:p>
+        </p:txBody>
+      </p:sp>
+      <p:sp>
+        <p:nvSpPr>
+          <p:cNvPr id="7" name="Shape 4"/>
           <p:cNvSpPr/>
           <p:nvPr/>
         </p:nvSpPr>
         <p:spPr>
           <a:xfrm>
-            <a:off x="5943600" y="1325880"/>
-            <a:ext cx="2743200" cy="914400"/>
+            <a:off x="4663440" y="1371600"/>
+            <a:ext cx="4023360" cy="2377440"/>
           </a:xfrm>
           <a:prstGeom prst="rect">
             <a:avLst/>
@@ -3243,14 +3295,53 @@
       </p:sp>
       <p:sp>
         <p:nvSpPr>
+          <p:cNvPr id="8" name="Text 5"/>
+          <p:cNvSpPr txBox="1"/>
+          <p:nvPr/>
+        </p:nvSpPr>
+        <p:spPr>
+          <a:xfrm>
+            <a:off x="4846320" y="1463040"/>
+            <a:ext cx="3657600" cy="274320"/>
+          </a:xfrm>
+          <a:prstGeom prst="rect">
+            <a:avLst/>
+          </a:prstGeom>
+          <a:noFill/>
+          <a:ln/>
+        </p:spPr>
+        <p:txBody>
+          <a:bodyPr wrap="square" lIns="0" tIns="0" rIns="0" bIns="0" rtlCol="0" anchor="t"/>
+          <a:lstStyle/>
+          <a:p>
+            <a:pPr indent="0" marL="0">
+              <a:buNone/>
+            </a:pPr>
+            <a:r>
+              <a:rPr lang="en-US" sz="1300" b="1" dirty="0">
+                <a:solidFill>
+                  <a:srgbClr val="D92D20"/>
+                </a:solidFill>
+                <a:latin typeface="Arial" pitchFamily="34" charset="0"/>
+                <a:ea typeface="Arial" pitchFamily="34" charset="-122"/>
+                <a:cs typeface="Arial" pitchFamily="34" charset="-120"/>
+              </a:rPr>
+              <a:t>Hold up, après « me connecter »</a:t>
+            </a:r>
+            <a:endParaRPr lang="en-US" sz="1300" dirty="0"/>
+          </a:p>
+        </p:txBody>
+      </p:sp>
+      <p:sp>
+        <p:nvSpPr>
           <p:cNvPr id="9" name="Text 6"/>
           <p:cNvSpPr txBox="1"/>
           <p:nvPr/>
         </p:nvSpPr>
         <p:spPr>
           <a:xfrm>
-            <a:off x="6080760" y="1371600"/>
-            <a:ext cx="2468880" cy="822960"/>
+            <a:off x="4846320" y="1828800"/>
+            <a:ext cx="3657600" cy="1645920"/>
           </a:xfrm>
           <a:prstGeom prst="rect">
             <a:avLst/>
@@ -3266,54 +3357,30 @@
               <a:buNone/>
             </a:pPr>
             <a:r>
-              <a:rPr lang="en-US" sz="1200" b="1" dirty="0">
-                <a:solidFill>
-                  <a:srgbClr val="000000"/>
-                </a:solidFill>
-                <a:latin typeface="Arial" pitchFamily="34" charset="0"/>
-                <a:ea typeface="Arial" pitchFamily="34" charset="-122"/>
-                <a:cs typeface="Arial" pitchFamily="34" charset="-120"/>
-              </a:rPr>
-              <a:t>Ce qui arrive sur la chaîne si on signe (exécution, puis retour en arrière)</a:t>
-            </a:r>
-            <a:endParaRPr lang="en-US" sz="1200" dirty="0"/>
-          </a:p>
-        </p:txBody>
-      </p:sp>
-      <p:sp>
-        <p:nvSpPr>
-          <p:cNvPr id="10" name="Shape 7"/>
-          <p:cNvSpPr/>
-          <p:nvPr/>
-        </p:nvSpPr>
-        <p:spPr>
-          <a:xfrm>
-            <a:off x="2468880" y="1783080"/>
-            <a:ext cx="640080" cy="0"/>
-          </a:xfrm>
-          <a:prstGeom prst="line">
-            <a:avLst/>
-          </a:prstGeom>
-          <a:noFill/>
-          <a:ln w="19050">
-            <a:solidFill>
-              <a:srgbClr val="000000"/>
-            </a:solidFill>
-            <a:prstDash val="solid"/>
-            <a:tailEnd type="triangle"/>
-          </a:ln>
-        </p:spPr>
-      </p:sp>
-      <p:sp>
-        <p:nvSpPr>
-          <p:cNvPr id="11" name="Text 8"/>
+              <a:rPr lang="en-US" sz="1700" b="1" dirty="0">
+                <a:solidFill>
+                  <a:srgbClr val="D92D20"/>
+                </a:solidFill>
+                <a:latin typeface="Arial" pitchFamily="34" charset="0"/>
+                <a:ea typeface="Arial" pitchFamily="34" charset="-122"/>
+                <a:cs typeface="Arial" pitchFamily="34" charset="-120"/>
+              </a:rPr>
+              <a:t>Ça ne correspond pas : une connexion ne devrait pas donner un droit de dépense.</a:t>
+            </a:r>
+            <a:endParaRPr lang="en-US" sz="1700" dirty="0"/>
+          </a:p>
+        </p:txBody>
+      </p:sp>
+      <p:sp>
+        <p:nvSpPr>
+          <p:cNvPr id="10" name="Text 7"/>
           <p:cNvSpPr txBox="1"/>
           <p:nvPr/>
         </p:nvSpPr>
         <p:spPr>
           <a:xfrm>
-            <a:off x="457200" y="2560320"/>
-            <a:ext cx="8229600" cy="320040"/>
+            <a:off x="457200" y="4023360"/>
+            <a:ext cx="8229600" cy="365760"/>
           </a:xfrm>
           <a:prstGeom prst="rect">
             <a:avLst/>
@@ -3329,221 +3396,15 @@
               <a:buNone/>
             </a:pPr>
             <a:r>
-              <a:rPr lang="en-US" sz="1600" b="1" dirty="0">
-                <a:solidFill>
-                  <a:srgbClr val="000000"/>
-                </a:solidFill>
-                <a:latin typeface="Arial" pitchFamily="34" charset="0"/>
-                <a:ea typeface="Arial" pitchFamily="34" charset="-122"/>
-                <a:cs typeface="Arial" pitchFamily="34" charset="-120"/>
-              </a:rPr>
-              <a:t>Un moteur, deux portes</a:t>
-            </a:r>
-            <a:endParaRPr lang="en-US" sz="1600" dirty="0"/>
-          </a:p>
-        </p:txBody>
-      </p:sp>
-      <p:sp>
-        <p:nvSpPr>
-          <p:cNvPr id="12" name="Shape 9"/>
-          <p:cNvSpPr/>
-          <p:nvPr/>
-        </p:nvSpPr>
-        <p:spPr>
-          <a:xfrm>
-            <a:off x="457200" y="2971800"/>
-            <a:ext cx="4023360" cy="1554480"/>
-          </a:xfrm>
-          <a:prstGeom prst="rect">
-            <a:avLst/>
-          </a:prstGeom>
-          <a:solidFill>
-            <a:srgbClr val="F5F5F5"/>
-          </a:solidFill>
-          <a:ln w="9525">
-            <a:solidFill>
-              <a:srgbClr val="E2E2E2"/>
-            </a:solidFill>
-            <a:prstDash val="solid"/>
-          </a:ln>
-        </p:spPr>
-      </p:sp>
-      <p:sp>
-        <p:nvSpPr>
-          <p:cNvPr id="13" name="Text 10"/>
-          <p:cNvSpPr txBox="1"/>
-          <p:nvPr/>
-        </p:nvSpPr>
-        <p:spPr>
-          <a:xfrm>
-            <a:off x="640080" y="3063240"/>
-            <a:ext cx="3657600" cy="274320"/>
-          </a:xfrm>
-          <a:prstGeom prst="rect">
-            <a:avLst/>
-          </a:prstGeom>
-          <a:noFill/>
-          <a:ln/>
-        </p:spPr>
-        <p:txBody>
-          <a:bodyPr wrap="square" lIns="0" tIns="0" rIns="0" bIns="0" rtlCol="0" anchor="t"/>
-          <a:lstStyle/>
-          <a:p>
-            <a:pPr indent="0" marL="0">
-              <a:buNone/>
-            </a:pPr>
-            <a:r>
-              <a:rPr lang="en-US" sz="1400" b="1" dirty="0">
-                <a:solidFill>
-                  <a:srgbClr val="000000"/>
-                </a:solidFill>
-                <a:latin typeface="Arial" pitchFamily="34" charset="0"/>
-                <a:ea typeface="Arial" pitchFamily="34" charset="-122"/>
-                <a:cs typeface="Arial" pitchFamily="34" charset="-120"/>
-              </a:rPr>
-              <a:t>Extension, avant la signature</a:t>
-            </a:r>
-            <a:endParaRPr lang="en-US" sz="1400" dirty="0"/>
-          </a:p>
-        </p:txBody>
-      </p:sp>
-      <p:sp>
-        <p:nvSpPr>
-          <p:cNvPr id="14" name="Text 11"/>
-          <p:cNvSpPr txBox="1"/>
-          <p:nvPr/>
-        </p:nvSpPr>
-        <p:spPr>
-          <a:xfrm>
-            <a:off x="640080" y="3429000"/>
-            <a:ext cx="3657600" cy="822960"/>
-          </a:xfrm>
-          <a:prstGeom prst="rect">
-            <a:avLst/>
-          </a:prstGeom>
-          <a:noFill/>
-          <a:ln/>
-        </p:spPr>
-        <p:txBody>
-          <a:bodyPr wrap="square" lIns="0" tIns="0" rIns="0" bIns="0" rtlCol="0" anchor="t"/>
-          <a:lstStyle/>
-          <a:p>
-            <a:pPr indent="0" marL="0">
-              <a:buNone/>
-            </a:pPr>
-            <a:r>
               <a:rPr lang="en-US" sz="1300" dirty="0">
                 <a:solidFill>
-                  <a:srgbClr val="000000"/>
-                </a:solidFill>
-                <a:latin typeface="Arial" pitchFamily="34" charset="0"/>
-                <a:ea typeface="Arial" pitchFamily="34" charset="-122"/>
-                <a:cs typeface="Arial" pitchFamily="34" charset="-120"/>
-              </a:rPr>
-              <a:t>Seule à voir les signatures hors chaîne, comme un Permit.</a:t>
-            </a:r>
-            <a:endParaRPr lang="en-US" sz="1300" dirty="0"/>
-          </a:p>
-        </p:txBody>
-      </p:sp>
-      <p:sp>
-        <p:nvSpPr>
-          <p:cNvPr id="15" name="Shape 12"/>
-          <p:cNvSpPr/>
-          <p:nvPr/>
-        </p:nvSpPr>
-        <p:spPr>
-          <a:xfrm>
-            <a:off x="4663440" y="2971800"/>
-            <a:ext cx="4023360" cy="1554480"/>
-          </a:xfrm>
-          <a:prstGeom prst="rect">
-            <a:avLst/>
-          </a:prstGeom>
-          <a:solidFill>
-            <a:srgbClr val="F5F5F5"/>
-          </a:solidFill>
-          <a:ln w="9525">
-            <a:solidFill>
-              <a:srgbClr val="E2E2E2"/>
-            </a:solidFill>
-            <a:prstDash val="solid"/>
-          </a:ln>
-        </p:spPr>
-      </p:sp>
-      <p:sp>
-        <p:nvSpPr>
-          <p:cNvPr id="16" name="Text 13"/>
-          <p:cNvSpPr txBox="1"/>
-          <p:nvPr/>
-        </p:nvSpPr>
-        <p:spPr>
-          <a:xfrm>
-            <a:off x="4846320" y="3063240"/>
-            <a:ext cx="3657600" cy="274320"/>
-          </a:xfrm>
-          <a:prstGeom prst="rect">
-            <a:avLst/>
-          </a:prstGeom>
-          <a:noFill/>
-          <a:ln/>
-        </p:spPr>
-        <p:txBody>
-          <a:bodyPr wrap="square" lIns="0" tIns="0" rIns="0" bIns="0" rtlCol="0" anchor="t"/>
-          <a:lstStyle/>
-          <a:p>
-            <a:pPr indent="0" marL="0">
-              <a:buNone/>
-            </a:pPr>
-            <a:r>
-              <a:rPr lang="en-US" sz="1400" b="1" dirty="0">
-                <a:solidFill>
-                  <a:srgbClr val="000000"/>
-                </a:solidFill>
-                <a:latin typeface="Arial" pitchFamily="34" charset="0"/>
-                <a:ea typeface="Arial" pitchFamily="34" charset="-122"/>
-                <a:cs typeface="Arial" pitchFamily="34" charset="-120"/>
-              </a:rPr>
-              <a:t>RPC de garde, après la signature</a:t>
-            </a:r>
-            <a:endParaRPr lang="en-US" sz="1400" dirty="0"/>
-          </a:p>
-        </p:txBody>
-      </p:sp>
-      <p:sp>
-        <p:nvSpPr>
-          <p:cNvPr id="17" name="Text 14"/>
-          <p:cNvSpPr txBox="1"/>
-          <p:nvPr/>
-        </p:nvSpPr>
-        <p:spPr>
-          <a:xfrm>
-            <a:off x="4846320" y="3429000"/>
-            <a:ext cx="3657600" cy="1005840"/>
-          </a:xfrm>
-          <a:prstGeom prst="rect">
-            <a:avLst/>
-          </a:prstGeom>
-          <a:noFill/>
-          <a:ln/>
-        </p:spPr>
-        <p:txBody>
-          <a:bodyPr wrap="square" lIns="0" tIns="0" rIns="0" bIns="0" rtlCol="0" anchor="t"/>
-          <a:lstStyle/>
-          <a:p>
-            <a:pPr indent="0" marL="0">
-              <a:buNone/>
-            </a:pPr>
-            <a:r>
-              <a:rPr lang="en-US" sz="1300" dirty="0">
-                <a:solidFill>
-                  <a:srgbClr val="000000"/>
-                </a:solidFill>
-                <a:latin typeface="Arial" pitchFamily="34" charset="0"/>
-                <a:ea typeface="Arial" pitchFamily="34" charset="-122"/>
-                <a:cs typeface="Arial" pitchFamily="34" charset="-120"/>
-              </a:rPr>
-              <a:t>Avant la diffusion : envois tapés dans le wallet, mobile. Retraits de plateforme : coller et vérifier à la main.</a:t>
+                  <a:srgbClr val="595959"/>
+                </a:solidFill>
+                <a:latin typeface="Arial" pitchFamily="34" charset="0"/>
+                <a:ea typeface="Arial" pitchFamily="34" charset="-122"/>
+                <a:cs typeface="Arial" pitchFamily="34" charset="-120"/>
+              </a:rPr>
+              <a:t>Démo locale : le résultat ne dit rien du comportement de MetaMask en production.</a:t>
             </a:r>
             <a:endParaRPr lang="en-US" sz="1300" dirty="0"/>
           </a:p>
@@ -3684,8 +3545,8 @@
             <a:tbl>
               <a:tblPr/>
               <a:tblGrid>
-                <a:gridCol w="2651760"/>
-                <a:gridCol w="3383280"/>
+                <a:gridCol w="2743200"/>
+                <a:gridCol w="3291840"/>
                 <a:gridCol w="2194560"/>
               </a:tblGrid>
               <a:tr h="320040">
@@ -3706,7 +3567,7 @@
                           <a:ea typeface="Arial" pitchFamily="34" charset="-122"/>
                           <a:cs typeface="Arial" pitchFamily="34" charset="-120"/>
                         </a:rPr>
-                        <a:t>Jeu</a:t>
+                        <a:t>Synthétique (cas écrits par nous)</a:t>
                       </a:r>
                       <a:endParaRPr lang="en-US" sz="1200" dirty="0">
                         <a:latin typeface="Arial" charset="0"/>
@@ -3894,7 +3755,7 @@
                   </a:tcPr>
                 </a:tc>
               </a:tr>
-              <a:tr h="685800">
+              <a:tr h="640080">
                 <a:tc>
                   <a:txBody>
                     <a:bodyPr/>
@@ -3912,7 +3773,7 @@
                           <a:ea typeface="Arial" pitchFamily="34" charset="-122"/>
                           <a:cs typeface="Arial" pitchFamily="34" charset="-120"/>
                         </a:rPr>
-                        <a:t>TEST, ouvert une fois, avant correctifs</a:t>
+                        <a:t>410 cas de décalage</a:t>
                       </a:r>
                       <a:endParaRPr lang="en-US" sz="1200" dirty="0">
                         <a:latin typeface="Arial" charset="0"/>
@@ -3977,7 +3838,7 @@
                           <a:ea typeface="Arial" pitchFamily="34" charset="-122"/>
                           <a:cs typeface="Arial" pitchFamily="34" charset="-120"/>
                         </a:rPr>
-                        <a:t>Rappel 94,5 % (104/110). Fausses alertes critiques 23,1 % (18/78).</a:t>
+                        <a:t>228 écarts sur 228 signalés. 0 fausse alerte rouge sur 166 honnêtes.</a:t>
                       </a:r>
                       <a:endParaRPr lang="en-US" sz="1200" dirty="0">
                         <a:latin typeface="Arial" charset="0"/>
@@ -4036,13 +3897,13 @@
                       <a:r>
                         <a:rPr lang="en-US" sz="1200" dirty="0">
                           <a:solidFill>
-                            <a:srgbClr val="D92D20"/>
+                            <a:srgbClr val="000000"/>
                           </a:solidFill>
                           <a:latin typeface="Arial" pitchFamily="34" charset="0"/>
                           <a:ea typeface="Arial" pitchFamily="34" charset="-122"/>
                           <a:cs typeface="Arial" pitchFamily="34" charset="-120"/>
                         </a:rPr>
-                        <a:t>Écrit par nous. Trop de fausses alertes.</a:t>
+                        <a:t>Test de couverture, pas une mesure.</a:t>
                       </a:r>
                       <a:endParaRPr lang="en-US" sz="1200" dirty="0">
                         <a:latin typeface="Arial" charset="0"/>
@@ -4109,7 +3970,7 @@
                           <a:ea typeface="Arial" pitchFamily="34" charset="-122"/>
                           <a:cs typeface="Arial" pitchFamily="34" charset="-120"/>
                         </a:rPr>
-                        <a:t>DEV, règles réglées dessus</a:t>
+                        <a:t>Moteur en conditions produit</a:t>
                       </a:r>
                       <a:endParaRPr lang="en-US" sz="1200" dirty="0">
                         <a:latin typeface="Arial" charset="0"/>
@@ -4174,7 +4035,139 @@
                           <a:ea typeface="Arial" pitchFamily="34" charset="-122"/>
                           <a:cs typeface="Arial" pitchFamily="34" charset="-120"/>
                         </a:rPr>
-                        <a:t>252/252 et 0/90</a:t>
+                        <a:t>Rappel rouge 71,3 %. Honnêtes en rouge 13,9 %.</a:t>
+                      </a:r>
+                      <a:endParaRPr lang="en-US" sz="1200" dirty="0">
+                        <a:latin typeface="Arial" charset="0"/>
+                        <a:ea typeface="Arial" charset="0"/>
+                        <a:cs typeface="Arial" charset="0"/>
+                      </a:endParaRPr>
+                    </a:p>
+                  </a:txBody>
+                  <a:tcPr marL="91440" marR="91440" marT="45720" marB="45720" anchor="ctr">
+                    <a:lnL w="9525" cap="flat" cmpd="sng" algn="ctr">
+                      <a:solidFill>
+                        <a:srgbClr val="E2E2E2"/>
+                      </a:solidFill>
+                      <a:prstDash val="solid"/>
+                      <a:round/>
+                      <a:headEnd type="none" w="med" len="med"/>
+                      <a:tailEnd type="none" w="med" len="med"/>
+                    </a:lnL>
+                    <a:lnR w="9525" cap="flat" cmpd="sng" algn="ctr">
+                      <a:solidFill>
+                        <a:srgbClr val="E2E2E2"/>
+                      </a:solidFill>
+                      <a:prstDash val="solid"/>
+                      <a:round/>
+                      <a:headEnd type="none" w="med" len="med"/>
+                      <a:tailEnd type="none" w="med" len="med"/>
+                    </a:lnR>
+                    <a:lnT w="9525" cap="flat" cmpd="sng" algn="ctr">
+                      <a:solidFill>
+                        <a:srgbClr val="E2E2E2"/>
+                      </a:solidFill>
+                      <a:prstDash val="solid"/>
+                      <a:round/>
+                      <a:headEnd type="none" w="med" len="med"/>
+                      <a:tailEnd type="none" w="med" len="med"/>
+                    </a:lnT>
+                    <a:lnB w="9525" cap="flat" cmpd="sng" algn="ctr">
+                      <a:solidFill>
+                        <a:srgbClr val="E2E2E2"/>
+                      </a:solidFill>
+                      <a:prstDash val="solid"/>
+                      <a:round/>
+                      <a:headEnd type="none" w="med" len="med"/>
+                      <a:tailEnd type="none" w="med" len="med"/>
+                    </a:lnB>
+                  </a:tcPr>
+                </a:tc>
+                <a:tc>
+                  <a:txBody>
+                    <a:bodyPr/>
+                    <a:lstStyle/>
+                    <a:p>
+                      <a:pPr indent="0" marL="0">
+                        <a:buNone/>
+                      </a:pPr>
+                      <a:r>
+                        <a:rPr lang="en-US" sz="1200" dirty="0">
+                          <a:solidFill>
+                            <a:srgbClr val="D92D20"/>
+                          </a:solidFill>
+                          <a:latin typeface="Arial" pitchFamily="34" charset="0"/>
+                          <a:ea typeface="Arial" pitchFamily="34" charset="-122"/>
+                          <a:cs typeface="Arial" pitchFamily="34" charset="-120"/>
+                        </a:rPr>
+                        <a:t>Trop de fausses alertes.</a:t>
+                      </a:r>
+                      <a:endParaRPr lang="en-US" sz="1200" dirty="0">
+                        <a:latin typeface="Arial" charset="0"/>
+                        <a:ea typeface="Arial" charset="0"/>
+                        <a:cs typeface="Arial" charset="0"/>
+                      </a:endParaRPr>
+                    </a:p>
+                  </a:txBody>
+                  <a:tcPr marL="91440" marR="91440" marT="45720" marB="45720" anchor="ctr">
+                    <a:lnL w="9525" cap="flat" cmpd="sng" algn="ctr">
+                      <a:solidFill>
+                        <a:srgbClr val="E2E2E2"/>
+                      </a:solidFill>
+                      <a:prstDash val="solid"/>
+                      <a:round/>
+                      <a:headEnd type="none" w="med" len="med"/>
+                      <a:tailEnd type="none" w="med" len="med"/>
+                    </a:lnL>
+                    <a:lnR w="9525" cap="flat" cmpd="sng" algn="ctr">
+                      <a:solidFill>
+                        <a:srgbClr val="E2E2E2"/>
+                      </a:solidFill>
+                      <a:prstDash val="solid"/>
+                      <a:round/>
+                      <a:headEnd type="none" w="med" len="med"/>
+                      <a:tailEnd type="none" w="med" len="med"/>
+                    </a:lnR>
+                    <a:lnT w="9525" cap="flat" cmpd="sng" algn="ctr">
+                      <a:solidFill>
+                        <a:srgbClr val="E2E2E2"/>
+                      </a:solidFill>
+                      <a:prstDash val="solid"/>
+                      <a:round/>
+                      <a:headEnd type="none" w="med" len="med"/>
+                      <a:tailEnd type="none" w="med" len="med"/>
+                    </a:lnT>
+                    <a:lnB w="9525" cap="flat" cmpd="sng" algn="ctr">
+                      <a:solidFill>
+                        <a:srgbClr val="E2E2E2"/>
+                      </a:solidFill>
+                      <a:prstDash val="solid"/>
+                      <a:round/>
+                      <a:headEnd type="none" w="med" len="med"/>
+                      <a:tailEnd type="none" w="med" len="med"/>
+                    </a:lnB>
+                  </a:tcPr>
+                </a:tc>
+              </a:tr>
+              <a:tr h="640080">
+                <a:tc>
+                  <a:txBody>
+                    <a:bodyPr/>
+                    <a:lstStyle/>
+                    <a:p>
+                      <a:pPr indent="0" marL="0">
+                        <a:buNone/>
+                      </a:pPr>
+                      <a:r>
+                        <a:rPr lang="en-US" sz="1200" b="1" dirty="0">
+                          <a:solidFill>
+                            <a:srgbClr val="000000"/>
+                          </a:solidFill>
+                          <a:latin typeface="Arial" pitchFamily="34" charset="0"/>
+                          <a:ea typeface="Arial" pitchFamily="34" charset="-122"/>
+                          <a:cs typeface="Arial" pitchFamily="34" charset="-120"/>
+                        </a:rPr>
+                        <a:t>Phrase libre sur 298 arnaques vertes</a:t>
                       </a:r>
                       <a:endParaRPr lang="en-US" sz="1200" dirty="0">
                         <a:latin typeface="Arial" charset="0"/>
@@ -4239,139 +4232,7 @@
                           <a:ea typeface="Arial" pitchFamily="34" charset="-122"/>
                           <a:cs typeface="Arial" pitchFamily="34" charset="-120"/>
                         </a:rPr>
-                        <a:t>Non-régression, pas une mesure.</a:t>
-                      </a:r>
-                      <a:endParaRPr lang="en-US" sz="1200" dirty="0">
-                        <a:latin typeface="Arial" charset="0"/>
-                        <a:ea typeface="Arial" charset="0"/>
-                        <a:cs typeface="Arial" charset="0"/>
-                      </a:endParaRPr>
-                    </a:p>
-                  </a:txBody>
-                  <a:tcPr marL="91440" marR="91440" marT="45720" marB="45720" anchor="ctr">
-                    <a:lnL w="9525" cap="flat" cmpd="sng" algn="ctr">
-                      <a:solidFill>
-                        <a:srgbClr val="E2E2E2"/>
-                      </a:solidFill>
-                      <a:prstDash val="solid"/>
-                      <a:round/>
-                      <a:headEnd type="none" w="med" len="med"/>
-                      <a:tailEnd type="none" w="med" len="med"/>
-                    </a:lnL>
-                    <a:lnR w="9525" cap="flat" cmpd="sng" algn="ctr">
-                      <a:solidFill>
-                        <a:srgbClr val="E2E2E2"/>
-                      </a:solidFill>
-                      <a:prstDash val="solid"/>
-                      <a:round/>
-                      <a:headEnd type="none" w="med" len="med"/>
-                      <a:tailEnd type="none" w="med" len="med"/>
-                    </a:lnR>
-                    <a:lnT w="9525" cap="flat" cmpd="sng" algn="ctr">
-                      <a:solidFill>
-                        <a:srgbClr val="E2E2E2"/>
-                      </a:solidFill>
-                      <a:prstDash val="solid"/>
-                      <a:round/>
-                      <a:headEnd type="none" w="med" len="med"/>
-                      <a:tailEnd type="none" w="med" len="med"/>
-                    </a:lnT>
-                    <a:lnB w="9525" cap="flat" cmpd="sng" algn="ctr">
-                      <a:solidFill>
-                        <a:srgbClr val="E2E2E2"/>
-                      </a:solidFill>
-                      <a:prstDash val="solid"/>
-                      <a:round/>
-                      <a:headEnd type="none" w="med" len="med"/>
-                      <a:tailEnd type="none" w="med" len="med"/>
-                    </a:lnB>
-                  </a:tcPr>
-                </a:tc>
-              </a:tr>
-              <a:tr h="685800">
-                <a:tc>
-                  <a:txBody>
-                    <a:bodyPr/>
-                    <a:lstStyle/>
-                    <a:p>
-                      <a:pPr indent="0" marL="0">
-                        <a:buNone/>
-                      </a:pPr>
-                      <a:r>
-                        <a:rPr lang="en-US" sz="1200" b="1" dirty="0">
-                          <a:solidFill>
-                            <a:srgbClr val="000000"/>
-                          </a:solidFill>
-                          <a:latin typeface="Arial" pitchFamily="34" charset="0"/>
-                          <a:ea typeface="Arial" pitchFamily="34" charset="-122"/>
-                          <a:cs typeface="Arial" pitchFamily="34" charset="-120"/>
-                        </a:rPr>
-                        <a:t>Opérations honnêtes Avalanche</a:t>
-                      </a:r>
-                      <a:endParaRPr lang="en-US" sz="1200" dirty="0">
-                        <a:latin typeface="Arial" charset="0"/>
-                        <a:ea typeface="Arial" charset="0"/>
-                        <a:cs typeface="Arial" charset="0"/>
-                      </a:endParaRPr>
-                    </a:p>
-                  </a:txBody>
-                  <a:tcPr marL="91440" marR="91440" marT="45720" marB="45720" anchor="ctr">
-                    <a:lnL w="9525" cap="flat" cmpd="sng" algn="ctr">
-                      <a:solidFill>
-                        <a:srgbClr val="E2E2E2"/>
-                      </a:solidFill>
-                      <a:prstDash val="solid"/>
-                      <a:round/>
-                      <a:headEnd type="none" w="med" len="med"/>
-                      <a:tailEnd type="none" w="med" len="med"/>
-                    </a:lnL>
-                    <a:lnR w="9525" cap="flat" cmpd="sng" algn="ctr">
-                      <a:solidFill>
-                        <a:srgbClr val="E2E2E2"/>
-                      </a:solidFill>
-                      <a:prstDash val="solid"/>
-                      <a:round/>
-                      <a:headEnd type="none" w="med" len="med"/>
-                      <a:tailEnd type="none" w="med" len="med"/>
-                    </a:lnR>
-                    <a:lnT w="9525" cap="flat" cmpd="sng" algn="ctr">
-                      <a:solidFill>
-                        <a:srgbClr val="E2E2E2"/>
-                      </a:solidFill>
-                      <a:prstDash val="solid"/>
-                      <a:round/>
-                      <a:headEnd type="none" w="med" len="med"/>
-                      <a:tailEnd type="none" w="med" len="med"/>
-                    </a:lnT>
-                    <a:lnB w="9525" cap="flat" cmpd="sng" algn="ctr">
-                      <a:solidFill>
-                        <a:srgbClr val="E2E2E2"/>
-                      </a:solidFill>
-                      <a:prstDash val="solid"/>
-                      <a:round/>
-                      <a:headEnd type="none" w="med" len="med"/>
-                      <a:tailEnd type="none" w="med" len="med"/>
-                    </a:lnB>
-                  </a:tcPr>
-                </a:tc>
-                <a:tc>
-                  <a:txBody>
-                    <a:bodyPr/>
-                    <a:lstStyle/>
-                    <a:p>
-                      <a:pPr indent="0" marL="0">
-                        <a:buNone/>
-                      </a:pPr>
-                      <a:r>
-                        <a:rPr lang="en-US" sz="1200" dirty="0">
-                          <a:solidFill>
-                            <a:srgbClr val="000000"/>
-                          </a:solidFill>
-                          <a:latin typeface="Arial" pitchFamily="34" charset="0"/>
-                          <a:ea typeface="Arial" pitchFamily="34" charset="-122"/>
-                          <a:cs typeface="Arial" pitchFamily="34" charset="-120"/>
-                        </a:rPr>
-                        <a:t>Critique 22/123 (17,9 %). 69 % reçoivent un écran.</a:t>
+                        <a:t>0 arrêtée. Intention structurée : 34.</a:t>
                       </a:r>
                       <a:endParaRPr lang="en-US" sz="1200" dirty="0">
                         <a:latin typeface="Arial" charset="0"/>
@@ -4436,7 +4297,7 @@
                           <a:ea typeface="Arial" pitchFamily="34" charset="-122"/>
                           <a:cs typeface="Arial" pitchFamily="34" charset="-120"/>
                         </a:rPr>
-                        <a:t>Fatigue d'alerte : première limite.</a:t>
+                        <a:t>Peu d'apport sur nos cas actuels.</a:t>
                       </a:r>
                       <a:endParaRPr lang="en-US" sz="1200" dirty="0">
                         <a:latin typeface="Arial" charset="0"/>
@@ -4485,7 +4346,7 @@
                   </a:tcPr>
                 </a:tc>
               </a:tr>
-              <a:tr h="685800">
+              <a:tr h="640080">
                 <a:tc>
                   <a:txBody>
                     <a:bodyPr/>
@@ -4503,7 +4364,7 @@
                           <a:ea typeface="Arial" pitchFamily="34" charset="-122"/>
                           <a:cs typeface="Arial" pitchFamily="34" charset="-120"/>
                         </a:rPr>
-                        <a:t>Jeux aveugles, produit réel, Lab (30+ scénarios)</a:t>
+                        <a:t>Jeu aveugle (250 cas), grille (1 500 paires)</a:t>
                       </a:r>
                       <a:endParaRPr lang="en-US" sz="1200" dirty="0">
                         <a:latin typeface="Arial" charset="0"/>
@@ -4719,7 +4580,7 @@
                 <a:ea typeface="Arial" pitchFamily="34" charset="-122"/>
                 <a:cs typeface="Arial" pitchFamily="34" charset="-120"/>
               </a:rPr>
-              <a:t>Rappel : avertissement ou critique. Fausse alerte : opération honnête classée critique.</a:t>
+              <a:t>Données réelles : aucune ne mesure Hold up. Le contexte est en colonne B de livrables/CHIFFRES.md.</a:t>
             </a:r>
             <a:endParaRPr lang="en-US" sz="1100" dirty="0"/>
           </a:p>
@@ -4831,7 +4692,7 @@
                 <a:ea typeface="Arial" pitchFamily="34" charset="-122"/>
                 <a:cs typeface="Arial" pitchFamily="34" charset="-120"/>
               </a:rPr>
-              <a:t>Une décision, une preuve, un rejeu</a:t>
+              <a:t>Après l'alerte, la personne décide</a:t>
             </a:r>
             <a:endParaRPr lang="en-US" sz="3000" dirty="0"/>
           </a:p>
@@ -4846,17 +4707,17 @@
         <p:spPr>
           <a:xfrm>
             <a:off x="457200" y="1371600"/>
-            <a:ext cx="8229600" cy="2926080"/>
+            <a:ext cx="4023360" cy="2743200"/>
           </a:xfrm>
           <a:prstGeom prst="rect">
             <a:avLst/>
           </a:prstGeom>
           <a:solidFill>
-            <a:srgbClr val="FFF4F2"/>
+            <a:srgbClr val="F5F5F5"/>
           </a:solidFill>
           <a:ln w="9525">
             <a:solidFill>
-              <a:srgbClr val="D92D20"/>
+              <a:srgbClr val="E2E2E2"/>
             </a:solidFill>
             <a:prstDash val="solid"/>
           </a:ln>
@@ -4870,8 +4731,8 @@
         </p:nvSpPr>
         <p:spPr>
           <a:xfrm>
-            <a:off x="731520" y="2194560"/>
-            <a:ext cx="7680960" cy="457200"/>
+            <a:off x="640080" y="1463040"/>
+            <a:ext cx="3657600" cy="365760"/>
           </a:xfrm>
           <a:prstGeom prst="rect">
             <a:avLst/>
@@ -4887,17 +4748,17 @@
               <a:buNone/>
             </a:pPr>
             <a:r>
-              <a:rPr lang="en-US" sz="2200" b="1" dirty="0">
-                <a:solidFill>
-                  <a:srgbClr val="D92D20"/>
-                </a:solidFill>
-                <a:latin typeface="Arial" pitchFamily="34" charset="0"/>
-                <a:ea typeface="Arial" pitchFamily="34" charset="-122"/>
-                <a:cs typeface="Arial" pitchFamily="34" charset="-120"/>
-              </a:rPr>
-              <a:t>EN ATTENTE : livrables/SLIDE_CONFORMITE.md</a:t>
-            </a:r>
-            <a:endParaRPr lang="en-US" sz="2200" dirty="0"/>
+              <a:rPr lang="en-US" sz="2000" b="1" dirty="0">
+                <a:solidFill>
+                  <a:srgbClr val="000000"/>
+                </a:solidFill>
+                <a:latin typeface="Arial" pitchFamily="34" charset="0"/>
+                <a:ea typeface="Arial" pitchFamily="34" charset="-122"/>
+                <a:cs typeface="Arial" pitchFamily="34" charset="-120"/>
+              </a:rPr>
+              <a:t>Transaction</a:t>
+            </a:r>
+            <a:endParaRPr lang="en-US" sz="2000" dirty="0"/>
           </a:p>
         </p:txBody>
       </p:sp>
@@ -4909,8 +4770,8 @@
         </p:nvSpPr>
         <p:spPr>
           <a:xfrm>
-            <a:off x="731520" y="2834640"/>
-            <a:ext cx="7680960" cy="731520"/>
+            <a:off x="640080" y="1965960"/>
+            <a:ext cx="3657600" cy="2011680"/>
           </a:xfrm>
           <a:prstGeom prst="rect">
             <a:avLst/>
@@ -4926,7 +4787,7 @@
               <a:buNone/>
             </a:pPr>
             <a:r>
-              <a:rPr lang="en-US" sz="1400" dirty="0">
+              <a:rPr lang="en-US" sz="1500" dirty="0">
                 <a:solidFill>
                   <a:srgbClr val="000000"/>
                 </a:solidFill>
@@ -4934,22 +4795,47 @@
                 <a:ea typeface="Arial" pitchFamily="34" charset="-122"/>
                 <a:cs typeface="Arial" pitchFamily="34" charset="-120"/>
               </a:rPr>
-              <a:t>Cette slide lira ce fichier au prochain lancement de build_deck.js. Ne pas présenter tant que ce cadre est visible.</a:t>
-            </a:r>
-            <a:endParaRPr lang="en-US" sz="1400" dirty="0"/>
-          </a:p>
-        </p:txBody>
-      </p:sp>
-      <p:sp>
-        <p:nvSpPr>
-          <p:cNvPr id="7" name="Text 4"/>
+              <a:t>La ligne dit : tu as écrit 50 USDC, la demande donne accès à tout ton USDC. Elle explique comment ramener le plafond à 50 USDC.</a:t>
+            </a:r>
+            <a:endParaRPr lang="en-US" sz="1500" dirty="0"/>
+          </a:p>
+        </p:txBody>
+      </p:sp>
+      <p:sp>
+        <p:nvSpPr>
+          <p:cNvPr id="7" name="Shape 4"/>
+          <p:cNvSpPr/>
+          <p:nvPr/>
+        </p:nvSpPr>
+        <p:spPr>
+          <a:xfrm>
+            <a:off x="4663440" y="1371600"/>
+            <a:ext cx="4023360" cy="2743200"/>
+          </a:xfrm>
+          <a:prstGeom prst="rect">
+            <a:avLst/>
+          </a:prstGeom>
+          <a:solidFill>
+            <a:srgbClr val="F5F5F5"/>
+          </a:solidFill>
+          <a:ln w="9525">
+            <a:solidFill>
+              <a:srgbClr val="E2E2E2"/>
+            </a:solidFill>
+            <a:prstDash val="solid"/>
+          </a:ln>
+        </p:spPr>
+      </p:sp>
+      <p:sp>
+        <p:nvSpPr>
+          <p:cNvPr id="8" name="Text 5"/>
           <p:cNvSpPr txBox="1"/>
           <p:nvPr/>
         </p:nvSpPr>
         <p:spPr>
           <a:xfrm>
-            <a:off x="457200" y="4434840"/>
-            <a:ext cx="8229600" cy="274320"/>
+            <a:off x="4846320" y="1463040"/>
+            <a:ext cx="3657600" cy="365760"/>
           </a:xfrm>
           <a:prstGeom prst="rect">
             <a:avLst/>
@@ -4965,6 +4851,84 @@
               <a:buNone/>
             </a:pPr>
             <a:r>
+              <a:rPr lang="en-US" sz="2000" b="1" dirty="0">
+                <a:solidFill>
+                  <a:srgbClr val="000000"/>
+                </a:solidFill>
+                <a:latin typeface="Arial" pitchFamily="34" charset="0"/>
+                <a:ea typeface="Arial" pitchFamily="34" charset="-122"/>
+                <a:cs typeface="Arial" pitchFamily="34" charset="-120"/>
+              </a:rPr>
+              <a:t>Signature</a:t>
+            </a:r>
+            <a:endParaRPr lang="en-US" sz="2000" dirty="0"/>
+          </a:p>
+        </p:txBody>
+      </p:sp>
+      <p:sp>
+        <p:nvSpPr>
+          <p:cNvPr id="9" name="Text 6"/>
+          <p:cNvSpPr txBox="1"/>
+          <p:nvPr/>
+        </p:nvSpPr>
+        <p:spPr>
+          <a:xfrm>
+            <a:off x="4846320" y="1965960"/>
+            <a:ext cx="3657600" cy="2011680"/>
+          </a:xfrm>
+          <a:prstGeom prst="rect">
+            <a:avLst/>
+          </a:prstGeom>
+          <a:noFill/>
+          <a:ln/>
+        </p:spPr>
+        <p:txBody>
+          <a:bodyPr wrap="square" lIns="0" tIns="0" rIns="0" bIns="0" rtlCol="0" anchor="t"/>
+          <a:lstStyle/>
+          <a:p>
+            <a:pPr indent="0" marL="0">
+              <a:buNone/>
+            </a:pPr>
+            <a:r>
+              <a:rPr lang="en-US" sz="1500" dirty="0">
+                <a:solidFill>
+                  <a:srgbClr val="000000"/>
+                </a:solidFill>
+                <a:latin typeface="Arial" pitchFamily="34" charset="0"/>
+                <a:ea typeface="Arial" pitchFamily="34" charset="-122"/>
+                <a:cs typeface="Arial" pitchFamily="34" charset="-120"/>
+              </a:rPr>
+              <a:t>Elle ne peut pas être limitée : la ligne le dit et ne donne aucun conseil que personne ne peut suivre.</a:t>
+            </a:r>
+            <a:endParaRPr lang="en-US" sz="1500" dirty="0"/>
+          </a:p>
+        </p:txBody>
+      </p:sp>
+      <p:sp>
+        <p:nvSpPr>
+          <p:cNvPr id="10" name="Text 7"/>
+          <p:cNvSpPr txBox="1"/>
+          <p:nvPr/>
+        </p:nvSpPr>
+        <p:spPr>
+          <a:xfrm>
+            <a:off x="457200" y="4343400"/>
+            <a:ext cx="8229600" cy="274320"/>
+          </a:xfrm>
+          <a:prstGeom prst="rect">
+            <a:avLst/>
+          </a:prstGeom>
+          <a:noFill/>
+          <a:ln/>
+        </p:spPr>
+        <p:txBody>
+          <a:bodyPr wrap="square" lIns="0" tIns="0" rIns="0" bIns="0" rtlCol="0" anchor="t"/>
+          <a:lstStyle/>
+          <a:p>
+            <a:pPr indent="0" marL="0">
+              <a:buNone/>
+            </a:pPr>
+            <a:r>
               <a:rPr lang="en-US" sz="1200" b="1" dirty="0">
                 <a:solidFill>
                   <a:srgbClr val="595959"/>
@@ -4973,7 +4937,7 @@
                 <a:ea typeface="Arial" pitchFamily="34" charset="-122"/>
                 <a:cs typeface="Arial" pitchFamily="34" charset="-120"/>
               </a:rPr>
-              <a:t>NIST CSF 2.0 : Detect, Respond.   ATT&amp;CK : T1566, T1657.</a:t>
+              <a:t>Chaque décision laisse une ligne dans un journal chaîné par hachage.</a:t>
             </a:r>
             <a:endParaRPr lang="en-US" sz="1200" dirty="0"/>
           </a:p>
@@ -5085,7 +5049,7 @@
                 <a:ea typeface="Arial" pitchFamily="34" charset="-122"/>
                 <a:cs typeface="Arial" pitchFamily="34" charset="-120"/>
               </a:rPr>
-              <a:t>Gratuit pour les personnes, intégration payante</a:t>
+              <a:t>Une décision, une trace, un rejeu</a:t>
             </a:r>
             <a:endParaRPr lang="en-US" sz="3000" dirty="0"/>
           </a:p>
@@ -5100,7 +5064,7 @@
         <p:spPr>
           <a:xfrm>
             <a:off x="457200" y="1371600"/>
-            <a:ext cx="4023360" cy="2286000"/>
+            <a:ext cx="1993392" cy="2926080"/>
           </a:xfrm>
           <a:prstGeom prst="rect">
             <a:avLst/>
@@ -5124,8 +5088,8 @@
         </p:nvSpPr>
         <p:spPr>
           <a:xfrm>
-            <a:off x="640080" y="1508760"/>
-            <a:ext cx="3657600" cy="365760"/>
+            <a:off x="566928" y="1481328"/>
+            <a:ext cx="1783080" cy="365760"/>
           </a:xfrm>
           <a:prstGeom prst="rect">
             <a:avLst/>
@@ -5141,7 +5105,7 @@
               <a:buNone/>
             </a:pPr>
             <a:r>
-              <a:rPr lang="en-US" sz="2000" b="1" dirty="0">
+              <a:rPr lang="en-US" sz="1400" b="1" dirty="0">
                 <a:solidFill>
                   <a:srgbClr val="000000"/>
                 </a:solidFill>
@@ -5149,9 +5113,9 @@
                 <a:ea typeface="Arial" pitchFamily="34" charset="-122"/>
                 <a:cs typeface="Arial" pitchFamily="34" charset="-120"/>
               </a:rPr>
-              <a:t>Particuliers</a:t>
-            </a:r>
-            <a:endParaRPr lang="en-US" sz="2000" dirty="0"/>
+              <a:t>DORA</a:t>
+            </a:r>
+            <a:endParaRPr lang="en-US" sz="1400" dirty="0"/>
           </a:p>
         </p:txBody>
       </p:sp>
@@ -5163,8 +5127,8 @@
         </p:nvSpPr>
         <p:spPr>
           <a:xfrm>
-            <a:off x="640080" y="2011680"/>
-            <a:ext cx="3657600" cy="1280160"/>
+            <a:off x="566928" y="1920240"/>
+            <a:ext cx="1783080" cy="2286000"/>
           </a:xfrm>
           <a:prstGeom prst="rect">
             <a:avLst/>
@@ -5180,7 +5144,7 @@
               <a:buNone/>
             </a:pPr>
             <a:r>
-              <a:rPr lang="en-US" sz="1600" dirty="0">
+              <a:rPr lang="en-US" sz="1100" dirty="0">
                 <a:solidFill>
                   <a:srgbClr val="000000"/>
                 </a:solidFill>
@@ -5188,9 +5152,9 @@
                 <a:ea typeface="Arial" pitchFamily="34" charset="-122"/>
                 <a:cs typeface="Arial" pitchFamily="34" charset="-120"/>
               </a:rPr>
-              <a:t>Extension gratuite. Porte d'entrée et démonstration.</a:t>
-            </a:r>
-            <a:endParaRPr lang="en-US" sz="1600" dirty="0"/>
+              <a:t>Une ligne datée par décision, rejouable : matière pour le registre. Pas de classification ni de déclaration.</a:t>
+            </a:r>
+            <a:endParaRPr lang="en-US" sz="1100" dirty="0"/>
           </a:p>
         </p:txBody>
       </p:sp>
@@ -5202,8 +5166,8 @@
         </p:nvSpPr>
         <p:spPr>
           <a:xfrm>
-            <a:off x="4663440" y="1371600"/>
-            <a:ext cx="4023360" cy="2286000"/>
+            <a:off x="2542032" y="1371600"/>
+            <a:ext cx="1993392" cy="2926080"/>
           </a:xfrm>
           <a:prstGeom prst="rect">
             <a:avLst/>
@@ -5227,8 +5191,8 @@
         </p:nvSpPr>
         <p:spPr>
           <a:xfrm>
-            <a:off x="4846320" y="1508760"/>
-            <a:ext cx="3657600" cy="365760"/>
+            <a:off x="2651760" y="1481328"/>
+            <a:ext cx="1783080" cy="365760"/>
           </a:xfrm>
           <a:prstGeom prst="rect">
             <a:avLst/>
@@ -5244,7 +5208,7 @@
               <a:buNone/>
             </a:pPr>
             <a:r>
-              <a:rPr lang="en-US" sz="2000" b="1" dirty="0">
+              <a:rPr lang="en-US" sz="1400" b="1" dirty="0">
                 <a:solidFill>
                   <a:srgbClr val="000000"/>
                 </a:solidFill>
@@ -5252,9 +5216,9 @@
                 <a:ea typeface="Arial" pitchFamily="34" charset="-122"/>
                 <a:cs typeface="Arial" pitchFamily="34" charset="-120"/>
               </a:rPr>
-              <a:t>Wallets et plateformes</a:t>
-            </a:r>
-            <a:endParaRPr lang="en-US" sz="2000" dirty="0"/>
+              <a:t>MiCA, LCB-FT</a:t>
+            </a:r>
+            <a:endParaRPr lang="en-US" sz="1400" dirty="0"/>
           </a:p>
         </p:txBody>
       </p:sp>
@@ -5266,8 +5230,8 @@
         </p:nvSpPr>
         <p:spPr>
           <a:xfrm>
-            <a:off x="4846320" y="2011680"/>
-            <a:ext cx="3657600" cy="1371600"/>
+            <a:off x="2651760" y="1920240"/>
+            <a:ext cx="1783080" cy="2286000"/>
           </a:xfrm>
           <a:prstGeom prst="rect">
             <a:avLst/>
@@ -5283,7 +5247,7 @@
               <a:buNone/>
             </a:pPr>
             <a:r>
-              <a:rPr lang="en-US" sz="1600" dirty="0">
+              <a:rPr lang="en-US" sz="1100" dirty="0">
                 <a:solidFill>
                   <a:srgbClr val="000000"/>
                 </a:solidFill>
@@ -5291,22 +5255,47 @@
                 <a:ea typeface="Arial" pitchFamily="34" charset="-122"/>
                 <a:cs typeface="Arial" pitchFamily="34" charset="-120"/>
               </a:rPr>
-              <a:t>Intégration payante : le moteur et le journal vérifiable derrière leur propre interface.</a:t>
-            </a:r>
-            <a:endParaRPr lang="en-US" sz="1600" dirty="0"/>
-          </a:p>
-        </p:txBody>
-      </p:sp>
-      <p:sp>
-        <p:nvSpPr>
-          <p:cNvPr id="10" name="Text 7"/>
+              <a:t>Trace de ce qui a été écrit et répondu. Aucun filtrage de sanctions, aucune déclaration de soupçon.</a:t>
+            </a:r>
+            <a:endParaRPr lang="en-US" sz="1100" dirty="0"/>
+          </a:p>
+        </p:txBody>
+      </p:sp>
+      <p:sp>
+        <p:nvSpPr>
+          <p:cNvPr id="10" name="Shape 7"/>
+          <p:cNvSpPr/>
+          <p:nvPr/>
+        </p:nvSpPr>
+        <p:spPr>
+          <a:xfrm>
+            <a:off x="4626864" y="1371600"/>
+            <a:ext cx="1993392" cy="2926080"/>
+          </a:xfrm>
+          <a:prstGeom prst="rect">
+            <a:avLst/>
+          </a:prstGeom>
+          <a:solidFill>
+            <a:srgbClr val="F5F5F5"/>
+          </a:solidFill>
+          <a:ln w="9525">
+            <a:solidFill>
+              <a:srgbClr val="E2E2E2"/>
+            </a:solidFill>
+            <a:prstDash val="solid"/>
+          </a:ln>
+        </p:spPr>
+      </p:sp>
+      <p:sp>
+        <p:nvSpPr>
+          <p:cNvPr id="11" name="Text 8"/>
           <p:cNvSpPr txBox="1"/>
           <p:nvPr/>
         </p:nvSpPr>
         <p:spPr>
           <a:xfrm>
-            <a:off x="457200" y="3931920"/>
-            <a:ext cx="8229600" cy="548640"/>
+            <a:off x="4736592" y="1481328"/>
+            <a:ext cx="1783080" cy="365760"/>
           </a:xfrm>
           <a:prstGeom prst="rect">
             <a:avLst/>
@@ -5322,7 +5311,188 @@
               <a:buNone/>
             </a:pPr>
             <a:r>
-              <a:rPr lang="en-US" sz="1400" dirty="0">
+              <a:rPr lang="en-US" sz="1400" b="1" dirty="0">
+                <a:solidFill>
+                  <a:srgbClr val="000000"/>
+                </a:solidFill>
+                <a:latin typeface="Arial" pitchFamily="34" charset="0"/>
+                <a:ea typeface="Arial" pitchFamily="34" charset="-122"/>
+                <a:cs typeface="Arial" pitchFamily="34" charset="-120"/>
+              </a:rPr>
+              <a:t>AI Act</a:t>
+            </a:r>
+            <a:endParaRPr lang="en-US" sz="1400" dirty="0"/>
+          </a:p>
+        </p:txBody>
+      </p:sp>
+      <p:sp>
+        <p:nvSpPr>
+          <p:cNvPr id="12" name="Text 9"/>
+          <p:cNvSpPr txBox="1"/>
+          <p:nvPr/>
+        </p:nvSpPr>
+        <p:spPr>
+          <a:xfrm>
+            <a:off x="4736592" y="1920240"/>
+            <a:ext cx="1783080" cy="2286000"/>
+          </a:xfrm>
+          <a:prstGeom prst="rect">
+            <a:avLst/>
+          </a:prstGeom>
+          <a:noFill/>
+          <a:ln/>
+        </p:spPr>
+        <p:txBody>
+          <a:bodyPr wrap="square" lIns="0" tIns="0" rIns="0" bIns="0" rtlCol="0" anchor="t"/>
+          <a:lstStyle/>
+          <a:p>
+            <a:pPr indent="0" marL="0">
+              <a:buNone/>
+            </a:pPr>
+            <a:r>
+              <a:rPr lang="en-US" sz="1100" dirty="0">
+                <a:solidFill>
+                  <a:srgbClr val="000000"/>
+                </a:solidFill>
+                <a:latin typeface="Arial" pitchFamily="34" charset="0"/>
+                <a:ea typeface="Arial" pitchFamily="34" charset="-122"/>
+                <a:cs typeface="Arial" pitchFamily="34" charset="-120"/>
+              </a:rPr>
+              <a:t>Un modèle lit la phrase. Du code lit montants, jetons, adresses. Pas de qualification établie.</a:t>
+            </a:r>
+            <a:endParaRPr lang="en-US" sz="1100" dirty="0"/>
+          </a:p>
+        </p:txBody>
+      </p:sp>
+      <p:sp>
+        <p:nvSpPr>
+          <p:cNvPr id="13" name="Shape 10"/>
+          <p:cNvSpPr/>
+          <p:nvPr/>
+        </p:nvSpPr>
+        <p:spPr>
+          <a:xfrm>
+            <a:off x="6711696" y="1371600"/>
+            <a:ext cx="1993392" cy="2926080"/>
+          </a:xfrm>
+          <a:prstGeom prst="rect">
+            <a:avLst/>
+          </a:prstGeom>
+          <a:solidFill>
+            <a:srgbClr val="F5F5F5"/>
+          </a:solidFill>
+          <a:ln w="9525">
+            <a:solidFill>
+              <a:srgbClr val="E2E2E2"/>
+            </a:solidFill>
+            <a:prstDash val="solid"/>
+          </a:ln>
+        </p:spPr>
+      </p:sp>
+      <p:sp>
+        <p:nvSpPr>
+          <p:cNvPr id="14" name="Text 11"/>
+          <p:cNvSpPr txBox="1"/>
+          <p:nvPr/>
+        </p:nvSpPr>
+        <p:spPr>
+          <a:xfrm>
+            <a:off x="6821424" y="1481328"/>
+            <a:ext cx="1783080" cy="365760"/>
+          </a:xfrm>
+          <a:prstGeom prst="rect">
+            <a:avLst/>
+          </a:prstGeom>
+          <a:noFill/>
+          <a:ln/>
+        </p:spPr>
+        <p:txBody>
+          <a:bodyPr wrap="square" lIns="0" tIns="0" rIns="0" bIns="0" rtlCol="0" anchor="t"/>
+          <a:lstStyle/>
+          <a:p>
+            <a:pPr indent="0" marL="0">
+              <a:buNone/>
+            </a:pPr>
+            <a:r>
+              <a:rPr lang="en-US" sz="1400" b="1" dirty="0">
+                <a:solidFill>
+                  <a:srgbClr val="000000"/>
+                </a:solidFill>
+                <a:latin typeface="Arial" pitchFamily="34" charset="0"/>
+                <a:ea typeface="Arial" pitchFamily="34" charset="-122"/>
+                <a:cs typeface="Arial" pitchFamily="34" charset="-120"/>
+              </a:rPr>
+              <a:t>Auditeur</a:t>
+            </a:r>
+            <a:endParaRPr lang="en-US" sz="1400" dirty="0"/>
+          </a:p>
+        </p:txBody>
+      </p:sp>
+      <p:sp>
+        <p:nvSpPr>
+          <p:cNvPr id="15" name="Text 12"/>
+          <p:cNvSpPr txBox="1"/>
+          <p:nvPr/>
+        </p:nvSpPr>
+        <p:spPr>
+          <a:xfrm>
+            <a:off x="6821424" y="1920240"/>
+            <a:ext cx="1783080" cy="2286000"/>
+          </a:xfrm>
+          <a:prstGeom prst="rect">
+            <a:avLst/>
+          </a:prstGeom>
+          <a:noFill/>
+          <a:ln/>
+        </p:spPr>
+        <p:txBody>
+          <a:bodyPr wrap="square" lIns="0" tIns="0" rIns="0" bIns="0" rtlCol="0" anchor="t"/>
+          <a:lstStyle/>
+          <a:p>
+            <a:pPr indent="0" marL="0">
+              <a:buNone/>
+            </a:pPr>
+            <a:r>
+              <a:rPr lang="en-US" sz="1100" dirty="0">
+                <a:solidFill>
+                  <a:srgbClr val="000000"/>
+                </a:solidFill>
+                <a:latin typeface="Arial" pitchFamily="34" charset="0"/>
+                <a:ea typeface="Arial" pitchFamily="34" charset="-122"/>
+                <a:cs typeface="Arial" pitchFamily="34" charset="-120"/>
+              </a:rPr>
+              <a:t>Une commande recalcule la chaîne et rejoue le moteur. Réécriture complète : détectée seulement après ancrage.</a:t>
+            </a:r>
+            <a:endParaRPr lang="en-US" sz="1100" dirty="0"/>
+          </a:p>
+        </p:txBody>
+      </p:sp>
+      <p:sp>
+        <p:nvSpPr>
+          <p:cNvPr id="16" name="Text 13"/>
+          <p:cNvSpPr txBox="1"/>
+          <p:nvPr/>
+        </p:nvSpPr>
+        <p:spPr>
+          <a:xfrm>
+            <a:off x="457200" y="4434840"/>
+            <a:ext cx="8229600" cy="274320"/>
+          </a:xfrm>
+          <a:prstGeom prst="rect">
+            <a:avLst/>
+          </a:prstGeom>
+          <a:noFill/>
+          <a:ln/>
+        </p:spPr>
+        <p:txBody>
+          <a:bodyPr wrap="square" lIns="0" tIns="0" rIns="0" bIns="0" rtlCol="0" anchor="t"/>
+          <a:lstStyle/>
+          <a:p>
+            <a:pPr indent="0" marL="0">
+              <a:buNone/>
+            </a:pPr>
+            <a:r>
+              <a:rPr lang="en-US" sz="1100" b="1" dirty="0">
                 <a:solidFill>
                   <a:srgbClr val="595959"/>
                 </a:solidFill>
@@ -5330,9 +5500,9 @@
                 <a:ea typeface="Arial" pitchFamily="34" charset="-122"/>
                 <a:cs typeface="Arial" pitchFamily="34" charset="-120"/>
               </a:rPr>
-              <a:t>Prix non fixé. Aucun client, aucune étude de marché dans le dépôt. Qui paie côté particulier : question ouverte.</a:t>
-            </a:r>
-            <a:endParaRPr lang="en-US" sz="1400" dirty="0"/>
+              <a:t>NIST CSF 2.0 : DE.AE-02, DE.AE-07, DE.CM-09, RS.MI-01.   ATT&amp;CK : T1657, T1566, T1204.</a:t>
+            </a:r>
+            <a:endParaRPr lang="en-US" sz="1100" dirty="0"/>
           </a:p>
         </p:txBody>
       </p:sp>
@@ -5442,7 +5612,7 @@
                 <a:ea typeface="Arial" pitchFamily="34" charset="-122"/>
                 <a:cs typeface="Arial" pitchFamily="34" charset="-120"/>
               </a:rPr>
-              <a:t>Adem et Titouan</a:t>
+              <a:t>Ce qu'on ne couvre pas</a:t>
             </a:r>
             <a:endParaRPr lang="en-US" sz="3000" dirty="0"/>
           </a:p>
@@ -5457,7 +5627,7 @@
         <p:spPr>
           <a:xfrm>
             <a:off x="457200" y="1371600"/>
-            <a:ext cx="2377440" cy="914400"/>
+            <a:ext cx="4023360" cy="1371600"/>
           </a:xfrm>
           <a:prstGeom prst="rect">
             <a:avLst/>
@@ -5481,8 +5651,8 @@
         </p:nvSpPr>
         <p:spPr>
           <a:xfrm>
-            <a:off x="640080" y="1463040"/>
-            <a:ext cx="2011680" cy="365760"/>
+            <a:off x="640080" y="1481328"/>
+            <a:ext cx="3657600" cy="320040"/>
           </a:xfrm>
           <a:prstGeom prst="rect">
             <a:avLst/>
@@ -5498,7 +5668,7 @@
               <a:buNone/>
             </a:pPr>
             <a:r>
-              <a:rPr lang="en-US" sz="2000" b="1" dirty="0">
+              <a:rPr lang="en-US" sz="1600" b="1" dirty="0">
                 <a:solidFill>
                   <a:srgbClr val="000000"/>
                 </a:solidFill>
@@ -5506,9 +5676,9 @@
                 <a:ea typeface="Arial" pitchFamily="34" charset="-122"/>
                 <a:cs typeface="Arial" pitchFamily="34" charset="-120"/>
               </a:rPr>
-              <a:t>Adem</a:t>
-            </a:r>
-            <a:endParaRPr lang="en-US" sz="2000" dirty="0"/>
+              <a:t>Fraude consentie</a:t>
+            </a:r>
+            <a:endParaRPr lang="en-US" sz="1600" dirty="0"/>
           </a:p>
         </p:txBody>
       </p:sp>
@@ -5520,8 +5690,8 @@
         </p:nvSpPr>
         <p:spPr>
           <a:xfrm>
-            <a:off x="640080" y="1874520"/>
-            <a:ext cx="2011680" cy="274320"/>
+            <a:off x="640080" y="1901952"/>
+            <a:ext cx="3657600" cy="777240"/>
           </a:xfrm>
           <a:prstGeom prst="rect">
             <a:avLst/>
@@ -5539,13 +5709,13 @@
             <a:r>
               <a:rPr lang="en-US" sz="1300" dirty="0">
                 <a:solidFill>
-                  <a:srgbClr val="595959"/>
-                </a:solidFill>
-                <a:latin typeface="Arial" pitchFamily="34" charset="0"/>
-                <a:ea typeface="Arial" pitchFamily="34" charset="-122"/>
-                <a:cs typeface="Arial" pitchFamily="34" charset="-120"/>
-              </a:rPr>
-              <a:t>Responsable technique</a:t>
+                  <a:srgbClr val="000000"/>
+                </a:solidFill>
+                <a:latin typeface="Arial" pitchFamily="34" charset="0"/>
+                <a:ea typeface="Arial" pitchFamily="34" charset="-122"/>
+                <a:cs typeface="Arial" pitchFamily="34" charset="-120"/>
+              </a:rPr>
+              <a:t>Tu veux vraiment faire ce paiement. La demande correspond.</a:t>
             </a:r>
             <a:endParaRPr lang="en-US" sz="1300" dirty="0"/>
           </a:p>
@@ -5559,8 +5729,8 @@
         </p:nvSpPr>
         <p:spPr>
           <a:xfrm>
-            <a:off x="457200" y="2468880"/>
-            <a:ext cx="2377440" cy="914400"/>
+            <a:off x="4663440" y="1371600"/>
+            <a:ext cx="4023360" cy="1371600"/>
           </a:xfrm>
           <a:prstGeom prst="rect">
             <a:avLst/>
@@ -5584,8 +5754,8 @@
         </p:nvSpPr>
         <p:spPr>
           <a:xfrm>
-            <a:off x="640080" y="2560320"/>
-            <a:ext cx="2011680" cy="365760"/>
+            <a:off x="4846320" y="1481328"/>
+            <a:ext cx="3657600" cy="320040"/>
           </a:xfrm>
           <a:prstGeom prst="rect">
             <a:avLst/>
@@ -5601,7 +5771,7 @@
               <a:buNone/>
             </a:pPr>
             <a:r>
-              <a:rPr lang="en-US" sz="2000" b="1" dirty="0">
+              <a:rPr lang="en-US" sz="1600" b="1" dirty="0">
                 <a:solidFill>
                   <a:srgbClr val="000000"/>
                 </a:solidFill>
@@ -5609,9 +5779,9 @@
                 <a:ea typeface="Arial" pitchFamily="34" charset="-122"/>
                 <a:cs typeface="Arial" pitchFamily="34" charset="-120"/>
               </a:rPr>
-              <a:t>Titouan</a:t>
-            </a:r>
-            <a:endParaRPr lang="en-US" sz="2000" dirty="0"/>
+              <a:t>Intention vague</a:t>
+            </a:r>
+            <a:endParaRPr lang="en-US" sz="1600" dirty="0"/>
           </a:p>
         </p:txBody>
       </p:sp>
@@ -5623,8 +5793,8 @@
         </p:nvSpPr>
         <p:spPr>
           <a:xfrm>
-            <a:off x="640080" y="2971800"/>
-            <a:ext cx="2011680" cy="274320"/>
+            <a:off x="4846320" y="1901952"/>
+            <a:ext cx="3657600" cy="777240"/>
           </a:xfrm>
           <a:prstGeom prst="rect">
             <a:avLst/>
@@ -5642,13 +5812,13 @@
             <a:r>
               <a:rPr lang="en-US" sz="1300" dirty="0">
                 <a:solidFill>
-                  <a:srgbClr val="595959"/>
-                </a:solidFill>
-                <a:latin typeface="Arial" pitchFamily="34" charset="0"/>
-                <a:ea typeface="Arial" pitchFamily="34" charset="-122"/>
-                <a:cs typeface="Arial" pitchFamily="34" charset="-120"/>
-              </a:rPr>
-              <a:t>Ingénieur</a:t>
+                  <a:srgbClr val="000000"/>
+                </a:solidFill>
+                <a:latin typeface="Arial" pitchFamily="34" charset="0"/>
+                <a:ea typeface="Arial" pitchFamily="34" charset="-122"/>
+                <a:cs typeface="Arial" pitchFamily="34" charset="-120"/>
+              </a:rPr>
+              <a:t>« Payer » sans montant ni destinataire : une relance, puis « je n'ai pas pu vérifier ».</a:t>
             </a:r>
             <a:endParaRPr lang="en-US" sz="1300" dirty="0"/>
           </a:p>
@@ -5656,14 +5826,39 @@
       </p:sp>
       <p:sp>
         <p:nvSpPr>
-          <p:cNvPr id="10" name="Text 7"/>
+          <p:cNvPr id="10" name="Shape 7"/>
+          <p:cNvSpPr/>
+          <p:nvPr/>
+        </p:nvSpPr>
+        <p:spPr>
+          <a:xfrm>
+            <a:off x="457200" y="2926080"/>
+            <a:ext cx="4023360" cy="1371600"/>
+          </a:xfrm>
+          <a:prstGeom prst="rect">
+            <a:avLst/>
+          </a:prstGeom>
+          <a:solidFill>
+            <a:srgbClr val="F5F5F5"/>
+          </a:solidFill>
+          <a:ln w="9525">
+            <a:solidFill>
+              <a:srgbClr val="E2E2E2"/>
+            </a:solidFill>
+            <a:prstDash val="solid"/>
+          </a:ln>
+        </p:spPr>
+      </p:sp>
+      <p:sp>
+        <p:nvSpPr>
+          <p:cNvPr id="11" name="Text 8"/>
           <p:cNvSpPr txBox="1"/>
           <p:nvPr/>
         </p:nvSpPr>
         <p:spPr>
           <a:xfrm>
-            <a:off x="3200400" y="1371600"/>
-            <a:ext cx="5486400" cy="365760"/>
+            <a:off x="640080" y="3035808"/>
+            <a:ext cx="3657600" cy="320040"/>
           </a:xfrm>
           <a:prstGeom prst="rect">
             <a:avLst/>
@@ -5679,30 +5874,30 @@
               <a:buNone/>
             </a:pPr>
             <a:r>
-              <a:rPr lang="en-US" sz="1800" b="1" dirty="0">
-                <a:solidFill>
-                  <a:srgbClr val="D92D20"/>
-                </a:solidFill>
-                <a:latin typeface="Arial" pitchFamily="34" charset="0"/>
-                <a:ea typeface="Arial" pitchFamily="34" charset="-122"/>
-                <a:cs typeface="Arial" pitchFamily="34" charset="-120"/>
-              </a:rPr>
-              <a:t>Ce que nous ne faisons pas encore</a:t>
-            </a:r>
-            <a:endParaRPr lang="en-US" sz="1800" dirty="0"/>
-          </a:p>
-        </p:txBody>
-      </p:sp>
-      <p:sp>
-        <p:nvSpPr>
-          <p:cNvPr id="11" name="Text 8"/>
+              <a:rPr lang="en-US" sz="1600" b="1" dirty="0">
+                <a:solidFill>
+                  <a:srgbClr val="000000"/>
+                </a:solidFill>
+                <a:latin typeface="Arial" pitchFamily="34" charset="0"/>
+                <a:ea typeface="Arial" pitchFamily="34" charset="-122"/>
+                <a:cs typeface="Arial" pitchFamily="34" charset="-120"/>
+              </a:rPr>
+              <a:t>Contrat qui change à l’exécution</a:t>
+            </a:r>
+            <a:endParaRPr lang="en-US" sz="1600" dirty="0"/>
+          </a:p>
+        </p:txBody>
+      </p:sp>
+      <p:sp>
+        <p:nvSpPr>
+          <p:cNvPr id="12" name="Text 9"/>
           <p:cNvSpPr txBox="1"/>
           <p:nvPr/>
         </p:nvSpPr>
         <p:spPr>
           <a:xfrm>
-            <a:off x="3200400" y="1874520"/>
-            <a:ext cx="5486400" cy="1737360"/>
+            <a:off x="640080" y="3456432"/>
+            <a:ext cx="3657600" cy="777240"/>
           </a:xfrm>
           <a:prstGeom prst="rect">
             <a:avLst/>
@@ -5714,15 +5909,11 @@
           <a:bodyPr wrap="square" lIns="0" tIns="0" rIns="0" bIns="0" rtlCol="0" anchor="t"/>
           <a:lstStyle/>
           <a:p>
-            <a:pPr marL="342900" indent="-342900">
-              <a:spcAft>
-                <a:spcPts val="600"/>
-              </a:spcAft>
-              <a:buSzPct val="100000"/>
-              <a:buChar char="•"/>
-            </a:pPr>
-            <a:r>
-              <a:rPr lang="en-US" sz="1600" dirty="0">
+            <a:pPr indent="0" marL="0">
+              <a:buNone/>
+            </a:pPr>
+            <a:r>
+              <a:rPr lang="en-US" sz="1300" dirty="0">
                 <a:solidFill>
                   <a:srgbClr val="000000"/>
                 </a:solidFill>
@@ -5730,85 +5921,47 @@
                 <a:ea typeface="Arial" pitchFamily="34" charset="-122"/>
                 <a:cs typeface="Arial" pitchFamily="34" charset="-120"/>
               </a:rPr>
-              <a:t>Testé avec un vrai MetaMask</a:t>
-            </a:r>
-            <a:endParaRPr lang="en-US" sz="1600" dirty="0"/>
-          </a:p>
-          <a:p>
-            <a:pPr marL="342900" indent="-342900">
-              <a:spcAft>
-                <a:spcPts val="600"/>
-              </a:spcAft>
-              <a:buSzPct val="100000"/>
-              <a:buChar char="•"/>
-            </a:pPr>
-            <a:r>
-              <a:rPr lang="en-US" sz="1600" dirty="0">
-                <a:solidFill>
-                  <a:srgbClr val="000000"/>
-                </a:solidFill>
-                <a:latin typeface="Arial" pitchFamily="34" charset="0"/>
-                <a:ea typeface="Arial" pitchFamily="34" charset="-122"/>
-                <a:cs typeface="Arial" pitchFamily="34" charset="-120"/>
-              </a:rPr>
-              <a:t>Modèle de langage non appelé dans la version actuelle</a:t>
-            </a:r>
-            <a:endParaRPr lang="en-US" sz="1600" dirty="0"/>
-          </a:p>
-          <a:p>
-            <a:pPr marL="342900" indent="-342900">
-              <a:spcAft>
-                <a:spcPts val="600"/>
-              </a:spcAft>
-              <a:buSzPct val="100000"/>
-              <a:buChar char="•"/>
-            </a:pPr>
-            <a:r>
-              <a:rPr lang="en-US" sz="1600" dirty="0">
-                <a:solidFill>
-                  <a:srgbClr val="000000"/>
-                </a:solidFill>
-                <a:latin typeface="Arial" pitchFamily="34" charset="0"/>
-                <a:ea typeface="Arial" pitchFamily="34" charset="-122"/>
-                <a:cs typeface="Arial" pitchFamily="34" charset="-120"/>
-              </a:rPr>
-              <a:t>Ancrage Fuji non déployé</a:t>
-            </a:r>
-            <a:endParaRPr lang="en-US" sz="1600" dirty="0"/>
-          </a:p>
-          <a:p>
-            <a:pPr marL="342900" indent="-342900">
-              <a:spcAft>
-                <a:spcPts val="600"/>
-              </a:spcAft>
-              <a:buSzPct val="100000"/>
-              <a:buChar char="•"/>
-            </a:pPr>
-            <a:r>
-              <a:rPr lang="en-US" sz="1600" dirty="0">
-                <a:solidFill>
-                  <a:srgbClr val="000000"/>
-                </a:solidFill>
-                <a:latin typeface="Arial" pitchFamily="34" charset="0"/>
-                <a:ea typeface="Arial" pitchFamily="34" charset="-122"/>
-                <a:cs typeface="Arial" pitchFamily="34" charset="-120"/>
-              </a:rPr>
-              <a:t>Mesure sur de vrais utilisateurs</a:t>
-            </a:r>
-            <a:endParaRPr lang="en-US" sz="1600" dirty="0"/>
-          </a:p>
-        </p:txBody>
-      </p:sp>
-      <p:sp>
-        <p:nvSpPr>
-          <p:cNvPr id="12" name="Text 9"/>
+              <a:t>Added Protection de MetaMask le traite mieux. Nous ne le revendiquons pas.</a:t>
+            </a:r>
+            <a:endParaRPr lang="en-US" sz="1300" dirty="0"/>
+          </a:p>
+        </p:txBody>
+      </p:sp>
+      <p:sp>
+        <p:nvSpPr>
+          <p:cNvPr id="13" name="Shape 10"/>
+          <p:cNvSpPr/>
+          <p:nvPr/>
+        </p:nvSpPr>
+        <p:spPr>
+          <a:xfrm>
+            <a:off x="4663440" y="2926080"/>
+            <a:ext cx="4023360" cy="1371600"/>
+          </a:xfrm>
+          <a:prstGeom prst="rect">
+            <a:avLst/>
+          </a:prstGeom>
+          <a:solidFill>
+            <a:srgbClr val="F5F5F5"/>
+          </a:solidFill>
+          <a:ln w="9525">
+            <a:solidFill>
+              <a:srgbClr val="E2E2E2"/>
+            </a:solidFill>
+            <a:prstDash val="solid"/>
+          </a:ln>
+        </p:spPr>
+      </p:sp>
+      <p:sp>
+        <p:nvSpPr>
+          <p:cNvPr id="14" name="Text 11"/>
           <p:cNvSpPr txBox="1"/>
           <p:nvPr/>
         </p:nvSpPr>
         <p:spPr>
           <a:xfrm>
-            <a:off x="3200400" y="3840480"/>
-            <a:ext cx="5486400" cy="365760"/>
+            <a:off x="4846320" y="3035808"/>
+            <a:ext cx="3657600" cy="320040"/>
           </a:xfrm>
           <a:prstGeom prst="rect">
             <a:avLst/>
@@ -5832,9 +5985,48 @@
                 <a:ea typeface="Arial" pitchFamily="34" charset="-122"/>
                 <a:cs typeface="Arial" pitchFamily="34" charset="-120"/>
               </a:rPr>
-              <a:t>Ce qu'on vous demande : attaquez le Lab.</a:t>
+              <a:t>Ledger direct</a:t>
             </a:r>
             <a:endParaRPr lang="en-US" sz="1600" dirty="0"/>
+          </a:p>
+        </p:txBody>
+      </p:sp>
+      <p:sp>
+        <p:nvSpPr>
+          <p:cNvPr id="15" name="Text 12"/>
+          <p:cNvSpPr txBox="1"/>
+          <p:nvPr/>
+        </p:nvSpPr>
+        <p:spPr>
+          <a:xfrm>
+            <a:off x="4846320" y="3456432"/>
+            <a:ext cx="3657600" cy="777240"/>
+          </a:xfrm>
+          <a:prstGeom prst="rect">
+            <a:avLst/>
+          </a:prstGeom>
+          <a:noFill/>
+          <a:ln/>
+        </p:spPr>
+        <p:txBody>
+          <a:bodyPr wrap="square" lIns="0" tIns="0" rIns="0" bIns="0" rtlCol="0" anchor="t"/>
+          <a:lstStyle/>
+          <a:p>
+            <a:pPr indent="0" marL="0">
+              <a:buNone/>
+            </a:pPr>
+            <a:r>
+              <a:rPr lang="en-US" sz="1300" dirty="0">
+                <a:solidFill>
+                  <a:srgbClr val="000000"/>
+                </a:solidFill>
+                <a:latin typeface="Arial" pitchFamily="34" charset="0"/>
+                <a:ea typeface="Arial" pitchFamily="34" charset="-122"/>
+                <a:cs typeface="Arial" pitchFamily="34" charset="-120"/>
+              </a:rPr>
+              <a:t>Une page qui parle au matériel sans passer par le navigateur échappe à l'extension.</a:t>
+            </a:r>
+            <a:endParaRPr lang="en-US" sz="1300" dirty="0"/>
           </a:p>
         </p:txBody>
       </p:sp>
@@ -5881,6 +6073,422 @@
             <a:fld id="{F7021451-1387-4CA6-816F-3879F97B5CBC}" type="slidenum">
               <a:rPr b="0" lang="en-US"/>
               <a:t>8</a:t>
+            </a:fld>
+            <a:endParaRPr lang="en-US"/>
+          </a:p>
+        </p:txBody>
+      </p:sp>
+    </p:spTree>
+  </p:cSld>
+  <p:clrMapOvr>
+    <a:masterClrMapping/>
+  </p:clrMapOvr>
+</p:sld>
+</file>
+
+<file path=ppt/slides/slide9.xml><?xml version="1.0" encoding="utf-8"?>
+<p:sld xmlns:a="http://schemas.openxmlformats.org/drawingml/2006/main" xmlns:r="http://schemas.openxmlformats.org/officeDocument/2006/relationships" xmlns:p="http://schemas.openxmlformats.org/presentationml/2006/main">
+  <p:cSld name="Slide 9">
+    <p:spTree>
+      <p:nvGrpSpPr>
+        <p:cNvPr id="1" name=""/>
+        <p:cNvGrpSpPr/>
+        <p:nvPr/>
+      </p:nvGrpSpPr>
+      <p:grpSpPr>
+        <a:xfrm>
+          <a:off x="0" y="0"/>
+          <a:ext cx="0" cy="0"/>
+          <a:chOff x="0" y="0"/>
+          <a:chExt cx="0" cy="0"/>
+        </a:xfrm>
+      </p:grpSpPr>
+      <p:sp>
+        <p:nvSpPr>
+          <p:cNvPr id="2" name="Text 0"/>
+          <p:cNvSpPr txBox="1"/>
+          <p:nvPr/>
+        </p:nvSpPr>
+        <p:spPr>
+          <a:xfrm>
+            <a:off x="457200" y="320040"/>
+            <a:ext cx="8229600" cy="868680"/>
+          </a:xfrm>
+          <a:prstGeom prst="rect">
+            <a:avLst/>
+          </a:prstGeom>
+          <a:noFill/>
+          <a:ln/>
+        </p:spPr>
+        <p:txBody>
+          <a:bodyPr wrap="square" lIns="0" tIns="0" rIns="0" bIns="0" rtlCol="0" anchor="t"/>
+          <a:lstStyle/>
+          <a:p>
+            <a:pPr indent="0" marL="0">
+              <a:buNone/>
+            </a:pPr>
+            <a:r>
+              <a:rPr lang="en-US" sz="3000" b="1" dirty="0">
+                <a:solidFill>
+                  <a:srgbClr val="000000"/>
+                </a:solidFill>
+                <a:latin typeface="Arial" pitchFamily="34" charset="0"/>
+                <a:ea typeface="Arial" pitchFamily="34" charset="-122"/>
+                <a:cs typeface="Arial" pitchFamily="34" charset="-120"/>
+              </a:rPr>
+              <a:t>Deux ingénieurs, des limites écrites</a:t>
+            </a:r>
+            <a:endParaRPr lang="en-US" sz="3000" dirty="0"/>
+          </a:p>
+        </p:txBody>
+      </p:sp>
+      <p:sp>
+        <p:nvSpPr>
+          <p:cNvPr id="4" name="Text 1"/>
+          <p:cNvSpPr txBox="1"/>
+          <p:nvPr/>
+        </p:nvSpPr>
+        <p:spPr>
+          <a:xfrm>
+            <a:off x="457200" y="1371600"/>
+            <a:ext cx="3200400" cy="365760"/>
+          </a:xfrm>
+          <a:prstGeom prst="rect">
+            <a:avLst/>
+          </a:prstGeom>
+          <a:noFill/>
+          <a:ln/>
+        </p:spPr>
+        <p:txBody>
+          <a:bodyPr wrap="square" lIns="0" tIns="0" rIns="0" bIns="0" rtlCol="0" anchor="t"/>
+          <a:lstStyle/>
+          <a:p>
+            <a:pPr indent="0" marL="0">
+              <a:buNone/>
+            </a:pPr>
+            <a:r>
+              <a:rPr lang="en-US" sz="2000" b="1" dirty="0">
+                <a:solidFill>
+                  <a:srgbClr val="000000"/>
+                </a:solidFill>
+                <a:latin typeface="Arial" pitchFamily="34" charset="0"/>
+                <a:ea typeface="Arial" pitchFamily="34" charset="-122"/>
+                <a:cs typeface="Arial" pitchFamily="34" charset="-120"/>
+              </a:rPr>
+              <a:t>Adem et Titouan</a:t>
+            </a:r>
+            <a:endParaRPr lang="en-US" sz="2000" dirty="0"/>
+          </a:p>
+        </p:txBody>
+      </p:sp>
+      <p:sp>
+        <p:nvSpPr>
+          <p:cNvPr id="5" name="Text 2"/>
+          <p:cNvSpPr txBox="1"/>
+          <p:nvPr/>
+        </p:nvSpPr>
+        <p:spPr>
+          <a:xfrm>
+            <a:off x="457200" y="1920240"/>
+            <a:ext cx="3200400" cy="1371600"/>
+          </a:xfrm>
+          <a:prstGeom prst="rect">
+            <a:avLst/>
+          </a:prstGeom>
+          <a:noFill/>
+          <a:ln/>
+        </p:spPr>
+        <p:txBody>
+          <a:bodyPr wrap="square" lIns="0" tIns="0" rIns="0" bIns="0" rtlCol="0" anchor="t"/>
+          <a:lstStyle/>
+          <a:p>
+            <a:pPr indent="0" marL="0">
+              <a:buNone/>
+            </a:pPr>
+            <a:r>
+              <a:rPr lang="en-US" sz="1500" dirty="0">
+                <a:solidFill>
+                  <a:srgbClr val="000000"/>
+                </a:solidFill>
+                <a:latin typeface="Arial" pitchFamily="34" charset="0"/>
+                <a:ea typeface="Arial" pitchFamily="34" charset="-122"/>
+                <a:cs typeface="Arial" pitchFamily="34" charset="-120"/>
+              </a:rPr>
+              <a:t>Gratuit pour les personnes, des partenaires ensuite. Pas de prix fixé, pas de client.</a:t>
+            </a:r>
+            <a:endParaRPr lang="en-US" sz="1500" dirty="0"/>
+          </a:p>
+        </p:txBody>
+      </p:sp>
+      <p:sp>
+        <p:nvSpPr>
+          <p:cNvPr id="6" name="Text 3"/>
+          <p:cNvSpPr txBox="1"/>
+          <p:nvPr/>
+        </p:nvSpPr>
+        <p:spPr>
+          <a:xfrm>
+            <a:off x="4023360" y="1371600"/>
+            <a:ext cx="4572000" cy="365760"/>
+          </a:xfrm>
+          <a:prstGeom prst="rect">
+            <a:avLst/>
+          </a:prstGeom>
+          <a:noFill/>
+          <a:ln/>
+        </p:spPr>
+        <p:txBody>
+          <a:bodyPr wrap="square" lIns="0" tIns="0" rIns="0" bIns="0" rtlCol="0" anchor="t"/>
+          <a:lstStyle/>
+          <a:p>
+            <a:pPr indent="0" marL="0">
+              <a:buNone/>
+            </a:pPr>
+            <a:r>
+              <a:rPr lang="en-US" sz="1800" b="1" dirty="0">
+                <a:solidFill>
+                  <a:srgbClr val="D92D20"/>
+                </a:solidFill>
+                <a:latin typeface="Arial" pitchFamily="34" charset="0"/>
+                <a:ea typeface="Arial" pitchFamily="34" charset="-122"/>
+                <a:cs typeface="Arial" pitchFamily="34" charset="-120"/>
+              </a:rPr>
+              <a:t>Pas encore fait</a:t>
+            </a:r>
+            <a:endParaRPr lang="en-US" sz="1800" dirty="0"/>
+          </a:p>
+        </p:txBody>
+      </p:sp>
+      <p:sp>
+        <p:nvSpPr>
+          <p:cNvPr id="7" name="Text 4"/>
+          <p:cNvSpPr txBox="1"/>
+          <p:nvPr/>
+        </p:nvSpPr>
+        <p:spPr>
+          <a:xfrm>
+            <a:off x="4023360" y="1874520"/>
+            <a:ext cx="4572000" cy="2103120"/>
+          </a:xfrm>
+          <a:prstGeom prst="rect">
+            <a:avLst/>
+          </a:prstGeom>
+          <a:noFill/>
+          <a:ln/>
+        </p:spPr>
+        <p:txBody>
+          <a:bodyPr wrap="square" lIns="0" tIns="0" rIns="0" bIns="0" rtlCol="0" anchor="t"/>
+          <a:lstStyle/>
+          <a:p>
+            <a:pPr marL="342900" indent="-342900">
+              <a:spcAft>
+                <a:spcPts val="500"/>
+              </a:spcAft>
+              <a:buSzPct val="100000"/>
+              <a:buChar char="•"/>
+            </a:pPr>
+            <a:r>
+              <a:rPr lang="en-US" sz="1500" dirty="0">
+                <a:solidFill>
+                  <a:srgbClr val="000000"/>
+                </a:solidFill>
+                <a:latin typeface="Arial" pitchFamily="34" charset="0"/>
+                <a:ea typeface="Arial" pitchFamily="34" charset="-122"/>
+                <a:cs typeface="Arial" pitchFamily="34" charset="-120"/>
+              </a:rPr>
+              <a:t>Essai avec un vrai portefeuille</a:t>
+            </a:r>
+            <a:endParaRPr lang="en-US" sz="1500" dirty="0"/>
+          </a:p>
+          <a:p>
+            <a:pPr marL="342900" indent="-342900">
+              <a:spcAft>
+                <a:spcPts val="500"/>
+              </a:spcAft>
+              <a:buSzPct val="100000"/>
+              <a:buChar char="•"/>
+            </a:pPr>
+            <a:r>
+              <a:rPr lang="en-US" sz="1500" dirty="0">
+                <a:solidFill>
+                  <a:srgbClr val="000000"/>
+                </a:solidFill>
+                <a:latin typeface="Arial" pitchFamily="34" charset="0"/>
+                <a:ea typeface="Arial" pitchFamily="34" charset="-122"/>
+                <a:cs typeface="Arial" pitchFamily="34" charset="-120"/>
+              </a:rPr>
+              <a:t>Jeu aveugle de 250 cas</a:t>
+            </a:r>
+            <a:endParaRPr lang="en-US" sz="1500" dirty="0"/>
+          </a:p>
+          <a:p>
+            <a:pPr marL="342900" indent="-342900">
+              <a:spcAft>
+                <a:spcPts val="500"/>
+              </a:spcAft>
+              <a:buSzPct val="100000"/>
+              <a:buChar char="•"/>
+            </a:pPr>
+            <a:r>
+              <a:rPr lang="en-US" sz="1500" dirty="0">
+                <a:solidFill>
+                  <a:srgbClr val="000000"/>
+                </a:solidFill>
+                <a:latin typeface="Arial" pitchFamily="34" charset="0"/>
+                <a:ea typeface="Arial" pitchFamily="34" charset="-122"/>
+                <a:cs typeface="Arial" pitchFamily="34" charset="-120"/>
+              </a:rPr>
+              <a:t>Grille de 1 500 paires</a:t>
+            </a:r>
+            <a:endParaRPr lang="en-US" sz="1500" dirty="0"/>
+          </a:p>
+          <a:p>
+            <a:pPr marL="342900" indent="-342900">
+              <a:spcAft>
+                <a:spcPts val="500"/>
+              </a:spcAft>
+              <a:buSzPct val="100000"/>
+              <a:buChar char="•"/>
+            </a:pPr>
+            <a:r>
+              <a:rPr lang="en-US" sz="1500" dirty="0">
+                <a:solidFill>
+                  <a:srgbClr val="000000"/>
+                </a:solidFill>
+                <a:latin typeface="Arial" pitchFamily="34" charset="0"/>
+                <a:ea typeface="Arial" pitchFamily="34" charset="-122"/>
+                <a:cs typeface="Arial" pitchFamily="34" charset="-120"/>
+              </a:rPr>
+              <a:t>Mesure de Clef sur la comparaison</a:t>
+            </a:r>
+            <a:endParaRPr lang="en-US" sz="1500" dirty="0"/>
+          </a:p>
+          <a:p>
+            <a:pPr marL="342900" indent="-342900">
+              <a:spcAft>
+                <a:spcPts val="500"/>
+              </a:spcAft>
+              <a:buSzPct val="100000"/>
+              <a:buChar char="•"/>
+            </a:pPr>
+            <a:r>
+              <a:rPr lang="en-US" sz="1500" dirty="0">
+                <a:solidFill>
+                  <a:srgbClr val="000000"/>
+                </a:solidFill>
+                <a:latin typeface="Arial" pitchFamily="34" charset="0"/>
+                <a:ea typeface="Arial" pitchFamily="34" charset="-122"/>
+                <a:cs typeface="Arial" pitchFamily="34" charset="-120"/>
+              </a:rPr>
+              <a:t>Test avec de vraies personnes</a:t>
+            </a:r>
+            <a:endParaRPr lang="en-US" sz="1500" dirty="0"/>
+          </a:p>
+          <a:p>
+            <a:pPr marL="342900" indent="-342900">
+              <a:spcAft>
+                <a:spcPts val="500"/>
+              </a:spcAft>
+              <a:buSzPct val="100000"/>
+              <a:buChar char="•"/>
+            </a:pPr>
+            <a:r>
+              <a:rPr lang="en-US" sz="1500" dirty="0">
+                <a:solidFill>
+                  <a:srgbClr val="000000"/>
+                </a:solidFill>
+                <a:latin typeface="Arial" pitchFamily="34" charset="0"/>
+                <a:ea typeface="Arial" pitchFamily="34" charset="-122"/>
+                <a:cs typeface="Arial" pitchFamily="34" charset="-120"/>
+              </a:rPr>
+              <a:t>Ancrage sur Fuji</a:t>
+            </a:r>
+            <a:endParaRPr lang="en-US" sz="1500" dirty="0"/>
+          </a:p>
+        </p:txBody>
+      </p:sp>
+      <p:sp>
+        <p:nvSpPr>
+          <p:cNvPr id="8" name="Text 5"/>
+          <p:cNvSpPr txBox="1"/>
+          <p:nvPr/>
+        </p:nvSpPr>
+        <p:spPr>
+          <a:xfrm>
+            <a:off x="457200" y="4114800"/>
+            <a:ext cx="8229600" cy="365760"/>
+          </a:xfrm>
+          <a:prstGeom prst="rect">
+            <a:avLst/>
+          </a:prstGeom>
+          <a:noFill/>
+          <a:ln/>
+        </p:spPr>
+        <p:txBody>
+          <a:bodyPr wrap="square" lIns="0" tIns="0" rIns="0" bIns="0" rtlCol="0" anchor="t"/>
+          <a:lstStyle/>
+          <a:p>
+            <a:pPr indent="0" marL="0">
+              <a:buNone/>
+            </a:pPr>
+            <a:r>
+              <a:rPr lang="en-US" sz="1600" b="1" dirty="0">
+                <a:solidFill>
+                  <a:srgbClr val="000000"/>
+                </a:solidFill>
+                <a:latin typeface="Arial" pitchFamily="34" charset="0"/>
+                <a:ea typeface="Arial" pitchFamily="34" charset="-122"/>
+                <a:cs typeface="Arial" pitchFamily="34" charset="-120"/>
+              </a:rPr>
+              <a:t>Ce qu'on vous demande : écrivez votre phrase, attaquez-nous.</a:t>
+            </a:r>
+            <a:endParaRPr lang="en-US" sz="1600" dirty="0"/>
+          </a:p>
+        </p:txBody>
+      </p:sp>
+      <p:sp>
+        <p:nvSpPr>
+          <p:cNvPr id="25" name="Slide Number Placeholder 0"/>
+          <p:cNvSpPr>
+            <a:spLocks noGrp="1"/>
+          </p:cNvSpPr>
+          <p:nvPr>
+            <p:ph type="sldNum" sz="quarter" idx="4294967295"/>
+          </p:nvPr>
+        </p:nvSpPr>
+        <p:spPr>
+          <a:xfrm>
+            <a:off x="8229600" y="4754880"/>
+            <a:ext cx="457200" cy="228600"/>
+          </a:xfrm>
+          <a:prstGeom prst="rect">
+            <a:avLst/>
+          </a:prstGeom>
+          <a:extLst>
+            <a:ext uri="{C572A759-6A51-4108-AA02-DFA0A04FC94B}">
+              <ma14:wrappingTextBoxFlag xmlns:ma14="http://schemas.microsoft.com/office/mac/drawingml/2011/main" val="0"/>
+            </a:ext>
+          </a:extLst>
+        </p:spPr>
+        <p:txBody>
+          <a:bodyPr/>
+          <a:lstStyle>
+            <a:lvl1pPr>
+              <a:defRPr sz="1000">
+                <a:solidFill>
+                  <a:srgbClr val="595959"/>
+                </a:solidFill>
+                <a:latin typeface="Arial"/>
+                <a:ea typeface="Arial"/>
+                <a:cs typeface="Arial"/>
+              </a:defRPr>
+            </a:lvl1pPr>
+          </a:lstStyle>
+          <a:p>
+            <a:pPr algn="l"/>
+            <a:fld id="{F7021451-1387-4CA6-816F-3879F97B5CBC}" type="slidenum">
+              <a:rPr b="0" lang="en-US"/>
+              <a:t>9</a:t>
             </a:fld>
             <a:endParaRPr lang="en-US"/>
           </a:p>

</xml_diff>

<commit_message>
Sprint: etat intermediaire (agents en cours)
Co-Authored-By: Claude Sonnet 5.5 <noreply@anthropic.com>
</commit_message>
<xml_diff>
--- a/livrables/deck/holdup.pptx
+++ b/livrables/deck/holdup.pptx
@@ -510,7 +510,7 @@
           <a:p>
             <a:r>
               <a:rPr lang="en-US" dirty="0"/>
-              <a:t>Le site lui demande un droit sur tout son USDC. En 2025, 106 106 adresses ont perdu 83,85 millions de dollars en signant sur un site de phishing. Chiffre d'un éditeur (ScamSniffer), chaînes EVM, borne basse. Aucun chiffre propre à Avalanche. Source : livrables/CHIFFRES.md B3.</a:t>
+              <a:t>Ce jour-là, on perd ce qu'on lui a laissé le droit de prendre. Exemple : je veux échanger 50 USDC, le site me demande un droit sur tout mon USDC. En 2025, selon ScamSniffer (éditeur, chaînes EVM, borne basse), 83,85 millions de dollars ont été perdus par 106 106 victimes en signant sur un site de phishing. Dans un échantillon de blocs lus par nous (mesure interne, non représentative), 47,6 % des droits de dépense sont illimités sur Ethereum et 34,2 % sur Avalanche. Ce n'est pas la majorité. Aucun chiffre propre à Avalanche pour les pertes. Sources : livrables/CHIFFRES.md B1, B3.</a:t>
             </a:r>
             <a:endParaRPr lang="en-US" dirty="0"/>
           </a:p>
@@ -598,7 +598,7 @@
           <a:p>
             <a:r>
               <a:rPr lang="en-US" dirty="0"/>
-              <a:t>L'utilisateur écrit ce qu'il veut faire avant de voir la demande. Montant, jeton et adresse sont lus par du code. Le modèle Clef lit la phrase. Correspond : le portefeuille s'ouvre seul après une seconde. Ne correspond pas : alerte, Annuler visible. Pas pu vérifier : on le dit. Les signaux que le portefeuille donne déjà sont gardés. MetaMask affiche illimité sans alerte et ne sait ni combien tu voulais donner ni à qui, d'après son code public lu le 11 oct. 2026, pour une adresse non listée comme malveillante.</a:t>
+              <a:t>Hold up n'est pas un portefeuille : il ne tient aucune clé et ne signe rien. Il est pensé pour se poser devant le portefeuille existant (jamais essayé avec un vrai MetaMask, Core ou Rabby). Étage 1 : la personne écrit ce qu'elle veut faire avant de voir la demande, du code lit montant, jeton et adresse et compare. Correspond : le portefeuille s'ouvre seul après une seconde. Ne correspond pas : alerte, Annuler visible. Pas pu vérifier : on le dit. Étage 2 : un plancher de règles qui ne dépend pas de la phrase (droit illimité vers une adresse inconnue, appel délégué, changement de contrôle, signature illisible). D'après le code public de MetaMask lu le 11 oct. 2026, le montant illimité est affiché sans alerte propre à ce montant, pour une adresse non listée comme malveillante. Principe : Hold up ne lui laisse que ce que tu as écrit vouloir faire (un principe, pas une garantie : pour une signature, il alerte, la personne décide).</a:t>
             </a:r>
             <a:endParaRPr lang="en-US" dirty="0"/>
           </a:p>
@@ -686,7 +686,7 @@
           <a:p>
             <a:r>
               <a:rPr lang="en-US" dirty="0"/>
-              <a:t>Bybit, février 2025 : l'interface affichait une transaction légitime, une autre charge allait aux signataires (analyses NCC Group, BlockSec, Check Point, Cyfrin). Notre scène est synthétique, adresses factices, rejeu du moteur sans portefeuille (demo_typologie/safe_signataire.mjs). Elle montre le décodage, pas l'attaque de bout en bout. Une extension ne voit que ce qui passe par window.ethereum : si la page parle au matériel en direct, elle ne voit rien. Les analyses publiques ne confirment pas ce qu'affichait l'écran du matériel : ne pas l'affirmer.</a:t>
+              <a:t>Bybit, février 2025 : l'interface affichait une transaction légitime, une autre charge allait aux signataires (analyses NCC Group, BlockSec, Check Point, Cyfrin). Notre scène est synthétique, adresses factices, rejeu du moteur sans portefeuille (demo_typologie/safe_signataire.mjs). Elle montre le décodage et le plancher de règles (danger même sans phrase), pas l'attaque de bout en bout. Une extension ne voit que ce qui passe par window.ethereum : si la page parle au matériel en direct, elle ne voit rien. Les analyses publiques ne confirment pas ce qu'affichait l'écran du matériel : ne pas l'affirmer.</a:t>
             </a:r>
             <a:endParaRPr lang="en-US" dirty="0"/>
           </a:p>
@@ -862,7 +862,7 @@
           <a:p>
             <a:r>
               <a:rPr lang="en-US" dirty="0"/>
-              <a:t>Tout vient de cas écrits par nous, jeux de réglage. Le 228 sur 228 est un test de couverture. Le jeu aveugle (250 cas, hash publié) n'est pas passé. La grille de 1 500 paires est en cours. Clef n'est pas mesuré par nous (pas de clé). Latence locale : médiane 18,39 ms, p95 34,08 ms. Source : livrables/CHIFFRES.md A3, A4, A5, A6, A9.</a:t>
+              <a:t>Cas écrits par nous : 228 sur 228, test de couverture. Contrôle scellé de la grille (1 079 paires, sha256 publié, une seule mesure par bras) : même auteur pour les phrases et les règles, un seul modèle (Clef-flash), un contexte par famille. Code seul : 86,6 % attrapés, 7,7 % de fausses alertes. Un modèle classe puis le code compare : 86,6 % et 1,3 %, plus prudent pas plus sûr. Modèle juge seul : 64,4 %, non retenu. Produit, banc synthétique : rappel rouge 71,3 %, 13,9 % de rouges sur honnêtes, 54,2 % d'honnêtes avec avertissement. Avalanche réel : 19 rouges sur 6 325 (0,30 %), 76,84 % d'avertissements, légitime présumé, blocs aléatoires avec robots. Ne jamais citer 0,30 % sans 76,84 %. Jeu aveugle (autre auteur, hash publié) pas passé. Sources : livrables/CHIFFRES.md A4, A5, A6, A11, A12, A13, B11.</a:t>
             </a:r>
             <a:endParaRPr lang="en-US" dirty="0"/>
           </a:p>
@@ -950,7 +950,7 @@
           <a:p>
             <a:r>
               <a:rPr lang="en-US" dirty="0"/>
-              <a:t>Annuler est toujours visible. Transaction : la ligne dit comment ramener le droit au montant écrit (correction automatique : décision Q17, en cours, non vérifiée). Signature : le droit ne peut pas être limité, on le dit. Durée de retenue : non tranchée (Q16), ne pas citer de durée. Journal chaîné par hachage, fiche d'incident sur demande, retrait de droits testé sur chaîne locale.</a:t>
+              <a:t>Annuler est toujours visible. Transaction (approve, increaseAllowance) : sous conditions, Hold up remplace lui-même le droit trop large par le montant écrit avant le portefeuille (ligne « Droit limité à 50 USDC », Q17 : prouvé en Node, pas dans un vrai Chrome) ; sinon la ligne dit comment le ramener. Sur cet écart précis, plus d'attente de 30 s (Q16) ; dans les autres cas, ne pas citer de durée de retenue. Signature : le droit ne peut pas être limité, on le dit. Journal local de 500 lignes dans la version autonome ; chaîné par hachage dans la version serveur. Fiche d'incident sur demande, retrait de droits testé sur chaîne locale.</a:t>
             </a:r>
             <a:endParaRPr lang="en-US" dirty="0"/>
           </a:p>
@@ -1214,7 +1214,7 @@
           <a:p>
             <a:r>
               <a:rPr lang="en-US" dirty="0"/>
-              <a:t>Gratuit pour les personnes, des partenaires ensuite, sans prix fixé ni client. Harpie et Wallet Guard ont fermé en mars 2025 : le modèle reste une question ouverte. Pas de biographie. Ce qu'on demande : un test avec un vrai portefeuille et un jeu de cas écrit par quelqu'un d'autre.</a:t>
+              <a:t>Gratuit pour les personnes, des partenaires ensuite, sans prix fixé ni client. Harpie et Wallet Guard ont fermé en mars 2025 : le modèle reste une question ouverte. Pas de biographie. Ce qu'on demande : un test avec un vrai portefeuille et un jeu de cas écrit par quelqu'un d'autre. Une revue de sécurité interne a trouvé des contournements possibles dont un critique : corrections en cours, ne pas dire sécurisé.</a:t>
             </a:r>
             <a:endParaRPr lang="en-US" dirty="0"/>
           </a:p>
@@ -1781,7 +1781,7 @@
                 <a:ea typeface="Arial" pitchFamily="34" charset="-122"/>
                 <a:cs typeface="Arial" pitchFamily="34" charset="-120"/>
               </a:rPr>
-              <a:t>Camille veut échanger 50 USDC</a:t>
+              <a:t>Tout service peut être compromis</a:t>
             </a:r>
             <a:endParaRPr lang="en-US" sz="3000" dirty="0"/>
           </a:p>
@@ -1923,7 +1923,7 @@
                 <a:ea typeface="Arial" pitchFamily="34" charset="-122"/>
                 <a:cs typeface="Arial" pitchFamily="34" charset="-120"/>
               </a:rPr>
-              <a:t>Étape 1 : autoriser le routeur à dépenser votre USDC.</a:t>
+              <a:t>Étape 1 : autoriser le routeur à dépenser votre USDC (illimité).</a:t>
             </a:r>
             <a:endParaRPr lang="en-US" sz="1400" dirty="0"/>
           </a:p>
@@ -2003,8 +2003,8 @@
         </p:nvSpPr>
         <p:spPr>
           <a:xfrm>
-            <a:off x="4846320" y="1463040"/>
-            <a:ext cx="3840480" cy="914400"/>
+            <a:off x="4846320" y="1371600"/>
+            <a:ext cx="3840480" cy="822960"/>
           </a:xfrm>
           <a:prstGeom prst="rect">
             <a:avLst/>
@@ -2020,7 +2020,7 @@
               <a:buNone/>
             </a:pPr>
             <a:r>
-              <a:rPr lang="en-US" sz="5400" b="1" dirty="0">
+              <a:rPr lang="en-US" sz="4800" b="1" dirty="0">
                 <a:solidFill>
                   <a:srgbClr val="D92D20"/>
                 </a:solidFill>
@@ -2030,7 +2030,7 @@
               </a:rPr>
               <a:t>83,85 M$</a:t>
             </a:r>
-            <a:endParaRPr lang="en-US" sz="5400" dirty="0"/>
+            <a:endParaRPr lang="en-US" sz="4800" dirty="0"/>
           </a:p>
         </p:txBody>
       </p:sp>
@@ -2042,8 +2042,8 @@
         </p:nvSpPr>
         <p:spPr>
           <a:xfrm>
-            <a:off x="4846320" y="2468880"/>
-            <a:ext cx="3840480" cy="822960"/>
+            <a:off x="4846320" y="2194560"/>
+            <a:ext cx="3840480" cy="731520"/>
           </a:xfrm>
           <a:prstGeom prst="rect">
             <a:avLst/>
@@ -2059,7 +2059,7 @@
               <a:buNone/>
             </a:pPr>
             <a:r>
-              <a:rPr lang="en-US" sz="1600" dirty="0">
+              <a:rPr lang="en-US" sz="1400" dirty="0">
                 <a:solidFill>
                   <a:srgbClr val="000000"/>
                 </a:solidFill>
@@ -2067,9 +2067,9 @@
                 <a:ea typeface="Arial" pitchFamily="34" charset="-122"/>
                 <a:cs typeface="Arial" pitchFamily="34" charset="-120"/>
               </a:rPr>
-              <a:t>perdus par 106 106 adresses en 2025 en signant sur un site de phishing</a:t>
-            </a:r>
-            <a:endParaRPr lang="en-US" sz="1600" dirty="0"/>
+              <a:t>perdus par 106 106 victimes en 2025 en signant sur un site de phishing (ScamSniffer, EVM, borne basse)</a:t>
+            </a:r>
+            <a:endParaRPr lang="en-US" sz="1400" dirty="0"/>
           </a:p>
         </p:txBody>
       </p:sp>
@@ -2081,8 +2081,8 @@
         </p:nvSpPr>
         <p:spPr>
           <a:xfrm>
-            <a:off x="4846320" y="3474720"/>
-            <a:ext cx="3840480" cy="640080"/>
+            <a:off x="4846320" y="3108960"/>
+            <a:ext cx="3840480" cy="365760"/>
           </a:xfrm>
           <a:prstGeom prst="rect">
             <a:avLst/>
@@ -2098,7 +2098,46 @@
               <a:buNone/>
             </a:pPr>
             <a:r>
-              <a:rPr lang="en-US" sz="1300" dirty="0">
+              <a:rPr lang="en-US" sz="1600" b="1" dirty="0">
+                <a:solidFill>
+                  <a:srgbClr val="000000"/>
+                </a:solidFill>
+                <a:latin typeface="Arial" pitchFamily="34" charset="0"/>
+                <a:ea typeface="Arial" pitchFamily="34" charset="-122"/>
+                <a:cs typeface="Arial" pitchFamily="34" charset="-120"/>
+              </a:rPr>
+              <a:t>47,6 % Ethereum  |  34,2 % Avalanche</a:t>
+            </a:r>
+            <a:endParaRPr lang="en-US" sz="1600" dirty="0"/>
+          </a:p>
+        </p:txBody>
+      </p:sp>
+      <p:sp>
+        <p:nvSpPr>
+          <p:cNvPr id="13" name="Text 10"/>
+          <p:cNvSpPr txBox="1"/>
+          <p:nvPr/>
+        </p:nvSpPr>
+        <p:spPr>
+          <a:xfrm>
+            <a:off x="4846320" y="3520440"/>
+            <a:ext cx="3840480" cy="731520"/>
+          </a:xfrm>
+          <a:prstGeom prst="rect">
+            <a:avLst/>
+          </a:prstGeom>
+          <a:noFill/>
+          <a:ln/>
+        </p:spPr>
+        <p:txBody>
+          <a:bodyPr wrap="square" lIns="0" tIns="0" rIns="0" bIns="0" rtlCol="0" anchor="t"/>
+          <a:lstStyle/>
+          <a:p>
+            <a:pPr indent="0" marL="0">
+              <a:buNone/>
+            </a:pPr>
+            <a:r>
+              <a:rPr lang="en-US" sz="1200" dirty="0">
                 <a:solidFill>
                   <a:srgbClr val="595959"/>
                 </a:solidFill>
@@ -2106,9 +2145,9 @@
                 <a:ea typeface="Arial" pitchFamily="34" charset="-122"/>
                 <a:cs typeface="Arial" pitchFamily="34" charset="-120"/>
               </a:rPr>
-              <a:t>Chiffre ScamSniffer (éditeur), chaînes EVM, borne basse.</a:t>
-            </a:r>
-            <a:endParaRPr lang="en-US" sz="1300" dirty="0"/>
+              <a:t>des droits de dépense lus dans nos échantillons de blocs sont illimités. Mesure interne, non représentative.</a:t>
+            </a:r>
+            <a:endParaRPr lang="en-US" sz="1200" dirty="0"/>
           </a:p>
         </p:txBody>
       </p:sp>
@@ -2218,7 +2257,7 @@
                 <a:ea typeface="Arial" pitchFamily="34" charset="-122"/>
                 <a:cs typeface="Arial" pitchFamily="34" charset="-120"/>
               </a:rPr>
-              <a:t>Tu écris. Hold up compare.</a:t>
+              <a:t>Une couche indépendante, deux étages</a:t>
             </a:r>
             <a:endParaRPr lang="en-US" sz="3000" dirty="0"/>
           </a:p>
@@ -2541,8 +2580,8 @@
         </p:nvSpPr>
         <p:spPr>
           <a:xfrm>
-            <a:off x="457200" y="2834640"/>
-            <a:ext cx="8229600" cy="1371600"/>
+            <a:off x="457200" y="2743200"/>
+            <a:ext cx="8229600" cy="1554480"/>
           </a:xfrm>
           <a:prstGeom prst="rect">
             <a:avLst/>
@@ -2562,7 +2601,7 @@
               <a:buChar char="•"/>
             </a:pPr>
             <a:r>
-              <a:rPr lang="en-US" sz="1500" dirty="0">
+              <a:rPr lang="en-US" sz="1400" dirty="0">
                 <a:solidFill>
                   <a:srgbClr val="000000"/>
                 </a:solidFill>
@@ -2570,9 +2609,9 @@
                 <a:ea typeface="Arial" pitchFamily="34" charset="-122"/>
                 <a:cs typeface="Arial" pitchFamily="34" charset="-120"/>
               </a:rPr>
-              <a:t>Ça correspond : le portefeuille s’ouvre seul après une seconde.</a:t>
-            </a:r>
-            <a:endParaRPr lang="en-US" sz="1500" dirty="0"/>
+              <a:t>Étage 1 : ce que tu as écrit contre ce que la demande fait. Correspond : le portefeuille s’ouvre seul après une seconde.</a:t>
+            </a:r>
+            <a:endParaRPr lang="en-US" sz="1400" dirty="0"/>
           </a:p>
           <a:p>
             <a:pPr marL="342900" indent="-342900">
@@ -2583,7 +2622,7 @@
               <a:buChar char="•"/>
             </a:pPr>
             <a:r>
-              <a:rPr lang="en-US" sz="1500" dirty="0">
+              <a:rPr lang="en-US" sz="1400" dirty="0">
                 <a:solidFill>
                   <a:srgbClr val="000000"/>
                 </a:solidFill>
@@ -2591,9 +2630,9 @@
                 <a:ea typeface="Arial" pitchFamily="34" charset="-122"/>
                 <a:cs typeface="Arial" pitchFamily="34" charset="-120"/>
               </a:rPr>
-              <a:t>Ça ne correspond pas : alerte, Annuler visible.</a:t>
-            </a:r>
-            <a:endParaRPr lang="en-US" sz="1500" dirty="0"/>
+              <a:t>Étage 2 : un plancher de règles, même sans phrase. Droit illimité vers une adresse inconnue, appel délégué, signature illisible.</a:t>
+            </a:r>
+            <a:endParaRPr lang="en-US" sz="1400" dirty="0"/>
           </a:p>
           <a:p>
             <a:pPr marL="342900" indent="-342900">
@@ -2604,7 +2643,7 @@
               <a:buChar char="•"/>
             </a:pPr>
             <a:r>
-              <a:rPr lang="en-US" sz="1500" dirty="0">
+              <a:rPr lang="en-US" sz="1400" dirty="0">
                 <a:solidFill>
                   <a:srgbClr val="000000"/>
                 </a:solidFill>
@@ -2612,9 +2651,9 @@
                 <a:ea typeface="Arial" pitchFamily="34" charset="-122"/>
                 <a:cs typeface="Arial" pitchFamily="34" charset="-120"/>
               </a:rPr>
-              <a:t>Pas pu vérifier : la fenêtre le dit, jamais « correspond » par défaut.</a:t>
-            </a:r>
-            <a:endParaRPr lang="en-US" sz="1500" dirty="0"/>
+              <a:t>Pas pu vérifier : la fenêtre le dit, jamais « correspond » par défaut. Annuler reste visible.</a:t>
+            </a:r>
+            <a:endParaRPr lang="en-US" sz="1400" dirty="0"/>
           </a:p>
         </p:txBody>
       </p:sp>
@@ -2626,7 +2665,7 @@
         </p:nvSpPr>
         <p:spPr>
           <a:xfrm>
-            <a:off x="457200" y="4343400"/>
+            <a:off x="457200" y="4389120"/>
             <a:ext cx="8229600" cy="274320"/>
           </a:xfrm>
           <a:prstGeom prst="rect">
@@ -2651,7 +2690,7 @@
                 <a:ea typeface="Arial" pitchFamily="34" charset="-122"/>
                 <a:cs typeface="Arial" pitchFamily="34" charset="-120"/>
               </a:rPr>
-              <a:t>On garde aussi les signaux que le portefeuille donne déjà.</a:t>
+              <a:t>Pas un portefeuille : aucune clé, rien signé. Les signaux du portefeuille restent.</a:t>
             </a:r>
             <a:endParaRPr lang="en-US" sz="1200" dirty="0"/>
           </a:p>
@@ -3537,7 +3576,7 @@
           </p:nvPr>
         </p:nvGraphicFramePr>
         <p:xfrm>
-          <a:off x="457200" y="1371600"/>
+          <a:off x="457200" y="1280160"/>
           <a:ext cx="8229600" cy="914400"/>
         </p:xfrm>
         <a:graphic>
@@ -3545,11 +3584,11 @@
             <a:tbl>
               <a:tblPr/>
               <a:tblGrid>
-                <a:gridCol w="2743200"/>
-                <a:gridCol w="3291840"/>
-                <a:gridCol w="2194560"/>
+                <a:gridCol w="2834640"/>
+                <a:gridCol w="3383280"/>
+                <a:gridCol w="2011680"/>
               </a:tblGrid>
-              <a:tr h="320040">
+              <a:tr h="292608">
                 <a:tc>
                   <a:txBody>
                     <a:bodyPr/>
@@ -3559,7 +3598,7 @@
                         <a:buNone/>
                       </a:pPr>
                       <a:r>
-                        <a:rPr lang="en-US" sz="1200" b="1" dirty="0">
+                        <a:rPr lang="en-US" sz="1100" b="1" dirty="0">
                           <a:solidFill>
                             <a:srgbClr val="FFFFFF"/>
                           </a:solidFill>
@@ -3567,9 +3606,9 @@
                           <a:ea typeface="Arial" pitchFamily="34" charset="-122"/>
                           <a:cs typeface="Arial" pitchFamily="34" charset="-120"/>
                         </a:rPr>
-                        <a:t>Synthétique (cas écrits par nous)</a:t>
+                        <a:t>Jeu et statut</a:t>
                       </a:r>
-                      <a:endParaRPr lang="en-US" sz="1200" dirty="0">
+                      <a:endParaRPr lang="en-US" sz="1100" dirty="0">
                         <a:latin typeface="Arial" charset="0"/>
                         <a:ea typeface="Arial" charset="0"/>
                         <a:cs typeface="Arial" charset="0"/>
@@ -3627,7 +3666,7 @@
                         <a:buNone/>
                       </a:pPr>
                       <a:r>
-                        <a:rPr lang="en-US" sz="1200" b="1" dirty="0">
+                        <a:rPr lang="en-US" sz="1100" b="1" dirty="0">
                           <a:solidFill>
                             <a:srgbClr val="FFFFFF"/>
                           </a:solidFill>
@@ -3637,7 +3676,7 @@
                         </a:rPr>
                         <a:t>Résultat</a:t>
                       </a:r>
-                      <a:endParaRPr lang="en-US" sz="1200" dirty="0">
+                      <a:endParaRPr lang="en-US" sz="1100" dirty="0">
                         <a:latin typeface="Arial" charset="0"/>
                         <a:ea typeface="Arial" charset="0"/>
                         <a:cs typeface="Arial" charset="0"/>
@@ -3695,7 +3734,7 @@
                         <a:buNone/>
                       </a:pPr>
                       <a:r>
-                        <a:rPr lang="en-US" sz="1200" b="1" dirty="0">
+                        <a:rPr lang="en-US" sz="1100" b="1" dirty="0">
                           <a:solidFill>
                             <a:srgbClr val="FFFFFF"/>
                           </a:solidFill>
@@ -3705,7 +3744,7 @@
                         </a:rPr>
                         <a:t>Lecture</a:t>
                       </a:r>
-                      <a:endParaRPr lang="en-US" sz="1200" dirty="0">
+                      <a:endParaRPr lang="en-US" sz="1100" dirty="0">
                         <a:latin typeface="Arial" charset="0"/>
                         <a:ea typeface="Arial" charset="0"/>
                         <a:cs typeface="Arial" charset="0"/>
@@ -3755,7 +3794,7 @@
                   </a:tcPr>
                 </a:tc>
               </a:tr>
-              <a:tr h="640080">
+              <a:tr h="502920">
                 <a:tc>
                   <a:txBody>
                     <a:bodyPr/>
@@ -3765,7 +3804,7 @@
                         <a:buNone/>
                       </a:pPr>
                       <a:r>
-                        <a:rPr lang="en-US" sz="1200" b="1" dirty="0">
+                        <a:rPr lang="en-US" sz="1100" b="1" dirty="0">
                           <a:solidFill>
                             <a:srgbClr val="000000"/>
                           </a:solidFill>
@@ -3773,9 +3812,9 @@
                           <a:ea typeface="Arial" pitchFamily="34" charset="-122"/>
                           <a:cs typeface="Arial" pitchFamily="34" charset="-120"/>
                         </a:rPr>
-                        <a:t>410 cas de décalage</a:t>
+                        <a:t>410 cas de décalage (écrits par nous)</a:t>
                       </a:r>
-                      <a:endParaRPr lang="en-US" sz="1200" dirty="0">
+                      <a:endParaRPr lang="en-US" sz="1100" dirty="0">
                         <a:latin typeface="Arial" charset="0"/>
                         <a:ea typeface="Arial" charset="0"/>
                         <a:cs typeface="Arial" charset="0"/>
@@ -3830,7 +3869,7 @@
                         <a:buNone/>
                       </a:pPr>
                       <a:r>
-                        <a:rPr lang="en-US" sz="1200" dirty="0">
+                        <a:rPr lang="en-US" sz="1100" dirty="0">
                           <a:solidFill>
                             <a:srgbClr val="000000"/>
                           </a:solidFill>
@@ -3840,7 +3879,7 @@
                         </a:rPr>
                         <a:t>228 écarts sur 228 signalés. 0 fausse alerte rouge sur 166 honnêtes.</a:t>
                       </a:r>
-                      <a:endParaRPr lang="en-US" sz="1200" dirty="0">
+                      <a:endParaRPr lang="en-US" sz="1100" dirty="0">
                         <a:latin typeface="Arial" charset="0"/>
                         <a:ea typeface="Arial" charset="0"/>
                         <a:cs typeface="Arial" charset="0"/>
@@ -3895,7 +3934,7 @@
                         <a:buNone/>
                       </a:pPr>
                       <a:r>
-                        <a:rPr lang="en-US" sz="1200" dirty="0">
+                        <a:rPr lang="en-US" sz="1100" dirty="0">
                           <a:solidFill>
                             <a:srgbClr val="000000"/>
                           </a:solidFill>
@@ -3905,7 +3944,204 @@
                         </a:rPr>
                         <a:t>Test de couverture, pas une mesure.</a:t>
                       </a:r>
-                      <a:endParaRPr lang="en-US" sz="1200" dirty="0">
+                      <a:endParaRPr lang="en-US" sz="1100" dirty="0">
+                        <a:latin typeface="Arial" charset="0"/>
+                        <a:ea typeface="Arial" charset="0"/>
+                        <a:cs typeface="Arial" charset="0"/>
+                      </a:endParaRPr>
+                    </a:p>
+                  </a:txBody>
+                  <a:tcPr marL="91440" marR="91440" marT="45720" marB="45720" anchor="ctr">
+                    <a:lnL w="9525" cap="flat" cmpd="sng" algn="ctr">
+                      <a:solidFill>
+                        <a:srgbClr val="E2E2E2"/>
+                      </a:solidFill>
+                      <a:prstDash val="solid"/>
+                      <a:round/>
+                      <a:headEnd type="none" w="med" len="med"/>
+                      <a:tailEnd type="none" w="med" len="med"/>
+                    </a:lnL>
+                    <a:lnR w="9525" cap="flat" cmpd="sng" algn="ctr">
+                      <a:solidFill>
+                        <a:srgbClr val="E2E2E2"/>
+                      </a:solidFill>
+                      <a:prstDash val="solid"/>
+                      <a:round/>
+                      <a:headEnd type="none" w="med" len="med"/>
+                      <a:tailEnd type="none" w="med" len="med"/>
+                    </a:lnR>
+                    <a:lnT w="9525" cap="flat" cmpd="sng" algn="ctr">
+                      <a:solidFill>
+                        <a:srgbClr val="E2E2E2"/>
+                      </a:solidFill>
+                      <a:prstDash val="solid"/>
+                      <a:round/>
+                      <a:headEnd type="none" w="med" len="med"/>
+                      <a:tailEnd type="none" w="med" len="med"/>
+                    </a:lnT>
+                    <a:lnB w="9525" cap="flat" cmpd="sng" algn="ctr">
+                      <a:solidFill>
+                        <a:srgbClr val="E2E2E2"/>
+                      </a:solidFill>
+                      <a:prstDash val="solid"/>
+                      <a:round/>
+                      <a:headEnd type="none" w="med" len="med"/>
+                      <a:tailEnd type="none" w="med" len="med"/>
+                    </a:lnB>
+                  </a:tcPr>
+                </a:tc>
+              </a:tr>
+              <a:tr h="685800">
+                <a:tc>
+                  <a:txBody>
+                    <a:bodyPr/>
+                    <a:lstStyle/>
+                    <a:p>
+                      <a:pPr indent="0" marL="0">
+                        <a:buNone/>
+                      </a:pPr>
+                      <a:r>
+                        <a:rPr lang="en-US" sz="1100" b="1" dirty="0">
+                          <a:solidFill>
+                            <a:srgbClr val="000000"/>
+                          </a:solidFill>
+                          <a:latin typeface="Arial" pitchFamily="34" charset="0"/>
+                          <a:ea typeface="Arial" pitchFamily="34" charset="-122"/>
+                          <a:cs typeface="Arial" pitchFamily="34" charset="-120"/>
+                        </a:rPr>
+                        <a:t>Contrôle scellé, 1 079 paires (mêmes auteurs phrases et règles)</a:t>
+                      </a:r>
+                      <a:endParaRPr lang="en-US" sz="1100" dirty="0">
+                        <a:latin typeface="Arial" charset="0"/>
+                        <a:ea typeface="Arial" charset="0"/>
+                        <a:cs typeface="Arial" charset="0"/>
+                      </a:endParaRPr>
+                    </a:p>
+                  </a:txBody>
+                  <a:tcPr marL="91440" marR="91440" marT="45720" marB="45720" anchor="ctr">
+                    <a:lnL w="9525" cap="flat" cmpd="sng" algn="ctr">
+                      <a:solidFill>
+                        <a:srgbClr val="E2E2E2"/>
+                      </a:solidFill>
+                      <a:prstDash val="solid"/>
+                      <a:round/>
+                      <a:headEnd type="none" w="med" len="med"/>
+                      <a:tailEnd type="none" w="med" len="med"/>
+                    </a:lnL>
+                    <a:lnR w="9525" cap="flat" cmpd="sng" algn="ctr">
+                      <a:solidFill>
+                        <a:srgbClr val="E2E2E2"/>
+                      </a:solidFill>
+                      <a:prstDash val="solid"/>
+                      <a:round/>
+                      <a:headEnd type="none" w="med" len="med"/>
+                      <a:tailEnd type="none" w="med" len="med"/>
+                    </a:lnR>
+                    <a:lnT w="9525" cap="flat" cmpd="sng" algn="ctr">
+                      <a:solidFill>
+                        <a:srgbClr val="E2E2E2"/>
+                      </a:solidFill>
+                      <a:prstDash val="solid"/>
+                      <a:round/>
+                      <a:headEnd type="none" w="med" len="med"/>
+                      <a:tailEnd type="none" w="med" len="med"/>
+                    </a:lnT>
+                    <a:lnB w="9525" cap="flat" cmpd="sng" algn="ctr">
+                      <a:solidFill>
+                        <a:srgbClr val="E2E2E2"/>
+                      </a:solidFill>
+                      <a:prstDash val="solid"/>
+                      <a:round/>
+                      <a:headEnd type="none" w="med" len="med"/>
+                      <a:tailEnd type="none" w="med" len="med"/>
+                    </a:lnB>
+                  </a:tcPr>
+                </a:tc>
+                <a:tc>
+                  <a:txBody>
+                    <a:bodyPr/>
+                    <a:lstStyle/>
+                    <a:p>
+                      <a:pPr indent="0" marL="0">
+                        <a:buNone/>
+                      </a:pPr>
+                      <a:r>
+                        <a:rPr lang="en-US" sz="1100" dirty="0">
+                          <a:solidFill>
+                            <a:srgbClr val="000000"/>
+                          </a:solidFill>
+                          <a:latin typeface="Arial" pitchFamily="34" charset="0"/>
+                          <a:ea typeface="Arial" pitchFamily="34" charset="-122"/>
+                          <a:cs typeface="Arial" pitchFamily="34" charset="-120"/>
+                        </a:rPr>
+                        <a:t>Code seul : 86,6 % attrapés, 7,7 % de fausses alertes. Avec un modèle qui classe : 86,6 % et 1,3 %.</a:t>
+                      </a:r>
+                      <a:endParaRPr lang="en-US" sz="1100" dirty="0">
+                        <a:latin typeface="Arial" charset="0"/>
+                        <a:ea typeface="Arial" charset="0"/>
+                        <a:cs typeface="Arial" charset="0"/>
+                      </a:endParaRPr>
+                    </a:p>
+                  </a:txBody>
+                  <a:tcPr marL="91440" marR="91440" marT="45720" marB="45720" anchor="ctr">
+                    <a:lnL w="9525" cap="flat" cmpd="sng" algn="ctr">
+                      <a:solidFill>
+                        <a:srgbClr val="E2E2E2"/>
+                      </a:solidFill>
+                      <a:prstDash val="solid"/>
+                      <a:round/>
+                      <a:headEnd type="none" w="med" len="med"/>
+                      <a:tailEnd type="none" w="med" len="med"/>
+                    </a:lnL>
+                    <a:lnR w="9525" cap="flat" cmpd="sng" algn="ctr">
+                      <a:solidFill>
+                        <a:srgbClr val="E2E2E2"/>
+                      </a:solidFill>
+                      <a:prstDash val="solid"/>
+                      <a:round/>
+                      <a:headEnd type="none" w="med" len="med"/>
+                      <a:tailEnd type="none" w="med" len="med"/>
+                    </a:lnR>
+                    <a:lnT w="9525" cap="flat" cmpd="sng" algn="ctr">
+                      <a:solidFill>
+                        <a:srgbClr val="E2E2E2"/>
+                      </a:solidFill>
+                      <a:prstDash val="solid"/>
+                      <a:round/>
+                      <a:headEnd type="none" w="med" len="med"/>
+                      <a:tailEnd type="none" w="med" len="med"/>
+                    </a:lnT>
+                    <a:lnB w="9525" cap="flat" cmpd="sng" algn="ctr">
+                      <a:solidFill>
+                        <a:srgbClr val="E2E2E2"/>
+                      </a:solidFill>
+                      <a:prstDash val="solid"/>
+                      <a:round/>
+                      <a:headEnd type="none" w="med" len="med"/>
+                      <a:tailEnd type="none" w="med" len="med"/>
+                    </a:lnB>
+                  </a:tcPr>
+                </a:tc>
+                <a:tc>
+                  <a:txBody>
+                    <a:bodyPr/>
+                    <a:lstStyle/>
+                    <a:p>
+                      <a:pPr indent="0" marL="0">
+                        <a:buNone/>
+                      </a:pPr>
+                      <a:r>
+                        <a:rPr lang="en-US" sz="1100" dirty="0">
+                          <a:solidFill>
+                            <a:srgbClr val="000000"/>
+                          </a:solidFill>
+                          <a:latin typeface="Arial" pitchFamily="34" charset="0"/>
+                          <a:ea typeface="Arial" pitchFamily="34" charset="-122"/>
+                          <a:cs typeface="Arial" pitchFamily="34" charset="-120"/>
+                        </a:rPr>
+                        <a:t>Plus prudent, pas plus sûr.</a:t>
+                      </a:r>
+                      <a:endParaRPr lang="en-US" sz="1100" dirty="0">
                         <a:latin typeface="Arial" charset="0"/>
                         <a:ea typeface="Arial" charset="0"/>
                         <a:cs typeface="Arial" charset="0"/>
@@ -3962,7 +4198,7 @@
                         <a:buNone/>
                       </a:pPr>
                       <a:r>
-                        <a:rPr lang="en-US" sz="1200" b="1" dirty="0">
+                        <a:rPr lang="en-US" sz="1100" b="1" dirty="0">
                           <a:solidFill>
                             <a:srgbClr val="000000"/>
                           </a:solidFill>
@@ -3970,9 +4206,9 @@
                           <a:ea typeface="Arial" pitchFamily="34" charset="-122"/>
                           <a:cs typeface="Arial" pitchFamily="34" charset="-120"/>
                         </a:rPr>
-                        <a:t>Moteur en conditions produit</a:t>
+                        <a:t>Conditions produit (banc synthétique)</a:t>
                       </a:r>
-                      <a:endParaRPr lang="en-US" sz="1200" dirty="0">
+                      <a:endParaRPr lang="en-US" sz="1100" dirty="0">
                         <a:latin typeface="Arial" charset="0"/>
                         <a:ea typeface="Arial" charset="0"/>
                         <a:cs typeface="Arial" charset="0"/>
@@ -4027,7 +4263,7 @@
                         <a:buNone/>
                       </a:pPr>
                       <a:r>
-                        <a:rPr lang="en-US" sz="1200" dirty="0">
+                        <a:rPr lang="en-US" sz="1100" dirty="0">
                           <a:solidFill>
                             <a:srgbClr val="000000"/>
                           </a:solidFill>
@@ -4035,9 +4271,9 @@
                           <a:ea typeface="Arial" pitchFamily="34" charset="-122"/>
                           <a:cs typeface="Arial" pitchFamily="34" charset="-120"/>
                         </a:rPr>
-                        <a:t>Rappel rouge 71,3 %. Honnêtes en rouge 13,9 %.</a:t>
+                        <a:t>Rappel rouge 71,3 %. Honnêtes en rouge 13,9 %, avertis 54,2 %.</a:t>
                       </a:r>
-                      <a:endParaRPr lang="en-US" sz="1200" dirty="0">
+                      <a:endParaRPr lang="en-US" sz="1100" dirty="0">
                         <a:latin typeface="Arial" charset="0"/>
                         <a:ea typeface="Arial" charset="0"/>
                         <a:cs typeface="Arial" charset="0"/>
@@ -4092,7 +4328,7 @@
                         <a:buNone/>
                       </a:pPr>
                       <a:r>
-                        <a:rPr lang="en-US" sz="1200" dirty="0">
+                        <a:rPr lang="en-US" sz="1100" dirty="0">
                           <a:solidFill>
                             <a:srgbClr val="D92D20"/>
                           </a:solidFill>
@@ -4102,7 +4338,7 @@
                         </a:rPr>
                         <a:t>Trop de fausses alertes.</a:t>
                       </a:r>
-                      <a:endParaRPr lang="en-US" sz="1200" dirty="0">
+                      <a:endParaRPr lang="en-US" sz="1100" dirty="0">
                         <a:latin typeface="Arial" charset="0"/>
                         <a:ea typeface="Arial" charset="0"/>
                         <a:cs typeface="Arial" charset="0"/>
@@ -4149,7 +4385,7 @@
                   </a:tcPr>
                 </a:tc>
               </a:tr>
-              <a:tr h="640080">
+              <a:tr h="502920">
                 <a:tc>
                   <a:txBody>
                     <a:bodyPr/>
@@ -4159,7 +4395,7 @@
                         <a:buNone/>
                       </a:pPr>
                       <a:r>
-                        <a:rPr lang="en-US" sz="1200" b="1" dirty="0">
+                        <a:rPr lang="en-US" sz="1100" b="1" dirty="0">
                           <a:solidFill>
                             <a:srgbClr val="000000"/>
                           </a:solidFill>
@@ -4167,9 +4403,9 @@
                           <a:ea typeface="Arial" pitchFamily="34" charset="-122"/>
                           <a:cs typeface="Arial" pitchFamily="34" charset="-120"/>
                         </a:rPr>
-                        <a:t>Phrase libre sur 298 arnaques vertes</a:t>
+                        <a:t>Avalanche réel, 6 325 transactions</a:t>
                       </a:r>
-                      <a:endParaRPr lang="en-US" sz="1200" dirty="0">
+                      <a:endParaRPr lang="en-US" sz="1100" dirty="0">
                         <a:latin typeface="Arial" charset="0"/>
                         <a:ea typeface="Arial" charset="0"/>
                         <a:cs typeface="Arial" charset="0"/>
@@ -4224,7 +4460,7 @@
                         <a:buNone/>
                       </a:pPr>
                       <a:r>
-                        <a:rPr lang="en-US" sz="1200" dirty="0">
+                        <a:rPr lang="en-US" sz="1100" dirty="0">
                           <a:solidFill>
                             <a:srgbClr val="000000"/>
                           </a:solidFill>
@@ -4232,9 +4468,9 @@
                           <a:ea typeface="Arial" pitchFamily="34" charset="-122"/>
                           <a:cs typeface="Arial" pitchFamily="34" charset="-120"/>
                         </a:rPr>
-                        <a:t>0 arrêtée. Intention structurée : 34.</a:t>
+                        <a:t>0,30 % de rouges, 76,84 % d’avertissements.</a:t>
                       </a:r>
-                      <a:endParaRPr lang="en-US" sz="1200" dirty="0">
+                      <a:endParaRPr lang="en-US" sz="1100" dirty="0">
                         <a:latin typeface="Arial" charset="0"/>
                         <a:ea typeface="Arial" charset="0"/>
                         <a:cs typeface="Arial" charset="0"/>
@@ -4289,7 +4525,7 @@
                         <a:buNone/>
                       </a:pPr>
                       <a:r>
-                        <a:rPr lang="en-US" sz="1200" dirty="0">
+                        <a:rPr lang="en-US" sz="1100" dirty="0">
                           <a:solidFill>
                             <a:srgbClr val="D92D20"/>
                           </a:solidFill>
@@ -4297,9 +4533,9 @@
                           <a:ea typeface="Arial" pitchFamily="34" charset="-122"/>
                           <a:cs typeface="Arial" pitchFamily="34" charset="-120"/>
                         </a:rPr>
-                        <a:t>Peu d'apport sur nos cas actuels.</a:t>
+                        <a:t>Légitime présumé. Opacité.</a:t>
                       </a:r>
-                      <a:endParaRPr lang="en-US" sz="1200" dirty="0">
+                      <a:endParaRPr lang="en-US" sz="1100" dirty="0">
                         <a:latin typeface="Arial" charset="0"/>
                         <a:ea typeface="Arial" charset="0"/>
                         <a:cs typeface="Arial" charset="0"/>
@@ -4346,7 +4582,7 @@
                   </a:tcPr>
                 </a:tc>
               </a:tr>
-              <a:tr h="640080">
+              <a:tr h="457200">
                 <a:tc>
                   <a:txBody>
                     <a:bodyPr/>
@@ -4356,7 +4592,7 @@
                         <a:buNone/>
                       </a:pPr>
                       <a:r>
-                        <a:rPr lang="en-US" sz="1200" b="1" dirty="0">
+                        <a:rPr lang="en-US" sz="1100" b="1" dirty="0">
                           <a:solidFill>
                             <a:srgbClr val="000000"/>
                           </a:solidFill>
@@ -4364,9 +4600,9 @@
                           <a:ea typeface="Arial" pitchFamily="34" charset="-122"/>
                           <a:cs typeface="Arial" pitchFamily="34" charset="-120"/>
                         </a:rPr>
-                        <a:t>Jeu aveugle (250 cas), grille (1 500 paires)</a:t>
+                        <a:t>Jeu aveugle, 250 cas (autre auteur)</a:t>
                       </a:r>
-                      <a:endParaRPr lang="en-US" sz="1200" dirty="0">
+                      <a:endParaRPr lang="en-US" sz="1100" dirty="0">
                         <a:latin typeface="Arial" charset="0"/>
                         <a:ea typeface="Arial" charset="0"/>
                         <a:cs typeface="Arial" charset="0"/>
@@ -4421,7 +4657,7 @@
                         <a:buNone/>
                       </a:pPr>
                       <a:r>
-                        <a:rPr lang="en-US" sz="1200" b="1" dirty="0">
+                        <a:rPr lang="en-US" sz="1100" b="1" dirty="0">
                           <a:solidFill>
                             <a:srgbClr val="D92D20"/>
                           </a:solidFill>
@@ -4431,7 +4667,7 @@
                         </a:rPr>
                         <a:t>À mesurer</a:t>
                       </a:r>
-                      <a:endParaRPr lang="en-US" sz="1200" dirty="0">
+                      <a:endParaRPr lang="en-US" sz="1100" dirty="0">
                         <a:latin typeface="Arial" charset="0"/>
                         <a:ea typeface="Arial" charset="0"/>
                         <a:cs typeface="Arial" charset="0"/>
@@ -4486,7 +4722,7 @@
                         <a:buNone/>
                       </a:pPr>
                       <a:r>
-                        <a:rPr lang="en-US" sz="1200" dirty="0">
+                        <a:rPr lang="en-US" sz="1100" dirty="0">
                           <a:solidFill>
                             <a:srgbClr val="000000"/>
                           </a:solidFill>
@@ -4496,7 +4732,7 @@
                         </a:rPr>
                         <a:t>Hash publié avant le test.</a:t>
                       </a:r>
-                      <a:endParaRPr lang="en-US" sz="1200" dirty="0">
+                      <a:endParaRPr lang="en-US" sz="1100" dirty="0">
                         <a:latin typeface="Arial" charset="0"/>
                         <a:ea typeface="Arial" charset="0"/>
                         <a:cs typeface="Arial" charset="0"/>
@@ -4580,7 +4816,7 @@
                 <a:ea typeface="Arial" pitchFamily="34" charset="-122"/>
                 <a:cs typeface="Arial" pitchFamily="34" charset="-120"/>
               </a:rPr>
-              <a:t>Données réelles : aucune ne mesure Hold up. Le contexte est en colonne B de livrables/CHIFFRES.md.</a:t>
+              <a:t>Contexte réel (47,6 % et 34,2 % d’illimité, 83,85 M$) : colonne « données réelles » de livrables/CHIFFRES.md. Aucun ne mesure Hold up.</a:t>
             </a:r>
             <a:endParaRPr lang="en-US" sz="1100" dirty="0"/>
           </a:p>
@@ -4937,7 +5173,7 @@
                 <a:ea typeface="Arial" pitchFamily="34" charset="-122"/>
                 <a:cs typeface="Arial" pitchFamily="34" charset="-120"/>
               </a:rPr>
-              <a:t>Chaque décision laisse une ligne dans un journal chaîné par hachage.</a:t>
+              <a:t>Chaque décision laisse une ligne datée (chaînée par hachage dans la version serveur).</a:t>
             </a:r>
             <a:endParaRPr lang="en-US" sz="1200" dirty="0"/>
           </a:p>
@@ -5152,7 +5388,7 @@
                 <a:ea typeface="Arial" pitchFamily="34" charset="-122"/>
                 <a:cs typeface="Arial" pitchFamily="34" charset="-120"/>
               </a:rPr>
-              <a:t>Une ligne datée par décision, rejouable : matière pour le registre. Pas de classification ni de déclaration.</a:t>
+              <a:t>Une ligne datée par décision, rejouable dans la version serveur : matière pour le registre. Pas de classification ni de déclaration.</a:t>
             </a:r>
             <a:endParaRPr lang="en-US" sz="1100" dirty="0"/>
           </a:p>
@@ -5358,7 +5594,7 @@
                 <a:ea typeface="Arial" pitchFamily="34" charset="-122"/>
                 <a:cs typeface="Arial" pitchFamily="34" charset="-120"/>
               </a:rPr>
-              <a:t>Un modèle lit la phrase. Du code lit montants, jetons, adresses. Pas de qualification établie.</a:t>
+              <a:t>Version autonome : aucun modèle, aucun réseau. Avec le relais Clef, un modèle hébergé lit la phrase ; du code lit montants, jetons, adresses. Pas de qualification établie.</a:t>
             </a:r>
             <a:endParaRPr lang="en-US" sz="1100" dirty="0"/>
           </a:p>
@@ -5461,7 +5697,7 @@
                 <a:ea typeface="Arial" pitchFamily="34" charset="-122"/>
                 <a:cs typeface="Arial" pitchFamily="34" charset="-120"/>
               </a:rPr>
-              <a:t>Une commande recalcule la chaîne et rejoue le moteur. Réécriture complète : détectée seulement après ancrage.</a:t>
+              <a:t>Version serveur : une commande recalcule la chaîne et rejoue le moteur. Réécriture complète : détectée seulement après ancrage.</a:t>
             </a:r>
             <a:endParaRPr lang="en-US" sz="1100" dirty="0"/>
           </a:p>
@@ -6338,7 +6574,7 @@
                 <a:ea typeface="Arial" pitchFamily="34" charset="-122"/>
                 <a:cs typeface="Arial" pitchFamily="34" charset="-120"/>
               </a:rPr>
-              <a:t>Grille de 1 500 paires</a:t>
+              <a:t>Correctifs de la revue de sécurité</a:t>
             </a:r>
             <a:endParaRPr lang="en-US" sz="1500" dirty="0"/>
           </a:p>
@@ -6359,7 +6595,7 @@
                 <a:ea typeface="Arial" pitchFamily="34" charset="-122"/>
                 <a:cs typeface="Arial" pitchFamily="34" charset="-120"/>
               </a:rPr>
-              <a:t>Mesure de Clef sur la comparaison</a:t>
+              <a:t>Contrôle écrit par un autre auteur</a:t>
             </a:r>
             <a:endParaRPr lang="en-US" sz="1500" dirty="0"/>
           </a:p>

</xml_diff>

<commit_message>
deck: slides 6 and 7 revised
Co-Authored-By: Claude Opus 5.5 <noreply@anthropic.com>
</commit_message>
<xml_diff>
--- a/livrables/deck/holdup.pptx
+++ b/livrables/deck/holdup.pptx
@@ -3736,45 +3736,6 @@
       </p:sp>
       <p:sp>
         <p:nvSpPr>
-          <p:cNvPr id="19" name="Text 16"/>
-          <p:cNvSpPr txBox="1"/>
-          <p:nvPr/>
-        </p:nvSpPr>
-        <p:spPr>
-          <a:xfrm>
-            <a:off x="457200" y="4224528"/>
-            <a:ext cx="8229600" cy="274320"/>
-          </a:xfrm>
-          <a:prstGeom prst="rect">
-            <a:avLst/>
-          </a:prstGeom>
-          <a:noFill/>
-          <a:ln/>
-        </p:spPr>
-        <p:txBody>
-          <a:bodyPr wrap="square" lIns="0" tIns="0" rIns="0" bIns="0" rtlCol="0" anchor="t"/>
-          <a:lstStyle/>
-          <a:p>
-            <a:pPr indent="0" marL="0">
-              <a:buNone/>
-            </a:pPr>
-            <a:r>
-              <a:rPr lang="en-US" sz="1200" dirty="0">
-                <a:solidFill>
-                  <a:srgbClr val="B3B3B3"/>
-                </a:solidFill>
-                <a:latin typeface="Segoe UI Variable Text" pitchFamily="34" charset="0"/>
-                <a:ea typeface="Segoe UI Variable Text" pitchFamily="34" charset="-122"/>
-                <a:cs typeface="Segoe UI Variable Text" pitchFamily="34" charset="-120"/>
-              </a:rPr>
-              <a:t>Pas l’extension livrée. Cas écrits par une IA de la même famille que celle qui nous a aidés.</a:t>
-            </a:r>
-            <a:endParaRPr lang="en-US" sz="1200" dirty="0"/>
-          </a:p>
-        </p:txBody>
-      </p:sp>
-      <p:sp>
-        <p:nvSpPr>
           <p:cNvPr id="25" name="Slide Number Placeholder 0"/>
           <p:cNvSpPr>
             <a:spLocks noGrp="1"/>
@@ -3988,8 +3949,8 @@
         </p:nvSpPr>
         <p:spPr>
           <a:xfrm>
-            <a:off x="457200" y="2880360"/>
-            <a:ext cx="4754880" cy="365760"/>
+            <a:off x="457200" y="2697480"/>
+            <a:ext cx="4937760" cy="365760"/>
           </a:xfrm>
           <a:prstGeom prst="rect">
             <a:avLst/>
@@ -4013,7 +3974,7 @@
                 <a:ea typeface="Segoe UI Variable Text Semibold" pitchFamily="34" charset="-122"/>
                 <a:cs typeface="Segoe UI Variable Text Semibold" pitchFamily="34" charset="-120"/>
               </a:rPr>
-              <a:t>Pas encore</a:t>
+              <a:t>Ce que Hold up ne fait pas encore</a:t>
             </a:r>
             <a:endParaRPr lang="en-US" sz="1800" dirty="0"/>
           </a:p>
@@ -4027,8 +3988,8 @@
         </p:nvSpPr>
         <p:spPr>
           <a:xfrm>
-            <a:off x="457200" y="3291840"/>
-            <a:ext cx="4754880" cy="731520"/>
+            <a:off x="457200" y="3154680"/>
+            <a:ext cx="4937760" cy="1371600"/>
           </a:xfrm>
           <a:prstGeom prst="rect">
             <a:avLst/>
@@ -4041,6 +4002,9 @@
           <a:lstStyle/>
           <a:p>
             <a:pPr indent="0" marL="0">
+              <a:spcAft>
+                <a:spcPts val="800"/>
+              </a:spcAft>
               <a:buNone/>
             </a:pPr>
             <a:r>
@@ -4052,7 +4016,47 @@
                 <a:ea typeface="Segoe UI Variable Text" pitchFamily="34" charset="-122"/>
                 <a:cs typeface="Segoe UI Variable Text" pitchFamily="34" charset="-120"/>
               </a:rPr>
-              <a:t>Le sens d’un échange. Un vrai MetaMask. Un Ledger en direct. Le téléphone.</a:t>
+              <a:t>Je ne vérifie pas ce que tu reçois en échange.</a:t>
+            </a:r>
+            <a:endParaRPr lang="en-US" sz="1600" dirty="0"/>
+          </a:p>
+          <a:p>
+            <a:pPr indent="0" marL="0">
+              <a:spcAft>
+                <a:spcPts val="800"/>
+              </a:spcAft>
+              <a:buNone/>
+            </a:pPr>
+            <a:r>
+              <a:rPr lang="en-US" sz="1600" dirty="0">
+                <a:solidFill>
+                  <a:srgbClr val="B3B3B3"/>
+                </a:solidFill>
+                <a:latin typeface="Segoe UI Variable Text" pitchFamily="34" charset="0"/>
+                <a:ea typeface="Segoe UI Variable Text" pitchFamily="34" charset="-122"/>
+                <a:cs typeface="Segoe UI Variable Text" pitchFamily="34" charset="-120"/>
+              </a:rPr>
+              <a:t>Je n’ai jamais été essayé devant un vrai MetaMask.</a:t>
+            </a:r>
+            <a:endParaRPr lang="en-US" sz="1600" dirty="0"/>
+          </a:p>
+          <a:p>
+            <a:pPr indent="0" marL="0">
+              <a:spcAft>
+                <a:spcPts val="800"/>
+              </a:spcAft>
+              <a:buNone/>
+            </a:pPr>
+            <a:r>
+              <a:rPr lang="en-US" sz="1600" dirty="0">
+                <a:solidFill>
+                  <a:srgbClr val="B3B3B3"/>
+                </a:solidFill>
+                <a:latin typeface="Segoe UI Variable Text" pitchFamily="34" charset="0"/>
+                <a:ea typeface="Segoe UI Variable Text" pitchFamily="34" charset="-122"/>
+                <a:cs typeface="Segoe UI Variable Text" pitchFamily="34" charset="-120"/>
+              </a:rPr>
+              <a:t>Je ne couvre ni un Ledger en direct, ni le téléphone.</a:t>
             </a:r>
             <a:endParaRPr lang="en-US" sz="1600" dirty="0"/>
           </a:p>

</xml_diff>

<commit_message>
deck: regenerated at 11:29 (slide 7 revised)
Co-Authored-By: Claude Opus 5.5 <noreply@anthropic.com>
</commit_message>
<xml_diff>
--- a/livrables/deck/holdup.pptx
+++ b/livrables/deck/holdup.pptx
@@ -509,7 +509,7 @@
           <a:p>
             <a:r>
               <a:rPr lang="en-US" dirty="0"/>
-              <a:t>Deux fenêtres, le même site, l'un piraté : à l'œil, impossible à dire. Ce jour-là, on perd ce qu'on lui a laissé le droit de prendre. Sur Avalanche C-Chain, 34,2 % [33,6 ; 34,9] des droits de dépense non nuls lus sont illimités (7 103 sur 20 753, 40 fenêtres de 500 blocs) : mesure interne, des événements et non des personnes, non représentative. Dire « une sur trois », jamais « la norme ». Nous adressons Avalanche : ne pas citer Ethereum. Méthode : Z4_illimite_par_plateforme.md dans le même dossier ; livrables/CHIFFRES.md B1.</a:t>
+              <a:t>Trame d'Adem (livrables/pitch_v7/PITCH_ADEM.md) : en 2026, on ne peut plus promettre qu'un site est sûr. 21 novembre 2025, le site d'Aerodrome est détourné (DNS modifié) : 81 minutes entre le changement et le signalement du domaine, environ 700 000 $ de pertes. Mesure de Blockaid sur son propre délai : source intéressée, le dire si on demande. Postulat : tout service en ligne finira par être compromis ; la question devient « qu'est-ce que je lui ai laissé le droit de prendre ce jour-là ». Sur Avalanche C-Chain, 34,2 % [33,6 ; 34,9] des droits de dépense non nuls lus sont illimités (7 103 sur 20 753) : mesure interne, des événements et non des personnes. Nous adressons Avalanche : ne pas citer Ethereum. Aerodrome n'est pas sur Avalanche : c'est un exemple de site détourné, pas une mesure de notre chaîne. CHIFFRES.md B16 et B1.</a:t>
             </a:r>
             <a:endParaRPr lang="en-US" dirty="0"/>
           </a:p>
@@ -685,7 +685,7 @@
           <a:p>
             <a:r>
               <a:rPr lang="en-US" dirty="0"/>
-              <a:t>Scène prouvée sur la chaîne (livrables/pitch_v7/DEMO_DEROULE.md, H2 et H3) : site honnête qui demande l'illimité, piraté plus tard. Sans Hold up : 100, 50 après l'échange, puis 0. Avec : autorisation ramenée à 50, consommée par l'échange, le compte garde 50. Le parcours avec Hold up est joué dans un vrai Chromium (film_scene.mjs), le « sans » sur la chaîne seulement. Le script demande une chaîne locale déployée (npm run demo:deploy -- --network localhost) : le jury ne le rejoue pas en une commande. Copie locale d'Avalanche, rien sur Fuji (D-016). Phrase exacte : « sans Hold up il te reste zéro, avec Hold up tu gardes 50 ».</a:t>
+              <a:t>Scène prouvée sur la chaîne (livrables/pitch_v7/DEMO_DEROULE.md, H2 et H3) : site honnête qui demande l'illimité, piraté plus tard. Le compte part de 100 USDC. Sans Hold up : 50 après l'échange, puis 0 après le piratage. Avec : autorisation limitée à 50 par le geste « Limiter à 50 USDC et envoyer », consommée par l'échange, le compte garde 50. Le parcours avec Hold up est joué dans un vrai Chromium (film_scene.mjs), le « sans » sur la chaîne seulement. Le script demande une chaîne locale déployée (npm run demo:deploy -- --network localhost) : le jury ne le rejoue pas en une commande. Copie locale d'Avalanche, rien sur Fuji (D-016).</a:t>
             </a:r>
             <a:endParaRPr lang="en-US" dirty="0"/>
           </a:p>
@@ -1645,7 +1645,7 @@
               <a:buNone/>
             </a:pPr>
             <a:r>
-              <a:rPr lang="en-US" sz="1100" dirty="0">
+              <a:rPr lang="en-US" sz="1000" dirty="0">
                 <a:solidFill>
                   <a:srgbClr val="B3B3B3"/>
                 </a:solidFill>
@@ -1653,9 +1653,9 @@
                 <a:ea typeface="Segoe UI Variable Text" pitchFamily="34" charset="-122"/>
                 <a:cs typeface="Segoe UI Variable Text" pitchFamily="34" charset="-120"/>
               </a:rPr>
-              <a:t>Dans le dépôt : research/titouan/Z_approbations/onchain/result_avax.json</a:t>
-            </a:r>
-            <a:endParaRPr lang="en-US" sz="1100" dirty="0"/>
+              <a:t>Dans le dépôt : research/demo_reelle/RECHERCHE_douleurs_secondaires.md, research/titouan/Z_approbations/onchain/result_avax.json</a:t>
+            </a:r>
+            <a:endParaRPr lang="en-US" sz="1000" dirty="0"/>
           </a:p>
         </p:txBody>
       </p:sp>
@@ -1667,8 +1667,8 @@
         </p:nvSpPr>
         <p:spPr>
           <a:xfrm>
-            <a:off x="457200" y="822960"/>
-            <a:ext cx="8229600" cy="1828800"/>
+            <a:off x="457200" y="685800"/>
+            <a:ext cx="8229600" cy="1645920"/>
           </a:xfrm>
           <a:prstGeom prst="rect">
             <a:avLst/>
@@ -1684,7 +1684,7 @@
               <a:buNone/>
             </a:pPr>
             <a:r>
-              <a:rPr lang="en-US" sz="13000" dirty="0">
+              <a:rPr lang="en-US" sz="11000" dirty="0">
                 <a:solidFill>
                   <a:srgbClr val="FFFFFF"/>
                 </a:solidFill>
@@ -1692,9 +1692,9 @@
                 <a:ea typeface="Segoe UI Variable Text Semibold" pitchFamily="34" charset="-122"/>
                 <a:cs typeface="Segoe UI Variable Text Semibold" pitchFamily="34" charset="-120"/>
               </a:rPr>
-              <a:t>34 %</a:t>
-            </a:r>
-            <a:endParaRPr lang="en-US" sz="13000" dirty="0"/>
+              <a:t>81 minutes</a:t>
+            </a:r>
+            <a:endParaRPr lang="en-US" sz="11000" dirty="0"/>
           </a:p>
         </p:txBody>
       </p:sp>
@@ -1706,7 +1706,7 @@
         </p:nvSpPr>
         <p:spPr>
           <a:xfrm>
-            <a:off x="457200" y="2880360"/>
+            <a:off x="457200" y="2606040"/>
             <a:ext cx="8229600" cy="457200"/>
           </a:xfrm>
           <a:prstGeom prst="rect">
@@ -1731,7 +1731,7 @@
                 <a:ea typeface="Segoe UI Variable Text Semibold" pitchFamily="34" charset="-122"/>
                 <a:cs typeface="Segoe UI Variable Text Semibold" pitchFamily="34" charset="-120"/>
               </a:rPr>
-              <a:t>des autorisations de dépense lues sur Avalanche sont illimitées.</a:t>
+              <a:t>Aerodrome est piraté. Personne ne le signale pendant 81 minutes.</a:t>
             </a:r>
             <a:endParaRPr lang="en-US" sz="2000" dirty="0"/>
           </a:p>
@@ -1745,7 +1745,7 @@
         </p:nvSpPr>
         <p:spPr>
           <a:xfrm>
-            <a:off x="457200" y="3429000"/>
+            <a:off x="457200" y="3154680"/>
             <a:ext cx="8229600" cy="365760"/>
           </a:xfrm>
           <a:prstGeom prst="rect">
@@ -1770,7 +1770,46 @@
                 <a:ea typeface="Segoe UI Variable Text" pitchFamily="34" charset="-122"/>
                 <a:cs typeface="Segoe UI Variable Text" pitchFamily="34" charset="-120"/>
               </a:rPr>
-              <a:t>Une sur trois. Notre mesure, sur un échantillon de blocs.</a:t>
+              <a:t>Novembre 2025. Tout service en ligne finira par être piraté.</a:t>
+            </a:r>
+            <a:endParaRPr lang="en-US" sz="1600" dirty="0"/>
+          </a:p>
+        </p:txBody>
+      </p:sp>
+      <p:sp>
+        <p:nvSpPr>
+          <p:cNvPr id="7" name="Text 4"/>
+          <p:cNvSpPr txBox="1"/>
+          <p:nvPr/>
+        </p:nvSpPr>
+        <p:spPr>
+          <a:xfrm>
+            <a:off x="457200" y="3611880"/>
+            <a:ext cx="8229600" cy="365760"/>
+          </a:xfrm>
+          <a:prstGeom prst="rect">
+            <a:avLst/>
+          </a:prstGeom>
+          <a:noFill/>
+          <a:ln/>
+        </p:spPr>
+        <p:txBody>
+          <a:bodyPr wrap="square" lIns="0" tIns="0" rIns="0" bIns="0" rtlCol="0" anchor="t"/>
+          <a:lstStyle/>
+          <a:p>
+            <a:pPr indent="0" marL="0">
+              <a:buNone/>
+            </a:pPr>
+            <a:r>
+              <a:rPr lang="en-US" sz="1600" dirty="0">
+                <a:solidFill>
+                  <a:srgbClr val="B3B3B3"/>
+                </a:solidFill>
+                <a:latin typeface="Segoe UI Variable Text" pitchFamily="34" charset="0"/>
+                <a:ea typeface="Segoe UI Variable Text" pitchFamily="34" charset="-122"/>
+                <a:cs typeface="Segoe UI Variable Text" pitchFamily="34" charset="-120"/>
+              </a:rPr>
+              <a:t>Sur Avalanche, une autorisation sur trois est illimitée.</a:t>
             </a:r>
             <a:endParaRPr lang="en-US" sz="1600" dirty="0"/>
           </a:p>
@@ -2198,7 +2237,7 @@
                 <a:ea typeface="Segoe UI Variable Text Semibold" pitchFamily="34" charset="-122"/>
                 <a:cs typeface="Segoe UI Variable Text Semibold" pitchFamily="34" charset="-120"/>
               </a:rPr>
-              <a:t>Le même site, piraté plus tard</a:t>
+              <a:t>Tu échanges 50 USDC. Plus tard, le site est piraté.</a:t>
             </a:r>
             <a:endParaRPr lang="en-US" sz="2800" dirty="0"/>
           </a:p>
@@ -2251,8 +2290,8 @@
         </p:nvSpPr>
         <p:spPr>
           <a:xfrm>
-            <a:off x="457200" y="1325880"/>
-            <a:ext cx="3840480" cy="365760"/>
+            <a:off x="457200" y="1143000"/>
+            <a:ext cx="320040" cy="365760"/>
           </a:xfrm>
           <a:prstGeom prst="rect">
             <a:avLst/>
@@ -2268,7 +2307,46 @@
               <a:buNone/>
             </a:pPr>
             <a:r>
-              <a:rPr lang="en-US" sz="1600" dirty="0">
+              <a:rPr lang="en-US" sz="1800" dirty="0">
+                <a:solidFill>
+                  <a:srgbClr val="FFFFFF"/>
+                </a:solidFill>
+                <a:latin typeface="Segoe UI Variable Text Semibold" pitchFamily="34" charset="0"/>
+                <a:ea typeface="Segoe UI Variable Text Semibold" pitchFamily="34" charset="-122"/>
+                <a:cs typeface="Segoe UI Variable Text Semibold" pitchFamily="34" charset="-120"/>
+              </a:rPr>
+              <a:t>1</a:t>
+            </a:r>
+            <a:endParaRPr lang="en-US" sz="1800" dirty="0"/>
+          </a:p>
+        </p:txBody>
+      </p:sp>
+      <p:sp>
+        <p:nvSpPr>
+          <p:cNvPr id="6" name="Text 3"/>
+          <p:cNvSpPr txBox="1"/>
+          <p:nvPr/>
+        </p:nvSpPr>
+        <p:spPr>
+          <a:xfrm>
+            <a:off x="777240" y="1161288"/>
+            <a:ext cx="2240280" cy="822960"/>
+          </a:xfrm>
+          <a:prstGeom prst="rect">
+            <a:avLst/>
+          </a:prstGeom>
+          <a:noFill/>
+          <a:ln/>
+        </p:spPr>
+        <p:txBody>
+          <a:bodyPr wrap="square" lIns="0" tIns="0" rIns="0" bIns="0" rtlCol="0" anchor="t"/>
+          <a:lstStyle/>
+          <a:p>
+            <a:pPr indent="0" marL="0">
+              <a:buNone/>
+            </a:pPr>
+            <a:r>
+              <a:rPr lang="en-US" sz="1400" dirty="0">
                 <a:solidFill>
                   <a:srgbClr val="B3B3B3"/>
                 </a:solidFill>
@@ -2276,22 +2354,22 @@
                 <a:ea typeface="Segoe UI Variable Text" pitchFamily="34" charset="-122"/>
                 <a:cs typeface="Segoe UI Variable Text" pitchFamily="34" charset="-120"/>
               </a:rPr>
-              <a:t>Sans Hold up</a:t>
-            </a:r>
-            <a:endParaRPr lang="en-US" sz="1600" dirty="0"/>
-          </a:p>
-        </p:txBody>
-      </p:sp>
-      <p:sp>
-        <p:nvSpPr>
-          <p:cNvPr id="6" name="Text 3"/>
-          <p:cNvSpPr txBox="1"/>
-          <p:nvPr/>
-        </p:nvSpPr>
-        <p:spPr>
-          <a:xfrm>
-            <a:off x="457200" y="1691640"/>
-            <a:ext cx="3931920" cy="1371600"/>
+              <a:t>Tu as 100 USDC. Tu en échanges 50 sur un site honnête.</a:t>
+            </a:r>
+            <a:endParaRPr lang="en-US" sz="1400" dirty="0"/>
+          </a:p>
+        </p:txBody>
+      </p:sp>
+      <p:sp>
+        <p:nvSpPr>
+          <p:cNvPr id="7" name="Text 4"/>
+          <p:cNvSpPr txBox="1"/>
+          <p:nvPr/>
+        </p:nvSpPr>
+        <p:spPr>
+          <a:xfrm>
+            <a:off x="3291840" y="1143000"/>
+            <a:ext cx="320040" cy="365760"/>
           </a:xfrm>
           <a:prstGeom prst="rect">
             <a:avLst/>
@@ -2307,7 +2385,7 @@
               <a:buNone/>
             </a:pPr>
             <a:r>
-              <a:rPr lang="en-US" sz="6400" dirty="0">
+              <a:rPr lang="en-US" sz="1800" dirty="0">
                 <a:solidFill>
                   <a:srgbClr val="FFFFFF"/>
                 </a:solidFill>
@@ -2315,22 +2393,22 @@
                 <a:ea typeface="Segoe UI Variable Text Semibold" pitchFamily="34" charset="-122"/>
                 <a:cs typeface="Segoe UI Variable Text Semibold" pitchFamily="34" charset="-120"/>
               </a:rPr>
-              <a:t>50 → 0</a:t>
-            </a:r>
-            <a:endParaRPr lang="en-US" sz="6400" dirty="0"/>
-          </a:p>
-        </p:txBody>
-      </p:sp>
-      <p:sp>
-        <p:nvSpPr>
-          <p:cNvPr id="7" name="Text 4"/>
-          <p:cNvSpPr txBox="1"/>
-          <p:nvPr/>
-        </p:nvSpPr>
-        <p:spPr>
-          <a:xfrm>
-            <a:off x="457200" y="2926080"/>
-            <a:ext cx="3657600" cy="731520"/>
+              <a:t>2</a:t>
+            </a:r>
+            <a:endParaRPr lang="en-US" sz="1800" dirty="0"/>
+          </a:p>
+        </p:txBody>
+      </p:sp>
+      <p:sp>
+        <p:nvSpPr>
+          <p:cNvPr id="8" name="Text 5"/>
+          <p:cNvSpPr txBox="1"/>
+          <p:nvPr/>
+        </p:nvSpPr>
+        <p:spPr>
+          <a:xfrm>
+            <a:off x="3611880" y="1161288"/>
+            <a:ext cx="2240280" cy="822960"/>
           </a:xfrm>
           <a:prstGeom prst="rect">
             <a:avLst/>
@@ -2346,7 +2424,7 @@
               <a:buNone/>
             </a:pPr>
             <a:r>
-              <a:rPr lang="en-US" sz="1600" dirty="0">
+              <a:rPr lang="en-US" sz="1400" dirty="0">
                 <a:solidFill>
                   <a:srgbClr val="B3B3B3"/>
                 </a:solidFill>
@@ -2354,22 +2432,22 @@
                 <a:ea typeface="Segoe UI Variable Text" pitchFamily="34" charset="-122"/>
                 <a:cs typeface="Segoe UI Variable Text" pitchFamily="34" charset="-120"/>
               </a:rPr>
-              <a:t>Autorisation illimitée : le pirate vide le compte.</a:t>
-            </a:r>
-            <a:endParaRPr lang="en-US" sz="1600" dirty="0"/>
-          </a:p>
-        </p:txBody>
-      </p:sp>
-      <p:sp>
-        <p:nvSpPr>
-          <p:cNvPr id="8" name="Text 5"/>
-          <p:cNvSpPr txBox="1"/>
-          <p:nvPr/>
-        </p:nvSpPr>
-        <p:spPr>
-          <a:xfrm>
-            <a:off x="4846320" y="1325880"/>
-            <a:ext cx="3840480" cy="365760"/>
+              <a:t>Pour le faire, le site te demande l’accès à tout ton USDC, sans date de fin.</a:t>
+            </a:r>
+            <a:endParaRPr lang="en-US" sz="1400" dirty="0"/>
+          </a:p>
+        </p:txBody>
+      </p:sp>
+      <p:sp>
+        <p:nvSpPr>
+          <p:cNvPr id="9" name="Text 6"/>
+          <p:cNvSpPr txBox="1"/>
+          <p:nvPr/>
+        </p:nvSpPr>
+        <p:spPr>
+          <a:xfrm>
+            <a:off x="6126480" y="1143000"/>
+            <a:ext cx="320040" cy="365760"/>
           </a:xfrm>
           <a:prstGeom prst="rect">
             <a:avLst/>
@@ -2385,7 +2463,46 @@
               <a:buNone/>
             </a:pPr>
             <a:r>
-              <a:rPr lang="en-US" sz="1600" dirty="0">
+              <a:rPr lang="en-US" sz="1800" dirty="0">
+                <a:solidFill>
+                  <a:srgbClr val="FFFFFF"/>
+                </a:solidFill>
+                <a:latin typeface="Segoe UI Variable Text Semibold" pitchFamily="34" charset="0"/>
+                <a:ea typeface="Segoe UI Variable Text Semibold" pitchFamily="34" charset="-122"/>
+                <a:cs typeface="Segoe UI Variable Text Semibold" pitchFamily="34" charset="-120"/>
+              </a:rPr>
+              <a:t>3</a:t>
+            </a:r>
+            <a:endParaRPr lang="en-US" sz="1800" dirty="0"/>
+          </a:p>
+        </p:txBody>
+      </p:sp>
+      <p:sp>
+        <p:nvSpPr>
+          <p:cNvPr id="10" name="Text 7"/>
+          <p:cNvSpPr txBox="1"/>
+          <p:nvPr/>
+        </p:nvSpPr>
+        <p:spPr>
+          <a:xfrm>
+            <a:off x="6446520" y="1161288"/>
+            <a:ext cx="2240280" cy="822960"/>
+          </a:xfrm>
+          <a:prstGeom prst="rect">
+            <a:avLst/>
+          </a:prstGeom>
+          <a:noFill/>
+          <a:ln/>
+        </p:spPr>
+        <p:txBody>
+          <a:bodyPr wrap="square" lIns="0" tIns="0" rIns="0" bIns="0" rtlCol="0" anchor="t"/>
+          <a:lstStyle/>
+          <a:p>
+            <a:pPr indent="0" marL="0">
+              <a:buNone/>
+            </a:pPr>
+            <a:r>
+              <a:rPr lang="en-US" sz="1400" dirty="0">
                 <a:solidFill>
                   <a:srgbClr val="B3B3B3"/>
                 </a:solidFill>
@@ -2393,7 +2510,46 @@
                 <a:ea typeface="Segoe UI Variable Text" pitchFamily="34" charset="-122"/>
                 <a:cs typeface="Segoe UI Variable Text" pitchFamily="34" charset="-120"/>
               </a:rPr>
-              <a:t>Avec Hold up</a:t>
+              <a:t>Plus tard, ce site est piraté. Il te restait 50 USDC.</a:t>
+            </a:r>
+            <a:endParaRPr lang="en-US" sz="1400" dirty="0"/>
+          </a:p>
+        </p:txBody>
+      </p:sp>
+      <p:sp>
+        <p:nvSpPr>
+          <p:cNvPr id="11" name="Text 8"/>
+          <p:cNvSpPr txBox="1"/>
+          <p:nvPr/>
+        </p:nvSpPr>
+        <p:spPr>
+          <a:xfrm>
+            <a:off x="457200" y="2331720"/>
+            <a:ext cx="3840480" cy="320040"/>
+          </a:xfrm>
+          <a:prstGeom prst="rect">
+            <a:avLst/>
+          </a:prstGeom>
+          <a:noFill/>
+          <a:ln/>
+        </p:spPr>
+        <p:txBody>
+          <a:bodyPr wrap="square" lIns="0" tIns="0" rIns="0" bIns="0" rtlCol="0" anchor="t"/>
+          <a:lstStyle/>
+          <a:p>
+            <a:pPr indent="0" marL="0">
+              <a:buNone/>
+            </a:pPr>
+            <a:r>
+              <a:rPr lang="en-US" sz="1600" dirty="0">
+                <a:solidFill>
+                  <a:srgbClr val="B3B3B3"/>
+                </a:solidFill>
+                <a:latin typeface="Segoe UI Variable Text" pitchFamily="34" charset="0"/>
+                <a:ea typeface="Segoe UI Variable Text" pitchFamily="34" charset="-122"/>
+                <a:cs typeface="Segoe UI Variable Text" pitchFamily="34" charset="-120"/>
+              </a:rPr>
+              <a:t>Sans Hold up, il te reste</a:t>
             </a:r>
             <a:endParaRPr lang="en-US" sz="1600" dirty="0"/>
           </a:p>
@@ -2401,14 +2557,14 @@
       </p:sp>
       <p:sp>
         <p:nvSpPr>
-          <p:cNvPr id="9" name="Text 6"/>
-          <p:cNvSpPr txBox="1"/>
-          <p:nvPr/>
-        </p:nvSpPr>
-        <p:spPr>
-          <a:xfrm>
-            <a:off x="4846320" y="1691640"/>
-            <a:ext cx="3931920" cy="1371600"/>
+          <p:cNvPr id="12" name="Text 9"/>
+          <p:cNvSpPr txBox="1"/>
+          <p:nvPr/>
+        </p:nvSpPr>
+        <p:spPr>
+          <a:xfrm>
+            <a:off x="457200" y="2651760"/>
+            <a:ext cx="3931920" cy="914400"/>
           </a:xfrm>
           <a:prstGeom prst="rect">
             <a:avLst/>
@@ -2424,7 +2580,7 @@
               <a:buNone/>
             </a:pPr>
             <a:r>
-              <a:rPr lang="en-US" sz="6400" dirty="0">
+              <a:rPr lang="en-US" sz="6000" dirty="0">
                 <a:solidFill>
                   <a:srgbClr val="FFFFFF"/>
                 </a:solidFill>
@@ -2432,22 +2588,22 @@
                 <a:ea typeface="Segoe UI Variable Text Semibold" pitchFamily="34" charset="-122"/>
                 <a:cs typeface="Segoe UI Variable Text Semibold" pitchFamily="34" charset="-120"/>
               </a:rPr>
-              <a:t>50 → 50</a:t>
-            </a:r>
-            <a:endParaRPr lang="en-US" sz="6400" dirty="0"/>
-          </a:p>
-        </p:txBody>
-      </p:sp>
-      <p:sp>
-        <p:nvSpPr>
-          <p:cNvPr id="10" name="Text 7"/>
-          <p:cNvSpPr txBox="1"/>
-          <p:nvPr/>
-        </p:nvSpPr>
-        <p:spPr>
-          <a:xfrm>
-            <a:off x="4846320" y="2926080"/>
-            <a:ext cx="3657600" cy="731520"/>
+              <a:t>0 USDC</a:t>
+            </a:r>
+            <a:endParaRPr lang="en-US" sz="6000" dirty="0"/>
+          </a:p>
+        </p:txBody>
+      </p:sp>
+      <p:sp>
+        <p:nvSpPr>
+          <p:cNvPr id="13" name="Text 10"/>
+          <p:cNvSpPr txBox="1"/>
+          <p:nvPr/>
+        </p:nvSpPr>
+        <p:spPr>
+          <a:xfrm>
+            <a:off x="457200" y="3703320"/>
+            <a:ext cx="3840480" cy="365760"/>
           </a:xfrm>
           <a:prstGeom prst="rect">
             <a:avLst/>
@@ -2463,7 +2619,7 @@
               <a:buNone/>
             </a:pPr>
             <a:r>
-              <a:rPr lang="en-US" sz="1600" dirty="0">
+              <a:rPr lang="en-US" sz="1400" dirty="0">
                 <a:solidFill>
                   <a:srgbClr val="B3B3B3"/>
                 </a:solidFill>
@@ -2471,9 +2627,126 @@
                 <a:ea typeface="Segoe UI Variable Text" pitchFamily="34" charset="-122"/>
                 <a:cs typeface="Segoe UI Variable Text" pitchFamily="34" charset="-120"/>
               </a:rPr>
-              <a:t>Autorisation limitée à 50 USDC, consommée par l’échange : rien à prendre.</a:t>
+              <a:t>Le pirate se sert de l’accès illimité.</a:t>
+            </a:r>
+            <a:endParaRPr lang="en-US" sz="1400" dirty="0"/>
+          </a:p>
+        </p:txBody>
+      </p:sp>
+      <p:sp>
+        <p:nvSpPr>
+          <p:cNvPr id="14" name="Text 11"/>
+          <p:cNvSpPr txBox="1"/>
+          <p:nvPr/>
+        </p:nvSpPr>
+        <p:spPr>
+          <a:xfrm>
+            <a:off x="4846320" y="2331720"/>
+            <a:ext cx="3840480" cy="320040"/>
+          </a:xfrm>
+          <a:prstGeom prst="rect">
+            <a:avLst/>
+          </a:prstGeom>
+          <a:noFill/>
+          <a:ln/>
+        </p:spPr>
+        <p:txBody>
+          <a:bodyPr wrap="square" lIns="0" tIns="0" rIns="0" bIns="0" rtlCol="0" anchor="t"/>
+          <a:lstStyle/>
+          <a:p>
+            <a:pPr indent="0" marL="0">
+              <a:buNone/>
+            </a:pPr>
+            <a:r>
+              <a:rPr lang="en-US" sz="1600" dirty="0">
+                <a:solidFill>
+                  <a:srgbClr val="B3B3B3"/>
+                </a:solidFill>
+                <a:latin typeface="Segoe UI Variable Text" pitchFamily="34" charset="0"/>
+                <a:ea typeface="Segoe UI Variable Text" pitchFamily="34" charset="-122"/>
+                <a:cs typeface="Segoe UI Variable Text" pitchFamily="34" charset="-120"/>
+              </a:rPr>
+              <a:t>Avec Hold up, il te reste</a:t>
             </a:r>
             <a:endParaRPr lang="en-US" sz="1600" dirty="0"/>
+          </a:p>
+        </p:txBody>
+      </p:sp>
+      <p:sp>
+        <p:nvSpPr>
+          <p:cNvPr id="15" name="Text 12"/>
+          <p:cNvSpPr txBox="1"/>
+          <p:nvPr/>
+        </p:nvSpPr>
+        <p:spPr>
+          <a:xfrm>
+            <a:off x="4846320" y="2651760"/>
+            <a:ext cx="3931920" cy="914400"/>
+          </a:xfrm>
+          <a:prstGeom prst="rect">
+            <a:avLst/>
+          </a:prstGeom>
+          <a:noFill/>
+          <a:ln/>
+        </p:spPr>
+        <p:txBody>
+          <a:bodyPr wrap="square" lIns="0" tIns="0" rIns="0" bIns="0" rtlCol="0" anchor="t"/>
+          <a:lstStyle/>
+          <a:p>
+            <a:pPr indent="0" marL="0">
+              <a:buNone/>
+            </a:pPr>
+            <a:r>
+              <a:rPr lang="en-US" sz="6000" dirty="0">
+                <a:solidFill>
+                  <a:srgbClr val="FFFFFF"/>
+                </a:solidFill>
+                <a:latin typeface="Segoe UI Variable Text Semibold" pitchFamily="34" charset="0"/>
+                <a:ea typeface="Segoe UI Variable Text Semibold" pitchFamily="34" charset="-122"/>
+                <a:cs typeface="Segoe UI Variable Text Semibold" pitchFamily="34" charset="-120"/>
+              </a:rPr>
+              <a:t>50 USDC</a:t>
+            </a:r>
+            <a:endParaRPr lang="en-US" sz="6000" dirty="0"/>
+          </a:p>
+        </p:txBody>
+      </p:sp>
+      <p:sp>
+        <p:nvSpPr>
+          <p:cNvPr id="16" name="Text 13"/>
+          <p:cNvSpPr txBox="1"/>
+          <p:nvPr/>
+        </p:nvSpPr>
+        <p:spPr>
+          <a:xfrm>
+            <a:off x="4846320" y="3703320"/>
+            <a:ext cx="3840480" cy="548640"/>
+          </a:xfrm>
+          <a:prstGeom prst="rect">
+            <a:avLst/>
+          </a:prstGeom>
+          <a:noFill/>
+          <a:ln/>
+        </p:spPr>
+        <p:txBody>
+          <a:bodyPr wrap="square" lIns="0" tIns="0" rIns="0" bIns="0" rtlCol="0" anchor="t"/>
+          <a:lstStyle/>
+          <a:p>
+            <a:pPr indent="0" marL="0">
+              <a:buNone/>
+            </a:pPr>
+            <a:r>
+              <a:rPr lang="en-US" sz="1400" dirty="0">
+                <a:solidFill>
+                  <a:srgbClr val="B3B3B3"/>
+                </a:solidFill>
+                <a:latin typeface="Segoe UI Variable Text" pitchFamily="34" charset="0"/>
+                <a:ea typeface="Segoe UI Variable Text" pitchFamily="34" charset="-122"/>
+                <a:cs typeface="Segoe UI Variable Text" pitchFamily="34" charset="-120"/>
+              </a:rPr>
+              <a:t>Tu avais limité l’accès aux 50 de l’échange. Il n’y a plus rien à prendre.</a:t>
+            </a:r>
+            <a:endParaRPr lang="en-US" sz="1400" dirty="0"/>
           </a:p>
         </p:txBody>
       </p:sp>
@@ -3840,7 +4113,7 @@
                 <a:ea typeface="Segoe UI Variable Text Semibold" pitchFamily="34" charset="-122"/>
                 <a:cs typeface="Segoe UI Variable Text Semibold" pitchFamily="34" charset="-120"/>
               </a:rPr>
-              <a:t>Notre testeuse s’est fait</a:t>
+              <a:t>36 parcours. Notre testeuse</a:t>
             </a:r>
             <a:endParaRPr lang="en-US" sz="2800" dirty="0"/>
           </a:p>
@@ -3857,7 +4130,7 @@
                 <a:ea typeface="Segoe UI Variable Text Semibold" pitchFamily="34" charset="-122"/>
                 <a:cs typeface="Segoe UI Variable Text Semibold" pitchFamily="34" charset="-120"/>
               </a:rPr>
-              <a:t>piéger 4 fois</a:t>
+              <a:t>s’est fait piéger 4 fois.</a:t>
             </a:r>
             <a:endParaRPr lang="en-US" sz="2800" dirty="0"/>
           </a:p>
@@ -3910,8 +4183,8 @@
         </p:nvSpPr>
         <p:spPr>
           <a:xfrm>
-            <a:off x="457200" y="1600200"/>
-            <a:ext cx="4754880" cy="914400"/>
+            <a:off x="457200" y="1463040"/>
+            <a:ext cx="4937760" cy="1097280"/>
           </a:xfrm>
           <a:prstGeom prst="rect">
             <a:avLst/>
@@ -3927,7 +4200,7 @@
               <a:buNone/>
             </a:pPr>
             <a:r>
-              <a:rPr lang="en-US" sz="1600" dirty="0">
+              <a:rPr lang="en-US" sz="1400" dirty="0">
                 <a:solidFill>
                   <a:srgbClr val="B3B3B3"/>
                 </a:solidFill>
@@ -3935,9 +4208,9 @@
                 <a:ea typeface="Segoe UI Variable Text" pitchFamily="34" charset="-122"/>
                 <a:cs typeface="Segoe UI Variable Text" pitchFamily="34" charset="-120"/>
               </a:rPr>
-              <a:t>Un agent qui joue une personne prudente, au clavier. « Continuer » était actif tout de suite. Corrigé depuis.</a:t>
-            </a:r>
-            <a:endParaRPr lang="en-US" sz="1600" dirty="0"/>
+              <a:t>Les 4 fois, elle avait lu « Ça ne correspond pas » et appuyé sur « Continuer » quand même. Jamais piégée sans ce geste. La testeuse est un agent qui joue une personne prudente, au clavier.</a:t>
+            </a:r>
+            <a:endParaRPr lang="en-US" sz="1400" dirty="0"/>
           </a:p>
         </p:txBody>
       </p:sp>
@@ -4017,26 +4290,6 @@
                 <a:cs typeface="Segoe UI Variable Text" pitchFamily="34" charset="-120"/>
               </a:rPr>
               <a:t>Je ne vérifie pas ce que tu reçois en échange.</a:t>
-            </a:r>
-            <a:endParaRPr lang="en-US" sz="1600" dirty="0"/>
-          </a:p>
-          <a:p>
-            <a:pPr indent="0" marL="0">
-              <a:spcAft>
-                <a:spcPts val="800"/>
-              </a:spcAft>
-              <a:buNone/>
-            </a:pPr>
-            <a:r>
-              <a:rPr lang="en-US" sz="1600" dirty="0">
-                <a:solidFill>
-                  <a:srgbClr val="B3B3B3"/>
-                </a:solidFill>
-                <a:latin typeface="Segoe UI Variable Text" pitchFamily="34" charset="0"/>
-                <a:ea typeface="Segoe UI Variable Text" pitchFamily="34" charset="-122"/>
-                <a:cs typeface="Segoe UI Variable Text" pitchFamily="34" charset="-120"/>
-              </a:rPr>
-              <a:t>Je n’ai jamais été essayé devant un vrai MetaMask.</a:t>
             </a:r>
             <a:endParaRPr lang="en-US" sz="1600" dirty="0"/>
           </a:p>

</xml_diff>

<commit_message>
deck: slide 1 on LI.FI, duplicate slide removed (7 slides)
Co-Authored-By: Claude Opus 5.5 <noreply@anthropic.com>
</commit_message>
<xml_diff>
--- a/livrables/deck/holdup.pptx
+++ b/livrables/deck/holdup.pptx
@@ -12,10 +12,9 @@
     <p:sldId id="260" r:id="rId6"/>
     <p:sldId id="261" r:id="rId7"/>
     <p:sldId id="262" r:id="rId8"/>
-    <p:sldId id="263" r:id="rId9"/>
   </p:sldIdLst>
   <p:notesMasterIdLst>
-    <p:notesMasterId r:id="rId10"/>
+    <p:notesMasterId r:id="rId9"/>
   </p:notesMasterIdLst>
   <p:sldSz cx="9144000" cy="5143500"/>
   <p:notesSz cx="5143500" cy="9144000"/>
@@ -509,7 +508,7 @@
           <a:p>
             <a:r>
               <a:rPr lang="en-US" dirty="0"/>
-              <a:t>Trame d'Adem (livrables/pitch_v7/PITCH_ADEM.md) : en 2026, on ne peut plus promettre qu'un site est sûr. 21 novembre 2025, le site d'Aerodrome est détourné (DNS modifié) : 81 minutes entre le changement et le signalement du domaine, environ 700 000 $ de pertes. Mesure de Blockaid sur son propre délai : source intéressée, le dire si on demande. Postulat : tout service en ligne finira par être compromis ; la question devient « qu'est-ce que je lui ai laissé le droit de prendre ce jour-là ». Sur Avalanche C-Chain, 34,2 % [33,6 ; 34,9] des droits de dépense non nuls lus sont illimités (7 103 sur 20 753) : mesure interne, des événements et non des personnes. Nous adressons Avalanche : ne pas citer Ethereum. Aerodrome n'est pas sur Avalanche : c'est un exemple de site détourné, pas une mesure de notre chaîne. CHIFFRES.md B16 et B1.</a:t>
+              <a:t>Trame d'Adem (livrables/pitch_v7/PITCH_ADEM.md, bloc 2). LI.FI, 16 juillet 2024 : 11,6 M$ pris à 153 portefeuilles qui avaient laissé une approbation illimitée, rien aux approbations finies, selon le rapport de LI.FI (li.fi/knowledge-hub/incident-report-16th-july, source éditeur ; CHIFFRES.md B7). À dire si on le demande : le montant fini était déjà le réglage par défaut de LI.FI, les 153 avaient choisi l'illimité ; et c'est sur plusieurs chaînes, pas un chiffre Avalanche. Postulat : tout service en ligne finira par être piraté ; la question devient « qu'est-ce que je lui ai laissé le droit de prendre ce jour-là ». Sur Avalanche C-Chain, 34,2 % [33,6 ; 34,9] des droits de dépense non nuls lus sont illimités (7 103 sur 20 753) : mesure interne, des événements et non des personnes. Ne pas citer Ethereum.</a:t>
             </a:r>
             <a:endParaRPr lang="en-US" dirty="0"/>
           </a:p>
@@ -861,7 +860,7 @@
           <a:p>
             <a:r>
               <a:rPr lang="en-US" dirty="0"/>
-              <a:t>LI.FI, 16 juillet 2024 : 11,6 M$ pris à 153 portefeuilles en approbation illimitée, rien aux approbations finies, selon le rapport de LI.FI (source éditeur). Les victimes avaient choisi l'illimité alors que le défaut était fini. Chiffres sur la slide, pas à l'oral (quatre chiffres seulement).</a:t>
+              <a:t>250 cas (150 arnaques, 100 jumeaux honnêtes), écrits sans lire nos règles, sha256 publié, ouverts une fois le 11 oct. 2026, moteur figé. Signalé = avertissement ou rouge. Code seul : 87,3 % [81,1 ; 91,7], faux rouges 15,0 % [9,3 ; 23,3]. Sans phrase : 64,7 %. Critères publiés avant : rappel au moins 80 % atteint, faux rouges au plus 10 % non atteint. 11 des 15 faux rouges : achat NFT à prix quasi nul. Ces chiffres mesurent le moteur de comparaison côté serveur (blind_decalage/run/chaine/), en Node, pas l'extension livrée : ne jamais dire « l'extension attrape 87 % ». Ne pas citer A11 ni A12 de CHIFFRES.md comme mesure du produit (rejoué sur le build réel : 38,2 % et 9,1 %, preuves/ECARTS_LIVRABLES.md). Limite : auteur de la même famille de modèles que ceux qui nous ont aidés ; cas synthétiques. Ne plus citer le 1,3 %.</a:t>
             </a:r>
             <a:endParaRPr lang="en-US" dirty="0"/>
           </a:p>
@@ -949,7 +948,7 @@
           <a:p>
             <a:r>
               <a:rPr lang="en-US" dirty="0"/>
-              <a:t>250 cas (150 arnaques, 100 jumeaux honnêtes), écrits sans lire nos règles, sha256 publié, ouverts une fois le 11 oct. 2026, moteur figé. Signalé = avertissement ou rouge. Code seul : 87,3 % [81,1 ; 91,7], faux rouges 15,0 % [9,3 ; 23,3]. Sans phrase : 64,7 %. Critères publiés avant : rappel au moins 80 % atteint, faux rouges au plus 10 % non atteint. 11 des 15 faux rouges : achat NFT à prix quasi nul. Ces chiffres mesurent le moteur de comparaison côté serveur (blind_decalage/run/chaine/), en Node, pas l'extension livrée : ne jamais dire « l'extension attrape 87 % ». Ne pas citer A11 ni A12 de CHIFFRES.md comme mesure du produit (rejoué sur le build réel : 38,2 % et 9,1 %, preuves/ECARTS_LIVRABLES.md). Limite : auteur de la même famille de modèles que ceux qui nous ont aidés ; cas synthétiques. Ne plus citer le 1,3 %.</a:t>
+              <a:t>La testeuse est un agent qui joue une personne prudente, au clavier : 36 parcours, piégée 4 fois en appuyant sur Continuer, actif tout de suite sur « Ça ne correspond pas » (capture réelle de l'extension, coord/reports/testeurs/3_captures/s05_08_f1_continuer_actif.png). Corrigé dans le commit b42792d : le geste attend, la demande expire à 3 minutes. Tests unitaires de l'extension rejoués le 11 oct. à 10h49 sur l'arbre de travail : 225 tests, 213 réussis, 12 en échec ; ne pas citer « 217 tests » sans le rejouer. Sur 58 paires d'essai : 18 contrôlées, 7 en partie, 20 non, 13 non distinguées (EXHAUSTIVITE_INTENTION.md). Hors périmètre : fraude voulue, Ledger direct, téléphone. Jamais essayé avec un vrai MetaMask. Ne pas dire « sécurisé ».</a:t>
             </a:r>
             <a:endParaRPr lang="en-US" dirty="0"/>
           </a:p>
@@ -1037,7 +1036,7 @@
           <a:p>
             <a:r>
               <a:rPr lang="en-US" dirty="0"/>
-              <a:t>La testeuse est un agent qui joue une personne prudente, au clavier : 36 parcours, piégée 4 fois en appuyant sur Continuer, actif tout de suite sur « Ça ne correspond pas » (capture réelle de l'extension, coord/reports/testeurs/3_captures/s05_08_f1_continuer_actif.png). Corrigé dans le commit b42792d : le geste attend, la demande expire à 3 minutes. Tests unitaires de l'extension rejoués le 11 oct. à 10h49 sur l'arbre de travail : 225 tests, 213 réussis, 12 en échec ; ne pas citer « 217 tests » sans le rejouer. Sur 58 paires d'essai : 18 contrôlées, 7 en partie, 20 non, 13 non distinguées (EXHAUSTIVITE_INTENTION.md). Hors périmètre : fraude voulue, Ledger direct, téléphone. Jamais essayé avec un vrai MetaMask. Ne pas dire « sécurisé ».</a:t>
+              <a:t>Modèle : gratuit pour la personne. Paient ceux qui portent la perte : API « verdict avant retrait » pour exchanges et fintechs ; licence SDK pour portefeuilles ; mandats pour agents qui dépensent (prospectif, à 2 ans). Piste étudiée (BM_LABEL.md) : mesurer les plateformes qui ne demandent que le nécessaire ; la mesure est gratuite, publique, et ne s'achète pas. Ne pas dire « certification ». Prix : hypothèses, aucun client. Pilotes recherchés. Promesse de Titouan : cesser de donner plus que nécessaire. Fin d'Adem : on ne sait pas quel site sera piraté, on décide de ce qu'on lui laisse.</a:t>
             </a:r>
             <a:endParaRPr lang="en-US" dirty="0"/>
           </a:p>
@@ -1061,94 +1060,6 @@
             <a:fld id="{F7021451-1387-4CA6-816F-3879F97B5CBC}" type="slidenum">
               <a:rPr lang="en-US"/>
               <a:t>7</a:t>
-            </a:fld>
-            <a:endParaRPr lang="en-US"/>
-          </a:p>
-        </p:txBody>
-      </p:sp>
-    </p:spTree>
-    <p:extLst>
-      <p:ext uri="{BB962C8B-B14F-4D97-AF65-F5344CB8AC3E}">
-        <p14:creationId xmlns:p14="http://schemas.microsoft.com/office/powerpoint/2010/main" val="1024086991"/>
-      </p:ext>
-    </p:extLst>
-  </p:cSld>
-  <p:clrMapOvr>
-    <a:masterClrMapping/>
-  </p:clrMapOvr>
-</p:notes>
-</file>
-
-<file path=ppt/notesSlides/notesSlide8.xml><?xml version="1.0" encoding="utf-8"?>
-<p:notes xmlns:a="http://schemas.openxmlformats.org/drawingml/2006/main" xmlns:r="http://schemas.openxmlformats.org/officeDocument/2006/relationships" xmlns:p="http://schemas.openxmlformats.org/presentationml/2006/main">
-  <p:cSld>
-    <p:spTree>
-      <p:nvGrpSpPr>
-        <p:cNvPr id="1" name=""/>
-        <p:cNvGrpSpPr/>
-        <p:nvPr/>
-      </p:nvGrpSpPr>
-      <p:grpSpPr>
-        <a:xfrm>
-          <a:off x="0" y="0"/>
-          <a:ext cx="0" cy="0"/>
-          <a:chOff x="0" y="0"/>
-          <a:chExt cx="0" cy="0"/>
-        </a:xfrm>
-      </p:grpSpPr>
-      <p:sp>
-        <p:nvSpPr>
-          <p:cNvPr id="2" name="Slide Image Placeholder 1"/>
-          <p:cNvSpPr>
-            <a:spLocks noGrp="1" noRot="1" noChangeAspect="1"/>
-          </p:cNvSpPr>
-          <p:nvPr>
-            <p:ph type="sldImg"/>
-          </p:nvPr>
-        </p:nvSpPr>
-        <p:spPr/>
-      </p:sp>
-      <p:sp>
-        <p:nvSpPr>
-          <p:cNvPr id="3" name="Notes Placeholder 2"/>
-          <p:cNvSpPr>
-            <a:spLocks noGrp="1"/>
-          </p:cNvSpPr>
-          <p:nvPr>
-            <p:ph type="body" idx="1"/>
-          </p:nvPr>
-        </p:nvSpPr>
-        <p:spPr/>
-        <p:txBody>
-          <a:bodyPr/>
-          <a:lstStyle/>
-          <a:p>
-            <a:r>
-              <a:rPr lang="en-US" dirty="0"/>
-              <a:t>Modèle : gratuit pour la personne. Paient ceux qui portent la perte : API « verdict avant retrait » pour exchanges et fintechs ; licence SDK pour portefeuilles ; mandats pour agents qui dépensent (prospectif, à 2 ans). Piste étudiée (BM_LABEL.md) : mesurer les plateformes qui ne demandent que le nécessaire ; la mesure est gratuite, publique, et ne s'achète pas. Ne pas dire « certification ». Prix : hypothèses, aucun client. Pilotes recherchés. Promesse de Titouan : cesser de donner plus que nécessaire. Fin d'Adem : on ne sait pas quel site sera piraté, on décide de ce qu'on lui laisse.</a:t>
-            </a:r>
-            <a:endParaRPr lang="en-US" dirty="0"/>
-          </a:p>
-        </p:txBody>
-      </p:sp>
-      <p:sp>
-        <p:nvSpPr>
-          <p:cNvPr id="4" name="Slide Number Placeholder 3"/>
-          <p:cNvSpPr>
-            <a:spLocks noGrp="1"/>
-          </p:cNvSpPr>
-          <p:nvPr>
-            <p:ph type="sldNum" sz="quarter" idx="10"/>
-          </p:nvPr>
-        </p:nvSpPr>
-        <p:spPr/>
-        <p:txBody>
-          <a:bodyPr/>
-          <a:lstStyle/>
-          <a:p>
-            <a:fld id="{F7021451-1387-4CA6-816F-3879F97B5CBC}" type="slidenum">
-              <a:rPr lang="en-US"/>
-              <a:t>8</a:t>
             </a:fld>
             <a:endParaRPr lang="en-US"/>
           </a:p>
@@ -1667,8 +1578,8 @@
         </p:nvSpPr>
         <p:spPr>
           <a:xfrm>
-            <a:off x="457200" y="685800"/>
-            <a:ext cx="8229600" cy="1645920"/>
+            <a:off x="457200" y="548640"/>
+            <a:ext cx="8229600" cy="1828800"/>
           </a:xfrm>
           <a:prstGeom prst="rect">
             <a:avLst/>
@@ -1684,7 +1595,7 @@
               <a:buNone/>
             </a:pPr>
             <a:r>
-              <a:rPr lang="en-US" sz="11000" dirty="0">
+              <a:rPr lang="en-US" sz="13000" dirty="0">
                 <a:solidFill>
                   <a:srgbClr val="FFFFFF"/>
                 </a:solidFill>
@@ -1692,9 +1603,9 @@
                 <a:ea typeface="Segoe UI Variable Text Semibold" pitchFamily="34" charset="-122"/>
                 <a:cs typeface="Segoe UI Variable Text Semibold" pitchFamily="34" charset="-120"/>
               </a:rPr>
-              <a:t>81 minutes</a:t>
-            </a:r>
-            <a:endParaRPr lang="en-US" sz="11000" dirty="0"/>
+              <a:t>153</a:t>
+            </a:r>
+            <a:endParaRPr lang="en-US" sz="13000" dirty="0"/>
           </a:p>
         </p:txBody>
       </p:sp>
@@ -1731,7 +1642,7 @@
                 <a:ea typeface="Segoe UI Variable Text Semibold" pitchFamily="34" charset="-122"/>
                 <a:cs typeface="Segoe UI Variable Text Semibold" pitchFamily="34" charset="-120"/>
               </a:rPr>
-              <a:t>Aerodrome est piraté. Personne ne le signale pendant 81 minutes.</a:t>
+              <a:t>portefeuilles vidés chez LI.FI en juillet 2024 : 11,6 millions de dollars.</a:t>
             </a:r>
             <a:endParaRPr lang="en-US" sz="2000" dirty="0"/>
           </a:p>
@@ -1770,7 +1681,7 @@
                 <a:ea typeface="Segoe UI Variable Text" pitchFamily="34" charset="-122"/>
                 <a:cs typeface="Segoe UI Variable Text" pitchFamily="34" charset="-120"/>
               </a:rPr>
-              <a:t>Novembre 2025. Tout service en ligne finira par être piraté.</a:t>
+              <a:t>Tous avaient laissé une autorisation illimitée. Ceux qui l’avaient limitée n’ont rien perdu.</a:t>
             </a:r>
             <a:endParaRPr lang="en-US" sz="1600" dirty="0"/>
           </a:p>
@@ -3126,7 +3037,7 @@
                 <a:ea typeface="Segoe UI Variable Text Semibold" pitchFamily="34" charset="-122"/>
                 <a:cs typeface="Segoe UI Variable Text Semibold" pitchFamily="34" charset="-120"/>
               </a:rPr>
-              <a:t>C’est déjà arrivé : LI.FI, juillet 2024</a:t>
+              <a:t>Jeu aveugle : 250 cas, moteur de comparaison</a:t>
             </a:r>
             <a:endParaRPr lang="en-US" sz="2800" dirty="0"/>
           </a:p>
@@ -3165,7 +3076,7 @@
                 <a:ea typeface="Segoe UI Variable Text" pitchFamily="34" charset="-122"/>
                 <a:cs typeface="Segoe UI Variable Text" pitchFamily="34" charset="-120"/>
               </a:rPr>
-              <a:t>Dans le dépôt : livrables/CHIFFRES.md, ligne B7. Rapport : li.fi/knowledge-hub/incident-report-16th-july</a:t>
+              <a:t>Dans le dépôt : research/titouan/T_banc_e2e/blind_decalage/run/RESULTAT.md, preuves/ECARTS_LIVRABLES.md</a:t>
             </a:r>
             <a:endParaRPr lang="en-US" sz="1100" dirty="0"/>
           </a:p>
@@ -3179,8 +3090,8 @@
         </p:nvSpPr>
         <p:spPr>
           <a:xfrm>
-            <a:off x="457200" y="1463040"/>
-            <a:ext cx="3931920" cy="365760"/>
+            <a:off x="457200" y="1188720"/>
+            <a:ext cx="8229600" cy="320040"/>
           </a:xfrm>
           <a:prstGeom prst="rect">
             <a:avLst/>
@@ -3196,7 +3107,7 @@
               <a:buNone/>
             </a:pPr>
             <a:r>
-              <a:rPr lang="en-US" sz="1600" dirty="0">
+              <a:rPr lang="en-US" sz="1400" dirty="0">
                 <a:solidFill>
                   <a:srgbClr val="B3B3B3"/>
                 </a:solidFill>
@@ -3204,7 +3115,46 @@
                 <a:ea typeface="Segoe UI Variable Text" pitchFamily="34" charset="-122"/>
                 <a:cs typeface="Segoe UI Variable Text" pitchFamily="34" charset="-120"/>
               </a:rPr>
-              <a:t>Autorisations illimitées</a:t>
+              <a:t>Arnaques signalées</a:t>
+            </a:r>
+            <a:endParaRPr lang="en-US" sz="1400" dirty="0"/>
+          </a:p>
+        </p:txBody>
+      </p:sp>
+      <p:sp>
+        <p:nvSpPr>
+          <p:cNvPr id="6" name="Text 3"/>
+          <p:cNvSpPr txBox="1"/>
+          <p:nvPr/>
+        </p:nvSpPr>
+        <p:spPr>
+          <a:xfrm>
+            <a:off x="457200" y="1554480"/>
+            <a:ext cx="2377440" cy="457200"/>
+          </a:xfrm>
+          <a:prstGeom prst="rect">
+            <a:avLst/>
+          </a:prstGeom>
+          <a:noFill/>
+          <a:ln/>
+        </p:spPr>
+        <p:txBody>
+          <a:bodyPr wrap="square" lIns="0" tIns="0" rIns="0" bIns="0" rtlCol="0" anchor="ctr"/>
+          <a:lstStyle/>
+          <a:p>
+            <a:pPr indent="0" marL="0">
+              <a:buNone/>
+            </a:pPr>
+            <a:r>
+              <a:rPr lang="en-US" sz="1600" dirty="0">
+                <a:solidFill>
+                  <a:srgbClr val="B3B3B3"/>
+                </a:solidFill>
+                <a:latin typeface="Segoe UI Variable Text" pitchFamily="34" charset="0"/>
+                <a:ea typeface="Segoe UI Variable Text" pitchFamily="34" charset="-122"/>
+                <a:cs typeface="Segoe UI Variable Text" pitchFamily="34" charset="-120"/>
+              </a:rPr>
+              <a:t>Sans la phrase</a:t>
             </a:r>
             <a:endParaRPr lang="en-US" sz="1600" dirty="0"/>
           </a:p>
@@ -3212,62 +3162,87 @@
       </p:sp>
       <p:sp>
         <p:nvSpPr>
-          <p:cNvPr id="6" name="Text 3"/>
-          <p:cNvSpPr txBox="1"/>
-          <p:nvPr/>
-        </p:nvSpPr>
-        <p:spPr>
-          <a:xfrm>
-            <a:off x="457200" y="1828800"/>
-            <a:ext cx="3931920" cy="1188720"/>
-          </a:xfrm>
-          <a:prstGeom prst="rect">
-            <a:avLst/>
-          </a:prstGeom>
-          <a:noFill/>
-          <a:ln/>
-        </p:spPr>
-        <p:txBody>
-          <a:bodyPr wrap="square" lIns="0" tIns="0" rIns="0" bIns="0" rtlCol="0" anchor="t"/>
-          <a:lstStyle/>
-          <a:p>
-            <a:pPr indent="0" marL="0">
-              <a:buNone/>
-            </a:pPr>
-            <a:r>
-              <a:rPr lang="en-US" sz="6000" dirty="0">
-                <a:solidFill>
-                  <a:srgbClr val="FFFFFF"/>
+          <p:cNvPr id="7" name="Shape 4"/>
+          <p:cNvSpPr/>
+          <p:nvPr/>
+        </p:nvSpPr>
+        <p:spPr>
+          <a:xfrm>
+            <a:off x="2926080" y="1609344"/>
+            <a:ext cx="2958084" cy="347472"/>
+          </a:xfrm>
+          <a:prstGeom prst="rect">
+            <a:avLst/>
+          </a:prstGeom>
+          <a:solidFill>
+            <a:srgbClr val="808080"/>
+          </a:solidFill>
+          <a:ln w="12700">
+            <a:solidFill>
+              <a:srgbClr val="808080"/>
+            </a:solidFill>
+            <a:prstDash val="solid"/>
+          </a:ln>
+        </p:spPr>
+      </p:sp>
+      <p:sp>
+        <p:nvSpPr>
+          <p:cNvPr id="8" name="Text 5"/>
+          <p:cNvSpPr txBox="1"/>
+          <p:nvPr/>
+        </p:nvSpPr>
+        <p:spPr>
+          <a:xfrm>
+            <a:off x="6021324" y="1554480"/>
+            <a:ext cx="1280160" cy="457200"/>
+          </a:xfrm>
+          <a:prstGeom prst="rect">
+            <a:avLst/>
+          </a:prstGeom>
+          <a:noFill/>
+          <a:ln/>
+        </p:spPr>
+        <p:txBody>
+          <a:bodyPr wrap="square" lIns="0" tIns="0" rIns="0" bIns="0" rtlCol="0" anchor="ctr"/>
+          <a:lstStyle/>
+          <a:p>
+            <a:pPr indent="0" marL="0">
+              <a:buNone/>
+            </a:pPr>
+            <a:r>
+              <a:rPr lang="en-US" sz="2600" dirty="0">
+                <a:solidFill>
+                  <a:srgbClr val="808080"/>
                 </a:solidFill>
                 <a:latin typeface="Segoe UI Variable Text Semibold" pitchFamily="34" charset="0"/>
                 <a:ea typeface="Segoe UI Variable Text Semibold" pitchFamily="34" charset="-122"/>
                 <a:cs typeface="Segoe UI Variable Text Semibold" pitchFamily="34" charset="-120"/>
               </a:rPr>
-              <a:t>vidées</a:t>
-            </a:r>
-            <a:endParaRPr lang="en-US" sz="6000" dirty="0"/>
-          </a:p>
-        </p:txBody>
-      </p:sp>
-      <p:sp>
-        <p:nvSpPr>
-          <p:cNvPr id="7" name="Text 4"/>
-          <p:cNvSpPr txBox="1"/>
-          <p:nvPr/>
-        </p:nvSpPr>
-        <p:spPr>
-          <a:xfrm>
-            <a:off x="4846320" y="1463040"/>
-            <a:ext cx="3840480" cy="365760"/>
-          </a:xfrm>
-          <a:prstGeom prst="rect">
-            <a:avLst/>
-          </a:prstGeom>
-          <a:noFill/>
-          <a:ln/>
-        </p:spPr>
-        <p:txBody>
-          <a:bodyPr wrap="square" lIns="0" tIns="0" rIns="0" bIns="0" rtlCol="0" anchor="t"/>
+              <a:t>65 %</a:t>
+            </a:r>
+            <a:endParaRPr lang="en-US" sz="2600" dirty="0"/>
+          </a:p>
+        </p:txBody>
+      </p:sp>
+      <p:sp>
+        <p:nvSpPr>
+          <p:cNvPr id="9" name="Text 6"/>
+          <p:cNvSpPr txBox="1"/>
+          <p:nvPr/>
+        </p:nvSpPr>
+        <p:spPr>
+          <a:xfrm>
+            <a:off x="457200" y="2057400"/>
+            <a:ext cx="2377440" cy="457200"/>
+          </a:xfrm>
+          <a:prstGeom prst="rect">
+            <a:avLst/>
+          </a:prstGeom>
+          <a:noFill/>
+          <a:ln/>
+        </p:spPr>
+        <p:txBody>
+          <a:bodyPr wrap="square" lIns="0" tIns="0" rIns="0" bIns="0" rtlCol="0" anchor="ctr"/>
           <a:lstStyle/>
           <a:p>
             <a:pPr indent="0" marL="0">
@@ -3282,7 +3257,7 @@
                 <a:ea typeface="Segoe UI Variable Text" pitchFamily="34" charset="-122"/>
                 <a:cs typeface="Segoe UI Variable Text" pitchFamily="34" charset="-120"/>
               </a:rPr>
-              <a:t>Autorisations limitées</a:t>
+              <a:t>Avec la phrase</a:t>
             </a:r>
             <a:endParaRPr lang="en-US" sz="1600" dirty="0"/>
           </a:p>
@@ -3290,30 +3265,55 @@
       </p:sp>
       <p:sp>
         <p:nvSpPr>
-          <p:cNvPr id="8" name="Text 5"/>
-          <p:cNvSpPr txBox="1"/>
-          <p:nvPr/>
-        </p:nvSpPr>
-        <p:spPr>
-          <a:xfrm>
-            <a:off x="4846320" y="1828800"/>
-            <a:ext cx="3931920" cy="1188720"/>
-          </a:xfrm>
-          <a:prstGeom prst="rect">
-            <a:avLst/>
-          </a:prstGeom>
-          <a:noFill/>
-          <a:ln/>
-        </p:spPr>
-        <p:txBody>
-          <a:bodyPr wrap="square" lIns="0" tIns="0" rIns="0" bIns="0" rtlCol="0" anchor="t"/>
-          <a:lstStyle/>
-          <a:p>
-            <a:pPr indent="0" marL="0">
-              <a:buNone/>
-            </a:pPr>
-            <a:r>
-              <a:rPr lang="en-US" sz="6000" dirty="0">
+          <p:cNvPr id="10" name="Shape 7"/>
+          <p:cNvSpPr/>
+          <p:nvPr/>
+        </p:nvSpPr>
+        <p:spPr>
+          <a:xfrm>
+            <a:off x="2926080" y="2112264"/>
+            <a:ext cx="3991356" cy="347472"/>
+          </a:xfrm>
+          <a:prstGeom prst="rect">
+            <a:avLst/>
+          </a:prstGeom>
+          <a:solidFill>
+            <a:srgbClr val="FFFFFF"/>
+          </a:solidFill>
+          <a:ln w="12700">
+            <a:solidFill>
+              <a:srgbClr val="FFFFFF"/>
+            </a:solidFill>
+            <a:prstDash val="solid"/>
+          </a:ln>
+        </p:spPr>
+      </p:sp>
+      <p:sp>
+        <p:nvSpPr>
+          <p:cNvPr id="11" name="Text 8"/>
+          <p:cNvSpPr txBox="1"/>
+          <p:nvPr/>
+        </p:nvSpPr>
+        <p:spPr>
+          <a:xfrm>
+            <a:off x="7054596" y="2057400"/>
+            <a:ext cx="1280160" cy="457200"/>
+          </a:xfrm>
+          <a:prstGeom prst="rect">
+            <a:avLst/>
+          </a:prstGeom>
+          <a:noFill/>
+          <a:ln/>
+        </p:spPr>
+        <p:txBody>
+          <a:bodyPr wrap="square" lIns="0" tIns="0" rIns="0" bIns="0" rtlCol="0" anchor="ctr"/>
+          <a:lstStyle/>
+          <a:p>
+            <a:pPr indent="0" marL="0">
+              <a:buNone/>
+            </a:pPr>
+            <a:r>
+              <a:rPr lang="en-US" sz="2600" dirty="0">
                 <a:solidFill>
                   <a:srgbClr val="FFFFFF"/>
                 </a:solidFill>
@@ -3321,22 +3321,22 @@
                 <a:ea typeface="Segoe UI Variable Text Semibold" pitchFamily="34" charset="-122"/>
                 <a:cs typeface="Segoe UI Variable Text Semibold" pitchFamily="34" charset="-120"/>
               </a:rPr>
-              <a:t>rien perdu</a:t>
-            </a:r>
-            <a:endParaRPr lang="en-US" sz="6000" dirty="0"/>
-          </a:p>
-        </p:txBody>
-      </p:sp>
-      <p:sp>
-        <p:nvSpPr>
-          <p:cNvPr id="9" name="Text 6"/>
-          <p:cNvSpPr txBox="1"/>
-          <p:nvPr/>
-        </p:nvSpPr>
-        <p:spPr>
-          <a:xfrm>
-            <a:off x="457200" y="3474720"/>
-            <a:ext cx="8229600" cy="365760"/>
+              <a:t>87 %</a:t>
+            </a:r>
+            <a:endParaRPr lang="en-US" sz="2600" dirty="0"/>
+          </a:p>
+        </p:txBody>
+      </p:sp>
+      <p:sp>
+        <p:nvSpPr>
+          <p:cNvPr id="12" name="Text 9"/>
+          <p:cNvSpPr txBox="1"/>
+          <p:nvPr/>
+        </p:nvSpPr>
+        <p:spPr>
+          <a:xfrm>
+            <a:off x="457200" y="2788920"/>
+            <a:ext cx="8229600" cy="320040"/>
           </a:xfrm>
           <a:prstGeom prst="rect">
             <a:avLst/>
@@ -3352,7 +3352,7 @@
               <a:buNone/>
             </a:pPr>
             <a:r>
-              <a:rPr lang="en-US" sz="1600" dirty="0">
+              <a:rPr lang="en-US" sz="1400" dirty="0">
                 <a:solidFill>
                   <a:srgbClr val="B3B3B3"/>
                 </a:solidFill>
@@ -3360,9 +3360,215 @@
                 <a:ea typeface="Segoe UI Variable Text" pitchFamily="34" charset="-122"/>
                 <a:cs typeface="Segoe UI Variable Text" pitchFamily="34" charset="-120"/>
               </a:rPr>
-              <a:t>153 portefeuilles, 11,6 M$, selon le rapport de LI.FI.</a:t>
+              <a:t>Opérations honnêtes arrêtées à tort</a:t>
+            </a:r>
+            <a:endParaRPr lang="en-US" sz="1400" dirty="0"/>
+          </a:p>
+        </p:txBody>
+      </p:sp>
+      <p:sp>
+        <p:nvSpPr>
+          <p:cNvPr id="13" name="Text 10"/>
+          <p:cNvSpPr txBox="1"/>
+          <p:nvPr/>
+        </p:nvSpPr>
+        <p:spPr>
+          <a:xfrm>
+            <a:off x="457200" y="3154680"/>
+            <a:ext cx="2377440" cy="457200"/>
+          </a:xfrm>
+          <a:prstGeom prst="rect">
+            <a:avLst/>
+          </a:prstGeom>
+          <a:noFill/>
+          <a:ln/>
+        </p:spPr>
+        <p:txBody>
+          <a:bodyPr wrap="square" lIns="0" tIns="0" rIns="0" bIns="0" rtlCol="0" anchor="ctr"/>
+          <a:lstStyle/>
+          <a:p>
+            <a:pPr indent="0" marL="0">
+              <a:buNone/>
+            </a:pPr>
+            <a:r>
+              <a:rPr lang="en-US" sz="1600" dirty="0">
+                <a:solidFill>
+                  <a:srgbClr val="B3B3B3"/>
+                </a:solidFill>
+                <a:latin typeface="Segoe UI Variable Text" pitchFamily="34" charset="0"/>
+                <a:ea typeface="Segoe UI Variable Text" pitchFamily="34" charset="-122"/>
+                <a:cs typeface="Segoe UI Variable Text" pitchFamily="34" charset="-120"/>
+              </a:rPr>
+              <a:t>Seuil fixé avant</a:t>
             </a:r>
             <a:endParaRPr lang="en-US" sz="1600" dirty="0"/>
+          </a:p>
+        </p:txBody>
+      </p:sp>
+      <p:sp>
+        <p:nvSpPr>
+          <p:cNvPr id="14" name="Shape 11"/>
+          <p:cNvSpPr/>
+          <p:nvPr/>
+        </p:nvSpPr>
+        <p:spPr>
+          <a:xfrm>
+            <a:off x="2926080" y="3209544"/>
+            <a:ext cx="457200" cy="347472"/>
+          </a:xfrm>
+          <a:prstGeom prst="rect">
+            <a:avLst/>
+          </a:prstGeom>
+          <a:solidFill>
+            <a:srgbClr val="808080"/>
+          </a:solidFill>
+          <a:ln w="12700">
+            <a:solidFill>
+              <a:srgbClr val="808080"/>
+            </a:solidFill>
+            <a:prstDash val="solid"/>
+          </a:ln>
+        </p:spPr>
+      </p:sp>
+      <p:sp>
+        <p:nvSpPr>
+          <p:cNvPr id="15" name="Text 12"/>
+          <p:cNvSpPr txBox="1"/>
+          <p:nvPr/>
+        </p:nvSpPr>
+        <p:spPr>
+          <a:xfrm>
+            <a:off x="3520440" y="3154680"/>
+            <a:ext cx="1280160" cy="457200"/>
+          </a:xfrm>
+          <a:prstGeom prst="rect">
+            <a:avLst/>
+          </a:prstGeom>
+          <a:noFill/>
+          <a:ln/>
+        </p:spPr>
+        <p:txBody>
+          <a:bodyPr wrap="square" lIns="0" tIns="0" rIns="0" bIns="0" rtlCol="0" anchor="ctr"/>
+          <a:lstStyle/>
+          <a:p>
+            <a:pPr indent="0" marL="0">
+              <a:buNone/>
+            </a:pPr>
+            <a:r>
+              <a:rPr lang="en-US" sz="2600" dirty="0">
+                <a:solidFill>
+                  <a:srgbClr val="808080"/>
+                </a:solidFill>
+                <a:latin typeface="Segoe UI Variable Text Semibold" pitchFamily="34" charset="0"/>
+                <a:ea typeface="Segoe UI Variable Text Semibold" pitchFamily="34" charset="-122"/>
+                <a:cs typeface="Segoe UI Variable Text Semibold" pitchFamily="34" charset="-120"/>
+              </a:rPr>
+              <a:t>10 %</a:t>
+            </a:r>
+            <a:endParaRPr lang="en-US" sz="2600" dirty="0"/>
+          </a:p>
+        </p:txBody>
+      </p:sp>
+      <p:sp>
+        <p:nvSpPr>
+          <p:cNvPr id="16" name="Text 13"/>
+          <p:cNvSpPr txBox="1"/>
+          <p:nvPr/>
+        </p:nvSpPr>
+        <p:spPr>
+          <a:xfrm>
+            <a:off x="457200" y="3657600"/>
+            <a:ext cx="2377440" cy="457200"/>
+          </a:xfrm>
+          <a:prstGeom prst="rect">
+            <a:avLst/>
+          </a:prstGeom>
+          <a:noFill/>
+          <a:ln/>
+        </p:spPr>
+        <p:txBody>
+          <a:bodyPr wrap="square" lIns="0" tIns="0" rIns="0" bIns="0" rtlCol="0" anchor="ctr"/>
+          <a:lstStyle/>
+          <a:p>
+            <a:pPr indent="0" marL="0">
+              <a:buNone/>
+            </a:pPr>
+            <a:r>
+              <a:rPr lang="en-US" sz="1600" dirty="0">
+                <a:solidFill>
+                  <a:srgbClr val="B3B3B3"/>
+                </a:solidFill>
+                <a:latin typeface="Segoe UI Variable Text" pitchFamily="34" charset="0"/>
+                <a:ea typeface="Segoe UI Variable Text" pitchFamily="34" charset="-122"/>
+                <a:cs typeface="Segoe UI Variable Text" pitchFamily="34" charset="-120"/>
+              </a:rPr>
+              <a:t>Mesuré : seuil manqué</a:t>
+            </a:r>
+            <a:endParaRPr lang="en-US" sz="1600" dirty="0"/>
+          </a:p>
+        </p:txBody>
+      </p:sp>
+      <p:sp>
+        <p:nvSpPr>
+          <p:cNvPr id="17" name="Shape 14"/>
+          <p:cNvSpPr/>
+          <p:nvPr/>
+        </p:nvSpPr>
+        <p:spPr>
+          <a:xfrm>
+            <a:off x="2926080" y="3712464"/>
+            <a:ext cx="685800" cy="347472"/>
+          </a:xfrm>
+          <a:prstGeom prst="rect">
+            <a:avLst/>
+          </a:prstGeom>
+          <a:solidFill>
+            <a:srgbClr val="FFFFFF"/>
+          </a:solidFill>
+          <a:ln w="12700">
+            <a:solidFill>
+              <a:srgbClr val="FFFFFF"/>
+            </a:solidFill>
+            <a:prstDash val="solid"/>
+          </a:ln>
+        </p:spPr>
+      </p:sp>
+      <p:sp>
+        <p:nvSpPr>
+          <p:cNvPr id="18" name="Text 15"/>
+          <p:cNvSpPr txBox="1"/>
+          <p:nvPr/>
+        </p:nvSpPr>
+        <p:spPr>
+          <a:xfrm>
+            <a:off x="3749040" y="3657600"/>
+            <a:ext cx="1280160" cy="457200"/>
+          </a:xfrm>
+          <a:prstGeom prst="rect">
+            <a:avLst/>
+          </a:prstGeom>
+          <a:noFill/>
+          <a:ln/>
+        </p:spPr>
+        <p:txBody>
+          <a:bodyPr wrap="square" lIns="0" tIns="0" rIns="0" bIns="0" rtlCol="0" anchor="ctr"/>
+          <a:lstStyle/>
+          <a:p>
+            <a:pPr indent="0" marL="0">
+              <a:buNone/>
+            </a:pPr>
+            <a:r>
+              <a:rPr lang="en-US" sz="2600" dirty="0">
+                <a:solidFill>
+                  <a:srgbClr val="FFFFFF"/>
+                </a:solidFill>
+                <a:latin typeface="Segoe UI Variable Text Semibold" pitchFamily="34" charset="0"/>
+                <a:ea typeface="Segoe UI Variable Text Semibold" pitchFamily="34" charset="-122"/>
+                <a:cs typeface="Segoe UI Variable Text Semibold" pitchFamily="34" charset="-120"/>
+              </a:rPr>
+              <a:t>15 %</a:t>
+            </a:r>
+            <a:endParaRPr lang="en-US" sz="2600" dirty="0"/>
           </a:p>
         </p:txBody>
       </p:sp>
@@ -3448,7 +3654,7 @@
         <p:spPr>
           <a:xfrm>
             <a:off x="457200" y="365760"/>
-            <a:ext cx="8229600" cy="548640"/>
+            <a:ext cx="5120640" cy="548640"/>
           </a:xfrm>
           <a:prstGeom prst="rect">
             <a:avLst/>
@@ -3472,7 +3678,24 @@
                 <a:ea typeface="Segoe UI Variable Text Semibold" pitchFamily="34" charset="-122"/>
                 <a:cs typeface="Segoe UI Variable Text Semibold" pitchFamily="34" charset="-120"/>
               </a:rPr>
-              <a:t>Jeu aveugle : 250 cas, moteur de comparaison</a:t>
+              <a:t>36 parcours. Notre testeuse</a:t>
+            </a:r>
+            <a:endParaRPr lang="en-US" sz="2800" dirty="0"/>
+          </a:p>
+          <a:p>
+            <a:pPr indent="0" marL="0">
+              <a:buNone/>
+            </a:pPr>
+            <a:r>
+              <a:rPr lang="en-US" sz="2800" dirty="0">
+                <a:solidFill>
+                  <a:srgbClr val="FFFFFF"/>
+                </a:solidFill>
+                <a:latin typeface="Segoe UI Variable Text Semibold" pitchFamily="34" charset="0"/>
+                <a:ea typeface="Segoe UI Variable Text Semibold" pitchFamily="34" charset="-122"/>
+                <a:cs typeface="Segoe UI Variable Text Semibold" pitchFamily="34" charset="-120"/>
+              </a:rPr>
+              <a:t>s’est fait piéger 4 fois.</a:t>
             </a:r>
             <a:endParaRPr lang="en-US" sz="2800" dirty="0"/>
           </a:p>
@@ -3511,7 +3734,7 @@
                 <a:ea typeface="Segoe UI Variable Text" pitchFamily="34" charset="-122"/>
                 <a:cs typeface="Segoe UI Variable Text" pitchFamily="34" charset="-120"/>
               </a:rPr>
-              <a:t>Dans le dépôt : research/titouan/T_banc_e2e/blind_decalage/run/RESULTAT.md, preuves/ECARTS_LIVRABLES.md</a:t>
+              <a:t>Dans le dépôt : coord/reports/testeurs/3_prudente_clavier.md, preuves/exhaustivite/EXHAUSTIVITE_INTENTION.md</a:t>
             </a:r>
             <a:endParaRPr lang="en-US" sz="1100" dirty="0"/>
           </a:p>
@@ -3525,8 +3748,8 @@
         </p:nvSpPr>
         <p:spPr>
           <a:xfrm>
-            <a:off x="457200" y="1188720"/>
-            <a:ext cx="8229600" cy="320040"/>
+            <a:off x="457200" y="1463040"/>
+            <a:ext cx="4937760" cy="1097280"/>
           </a:xfrm>
           <a:prstGeom prst="rect">
             <a:avLst/>
@@ -3550,7 +3773,7 @@
                 <a:ea typeface="Segoe UI Variable Text" pitchFamily="34" charset="-122"/>
                 <a:cs typeface="Segoe UI Variable Text" pitchFamily="34" charset="-120"/>
               </a:rPr>
-              <a:t>Arnaques signalées</a:t>
+              <a:t>Les 4 fois, elle avait lu « Ça ne correspond pas » et appuyé sur « Continuer » quand même. Jamais piégée sans ce geste. La testeuse est un agent qui joue une personne prudente, au clavier.</a:t>
             </a:r>
             <a:endParaRPr lang="en-US" sz="1400" dirty="0"/>
           </a:p>
@@ -3564,20 +3787,62 @@
         </p:nvSpPr>
         <p:spPr>
           <a:xfrm>
-            <a:off x="457200" y="1554480"/>
-            <a:ext cx="2377440" cy="457200"/>
-          </a:xfrm>
-          <a:prstGeom prst="rect">
-            <a:avLst/>
-          </a:prstGeom>
-          <a:noFill/>
-          <a:ln/>
-        </p:spPr>
-        <p:txBody>
-          <a:bodyPr wrap="square" lIns="0" tIns="0" rIns="0" bIns="0" rtlCol="0" anchor="ctr"/>
-          <a:lstStyle/>
-          <a:p>
-            <a:pPr indent="0" marL="0">
+            <a:off x="457200" y="2697480"/>
+            <a:ext cx="4937760" cy="365760"/>
+          </a:xfrm>
+          <a:prstGeom prst="rect">
+            <a:avLst/>
+          </a:prstGeom>
+          <a:noFill/>
+          <a:ln/>
+        </p:spPr>
+        <p:txBody>
+          <a:bodyPr wrap="square" lIns="0" tIns="0" rIns="0" bIns="0" rtlCol="0" anchor="t"/>
+          <a:lstStyle/>
+          <a:p>
+            <a:pPr indent="0" marL="0">
+              <a:buNone/>
+            </a:pPr>
+            <a:r>
+              <a:rPr lang="en-US" sz="1800" dirty="0">
+                <a:solidFill>
+                  <a:srgbClr val="FFFFFF"/>
+                </a:solidFill>
+                <a:latin typeface="Segoe UI Variable Text Semibold" pitchFamily="34" charset="0"/>
+                <a:ea typeface="Segoe UI Variable Text Semibold" pitchFamily="34" charset="-122"/>
+                <a:cs typeface="Segoe UI Variable Text Semibold" pitchFamily="34" charset="-120"/>
+              </a:rPr>
+              <a:t>Ce que Hold up ne fait pas encore</a:t>
+            </a:r>
+            <a:endParaRPr lang="en-US" sz="1800" dirty="0"/>
+          </a:p>
+        </p:txBody>
+      </p:sp>
+      <p:sp>
+        <p:nvSpPr>
+          <p:cNvPr id="7" name="Text 4"/>
+          <p:cNvSpPr txBox="1"/>
+          <p:nvPr/>
+        </p:nvSpPr>
+        <p:spPr>
+          <a:xfrm>
+            <a:off x="457200" y="3154680"/>
+            <a:ext cx="4937760" cy="1371600"/>
+          </a:xfrm>
+          <a:prstGeom prst="rect">
+            <a:avLst/>
+          </a:prstGeom>
+          <a:noFill/>
+          <a:ln/>
+        </p:spPr>
+        <p:txBody>
+          <a:bodyPr wrap="square" lIns="0" tIns="0" rIns="0" bIns="0" rtlCol="0" anchor="t"/>
+          <a:lstStyle/>
+          <a:p>
+            <a:pPr indent="0" marL="0">
+              <a:spcAft>
+                <a:spcPts val="800"/>
+              </a:spcAft>
               <a:buNone/>
             </a:pPr>
             <a:r>
@@ -3589,98 +3854,15 @@
                 <a:ea typeface="Segoe UI Variable Text" pitchFamily="34" charset="-122"/>
                 <a:cs typeface="Segoe UI Variable Text" pitchFamily="34" charset="-120"/>
               </a:rPr>
-              <a:t>Sans la phrase</a:t>
+              <a:t>Je ne vérifie pas ce que tu reçois en échange.</a:t>
             </a:r>
             <a:endParaRPr lang="en-US" sz="1600" dirty="0"/>
           </a:p>
-        </p:txBody>
-      </p:sp>
-      <p:sp>
-        <p:nvSpPr>
-          <p:cNvPr id="7" name="Shape 4"/>
-          <p:cNvSpPr/>
-          <p:nvPr/>
-        </p:nvSpPr>
-        <p:spPr>
-          <a:xfrm>
-            <a:off x="2926080" y="1609344"/>
-            <a:ext cx="2958084" cy="347472"/>
-          </a:xfrm>
-          <a:prstGeom prst="rect">
-            <a:avLst/>
-          </a:prstGeom>
-          <a:solidFill>
-            <a:srgbClr val="808080"/>
-          </a:solidFill>
-          <a:ln w="12700">
-            <a:solidFill>
-              <a:srgbClr val="808080"/>
-            </a:solidFill>
-            <a:prstDash val="solid"/>
-          </a:ln>
-        </p:spPr>
-      </p:sp>
-      <p:sp>
-        <p:nvSpPr>
-          <p:cNvPr id="8" name="Text 5"/>
-          <p:cNvSpPr txBox="1"/>
-          <p:nvPr/>
-        </p:nvSpPr>
-        <p:spPr>
-          <a:xfrm>
-            <a:off x="6021324" y="1554480"/>
-            <a:ext cx="1280160" cy="457200"/>
-          </a:xfrm>
-          <a:prstGeom prst="rect">
-            <a:avLst/>
-          </a:prstGeom>
-          <a:noFill/>
-          <a:ln/>
-        </p:spPr>
-        <p:txBody>
-          <a:bodyPr wrap="square" lIns="0" tIns="0" rIns="0" bIns="0" rtlCol="0" anchor="ctr"/>
-          <a:lstStyle/>
-          <a:p>
-            <a:pPr indent="0" marL="0">
-              <a:buNone/>
-            </a:pPr>
-            <a:r>
-              <a:rPr lang="en-US" sz="2600" dirty="0">
-                <a:solidFill>
-                  <a:srgbClr val="808080"/>
-                </a:solidFill>
-                <a:latin typeface="Segoe UI Variable Text Semibold" pitchFamily="34" charset="0"/>
-                <a:ea typeface="Segoe UI Variable Text Semibold" pitchFamily="34" charset="-122"/>
-                <a:cs typeface="Segoe UI Variable Text Semibold" pitchFamily="34" charset="-120"/>
-              </a:rPr>
-              <a:t>65 %</a:t>
-            </a:r>
-            <a:endParaRPr lang="en-US" sz="2600" dirty="0"/>
-          </a:p>
-        </p:txBody>
-      </p:sp>
-      <p:sp>
-        <p:nvSpPr>
-          <p:cNvPr id="9" name="Text 6"/>
-          <p:cNvSpPr txBox="1"/>
-          <p:nvPr/>
-        </p:nvSpPr>
-        <p:spPr>
-          <a:xfrm>
-            <a:off x="457200" y="2057400"/>
-            <a:ext cx="2377440" cy="457200"/>
-          </a:xfrm>
-          <a:prstGeom prst="rect">
-            <a:avLst/>
-          </a:prstGeom>
-          <a:noFill/>
-          <a:ln/>
-        </p:spPr>
-        <p:txBody>
-          <a:bodyPr wrap="square" lIns="0" tIns="0" rIns="0" bIns="0" rtlCol="0" anchor="ctr"/>
-          <a:lstStyle/>
-          <a:p>
-            <a:pPr indent="0" marL="0">
+          <a:p>
+            <a:pPr indent="0" marL="0">
+              <a:spcAft>
+                <a:spcPts val="800"/>
+              </a:spcAft>
               <a:buNone/>
             </a:pPr>
             <a:r>
@@ -3692,86 +3874,46 @@
                 <a:ea typeface="Segoe UI Variable Text" pitchFamily="34" charset="-122"/>
                 <a:cs typeface="Segoe UI Variable Text" pitchFamily="34" charset="-120"/>
               </a:rPr>
-              <a:t>Avec la phrase</a:t>
+              <a:t>Je ne couvre ni un Ledger en direct, ni le téléphone.</a:t>
             </a:r>
             <a:endParaRPr lang="en-US" sz="1600" dirty="0"/>
           </a:p>
         </p:txBody>
       </p:sp>
-      <p:sp>
-        <p:nvSpPr>
-          <p:cNvPr id="10" name="Shape 7"/>
-          <p:cNvSpPr/>
-          <p:nvPr/>
-        </p:nvSpPr>
-        <p:spPr>
-          <a:xfrm>
-            <a:off x="2926080" y="2112264"/>
-            <a:ext cx="3991356" cy="347472"/>
-          </a:xfrm>
-          <a:prstGeom prst="rect">
-            <a:avLst/>
-          </a:prstGeom>
-          <a:solidFill>
-            <a:srgbClr val="FFFFFF"/>
-          </a:solidFill>
-          <a:ln w="12700">
-            <a:solidFill>
-              <a:srgbClr val="FFFFFF"/>
-            </a:solidFill>
-            <a:prstDash val="solid"/>
-          </a:ln>
-        </p:spPr>
-      </p:sp>
-      <p:sp>
-        <p:nvSpPr>
-          <p:cNvPr id="11" name="Text 8"/>
-          <p:cNvSpPr txBox="1"/>
-          <p:nvPr/>
-        </p:nvSpPr>
-        <p:spPr>
-          <a:xfrm>
-            <a:off x="7054596" y="2057400"/>
-            <a:ext cx="1280160" cy="457200"/>
-          </a:xfrm>
-          <a:prstGeom prst="rect">
-            <a:avLst/>
-          </a:prstGeom>
-          <a:noFill/>
-          <a:ln/>
-        </p:spPr>
-        <p:txBody>
-          <a:bodyPr wrap="square" lIns="0" tIns="0" rIns="0" bIns="0" rtlCol="0" anchor="ctr"/>
-          <a:lstStyle/>
-          <a:p>
-            <a:pPr indent="0" marL="0">
-              <a:buNone/>
-            </a:pPr>
-            <a:r>
-              <a:rPr lang="en-US" sz="2600" dirty="0">
-                <a:solidFill>
-                  <a:srgbClr val="FFFFFF"/>
-                </a:solidFill>
-                <a:latin typeface="Segoe UI Variable Text Semibold" pitchFamily="34" charset="0"/>
-                <a:ea typeface="Segoe UI Variable Text Semibold" pitchFamily="34" charset="-122"/>
-                <a:cs typeface="Segoe UI Variable Text Semibold" pitchFamily="34" charset="-120"/>
-              </a:rPr>
-              <a:t>87 %</a:t>
-            </a:r>
-            <a:endParaRPr lang="en-US" sz="2600" dirty="0"/>
-          </a:p>
-        </p:txBody>
-      </p:sp>
-      <p:sp>
-        <p:nvSpPr>
-          <p:cNvPr id="12" name="Text 9"/>
-          <p:cNvSpPr txBox="1"/>
-          <p:nvPr/>
-        </p:nvSpPr>
-        <p:spPr>
-          <a:xfrm>
-            <a:off x="457200" y="2788920"/>
-            <a:ext cx="8229600" cy="320040"/>
+      <p:pic>
+        <p:nvPicPr>
+          <p:cNvPr id="8" name="Image 0" descr="C:\Users\Adem\Secure Horizon\coord\reports\testeurs\3_captures\s05_08_f1_continuer_actif.png">    </p:cNvPr>
+          <p:cNvPicPr>
+            <a:picLocks noChangeAspect="1"/>
+          </p:cNvPicPr>
+          <p:nvPr/>
+        </p:nvPicPr>
+        <p:blipFill>
+          <a:blip r:embed="rId1"/>
+          <a:stretch>
+            <a:fillRect/>
+          </a:stretch>
+        </p:blipFill>
+        <p:spPr>
+          <a:xfrm>
+            <a:off x="5760720" y="457200"/>
+            <a:ext cx="2926080" cy="3419856"/>
+          </a:xfrm>
+          <a:prstGeom prst="rect">
+            <a:avLst/>
+          </a:prstGeom>
+        </p:spPr>
+      </p:pic>
+      <p:sp>
+        <p:nvSpPr>
+          <p:cNvPr id="9" name="Text 5"/>
+          <p:cNvSpPr txBox="1"/>
+          <p:nvPr/>
+        </p:nvSpPr>
+        <p:spPr>
+          <a:xfrm>
+            <a:off x="5760720" y="4023360"/>
+            <a:ext cx="2926080" cy="274320"/>
           </a:xfrm>
           <a:prstGeom prst="rect">
             <a:avLst/>
@@ -3787,7 +3929,7 @@
               <a:buNone/>
             </a:pPr>
             <a:r>
-              <a:rPr lang="en-US" sz="1400" dirty="0">
+              <a:rPr lang="en-US" sz="1200" dirty="0">
                 <a:solidFill>
                   <a:srgbClr val="B3B3B3"/>
                 </a:solidFill>
@@ -3795,215 +3937,9 @@
                 <a:ea typeface="Segoe UI Variable Text" pitchFamily="34" charset="-122"/>
                 <a:cs typeface="Segoe UI Variable Text" pitchFamily="34" charset="-120"/>
               </a:rPr>
-              <a:t>Opérations honnêtes arrêtées à tort</a:t>
-            </a:r>
-            <a:endParaRPr lang="en-US" sz="1400" dirty="0"/>
-          </a:p>
-        </p:txBody>
-      </p:sp>
-      <p:sp>
-        <p:nvSpPr>
-          <p:cNvPr id="13" name="Text 10"/>
-          <p:cNvSpPr txBox="1"/>
-          <p:nvPr/>
-        </p:nvSpPr>
-        <p:spPr>
-          <a:xfrm>
-            <a:off x="457200" y="3154680"/>
-            <a:ext cx="2377440" cy="457200"/>
-          </a:xfrm>
-          <a:prstGeom prst="rect">
-            <a:avLst/>
-          </a:prstGeom>
-          <a:noFill/>
-          <a:ln/>
-        </p:spPr>
-        <p:txBody>
-          <a:bodyPr wrap="square" lIns="0" tIns="0" rIns="0" bIns="0" rtlCol="0" anchor="ctr"/>
-          <a:lstStyle/>
-          <a:p>
-            <a:pPr indent="0" marL="0">
-              <a:buNone/>
-            </a:pPr>
-            <a:r>
-              <a:rPr lang="en-US" sz="1600" dirty="0">
-                <a:solidFill>
-                  <a:srgbClr val="B3B3B3"/>
-                </a:solidFill>
-                <a:latin typeface="Segoe UI Variable Text" pitchFamily="34" charset="0"/>
-                <a:ea typeface="Segoe UI Variable Text" pitchFamily="34" charset="-122"/>
-                <a:cs typeface="Segoe UI Variable Text" pitchFamily="34" charset="-120"/>
-              </a:rPr>
-              <a:t>Seuil fixé avant</a:t>
-            </a:r>
-            <a:endParaRPr lang="en-US" sz="1600" dirty="0"/>
-          </a:p>
-        </p:txBody>
-      </p:sp>
-      <p:sp>
-        <p:nvSpPr>
-          <p:cNvPr id="14" name="Shape 11"/>
-          <p:cNvSpPr/>
-          <p:nvPr/>
-        </p:nvSpPr>
-        <p:spPr>
-          <a:xfrm>
-            <a:off x="2926080" y="3209544"/>
-            <a:ext cx="457200" cy="347472"/>
-          </a:xfrm>
-          <a:prstGeom prst="rect">
-            <a:avLst/>
-          </a:prstGeom>
-          <a:solidFill>
-            <a:srgbClr val="808080"/>
-          </a:solidFill>
-          <a:ln w="12700">
-            <a:solidFill>
-              <a:srgbClr val="808080"/>
-            </a:solidFill>
-            <a:prstDash val="solid"/>
-          </a:ln>
-        </p:spPr>
-      </p:sp>
-      <p:sp>
-        <p:nvSpPr>
-          <p:cNvPr id="15" name="Text 12"/>
-          <p:cNvSpPr txBox="1"/>
-          <p:nvPr/>
-        </p:nvSpPr>
-        <p:spPr>
-          <a:xfrm>
-            <a:off x="3520440" y="3154680"/>
-            <a:ext cx="1280160" cy="457200"/>
-          </a:xfrm>
-          <a:prstGeom prst="rect">
-            <a:avLst/>
-          </a:prstGeom>
-          <a:noFill/>
-          <a:ln/>
-        </p:spPr>
-        <p:txBody>
-          <a:bodyPr wrap="square" lIns="0" tIns="0" rIns="0" bIns="0" rtlCol="0" anchor="ctr"/>
-          <a:lstStyle/>
-          <a:p>
-            <a:pPr indent="0" marL="0">
-              <a:buNone/>
-            </a:pPr>
-            <a:r>
-              <a:rPr lang="en-US" sz="2600" dirty="0">
-                <a:solidFill>
-                  <a:srgbClr val="808080"/>
-                </a:solidFill>
-                <a:latin typeface="Segoe UI Variable Text Semibold" pitchFamily="34" charset="0"/>
-                <a:ea typeface="Segoe UI Variable Text Semibold" pitchFamily="34" charset="-122"/>
-                <a:cs typeface="Segoe UI Variable Text Semibold" pitchFamily="34" charset="-120"/>
-              </a:rPr>
-              <a:t>10 %</a:t>
-            </a:r>
-            <a:endParaRPr lang="en-US" sz="2600" dirty="0"/>
-          </a:p>
-        </p:txBody>
-      </p:sp>
-      <p:sp>
-        <p:nvSpPr>
-          <p:cNvPr id="16" name="Text 13"/>
-          <p:cNvSpPr txBox="1"/>
-          <p:nvPr/>
-        </p:nvSpPr>
-        <p:spPr>
-          <a:xfrm>
-            <a:off x="457200" y="3657600"/>
-            <a:ext cx="2377440" cy="457200"/>
-          </a:xfrm>
-          <a:prstGeom prst="rect">
-            <a:avLst/>
-          </a:prstGeom>
-          <a:noFill/>
-          <a:ln/>
-        </p:spPr>
-        <p:txBody>
-          <a:bodyPr wrap="square" lIns="0" tIns="0" rIns="0" bIns="0" rtlCol="0" anchor="ctr"/>
-          <a:lstStyle/>
-          <a:p>
-            <a:pPr indent="0" marL="0">
-              <a:buNone/>
-            </a:pPr>
-            <a:r>
-              <a:rPr lang="en-US" sz="1600" dirty="0">
-                <a:solidFill>
-                  <a:srgbClr val="B3B3B3"/>
-                </a:solidFill>
-                <a:latin typeface="Segoe UI Variable Text" pitchFamily="34" charset="0"/>
-                <a:ea typeface="Segoe UI Variable Text" pitchFamily="34" charset="-122"/>
-                <a:cs typeface="Segoe UI Variable Text" pitchFamily="34" charset="-120"/>
-              </a:rPr>
-              <a:t>Mesuré : seuil manqué</a:t>
-            </a:r>
-            <a:endParaRPr lang="en-US" sz="1600" dirty="0"/>
-          </a:p>
-        </p:txBody>
-      </p:sp>
-      <p:sp>
-        <p:nvSpPr>
-          <p:cNvPr id="17" name="Shape 14"/>
-          <p:cNvSpPr/>
-          <p:nvPr/>
-        </p:nvSpPr>
-        <p:spPr>
-          <a:xfrm>
-            <a:off x="2926080" y="3712464"/>
-            <a:ext cx="685800" cy="347472"/>
-          </a:xfrm>
-          <a:prstGeom prst="rect">
-            <a:avLst/>
-          </a:prstGeom>
-          <a:solidFill>
-            <a:srgbClr val="FFFFFF"/>
-          </a:solidFill>
-          <a:ln w="12700">
-            <a:solidFill>
-              <a:srgbClr val="FFFFFF"/>
-            </a:solidFill>
-            <a:prstDash val="solid"/>
-          </a:ln>
-        </p:spPr>
-      </p:sp>
-      <p:sp>
-        <p:nvSpPr>
-          <p:cNvPr id="18" name="Text 15"/>
-          <p:cNvSpPr txBox="1"/>
-          <p:nvPr/>
-        </p:nvSpPr>
-        <p:spPr>
-          <a:xfrm>
-            <a:off x="3749040" y="3657600"/>
-            <a:ext cx="1280160" cy="457200"/>
-          </a:xfrm>
-          <a:prstGeom prst="rect">
-            <a:avLst/>
-          </a:prstGeom>
-          <a:noFill/>
-          <a:ln/>
-        </p:spPr>
-        <p:txBody>
-          <a:bodyPr wrap="square" lIns="0" tIns="0" rIns="0" bIns="0" rtlCol="0" anchor="ctr"/>
-          <a:lstStyle/>
-          <a:p>
-            <a:pPr indent="0" marL="0">
-              <a:buNone/>
-            </a:pPr>
-            <a:r>
-              <a:rPr lang="en-US" sz="2600" dirty="0">
-                <a:solidFill>
-                  <a:srgbClr val="FFFFFF"/>
-                </a:solidFill>
-                <a:latin typeface="Segoe UI Variable Text Semibold" pitchFamily="34" charset="0"/>
-                <a:ea typeface="Segoe UI Variable Text Semibold" pitchFamily="34" charset="-122"/>
-                <a:cs typeface="Segoe UI Variable Text Semibold" pitchFamily="34" charset="-120"/>
-              </a:rPr>
-              <a:t>15 %</a:t>
-            </a:r>
-            <a:endParaRPr lang="en-US" sz="2600" dirty="0"/>
+              <a:t>L’extension, pendant l’essai.</a:t>
+            </a:r>
+            <a:endParaRPr lang="en-US" sz="1200" dirty="0"/>
           </a:p>
         </p:txBody>
       </p:sp>
@@ -4088,8 +4024,8 @@
         </p:nvSpPr>
         <p:spPr>
           <a:xfrm>
-            <a:off x="457200" y="365760"/>
-            <a:ext cx="5120640" cy="548640"/>
+            <a:off x="457200" y="4663440"/>
+            <a:ext cx="7680960" cy="228600"/>
           </a:xfrm>
           <a:prstGeom prst="rect">
             <a:avLst/>
@@ -4105,7 +4041,46 @@
               <a:buNone/>
             </a:pPr>
             <a:r>
-              <a:rPr lang="en-US" sz="2800" dirty="0">
+              <a:rPr lang="en-US" sz="1100" dirty="0">
+                <a:solidFill>
+                  <a:srgbClr val="B3B3B3"/>
+                </a:solidFill>
+                <a:latin typeface="Segoe UI Variable Text" pitchFamily="34" charset="0"/>
+                <a:ea typeface="Segoe UI Variable Text" pitchFamily="34" charset="-122"/>
+                <a:cs typeface="Segoe UI Variable Text" pitchFamily="34" charset="-120"/>
+              </a:rPr>
+              <a:t>Dans le dépôt : research/titouan/BM2/BM_MODELE.md, BM_LABEL.md</a:t>
+            </a:r>
+            <a:endParaRPr lang="en-US" sz="1100" dirty="0"/>
+          </a:p>
+        </p:txBody>
+      </p:sp>
+      <p:sp>
+        <p:nvSpPr>
+          <p:cNvPr id="4" name="Text 1"/>
+          <p:cNvSpPr txBox="1"/>
+          <p:nvPr/>
+        </p:nvSpPr>
+        <p:spPr>
+          <a:xfrm>
+            <a:off x="457200" y="1737360"/>
+            <a:ext cx="8229600" cy="1463040"/>
+          </a:xfrm>
+          <a:prstGeom prst="rect">
+            <a:avLst/>
+          </a:prstGeom>
+          <a:noFill/>
+          <a:ln/>
+        </p:spPr>
+        <p:txBody>
+          <a:bodyPr wrap="square" lIns="0" tIns="0" rIns="0" bIns="0" rtlCol="0" anchor="t"/>
+          <a:lstStyle/>
+          <a:p>
+            <a:pPr indent="0" marL="0">
+              <a:buNone/>
+            </a:pPr>
+            <a:r>
+              <a:rPr lang="en-US" sz="4000" dirty="0">
                 <a:solidFill>
                   <a:srgbClr val="FFFFFF"/>
                 </a:solidFill>
@@ -4113,16 +4088,16 @@
                 <a:ea typeface="Segoe UI Variable Text Semibold" pitchFamily="34" charset="-122"/>
                 <a:cs typeface="Segoe UI Variable Text Semibold" pitchFamily="34" charset="-120"/>
               </a:rPr>
-              <a:t>36 parcours. Notre testeuse</a:t>
-            </a:r>
-            <a:endParaRPr lang="en-US" sz="2800" dirty="0"/>
-          </a:p>
-          <a:p>
-            <a:pPr indent="0" marL="0">
-              <a:buNone/>
-            </a:pPr>
-            <a:r>
-              <a:rPr lang="en-US" sz="2800" dirty="0">
+              <a:t>On ne sait pas quel site sera piraté.</a:t>
+            </a:r>
+            <a:endParaRPr lang="en-US" sz="4000" dirty="0"/>
+          </a:p>
+          <a:p>
+            <a:pPr indent="0" marL="0">
+              <a:buNone/>
+            </a:pPr>
+            <a:r>
+              <a:rPr lang="en-US" sz="4000" dirty="0">
                 <a:solidFill>
                   <a:srgbClr val="FFFFFF"/>
                 </a:solidFill>
@@ -4130,251 +4105,9 @@
                 <a:ea typeface="Segoe UI Variable Text Semibold" pitchFamily="34" charset="-122"/>
                 <a:cs typeface="Segoe UI Variable Text Semibold" pitchFamily="34" charset="-120"/>
               </a:rPr>
-              <a:t>s’est fait piéger 4 fois.</a:t>
-            </a:r>
-            <a:endParaRPr lang="en-US" sz="2800" dirty="0"/>
-          </a:p>
-        </p:txBody>
-      </p:sp>
-      <p:sp>
-        <p:nvSpPr>
-          <p:cNvPr id="3" name="Text 1"/>
-          <p:cNvSpPr txBox="1"/>
-          <p:nvPr/>
-        </p:nvSpPr>
-        <p:spPr>
-          <a:xfrm>
-            <a:off x="457200" y="4663440"/>
-            <a:ext cx="7680960" cy="228600"/>
-          </a:xfrm>
-          <a:prstGeom prst="rect">
-            <a:avLst/>
-          </a:prstGeom>
-          <a:noFill/>
-          <a:ln/>
-        </p:spPr>
-        <p:txBody>
-          <a:bodyPr wrap="square" lIns="0" tIns="0" rIns="0" bIns="0" rtlCol="0" anchor="t"/>
-          <a:lstStyle/>
-          <a:p>
-            <a:pPr indent="0" marL="0">
-              <a:buNone/>
-            </a:pPr>
-            <a:r>
-              <a:rPr lang="en-US" sz="1100" dirty="0">
-                <a:solidFill>
-                  <a:srgbClr val="B3B3B3"/>
-                </a:solidFill>
-                <a:latin typeface="Segoe UI Variable Text" pitchFamily="34" charset="0"/>
-                <a:ea typeface="Segoe UI Variable Text" pitchFamily="34" charset="-122"/>
-                <a:cs typeface="Segoe UI Variable Text" pitchFamily="34" charset="-120"/>
-              </a:rPr>
-              <a:t>Dans le dépôt : coord/reports/testeurs/3_prudente_clavier.md, preuves/exhaustivite/EXHAUSTIVITE_INTENTION.md</a:t>
-            </a:r>
-            <a:endParaRPr lang="en-US" sz="1100" dirty="0"/>
-          </a:p>
-        </p:txBody>
-      </p:sp>
-      <p:sp>
-        <p:nvSpPr>
-          <p:cNvPr id="5" name="Text 2"/>
-          <p:cNvSpPr txBox="1"/>
-          <p:nvPr/>
-        </p:nvSpPr>
-        <p:spPr>
-          <a:xfrm>
-            <a:off x="457200" y="1463040"/>
-            <a:ext cx="4937760" cy="1097280"/>
-          </a:xfrm>
-          <a:prstGeom prst="rect">
-            <a:avLst/>
-          </a:prstGeom>
-          <a:noFill/>
-          <a:ln/>
-        </p:spPr>
-        <p:txBody>
-          <a:bodyPr wrap="square" lIns="0" tIns="0" rIns="0" bIns="0" rtlCol="0" anchor="t"/>
-          <a:lstStyle/>
-          <a:p>
-            <a:pPr indent="0" marL="0">
-              <a:buNone/>
-            </a:pPr>
-            <a:r>
-              <a:rPr lang="en-US" sz="1400" dirty="0">
-                <a:solidFill>
-                  <a:srgbClr val="B3B3B3"/>
-                </a:solidFill>
-                <a:latin typeface="Segoe UI Variable Text" pitchFamily="34" charset="0"/>
-                <a:ea typeface="Segoe UI Variable Text" pitchFamily="34" charset="-122"/>
-                <a:cs typeface="Segoe UI Variable Text" pitchFamily="34" charset="-120"/>
-              </a:rPr>
-              <a:t>Les 4 fois, elle avait lu « Ça ne correspond pas » et appuyé sur « Continuer » quand même. Jamais piégée sans ce geste. La testeuse est un agent qui joue une personne prudente, au clavier.</a:t>
-            </a:r>
-            <a:endParaRPr lang="en-US" sz="1400" dirty="0"/>
-          </a:p>
-        </p:txBody>
-      </p:sp>
-      <p:sp>
-        <p:nvSpPr>
-          <p:cNvPr id="6" name="Text 3"/>
-          <p:cNvSpPr txBox="1"/>
-          <p:nvPr/>
-        </p:nvSpPr>
-        <p:spPr>
-          <a:xfrm>
-            <a:off x="457200" y="2697480"/>
-            <a:ext cx="4937760" cy="365760"/>
-          </a:xfrm>
-          <a:prstGeom prst="rect">
-            <a:avLst/>
-          </a:prstGeom>
-          <a:noFill/>
-          <a:ln/>
-        </p:spPr>
-        <p:txBody>
-          <a:bodyPr wrap="square" lIns="0" tIns="0" rIns="0" bIns="0" rtlCol="0" anchor="t"/>
-          <a:lstStyle/>
-          <a:p>
-            <a:pPr indent="0" marL="0">
-              <a:buNone/>
-            </a:pPr>
-            <a:r>
-              <a:rPr lang="en-US" sz="1800" dirty="0">
-                <a:solidFill>
-                  <a:srgbClr val="FFFFFF"/>
-                </a:solidFill>
-                <a:latin typeface="Segoe UI Variable Text Semibold" pitchFamily="34" charset="0"/>
-                <a:ea typeface="Segoe UI Variable Text Semibold" pitchFamily="34" charset="-122"/>
-                <a:cs typeface="Segoe UI Variable Text Semibold" pitchFamily="34" charset="-120"/>
-              </a:rPr>
-              <a:t>Ce que Hold up ne fait pas encore</a:t>
-            </a:r>
-            <a:endParaRPr lang="en-US" sz="1800" dirty="0"/>
-          </a:p>
-        </p:txBody>
-      </p:sp>
-      <p:sp>
-        <p:nvSpPr>
-          <p:cNvPr id="7" name="Text 4"/>
-          <p:cNvSpPr txBox="1"/>
-          <p:nvPr/>
-        </p:nvSpPr>
-        <p:spPr>
-          <a:xfrm>
-            <a:off x="457200" y="3154680"/>
-            <a:ext cx="4937760" cy="1371600"/>
-          </a:xfrm>
-          <a:prstGeom prst="rect">
-            <a:avLst/>
-          </a:prstGeom>
-          <a:noFill/>
-          <a:ln/>
-        </p:spPr>
-        <p:txBody>
-          <a:bodyPr wrap="square" lIns="0" tIns="0" rIns="0" bIns="0" rtlCol="0" anchor="t"/>
-          <a:lstStyle/>
-          <a:p>
-            <a:pPr indent="0" marL="0">
-              <a:spcAft>
-                <a:spcPts val="800"/>
-              </a:spcAft>
-              <a:buNone/>
-            </a:pPr>
-            <a:r>
-              <a:rPr lang="en-US" sz="1600" dirty="0">
-                <a:solidFill>
-                  <a:srgbClr val="B3B3B3"/>
-                </a:solidFill>
-                <a:latin typeface="Segoe UI Variable Text" pitchFamily="34" charset="0"/>
-                <a:ea typeface="Segoe UI Variable Text" pitchFamily="34" charset="-122"/>
-                <a:cs typeface="Segoe UI Variable Text" pitchFamily="34" charset="-120"/>
-              </a:rPr>
-              <a:t>Je ne vérifie pas ce que tu reçois en échange.</a:t>
-            </a:r>
-            <a:endParaRPr lang="en-US" sz="1600" dirty="0"/>
-          </a:p>
-          <a:p>
-            <a:pPr indent="0" marL="0">
-              <a:spcAft>
-                <a:spcPts val="800"/>
-              </a:spcAft>
-              <a:buNone/>
-            </a:pPr>
-            <a:r>
-              <a:rPr lang="en-US" sz="1600" dirty="0">
-                <a:solidFill>
-                  <a:srgbClr val="B3B3B3"/>
-                </a:solidFill>
-                <a:latin typeface="Segoe UI Variable Text" pitchFamily="34" charset="0"/>
-                <a:ea typeface="Segoe UI Variable Text" pitchFamily="34" charset="-122"/>
-                <a:cs typeface="Segoe UI Variable Text" pitchFamily="34" charset="-120"/>
-              </a:rPr>
-              <a:t>Je ne couvre ni un Ledger en direct, ni le téléphone.</a:t>
-            </a:r>
-            <a:endParaRPr lang="en-US" sz="1600" dirty="0"/>
-          </a:p>
-        </p:txBody>
-      </p:sp>
-      <p:pic>
-        <p:nvPicPr>
-          <p:cNvPr id="8" name="Image 0" descr="C:\Users\Adem\Secure Horizon\coord\reports\testeurs\3_captures\s05_08_f1_continuer_actif.png">    </p:cNvPr>
-          <p:cNvPicPr>
-            <a:picLocks noChangeAspect="1"/>
-          </p:cNvPicPr>
-          <p:nvPr/>
-        </p:nvPicPr>
-        <p:blipFill>
-          <a:blip r:embed="rId1"/>
-          <a:stretch>
-            <a:fillRect/>
-          </a:stretch>
-        </p:blipFill>
-        <p:spPr>
-          <a:xfrm>
-            <a:off x="5760720" y="457200"/>
-            <a:ext cx="2926080" cy="3419856"/>
-          </a:xfrm>
-          <a:prstGeom prst="rect">
-            <a:avLst/>
-          </a:prstGeom>
-        </p:spPr>
-      </p:pic>
-      <p:sp>
-        <p:nvSpPr>
-          <p:cNvPr id="9" name="Text 5"/>
-          <p:cNvSpPr txBox="1"/>
-          <p:nvPr/>
-        </p:nvSpPr>
-        <p:spPr>
-          <a:xfrm>
-            <a:off x="5760720" y="4023360"/>
-            <a:ext cx="2926080" cy="274320"/>
-          </a:xfrm>
-          <a:prstGeom prst="rect">
-            <a:avLst/>
-          </a:prstGeom>
-          <a:noFill/>
-          <a:ln/>
-        </p:spPr>
-        <p:txBody>
-          <a:bodyPr wrap="square" lIns="0" tIns="0" rIns="0" bIns="0" rtlCol="0" anchor="t"/>
-          <a:lstStyle/>
-          <a:p>
-            <a:pPr indent="0" marL="0">
-              <a:buNone/>
-            </a:pPr>
-            <a:r>
-              <a:rPr lang="en-US" sz="1200" dirty="0">
-                <a:solidFill>
-                  <a:srgbClr val="B3B3B3"/>
-                </a:solidFill>
-                <a:latin typeface="Segoe UI Variable Text" pitchFamily="34" charset="0"/>
-                <a:ea typeface="Segoe UI Variable Text" pitchFamily="34" charset="-122"/>
-                <a:cs typeface="Segoe UI Variable Text" pitchFamily="34" charset="-120"/>
-              </a:rPr>
-              <a:t>L’extension, pendant l’essai.</a:t>
-            </a:r>
-            <a:endParaRPr lang="en-US" sz="1200" dirty="0"/>
+              <a:t>On décide de ce qu'on lui laisse.</a:t>
+            </a:r>
+            <a:endParaRPr lang="en-US" sz="4000" dirty="0"/>
           </a:p>
         </p:txBody>
       </p:sp>
@@ -4421,174 +4154,6 @@
             <a:fld id="{F7021451-1387-4CA6-816F-3879F97B5CBC}" type="slidenum">
               <a:rPr b="0" lang="en-US"/>
               <a:t>7</a:t>
-            </a:fld>
-            <a:endParaRPr lang="en-US"/>
-          </a:p>
-        </p:txBody>
-      </p:sp>
-    </p:spTree>
-  </p:cSld>
-  <p:clrMapOvr>
-    <a:masterClrMapping/>
-  </p:clrMapOvr>
-</p:sld>
-</file>
-
-<file path=ppt/slides/slide8.xml><?xml version="1.0" encoding="utf-8"?>
-<p:sld xmlns:a="http://schemas.openxmlformats.org/drawingml/2006/main" xmlns:r="http://schemas.openxmlformats.org/officeDocument/2006/relationships" xmlns:p="http://schemas.openxmlformats.org/presentationml/2006/main">
-  <p:cSld name="Slide 8">
-    <p:spTree>
-      <p:nvGrpSpPr>
-        <p:cNvPr id="1" name=""/>
-        <p:cNvGrpSpPr/>
-        <p:nvPr/>
-      </p:nvGrpSpPr>
-      <p:grpSpPr>
-        <a:xfrm>
-          <a:off x="0" y="0"/>
-          <a:ext cx="0" cy="0"/>
-          <a:chOff x="0" y="0"/>
-          <a:chExt cx="0" cy="0"/>
-        </a:xfrm>
-      </p:grpSpPr>
-      <p:sp>
-        <p:nvSpPr>
-          <p:cNvPr id="2" name="Text 0"/>
-          <p:cNvSpPr txBox="1"/>
-          <p:nvPr/>
-        </p:nvSpPr>
-        <p:spPr>
-          <a:xfrm>
-            <a:off x="457200" y="4663440"/>
-            <a:ext cx="7680960" cy="228600"/>
-          </a:xfrm>
-          <a:prstGeom prst="rect">
-            <a:avLst/>
-          </a:prstGeom>
-          <a:noFill/>
-          <a:ln/>
-        </p:spPr>
-        <p:txBody>
-          <a:bodyPr wrap="square" lIns="0" tIns="0" rIns="0" bIns="0" rtlCol="0" anchor="t"/>
-          <a:lstStyle/>
-          <a:p>
-            <a:pPr indent="0" marL="0">
-              <a:buNone/>
-            </a:pPr>
-            <a:r>
-              <a:rPr lang="en-US" sz="1100" dirty="0">
-                <a:solidFill>
-                  <a:srgbClr val="B3B3B3"/>
-                </a:solidFill>
-                <a:latin typeface="Segoe UI Variable Text" pitchFamily="34" charset="0"/>
-                <a:ea typeface="Segoe UI Variable Text" pitchFamily="34" charset="-122"/>
-                <a:cs typeface="Segoe UI Variable Text" pitchFamily="34" charset="-120"/>
-              </a:rPr>
-              <a:t>Dans le dépôt : research/titouan/BM2/BM_MODELE.md, BM_LABEL.md</a:t>
-            </a:r>
-            <a:endParaRPr lang="en-US" sz="1100" dirty="0"/>
-          </a:p>
-        </p:txBody>
-      </p:sp>
-      <p:sp>
-        <p:nvSpPr>
-          <p:cNvPr id="4" name="Text 1"/>
-          <p:cNvSpPr txBox="1"/>
-          <p:nvPr/>
-        </p:nvSpPr>
-        <p:spPr>
-          <a:xfrm>
-            <a:off x="457200" y="1737360"/>
-            <a:ext cx="8229600" cy="1463040"/>
-          </a:xfrm>
-          <a:prstGeom prst="rect">
-            <a:avLst/>
-          </a:prstGeom>
-          <a:noFill/>
-          <a:ln/>
-        </p:spPr>
-        <p:txBody>
-          <a:bodyPr wrap="square" lIns="0" tIns="0" rIns="0" bIns="0" rtlCol="0" anchor="t"/>
-          <a:lstStyle/>
-          <a:p>
-            <a:pPr indent="0" marL="0">
-              <a:buNone/>
-            </a:pPr>
-            <a:r>
-              <a:rPr lang="en-US" sz="4000" dirty="0">
-                <a:solidFill>
-                  <a:srgbClr val="FFFFFF"/>
-                </a:solidFill>
-                <a:latin typeface="Segoe UI Variable Text Semibold" pitchFamily="34" charset="0"/>
-                <a:ea typeface="Segoe UI Variable Text Semibold" pitchFamily="34" charset="-122"/>
-                <a:cs typeface="Segoe UI Variable Text Semibold" pitchFamily="34" charset="-120"/>
-              </a:rPr>
-              <a:t>On ne sait pas quel site sera piraté.</a:t>
-            </a:r>
-            <a:endParaRPr lang="en-US" sz="4000" dirty="0"/>
-          </a:p>
-          <a:p>
-            <a:pPr indent="0" marL="0">
-              <a:buNone/>
-            </a:pPr>
-            <a:r>
-              <a:rPr lang="en-US" sz="4000" dirty="0">
-                <a:solidFill>
-                  <a:srgbClr val="FFFFFF"/>
-                </a:solidFill>
-                <a:latin typeface="Segoe UI Variable Text Semibold" pitchFamily="34" charset="0"/>
-                <a:ea typeface="Segoe UI Variable Text Semibold" pitchFamily="34" charset="-122"/>
-                <a:cs typeface="Segoe UI Variable Text Semibold" pitchFamily="34" charset="-120"/>
-              </a:rPr>
-              <a:t>On décide de ce qu'on lui laisse.</a:t>
-            </a:r>
-            <a:endParaRPr lang="en-US" sz="4000" dirty="0"/>
-          </a:p>
-        </p:txBody>
-      </p:sp>
-      <p:sp>
-        <p:nvSpPr>
-          <p:cNvPr id="25" name="Slide Number Placeholder 0"/>
-          <p:cNvSpPr>
-            <a:spLocks noGrp="1"/>
-          </p:cNvSpPr>
-          <p:nvPr>
-            <p:ph type="sldNum" sz="quarter" idx="4294967295"/>
-          </p:nvPr>
-        </p:nvSpPr>
-        <p:spPr>
-          <a:xfrm>
-            <a:off x="8229600" y="4681728"/>
-            <a:ext cx="457200" cy="228600"/>
-          </a:xfrm>
-          <a:prstGeom prst="rect">
-            <a:avLst/>
-          </a:prstGeom>
-          <a:extLst>
-            <a:ext uri="{C572A759-6A51-4108-AA02-DFA0A04FC94B}">
-              <ma14:wrappingTextBoxFlag xmlns:ma14="http://schemas.microsoft.com/office/mac/drawingml/2011/main" val="0"/>
-            </a:ext>
-          </a:extLst>
-        </p:spPr>
-        <p:txBody>
-          <a:bodyPr/>
-          <a:lstStyle>
-            <a:lvl1pPr>
-              <a:defRPr sz="1000">
-                <a:solidFill>
-                  <a:srgbClr val="808080"/>
-                </a:solidFill>
-                <a:latin typeface="Segoe UI Variable Text"/>
-                <a:ea typeface="Segoe UI Variable Text"/>
-                <a:cs typeface="Segoe UI Variable Text"/>
-              </a:defRPr>
-            </a:lvl1pPr>
-          </a:lstStyle>
-          <a:p>
-            <a:pPr algn="r"/>
-            <a:fld id="{F7021451-1387-4CA6-816F-3879F97B5CBC}" type="slidenum">
-              <a:rPr b="0" lang="en-US"/>
-              <a:t>8</a:t>
             </a:fld>
             <a:endParaRPr lang="en-US"/>
           </a:p>

</xml_diff>

<commit_message>
freeze: deck 11:38, defense sheet reserve line, trial page zip aligned with merged build, slide count
Co-Authored-By: Claude Opus 5.5 <noreply@anthropic.com>
</commit_message>
<xml_diff>
--- a/livrables/deck/holdup.pptx
+++ b/livrables/deck/holdup.pptx
@@ -860,7 +860,7 @@
           <a:p>
             <a:r>
               <a:rPr lang="en-US" dirty="0"/>
-              <a:t>250 cas (150 arnaques, 100 jumeaux honnêtes), écrits sans lire nos règles, sha256 publié, ouverts une fois le 11 oct. 2026, moteur figé. Signalé = avertissement ou rouge. Code seul : 87,3 % [81,1 ; 91,7], faux rouges 15,0 % [9,3 ; 23,3]. Sans phrase : 64,7 %. Critères publiés avant : rappel au moins 80 % atteint, faux rouges au plus 10 % non atteint. 11 des 15 faux rouges : achat NFT à prix quasi nul. Ces chiffres mesurent le moteur de comparaison côté serveur (blind_decalage/run/chaine/), en Node, pas l'extension livrée : ne jamais dire « l'extension attrape 87 % ». Ne pas citer A11 ni A12 de CHIFFRES.md comme mesure du produit (rejoué sur le build réel : 38,2 % et 9,1 %, preuves/ECARTS_LIVRABLES.md). Limite : auteur de la même famille de modèles que ceux qui nous ont aidés ; cas synthétiques. Ne plus citer le 1,3 %.</a:t>
+              <a:t>Deux mesures différentes, ne pas les mélanger. (1) Extension, réserve scellée (preuves/RESULTAT_RESERVE_MOTS.md, commit 61dbe40) : preuves/panel/RESERVE.jsonl, 2 673 paires, ouverte une fois le 11 oct. 2026. Demandes non conformes : 1 789, dont 1 334 attrapées (74,6 %), 0 laissée passer sans alerte, 455 en « je n'ai pas pu vérifier » (25,4 %). Demandes conformes : 515, dont 190 « ça correspond », 71 fausses alertes (13,8 % des conformes, 27,2 % des conformes vérifiées), 254 en « pas pu vérifier ». Réserves : lecture de la phrase par mots-clés seulement, le bras avec Clef n'a pas été terminé ; build 6b9de2f, d'avant le nouvel habillage ; un fichier du code de décision était modifié hors commit au lancement ; la réserve est consommée. (2) Moteur de comparaison côté serveur, jeu aveugle de 250 cas (150 arnaques, 100 jumeaux honnêtes) : 87,3 % signalées avec la phrase, 64,7 % sans, faux rouges 15,0 % pour un seuil fixé avant à 10 %, manqué ; auteur des cas : une IA de la même famille que celle qui nous a aidés. Ne jamais dire « l'extension attrape 87 % ». Ne pas citer A11 ni A12 de CHIFFRES.md.</a:t>
             </a:r>
             <a:endParaRPr lang="en-US" dirty="0"/>
           </a:p>
@@ -3037,7 +3037,7 @@
                 <a:ea typeface="Segoe UI Variable Text Semibold" pitchFamily="34" charset="-122"/>
                 <a:cs typeface="Segoe UI Variable Text Semibold" pitchFamily="34" charset="-120"/>
               </a:rPr>
-              <a:t>Jeu aveugle : 250 cas, moteur de comparaison</a:t>
+              <a:t>Mesuré : l’extension, et le moteur de comparaison</a:t>
             </a:r>
             <a:endParaRPr lang="en-US" sz="2800" dirty="0"/>
           </a:p>
@@ -3068,7 +3068,7 @@
               <a:buNone/>
             </a:pPr>
             <a:r>
-              <a:rPr lang="en-US" sz="1100" dirty="0">
+              <a:rPr lang="en-US" sz="1000" dirty="0">
                 <a:solidFill>
                   <a:srgbClr val="B3B3B3"/>
                 </a:solidFill>
@@ -3076,9 +3076,9 @@
                 <a:ea typeface="Segoe UI Variable Text" pitchFamily="34" charset="-122"/>
                 <a:cs typeface="Segoe UI Variable Text" pitchFamily="34" charset="-120"/>
               </a:rPr>
-              <a:t>Dans le dépôt : research/titouan/T_banc_e2e/blind_decalage/run/RESULTAT.md, preuves/ECARTS_LIVRABLES.md</a:t>
-            </a:r>
-            <a:endParaRPr lang="en-US" sz="1100" dirty="0"/>
+              <a:t>Dans le dépôt : preuves/RESULTAT_RESERVE_MOTS.md, research/titouan/T_banc_e2e/blind_decalage/run/RESULTAT.md</a:t>
+            </a:r>
+            <a:endParaRPr lang="en-US" sz="1000" dirty="0"/>
           </a:p>
         </p:txBody>
       </p:sp>
@@ -3090,8 +3090,8 @@
         </p:nvSpPr>
         <p:spPr>
           <a:xfrm>
-            <a:off x="457200" y="1188720"/>
-            <a:ext cx="8229600" cy="320040"/>
+            <a:off x="457200" y="1097280"/>
+            <a:ext cx="3840480" cy="320040"/>
           </a:xfrm>
           <a:prstGeom prst="rect">
             <a:avLst/>
@@ -3107,7 +3107,46 @@
               <a:buNone/>
             </a:pPr>
             <a:r>
-              <a:rPr lang="en-US" sz="1400" dirty="0">
+              <a:rPr lang="en-US" sz="1800" dirty="0">
+                <a:solidFill>
+                  <a:srgbClr val="FFFFFF"/>
+                </a:solidFill>
+                <a:latin typeface="Segoe UI Variable Text Semibold" pitchFamily="34" charset="0"/>
+                <a:ea typeface="Segoe UI Variable Text Semibold" pitchFamily="34" charset="-122"/>
+                <a:cs typeface="Segoe UI Variable Text Semibold" pitchFamily="34" charset="-120"/>
+              </a:rPr>
+              <a:t>L’extension</a:t>
+            </a:r>
+            <a:endParaRPr lang="en-US" sz="1800" dirty="0"/>
+          </a:p>
+        </p:txBody>
+      </p:sp>
+      <p:sp>
+        <p:nvSpPr>
+          <p:cNvPr id="6" name="Text 3"/>
+          <p:cNvSpPr txBox="1"/>
+          <p:nvPr/>
+        </p:nvSpPr>
+        <p:spPr>
+          <a:xfrm>
+            <a:off x="457200" y="1444752"/>
+            <a:ext cx="3840480" cy="274320"/>
+          </a:xfrm>
+          <a:prstGeom prst="rect">
+            <a:avLst/>
+          </a:prstGeom>
+          <a:noFill/>
+          <a:ln/>
+        </p:spPr>
+        <p:txBody>
+          <a:bodyPr wrap="square" lIns="0" tIns="0" rIns="0" bIns="0" rtlCol="0" anchor="t"/>
+          <a:lstStyle/>
+          <a:p>
+            <a:pPr indent="0" marL="0">
+              <a:buNone/>
+            </a:pPr>
+            <a:r>
+              <a:rPr lang="en-US" sz="1300" dirty="0">
                 <a:solidFill>
                   <a:srgbClr val="B3B3B3"/>
                 </a:solidFill>
@@ -3115,22 +3154,22 @@
                 <a:ea typeface="Segoe UI Variable Text" pitchFamily="34" charset="-122"/>
                 <a:cs typeface="Segoe UI Variable Text" pitchFamily="34" charset="-120"/>
               </a:rPr>
-              <a:t>Arnaques signalées</a:t>
-            </a:r>
-            <a:endParaRPr lang="en-US" sz="1400" dirty="0"/>
-          </a:p>
-        </p:txBody>
-      </p:sp>
-      <p:sp>
-        <p:nvSpPr>
-          <p:cNvPr id="6" name="Text 3"/>
-          <p:cNvSpPr txBox="1"/>
-          <p:nvPr/>
-        </p:nvSpPr>
-        <p:spPr>
-          <a:xfrm>
-            <a:off x="457200" y="1554480"/>
-            <a:ext cx="2377440" cy="457200"/>
+              <a:t>Réserve scellée, 2 673 paires, ouverte une fois.</a:t>
+            </a:r>
+            <a:endParaRPr lang="en-US" sz="1300" dirty="0"/>
+          </a:p>
+        </p:txBody>
+      </p:sp>
+      <p:sp>
+        <p:nvSpPr>
+          <p:cNvPr id="7" name="Text 4"/>
+          <p:cNvSpPr txBox="1"/>
+          <p:nvPr/>
+        </p:nvSpPr>
+        <p:spPr>
+          <a:xfrm>
+            <a:off x="457200" y="1828800"/>
+            <a:ext cx="1143000" cy="457200"/>
           </a:xfrm>
           <a:prstGeom prst="rect">
             <a:avLst/>
@@ -3146,7 +3185,46 @@
               <a:buNone/>
             </a:pPr>
             <a:r>
-              <a:rPr lang="en-US" sz="1600" dirty="0">
+              <a:rPr lang="en-US" sz="2600" dirty="0">
+                <a:solidFill>
+                  <a:srgbClr val="FFFFFF"/>
+                </a:solidFill>
+                <a:latin typeface="Segoe UI Variable Text Semibold" pitchFamily="34" charset="0"/>
+                <a:ea typeface="Segoe UI Variable Text Semibold" pitchFamily="34" charset="-122"/>
+                <a:cs typeface="Segoe UI Variable Text Semibold" pitchFamily="34" charset="-120"/>
+              </a:rPr>
+              <a:t>75 %</a:t>
+            </a:r>
+            <a:endParaRPr lang="en-US" sz="2600" dirty="0"/>
+          </a:p>
+        </p:txBody>
+      </p:sp>
+      <p:sp>
+        <p:nvSpPr>
+          <p:cNvPr id="8" name="Text 5"/>
+          <p:cNvSpPr txBox="1"/>
+          <p:nvPr/>
+        </p:nvSpPr>
+        <p:spPr>
+          <a:xfrm>
+            <a:off x="1645920" y="1828800"/>
+            <a:ext cx="2697480" cy="457200"/>
+          </a:xfrm>
+          <a:prstGeom prst="rect">
+            <a:avLst/>
+          </a:prstGeom>
+          <a:noFill/>
+          <a:ln/>
+        </p:spPr>
+        <p:txBody>
+          <a:bodyPr wrap="square" lIns="0" tIns="0" rIns="0" bIns="0" rtlCol="0" anchor="ctr"/>
+          <a:lstStyle/>
+          <a:p>
+            <a:pPr indent="0" marL="0">
+              <a:buNone/>
+            </a:pPr>
+            <a:r>
+              <a:rPr lang="en-US" sz="1300" dirty="0">
                 <a:solidFill>
                   <a:srgbClr val="B3B3B3"/>
                 </a:solidFill>
@@ -3154,47 +3232,22 @@
                 <a:ea typeface="Segoe UI Variable Text" pitchFamily="34" charset="-122"/>
                 <a:cs typeface="Segoe UI Variable Text" pitchFamily="34" charset="-120"/>
               </a:rPr>
-              <a:t>Sans la phrase</a:t>
-            </a:r>
-            <a:endParaRPr lang="en-US" sz="1600" dirty="0"/>
-          </a:p>
-        </p:txBody>
-      </p:sp>
-      <p:sp>
-        <p:nvSpPr>
-          <p:cNvPr id="7" name="Shape 4"/>
-          <p:cNvSpPr/>
-          <p:nvPr/>
-        </p:nvSpPr>
-        <p:spPr>
-          <a:xfrm>
-            <a:off x="2926080" y="1609344"/>
-            <a:ext cx="2958084" cy="347472"/>
-          </a:xfrm>
-          <a:prstGeom prst="rect">
-            <a:avLst/>
-          </a:prstGeom>
-          <a:solidFill>
-            <a:srgbClr val="808080"/>
-          </a:solidFill>
-          <a:ln w="12700">
-            <a:solidFill>
-              <a:srgbClr val="808080"/>
-            </a:solidFill>
-            <a:prstDash val="solid"/>
-          </a:ln>
-        </p:spPr>
-      </p:sp>
-      <p:sp>
-        <p:nvSpPr>
-          <p:cNvPr id="8" name="Text 5"/>
-          <p:cNvSpPr txBox="1"/>
-          <p:nvPr/>
-        </p:nvSpPr>
-        <p:spPr>
-          <a:xfrm>
-            <a:off x="6021324" y="1554480"/>
-            <a:ext cx="1280160" cy="457200"/>
+              <a:t>des demandes non conformes attrapées (1 334 sur 1 789)</a:t>
+            </a:r>
+            <a:endParaRPr lang="en-US" sz="1300" dirty="0"/>
+          </a:p>
+        </p:txBody>
+      </p:sp>
+      <p:sp>
+        <p:nvSpPr>
+          <p:cNvPr id="9" name="Text 6"/>
+          <p:cNvSpPr txBox="1"/>
+          <p:nvPr/>
+        </p:nvSpPr>
+        <p:spPr>
+          <a:xfrm>
+            <a:off x="457200" y="2359152"/>
+            <a:ext cx="1143000" cy="457200"/>
           </a:xfrm>
           <a:prstGeom prst="rect">
             <a:avLst/>
@@ -3212,13 +3265,13 @@
             <a:r>
               <a:rPr lang="en-US" sz="2600" dirty="0">
                 <a:solidFill>
-                  <a:srgbClr val="808080"/>
+                  <a:srgbClr val="FFFFFF"/>
                 </a:solidFill>
                 <a:latin typeface="Segoe UI Variable Text Semibold" pitchFamily="34" charset="0"/>
                 <a:ea typeface="Segoe UI Variable Text Semibold" pitchFamily="34" charset="-122"/>
                 <a:cs typeface="Segoe UI Variable Text Semibold" pitchFamily="34" charset="-120"/>
               </a:rPr>
-              <a:t>65 %</a:t>
+              <a:t>0</a:t>
             </a:r>
             <a:endParaRPr lang="en-US" sz="2600" dirty="0"/>
           </a:p>
@@ -3226,14 +3279,14 @@
       </p:sp>
       <p:sp>
         <p:nvSpPr>
-          <p:cNvPr id="9" name="Text 6"/>
-          <p:cNvSpPr txBox="1"/>
-          <p:nvPr/>
-        </p:nvSpPr>
-        <p:spPr>
-          <a:xfrm>
-            <a:off x="457200" y="2057400"/>
-            <a:ext cx="2377440" cy="457200"/>
+          <p:cNvPr id="10" name="Text 7"/>
+          <p:cNvSpPr txBox="1"/>
+          <p:nvPr/>
+        </p:nvSpPr>
+        <p:spPr>
+          <a:xfrm>
+            <a:off x="1645920" y="2359152"/>
+            <a:ext cx="2697480" cy="457200"/>
           </a:xfrm>
           <a:prstGeom prst="rect">
             <a:avLst/>
@@ -3249,7 +3302,7 @@
               <a:buNone/>
             </a:pPr>
             <a:r>
-              <a:rPr lang="en-US" sz="1600" dirty="0">
+              <a:rPr lang="en-US" sz="1300" dirty="0">
                 <a:solidFill>
                   <a:srgbClr val="B3B3B3"/>
                 </a:solidFill>
@@ -3257,36 +3310,11 @@
                 <a:ea typeface="Segoe UI Variable Text" pitchFamily="34" charset="-122"/>
                 <a:cs typeface="Segoe UI Variable Text" pitchFamily="34" charset="-120"/>
               </a:rPr>
-              <a:t>Avec la phrase</a:t>
-            </a:r>
-            <a:endParaRPr lang="en-US" sz="1600" dirty="0"/>
-          </a:p>
-        </p:txBody>
-      </p:sp>
-      <p:sp>
-        <p:nvSpPr>
-          <p:cNvPr id="10" name="Shape 7"/>
-          <p:cNvSpPr/>
-          <p:nvPr/>
-        </p:nvSpPr>
-        <p:spPr>
-          <a:xfrm>
-            <a:off x="2926080" y="2112264"/>
-            <a:ext cx="3991356" cy="347472"/>
-          </a:xfrm>
-          <a:prstGeom prst="rect">
-            <a:avLst/>
-          </a:prstGeom>
-          <a:solidFill>
-            <a:srgbClr val="FFFFFF"/>
-          </a:solidFill>
-          <a:ln w="12700">
-            <a:solidFill>
-              <a:srgbClr val="FFFFFF"/>
-            </a:solidFill>
-            <a:prstDash val="solid"/>
-          </a:ln>
-        </p:spPr>
+              <a:t>laissée passer sans alerte</a:t>
+            </a:r>
+            <a:endParaRPr lang="en-US" sz="1300" dirty="0"/>
+          </a:p>
+        </p:txBody>
       </p:sp>
       <p:sp>
         <p:nvSpPr>
@@ -3296,8 +3324,8 @@
         </p:nvSpPr>
         <p:spPr>
           <a:xfrm>
-            <a:off x="7054596" y="2057400"/>
-            <a:ext cx="1280160" cy="457200"/>
+            <a:off x="457200" y="2889504"/>
+            <a:ext cx="1143000" cy="457200"/>
           </a:xfrm>
           <a:prstGeom prst="rect">
             <a:avLst/>
@@ -3321,7 +3349,7 @@
                 <a:ea typeface="Segoe UI Variable Text Semibold" pitchFamily="34" charset="-122"/>
                 <a:cs typeface="Segoe UI Variable Text Semibold" pitchFamily="34" charset="-120"/>
               </a:rPr>
-              <a:t>87 %</a:t>
+              <a:t>25 %</a:t>
             </a:r>
             <a:endParaRPr lang="en-US" sz="2600" dirty="0"/>
           </a:p>
@@ -3335,24 +3363,24 @@
         </p:nvSpPr>
         <p:spPr>
           <a:xfrm>
-            <a:off x="457200" y="2788920"/>
-            <a:ext cx="8229600" cy="320040"/>
-          </a:xfrm>
-          <a:prstGeom prst="rect">
-            <a:avLst/>
-          </a:prstGeom>
-          <a:noFill/>
-          <a:ln/>
-        </p:spPr>
-        <p:txBody>
-          <a:bodyPr wrap="square" lIns="0" tIns="0" rIns="0" bIns="0" rtlCol="0" anchor="t"/>
-          <a:lstStyle/>
-          <a:p>
-            <a:pPr indent="0" marL="0">
-              <a:buNone/>
-            </a:pPr>
-            <a:r>
-              <a:rPr lang="en-US" sz="1400" dirty="0">
+            <a:off x="1645920" y="2889504"/>
+            <a:ext cx="2697480" cy="457200"/>
+          </a:xfrm>
+          <a:prstGeom prst="rect">
+            <a:avLst/>
+          </a:prstGeom>
+          <a:noFill/>
+          <a:ln/>
+        </p:spPr>
+        <p:txBody>
+          <a:bodyPr wrap="square" lIns="0" tIns="0" rIns="0" bIns="0" rtlCol="0" anchor="ctr"/>
+          <a:lstStyle/>
+          <a:p>
+            <a:pPr indent="0" marL="0">
+              <a:buNone/>
+            </a:pPr>
+            <a:r>
+              <a:rPr lang="en-US" sz="1300" dirty="0">
                 <a:solidFill>
                   <a:srgbClr val="B3B3B3"/>
                 </a:solidFill>
@@ -3360,9 +3388,9 @@
                 <a:ea typeface="Segoe UI Variable Text" pitchFamily="34" charset="-122"/>
                 <a:cs typeface="Segoe UI Variable Text" pitchFamily="34" charset="-120"/>
               </a:rPr>
-              <a:t>Opérations honnêtes arrêtées à tort</a:t>
-            </a:r>
-            <a:endParaRPr lang="en-US" sz="1400" dirty="0"/>
+              <a:t>« Je n’ai pas pu vérifier »</a:t>
+            </a:r>
+            <a:endParaRPr lang="en-US" sz="1300" dirty="0"/>
           </a:p>
         </p:txBody>
       </p:sp>
@@ -3374,8 +3402,8 @@
         </p:nvSpPr>
         <p:spPr>
           <a:xfrm>
-            <a:off x="457200" y="3154680"/>
-            <a:ext cx="2377440" cy="457200"/>
+            <a:off x="457200" y="3419856"/>
+            <a:ext cx="1143000" cy="457200"/>
           </a:xfrm>
           <a:prstGeom prst="rect">
             <a:avLst/>
@@ -3391,7 +3419,46 @@
               <a:buNone/>
             </a:pPr>
             <a:r>
-              <a:rPr lang="en-US" sz="1600" dirty="0">
+              <a:rPr lang="en-US" sz="2600" dirty="0">
+                <a:solidFill>
+                  <a:srgbClr val="FFFFFF"/>
+                </a:solidFill>
+                <a:latin typeface="Segoe UI Variable Text Semibold" pitchFamily="34" charset="0"/>
+                <a:ea typeface="Segoe UI Variable Text Semibold" pitchFamily="34" charset="-122"/>
+                <a:cs typeface="Segoe UI Variable Text Semibold" pitchFamily="34" charset="-120"/>
+              </a:rPr>
+              <a:t>14 %</a:t>
+            </a:r>
+            <a:endParaRPr lang="en-US" sz="2600" dirty="0"/>
+          </a:p>
+        </p:txBody>
+      </p:sp>
+      <p:sp>
+        <p:nvSpPr>
+          <p:cNvPr id="14" name="Text 11"/>
+          <p:cNvSpPr txBox="1"/>
+          <p:nvPr/>
+        </p:nvSpPr>
+        <p:spPr>
+          <a:xfrm>
+            <a:off x="1645920" y="3419856"/>
+            <a:ext cx="2697480" cy="457200"/>
+          </a:xfrm>
+          <a:prstGeom prst="rect">
+            <a:avLst/>
+          </a:prstGeom>
+          <a:noFill/>
+          <a:ln/>
+        </p:spPr>
+        <p:txBody>
+          <a:bodyPr wrap="square" lIns="0" tIns="0" rIns="0" bIns="0" rtlCol="0" anchor="ctr"/>
+          <a:lstStyle/>
+          <a:p>
+            <a:pPr indent="0" marL="0">
+              <a:buNone/>
+            </a:pPr>
+            <a:r>
+              <a:rPr lang="en-US" sz="1300" dirty="0">
                 <a:solidFill>
                   <a:srgbClr val="B3B3B3"/>
                 </a:solidFill>
@@ -3399,36 +3466,11 @@
                 <a:ea typeface="Segoe UI Variable Text" pitchFamily="34" charset="-122"/>
                 <a:cs typeface="Segoe UI Variable Text" pitchFamily="34" charset="-120"/>
               </a:rPr>
-              <a:t>Seuil fixé avant</a:t>
-            </a:r>
-            <a:endParaRPr lang="en-US" sz="1600" dirty="0"/>
-          </a:p>
-        </p:txBody>
-      </p:sp>
-      <p:sp>
-        <p:nvSpPr>
-          <p:cNvPr id="14" name="Shape 11"/>
-          <p:cNvSpPr/>
-          <p:nvPr/>
-        </p:nvSpPr>
-        <p:spPr>
-          <a:xfrm>
-            <a:off x="2926080" y="3209544"/>
-            <a:ext cx="457200" cy="347472"/>
-          </a:xfrm>
-          <a:prstGeom prst="rect">
-            <a:avLst/>
-          </a:prstGeom>
-          <a:solidFill>
-            <a:srgbClr val="808080"/>
-          </a:solidFill>
-          <a:ln w="12700">
-            <a:solidFill>
-              <a:srgbClr val="808080"/>
-            </a:solidFill>
-            <a:prstDash val="solid"/>
-          </a:ln>
-        </p:spPr>
+              <a:t>de fausses alertes (71 sur 515 demandes conformes)</a:t>
+            </a:r>
+            <a:endParaRPr lang="en-US" sz="1300" dirty="0"/>
+          </a:p>
+        </p:txBody>
       </p:sp>
       <p:sp>
         <p:nvSpPr>
@@ -3438,34 +3480,34 @@
         </p:nvSpPr>
         <p:spPr>
           <a:xfrm>
-            <a:off x="3520440" y="3154680"/>
-            <a:ext cx="1280160" cy="457200"/>
-          </a:xfrm>
-          <a:prstGeom prst="rect">
-            <a:avLst/>
-          </a:prstGeom>
-          <a:noFill/>
-          <a:ln/>
-        </p:spPr>
-        <p:txBody>
-          <a:bodyPr wrap="square" lIns="0" tIns="0" rIns="0" bIns="0" rtlCol="0" anchor="ctr"/>
-          <a:lstStyle/>
-          <a:p>
-            <a:pPr indent="0" marL="0">
-              <a:buNone/>
-            </a:pPr>
-            <a:r>
-              <a:rPr lang="en-US" sz="2600" dirty="0">
-                <a:solidFill>
-                  <a:srgbClr val="808080"/>
+            <a:off x="4846320" y="1097280"/>
+            <a:ext cx="3840480" cy="320040"/>
+          </a:xfrm>
+          <a:prstGeom prst="rect">
+            <a:avLst/>
+          </a:prstGeom>
+          <a:noFill/>
+          <a:ln/>
+        </p:spPr>
+        <p:txBody>
+          <a:bodyPr wrap="square" lIns="0" tIns="0" rIns="0" bIns="0" rtlCol="0" anchor="t"/>
+          <a:lstStyle/>
+          <a:p>
+            <a:pPr indent="0" marL="0">
+              <a:buNone/>
+            </a:pPr>
+            <a:r>
+              <a:rPr lang="en-US" sz="1800" dirty="0">
+                <a:solidFill>
+                  <a:srgbClr val="FFFFFF"/>
                 </a:solidFill>
                 <a:latin typeface="Segoe UI Variable Text Semibold" pitchFamily="34" charset="0"/>
                 <a:ea typeface="Segoe UI Variable Text Semibold" pitchFamily="34" charset="-122"/>
                 <a:cs typeface="Segoe UI Variable Text Semibold" pitchFamily="34" charset="-120"/>
               </a:rPr>
-              <a:t>10 %</a:t>
-            </a:r>
-            <a:endParaRPr lang="en-US" sz="2600" dirty="0"/>
+              <a:t>Le moteur de comparaison</a:t>
+            </a:r>
+            <a:endParaRPr lang="en-US" sz="1800" dirty="0"/>
           </a:p>
         </p:txBody>
       </p:sp>
@@ -3477,24 +3519,24 @@
         </p:nvSpPr>
         <p:spPr>
           <a:xfrm>
-            <a:off x="457200" y="3657600"/>
-            <a:ext cx="2377440" cy="457200"/>
-          </a:xfrm>
-          <a:prstGeom prst="rect">
-            <a:avLst/>
-          </a:prstGeom>
-          <a:noFill/>
-          <a:ln/>
-        </p:spPr>
-        <p:txBody>
-          <a:bodyPr wrap="square" lIns="0" tIns="0" rIns="0" bIns="0" rtlCol="0" anchor="ctr"/>
-          <a:lstStyle/>
-          <a:p>
-            <a:pPr indent="0" marL="0">
-              <a:buNone/>
-            </a:pPr>
-            <a:r>
-              <a:rPr lang="en-US" sz="1600" dirty="0">
+            <a:off x="4846320" y="1444752"/>
+            <a:ext cx="3840480" cy="274320"/>
+          </a:xfrm>
+          <a:prstGeom prst="rect">
+            <a:avLst/>
+          </a:prstGeom>
+          <a:noFill/>
+          <a:ln/>
+        </p:spPr>
+        <p:txBody>
+          <a:bodyPr wrap="square" lIns="0" tIns="0" rIns="0" bIns="0" rtlCol="0" anchor="t"/>
+          <a:lstStyle/>
+          <a:p>
+            <a:pPr indent="0" marL="0">
+              <a:buNone/>
+            </a:pPr>
+            <a:r>
+              <a:rPr lang="en-US" sz="1300" dirty="0">
                 <a:solidFill>
                   <a:srgbClr val="B3B3B3"/>
                 </a:solidFill>
@@ -3502,47 +3544,22 @@
                 <a:ea typeface="Segoe UI Variable Text" pitchFamily="34" charset="-122"/>
                 <a:cs typeface="Segoe UI Variable Text" pitchFamily="34" charset="-120"/>
               </a:rPr>
-              <a:t>Mesuré : seuil manqué</a:t>
-            </a:r>
-            <a:endParaRPr lang="en-US" sz="1600" dirty="0"/>
-          </a:p>
-        </p:txBody>
-      </p:sp>
-      <p:sp>
-        <p:nvSpPr>
-          <p:cNvPr id="17" name="Shape 14"/>
-          <p:cNvSpPr/>
-          <p:nvPr/>
-        </p:nvSpPr>
-        <p:spPr>
-          <a:xfrm>
-            <a:off x="2926080" y="3712464"/>
-            <a:ext cx="685800" cy="347472"/>
-          </a:xfrm>
-          <a:prstGeom prst="rect">
-            <a:avLst/>
-          </a:prstGeom>
-          <a:solidFill>
-            <a:srgbClr val="FFFFFF"/>
-          </a:solidFill>
-          <a:ln w="12700">
-            <a:solidFill>
-              <a:srgbClr val="FFFFFF"/>
-            </a:solidFill>
-            <a:prstDash val="solid"/>
-          </a:ln>
-        </p:spPr>
-      </p:sp>
-      <p:sp>
-        <p:nvSpPr>
-          <p:cNvPr id="18" name="Text 15"/>
-          <p:cNvSpPr txBox="1"/>
-          <p:nvPr/>
-        </p:nvSpPr>
-        <p:spPr>
-          <a:xfrm>
-            <a:off x="3749040" y="3657600"/>
-            <a:ext cx="1280160" cy="457200"/>
+              <a:t>Jeu aveugle de 250 cas, écrits sans voir nos règles.</a:t>
+            </a:r>
+            <a:endParaRPr lang="en-US" sz="1300" dirty="0"/>
+          </a:p>
+        </p:txBody>
+      </p:sp>
+      <p:sp>
+        <p:nvSpPr>
+          <p:cNvPr id="17" name="Text 14"/>
+          <p:cNvSpPr txBox="1"/>
+          <p:nvPr/>
+        </p:nvSpPr>
+        <p:spPr>
+          <a:xfrm>
+            <a:off x="4846320" y="1828800"/>
+            <a:ext cx="1143000" cy="457200"/>
           </a:xfrm>
           <a:prstGeom prst="rect">
             <a:avLst/>
@@ -3566,9 +3583,243 @@
                 <a:ea typeface="Segoe UI Variable Text Semibold" pitchFamily="34" charset="-122"/>
                 <a:cs typeface="Segoe UI Variable Text Semibold" pitchFamily="34" charset="-120"/>
               </a:rPr>
+              <a:t>87 %</a:t>
+            </a:r>
+            <a:endParaRPr lang="en-US" sz="2600" dirty="0"/>
+          </a:p>
+        </p:txBody>
+      </p:sp>
+      <p:sp>
+        <p:nvSpPr>
+          <p:cNvPr id="18" name="Text 15"/>
+          <p:cNvSpPr txBox="1"/>
+          <p:nvPr/>
+        </p:nvSpPr>
+        <p:spPr>
+          <a:xfrm>
+            <a:off x="6035040" y="1828800"/>
+            <a:ext cx="2697480" cy="457200"/>
+          </a:xfrm>
+          <a:prstGeom prst="rect">
+            <a:avLst/>
+          </a:prstGeom>
+          <a:noFill/>
+          <a:ln/>
+        </p:spPr>
+        <p:txBody>
+          <a:bodyPr wrap="square" lIns="0" tIns="0" rIns="0" bIns="0" rtlCol="0" anchor="ctr"/>
+          <a:lstStyle/>
+          <a:p>
+            <a:pPr indent="0" marL="0">
+              <a:buNone/>
+            </a:pPr>
+            <a:r>
+              <a:rPr lang="en-US" sz="1300" dirty="0">
+                <a:solidFill>
+                  <a:srgbClr val="B3B3B3"/>
+                </a:solidFill>
+                <a:latin typeface="Segoe UI Variable Text" pitchFamily="34" charset="0"/>
+                <a:ea typeface="Segoe UI Variable Text" pitchFamily="34" charset="-122"/>
+                <a:cs typeface="Segoe UI Variable Text" pitchFamily="34" charset="-120"/>
+              </a:rPr>
+              <a:t>des arnaques signalées avec la phrase</a:t>
+            </a:r>
+            <a:endParaRPr lang="en-US" sz="1300" dirty="0"/>
+          </a:p>
+        </p:txBody>
+      </p:sp>
+      <p:sp>
+        <p:nvSpPr>
+          <p:cNvPr id="19" name="Text 16"/>
+          <p:cNvSpPr txBox="1"/>
+          <p:nvPr/>
+        </p:nvSpPr>
+        <p:spPr>
+          <a:xfrm>
+            <a:off x="4846320" y="2359152"/>
+            <a:ext cx="1143000" cy="457200"/>
+          </a:xfrm>
+          <a:prstGeom prst="rect">
+            <a:avLst/>
+          </a:prstGeom>
+          <a:noFill/>
+          <a:ln/>
+        </p:spPr>
+        <p:txBody>
+          <a:bodyPr wrap="square" lIns="0" tIns="0" rIns="0" bIns="0" rtlCol="0" anchor="ctr"/>
+          <a:lstStyle/>
+          <a:p>
+            <a:pPr indent="0" marL="0">
+              <a:buNone/>
+            </a:pPr>
+            <a:r>
+              <a:rPr lang="en-US" sz="2600" dirty="0">
+                <a:solidFill>
+                  <a:srgbClr val="FFFFFF"/>
+                </a:solidFill>
+                <a:latin typeface="Segoe UI Variable Text Semibold" pitchFamily="34" charset="0"/>
+                <a:ea typeface="Segoe UI Variable Text Semibold" pitchFamily="34" charset="-122"/>
+                <a:cs typeface="Segoe UI Variable Text Semibold" pitchFamily="34" charset="-120"/>
+              </a:rPr>
+              <a:t>65 %</a:t>
+            </a:r>
+            <a:endParaRPr lang="en-US" sz="2600" dirty="0"/>
+          </a:p>
+        </p:txBody>
+      </p:sp>
+      <p:sp>
+        <p:nvSpPr>
+          <p:cNvPr id="20" name="Text 17"/>
+          <p:cNvSpPr txBox="1"/>
+          <p:nvPr/>
+        </p:nvSpPr>
+        <p:spPr>
+          <a:xfrm>
+            <a:off x="6035040" y="2359152"/>
+            <a:ext cx="2697480" cy="457200"/>
+          </a:xfrm>
+          <a:prstGeom prst="rect">
+            <a:avLst/>
+          </a:prstGeom>
+          <a:noFill/>
+          <a:ln/>
+        </p:spPr>
+        <p:txBody>
+          <a:bodyPr wrap="square" lIns="0" tIns="0" rIns="0" bIns="0" rtlCol="0" anchor="ctr"/>
+          <a:lstStyle/>
+          <a:p>
+            <a:pPr indent="0" marL="0">
+              <a:buNone/>
+            </a:pPr>
+            <a:r>
+              <a:rPr lang="en-US" sz="1300" dirty="0">
+                <a:solidFill>
+                  <a:srgbClr val="B3B3B3"/>
+                </a:solidFill>
+                <a:latin typeface="Segoe UI Variable Text" pitchFamily="34" charset="0"/>
+                <a:ea typeface="Segoe UI Variable Text" pitchFamily="34" charset="-122"/>
+                <a:cs typeface="Segoe UI Variable Text" pitchFamily="34" charset="-120"/>
+              </a:rPr>
+              <a:t>sans la phrase</a:t>
+            </a:r>
+            <a:endParaRPr lang="en-US" sz="1300" dirty="0"/>
+          </a:p>
+        </p:txBody>
+      </p:sp>
+      <p:sp>
+        <p:nvSpPr>
+          <p:cNvPr id="21" name="Text 18"/>
+          <p:cNvSpPr txBox="1"/>
+          <p:nvPr/>
+        </p:nvSpPr>
+        <p:spPr>
+          <a:xfrm>
+            <a:off x="4846320" y="2889504"/>
+            <a:ext cx="1143000" cy="457200"/>
+          </a:xfrm>
+          <a:prstGeom prst="rect">
+            <a:avLst/>
+          </a:prstGeom>
+          <a:noFill/>
+          <a:ln/>
+        </p:spPr>
+        <p:txBody>
+          <a:bodyPr wrap="square" lIns="0" tIns="0" rIns="0" bIns="0" rtlCol="0" anchor="ctr"/>
+          <a:lstStyle/>
+          <a:p>
+            <a:pPr indent="0" marL="0">
+              <a:buNone/>
+            </a:pPr>
+            <a:r>
+              <a:rPr lang="en-US" sz="2600" dirty="0">
+                <a:solidFill>
+                  <a:srgbClr val="FFFFFF"/>
+                </a:solidFill>
+                <a:latin typeface="Segoe UI Variable Text Semibold" pitchFamily="34" charset="0"/>
+                <a:ea typeface="Segoe UI Variable Text Semibold" pitchFamily="34" charset="-122"/>
+                <a:cs typeface="Segoe UI Variable Text Semibold" pitchFamily="34" charset="-120"/>
+              </a:rPr>
               <a:t>15 %</a:t>
             </a:r>
             <a:endParaRPr lang="en-US" sz="2600" dirty="0"/>
+          </a:p>
+        </p:txBody>
+      </p:sp>
+      <p:sp>
+        <p:nvSpPr>
+          <p:cNvPr id="22" name="Text 19"/>
+          <p:cNvSpPr txBox="1"/>
+          <p:nvPr/>
+        </p:nvSpPr>
+        <p:spPr>
+          <a:xfrm>
+            <a:off x="6035040" y="2889504"/>
+            <a:ext cx="2697480" cy="457200"/>
+          </a:xfrm>
+          <a:prstGeom prst="rect">
+            <a:avLst/>
+          </a:prstGeom>
+          <a:noFill/>
+          <a:ln/>
+        </p:spPr>
+        <p:txBody>
+          <a:bodyPr wrap="square" lIns="0" tIns="0" rIns="0" bIns="0" rtlCol="0" anchor="ctr"/>
+          <a:lstStyle/>
+          <a:p>
+            <a:pPr indent="0" marL="0">
+              <a:buNone/>
+            </a:pPr>
+            <a:r>
+              <a:rPr lang="en-US" sz="1300" dirty="0">
+                <a:solidFill>
+                  <a:srgbClr val="B3B3B3"/>
+                </a:solidFill>
+                <a:latin typeface="Segoe UI Variable Text" pitchFamily="34" charset="0"/>
+                <a:ea typeface="Segoe UI Variable Text" pitchFamily="34" charset="-122"/>
+                <a:cs typeface="Segoe UI Variable Text" pitchFamily="34" charset="-120"/>
+              </a:rPr>
+              <a:t>d’opérations honnêtes arrêtées à tort (seuil fixé avant : 10 %)</a:t>
+            </a:r>
+            <a:endParaRPr lang="en-US" sz="1300" dirty="0"/>
+          </a:p>
+        </p:txBody>
+      </p:sp>
+      <p:sp>
+        <p:nvSpPr>
+          <p:cNvPr id="23" name="Text 20"/>
+          <p:cNvSpPr txBox="1"/>
+          <p:nvPr/>
+        </p:nvSpPr>
+        <p:spPr>
+          <a:xfrm>
+            <a:off x="457200" y="4041648"/>
+            <a:ext cx="8229600" cy="457200"/>
+          </a:xfrm>
+          <a:prstGeom prst="rect">
+            <a:avLst/>
+          </a:prstGeom>
+          <a:noFill/>
+          <a:ln/>
+        </p:spPr>
+        <p:txBody>
+          <a:bodyPr wrap="square" lIns="0" tIns="0" rIns="0" bIns="0" rtlCol="0" anchor="t"/>
+          <a:lstStyle/>
+          <a:p>
+            <a:pPr indent="0" marL="0">
+              <a:buNone/>
+            </a:pPr>
+            <a:r>
+              <a:rPr lang="en-US" sz="1200" dirty="0">
+                <a:solidFill>
+                  <a:srgbClr val="B3B3B3"/>
+                </a:solidFill>
+                <a:latin typeface="Segoe UI Variable Text" pitchFamily="34" charset="0"/>
+                <a:ea typeface="Segoe UI Variable Text" pitchFamily="34" charset="-122"/>
+                <a:cs typeface="Segoe UI Variable Text" pitchFamily="34" charset="-120"/>
+              </a:rPr>
+              <a:t>Extension mesurée sans modèle (mots-clés seuls), sur le build 6b9de2f d’avant le nouvel habillage, avec un fichier de décision modifié hors commit.</a:t>
+            </a:r>
+            <a:endParaRPr lang="en-US" sz="1200" dirty="0"/>
           </a:p>
         </p:txBody>
       </p:sp>

</xml_diff>

<commit_message>
video: film v2 with real extension captures; deck 11:41
Co-Authored-By: Claude Opus 5.5 <noreply@anthropic.com>
</commit_message>
<xml_diff>
--- a/livrables/deck/holdup.pptx
+++ b/livrables/deck/holdup.pptx
@@ -2513,8 +2513,8 @@
         </p:nvSpPr>
         <p:spPr>
           <a:xfrm>
-            <a:off x="457200" y="3703320"/>
-            <a:ext cx="3840480" cy="365760"/>
+            <a:off x="4846320" y="2331720"/>
+            <a:ext cx="3840480" cy="320040"/>
           </a:xfrm>
           <a:prstGeom prst="rect">
             <a:avLst/>
@@ -2530,7 +2530,7 @@
               <a:buNone/>
             </a:pPr>
             <a:r>
-              <a:rPr lang="en-US" sz="1400" dirty="0">
+              <a:rPr lang="en-US" sz="1600" dirty="0">
                 <a:solidFill>
                   <a:srgbClr val="B3B3B3"/>
                 </a:solidFill>
@@ -2538,54 +2538,15 @@
                 <a:ea typeface="Segoe UI Variable Text" pitchFamily="34" charset="-122"/>
                 <a:cs typeface="Segoe UI Variable Text" pitchFamily="34" charset="-120"/>
               </a:rPr>
-              <a:t>Le pirate se sert de l’accès illimité.</a:t>
-            </a:r>
-            <a:endParaRPr lang="en-US" sz="1400" dirty="0"/>
+              <a:t>Avec Hold up, il te reste</a:t>
+            </a:r>
+            <a:endParaRPr lang="en-US" sz="1600" dirty="0"/>
           </a:p>
         </p:txBody>
       </p:sp>
       <p:sp>
         <p:nvSpPr>
           <p:cNvPr id="14" name="Text 11"/>
-          <p:cNvSpPr txBox="1"/>
-          <p:nvPr/>
-        </p:nvSpPr>
-        <p:spPr>
-          <a:xfrm>
-            <a:off x="4846320" y="2331720"/>
-            <a:ext cx="3840480" cy="320040"/>
-          </a:xfrm>
-          <a:prstGeom prst="rect">
-            <a:avLst/>
-          </a:prstGeom>
-          <a:noFill/>
-          <a:ln/>
-        </p:spPr>
-        <p:txBody>
-          <a:bodyPr wrap="square" lIns="0" tIns="0" rIns="0" bIns="0" rtlCol="0" anchor="t"/>
-          <a:lstStyle/>
-          <a:p>
-            <a:pPr indent="0" marL="0">
-              <a:buNone/>
-            </a:pPr>
-            <a:r>
-              <a:rPr lang="en-US" sz="1600" dirty="0">
-                <a:solidFill>
-                  <a:srgbClr val="B3B3B3"/>
-                </a:solidFill>
-                <a:latin typeface="Segoe UI Variable Text" pitchFamily="34" charset="0"/>
-                <a:ea typeface="Segoe UI Variable Text" pitchFamily="34" charset="-122"/>
-                <a:cs typeface="Segoe UI Variable Text" pitchFamily="34" charset="-120"/>
-              </a:rPr>
-              <a:t>Avec Hold up, il te reste</a:t>
-            </a:r>
-            <a:endParaRPr lang="en-US" sz="1600" dirty="0"/>
-          </a:p>
-        </p:txBody>
-      </p:sp>
-      <p:sp>
-        <p:nvSpPr>
-          <p:cNvPr id="15" name="Text 12"/>
           <p:cNvSpPr txBox="1"/>
           <p:nvPr/>
         </p:nvSpPr>
@@ -2619,45 +2580,6 @@
               <a:t>50 USDC</a:t>
             </a:r>
             <a:endParaRPr lang="en-US" sz="6000" dirty="0"/>
-          </a:p>
-        </p:txBody>
-      </p:sp>
-      <p:sp>
-        <p:nvSpPr>
-          <p:cNvPr id="16" name="Text 13"/>
-          <p:cNvSpPr txBox="1"/>
-          <p:nvPr/>
-        </p:nvSpPr>
-        <p:spPr>
-          <a:xfrm>
-            <a:off x="4846320" y="3703320"/>
-            <a:ext cx="3840480" cy="548640"/>
-          </a:xfrm>
-          <a:prstGeom prst="rect">
-            <a:avLst/>
-          </a:prstGeom>
-          <a:noFill/>
-          <a:ln/>
-        </p:spPr>
-        <p:txBody>
-          <a:bodyPr wrap="square" lIns="0" tIns="0" rIns="0" bIns="0" rtlCol="0" anchor="t"/>
-          <a:lstStyle/>
-          <a:p>
-            <a:pPr indent="0" marL="0">
-              <a:buNone/>
-            </a:pPr>
-            <a:r>
-              <a:rPr lang="en-US" sz="1400" dirty="0">
-                <a:solidFill>
-                  <a:srgbClr val="B3B3B3"/>
-                </a:solidFill>
-                <a:latin typeface="Segoe UI Variable Text" pitchFamily="34" charset="0"/>
-                <a:ea typeface="Segoe UI Variable Text" pitchFamily="34" charset="-122"/>
-                <a:cs typeface="Segoe UI Variable Text" pitchFamily="34" charset="-120"/>
-              </a:rPr>
-              <a:t>Tu avais limité l’accès aux 50 de l’échange. Il n’y a plus rien à prendre.</a:t>
-            </a:r>
-            <a:endParaRPr lang="en-US" sz="1400" dirty="0"/>
           </a:p>
         </p:txBody>
       </p:sp>
@@ -2868,48 +2790,9 @@
           </a:p>
         </p:txBody>
       </p:sp>
-      <p:sp>
-        <p:nvSpPr>
-          <p:cNvPr id="6" name="Text 3"/>
-          <p:cNvSpPr txBox="1"/>
-          <p:nvPr/>
-        </p:nvSpPr>
-        <p:spPr>
-          <a:xfrm>
-            <a:off x="457200" y="3977640"/>
-            <a:ext cx="4754880" cy="365760"/>
-          </a:xfrm>
-          <a:prstGeom prst="rect">
-            <a:avLst/>
-          </a:prstGeom>
-          <a:noFill/>
-          <a:ln/>
-        </p:spPr>
-        <p:txBody>
-          <a:bodyPr wrap="square" lIns="0" tIns="0" rIns="0" bIns="0" rtlCol="0" anchor="t"/>
-          <a:lstStyle/>
-          <a:p>
-            <a:pPr indent="0" marL="0">
-              <a:buNone/>
-            </a:pPr>
-            <a:r>
-              <a:rPr lang="en-US" sz="1600" dirty="0">
-                <a:solidFill>
-                  <a:srgbClr val="B3B3B3"/>
-                </a:solidFill>
-                <a:latin typeface="Segoe UI Variable Text" pitchFamily="34" charset="0"/>
-                <a:ea typeface="Segoe UI Variable Text" pitchFamily="34" charset="-122"/>
-                <a:cs typeface="Segoe UI Variable Text" pitchFamily="34" charset="-120"/>
-              </a:rPr>
-              <a:t>Jamais joué devant un vrai portefeuille.</a:t>
-            </a:r>
-            <a:endParaRPr lang="en-US" sz="1600" dirty="0"/>
-          </a:p>
-        </p:txBody>
-      </p:sp>
       <p:pic>
         <p:nvPicPr>
-          <p:cNvPr id="7" name="Image 0" descr="C:\Users\Adem\Secure Horizon\docs\design\system\captures\pan-ouvert_sombre.png">    </p:cNvPr>
+          <p:cNvPr id="6" name="Image 0" descr="C:\Users\Adem\Secure Horizon\docs\design\system\captures\pan-ouvert_sombre.png">    </p:cNvPr>
           <p:cNvPicPr>
             <a:picLocks noChangeAspect="1"/>
           </p:cNvPicPr>
@@ -3037,7 +2920,7 @@
                 <a:ea typeface="Segoe UI Variable Text Semibold" pitchFamily="34" charset="-122"/>
                 <a:cs typeface="Segoe UI Variable Text Semibold" pitchFamily="34" charset="-120"/>
               </a:rPr>
-              <a:t>Mesuré : l’extension, et le moteur de comparaison</a:t>
+              <a:t>Ce que l’extension a trouvé</a:t>
             </a:r>
             <a:endParaRPr lang="en-US" sz="2800" dirty="0"/>
           </a:p>
@@ -3068,7 +2951,7 @@
               <a:buNone/>
             </a:pPr>
             <a:r>
-              <a:rPr lang="en-US" sz="1000" dirty="0">
+              <a:rPr lang="en-US" sz="1100" dirty="0">
                 <a:solidFill>
                   <a:srgbClr val="B3B3B3"/>
                 </a:solidFill>
@@ -3076,9 +2959,9 @@
                 <a:ea typeface="Segoe UI Variable Text" pitchFamily="34" charset="-122"/>
                 <a:cs typeface="Segoe UI Variable Text" pitchFamily="34" charset="-120"/>
               </a:rPr>
-              <a:t>Dans le dépôt : preuves/RESULTAT_RESERVE_MOTS.md, research/titouan/T_banc_e2e/blind_decalage/run/RESULTAT.md</a:t>
-            </a:r>
-            <a:endParaRPr lang="en-US" sz="1000" dirty="0"/>
+              <a:t>Dans le dépôt : preuves/RESULTAT_RESERVE_MOTS.md</a:t>
+            </a:r>
+            <a:endParaRPr lang="en-US" sz="1100" dirty="0"/>
           </a:p>
         </p:txBody>
       </p:sp>
@@ -3090,8 +2973,8 @@
         </p:nvSpPr>
         <p:spPr>
           <a:xfrm>
-            <a:off x="457200" y="1097280"/>
-            <a:ext cx="3840480" cy="320040"/>
+            <a:off x="457200" y="1143000"/>
+            <a:ext cx="3931920" cy="1188720"/>
           </a:xfrm>
           <a:prstGeom prst="rect">
             <a:avLst/>
@@ -3107,7 +2990,7 @@
               <a:buNone/>
             </a:pPr>
             <a:r>
-              <a:rPr lang="en-US" sz="1800" dirty="0">
+              <a:rPr lang="en-US" sz="8000" dirty="0">
                 <a:solidFill>
                   <a:srgbClr val="FFFFFF"/>
                 </a:solidFill>
@@ -3115,9 +2998,9 @@
                 <a:ea typeface="Segoe UI Variable Text Semibold" pitchFamily="34" charset="-122"/>
                 <a:cs typeface="Segoe UI Variable Text Semibold" pitchFamily="34" charset="-120"/>
               </a:rPr>
-              <a:t>L’extension</a:t>
-            </a:r>
-            <a:endParaRPr lang="en-US" sz="1800" dirty="0"/>
+              <a:t>1 334</a:t>
+            </a:r>
+            <a:endParaRPr lang="en-US" sz="8000" dirty="0"/>
           </a:p>
         </p:txBody>
       </p:sp>
@@ -3129,8 +3012,8 @@
         </p:nvSpPr>
         <p:spPr>
           <a:xfrm>
-            <a:off x="457200" y="1444752"/>
-            <a:ext cx="3840480" cy="274320"/>
+            <a:off x="457200" y="2514600"/>
+            <a:ext cx="3657600" cy="822960"/>
           </a:xfrm>
           <a:prstGeom prst="rect">
             <a:avLst/>
@@ -3146,7 +3029,7 @@
               <a:buNone/>
             </a:pPr>
             <a:r>
-              <a:rPr lang="en-US" sz="1300" dirty="0">
+              <a:rPr lang="en-US" sz="1600" dirty="0">
                 <a:solidFill>
                   <a:srgbClr val="B3B3B3"/>
                 </a:solidFill>
@@ -3154,9 +3037,9 @@
                 <a:ea typeface="Segoe UI Variable Text" pitchFamily="34" charset="-122"/>
                 <a:cs typeface="Segoe UI Variable Text" pitchFamily="34" charset="-120"/>
               </a:rPr>
-              <a:t>Réserve scellée, 2 673 paires, ouverte une fois.</a:t>
-            </a:r>
-            <a:endParaRPr lang="en-US" sz="1300" dirty="0"/>
+              <a:t>demandes piégées attrapées, sur 1 789. Aucune n’est passée sans alerte.</a:t>
+            </a:r>
+            <a:endParaRPr lang="en-US" sz="1600" dirty="0"/>
           </a:p>
         </p:txBody>
       </p:sp>
@@ -3168,8 +3051,8 @@
         </p:nvSpPr>
         <p:spPr>
           <a:xfrm>
-            <a:off x="457200" y="1828800"/>
-            <a:ext cx="1143000" cy="457200"/>
+            <a:off x="4846320" y="1143000"/>
+            <a:ext cx="3931920" cy="1188720"/>
           </a:xfrm>
           <a:prstGeom prst="rect">
             <a:avLst/>
@@ -3178,14 +3061,14 @@
           <a:ln/>
         </p:spPr>
         <p:txBody>
-          <a:bodyPr wrap="square" lIns="0" tIns="0" rIns="0" bIns="0" rtlCol="0" anchor="ctr"/>
-          <a:lstStyle/>
-          <a:p>
-            <a:pPr indent="0" marL="0">
-              <a:buNone/>
-            </a:pPr>
-            <a:r>
-              <a:rPr lang="en-US" sz="2600" dirty="0">
+          <a:bodyPr wrap="square" lIns="0" tIns="0" rIns="0" bIns="0" rtlCol="0" anchor="t"/>
+          <a:lstStyle/>
+          <a:p>
+            <a:pPr indent="0" marL="0">
+              <a:buNone/>
+            </a:pPr>
+            <a:r>
+              <a:rPr lang="en-US" sz="8000" dirty="0">
                 <a:solidFill>
                   <a:srgbClr val="FFFFFF"/>
                 </a:solidFill>
@@ -3193,9 +3076,9 @@
                 <a:ea typeface="Segoe UI Variable Text Semibold" pitchFamily="34" charset="-122"/>
                 <a:cs typeface="Segoe UI Variable Text Semibold" pitchFamily="34" charset="-120"/>
               </a:rPr>
-              <a:t>75 %</a:t>
-            </a:r>
-            <a:endParaRPr lang="en-US" sz="2600" dirty="0"/>
+              <a:t>14 %</a:t>
+            </a:r>
+            <a:endParaRPr lang="en-US" sz="8000" dirty="0"/>
           </a:p>
         </p:txBody>
       </p:sp>
@@ -3207,8 +3090,8 @@
         </p:nvSpPr>
         <p:spPr>
           <a:xfrm>
-            <a:off x="1645920" y="1828800"/>
-            <a:ext cx="2697480" cy="457200"/>
+            <a:off x="4846320" y="2514600"/>
+            <a:ext cx="3657600" cy="822960"/>
           </a:xfrm>
           <a:prstGeom prst="rect">
             <a:avLst/>
@@ -3217,14 +3100,14 @@
           <a:ln/>
         </p:spPr>
         <p:txBody>
-          <a:bodyPr wrap="square" lIns="0" tIns="0" rIns="0" bIns="0" rtlCol="0" anchor="ctr"/>
-          <a:lstStyle/>
-          <a:p>
-            <a:pPr indent="0" marL="0">
-              <a:buNone/>
-            </a:pPr>
-            <a:r>
-              <a:rPr lang="en-US" sz="1300" dirty="0">
+          <a:bodyPr wrap="square" lIns="0" tIns="0" rIns="0" bIns="0" rtlCol="0" anchor="t"/>
+          <a:lstStyle/>
+          <a:p>
+            <a:pPr indent="0" marL="0">
+              <a:buNone/>
+            </a:pPr>
+            <a:r>
+              <a:rPr lang="en-US" sz="1600" dirty="0">
                 <a:solidFill>
                   <a:srgbClr val="B3B3B3"/>
                 </a:solidFill>
@@ -3232,9 +3115,9 @@
                 <a:ea typeface="Segoe UI Variable Text" pitchFamily="34" charset="-122"/>
                 <a:cs typeface="Segoe UI Variable Text" pitchFamily="34" charset="-120"/>
               </a:rPr>
-              <a:t>des demandes non conformes attrapées (1 334 sur 1 789)</a:t>
-            </a:r>
-            <a:endParaRPr lang="en-US" sz="1300" dirty="0"/>
+              <a:t>de fausses alertes : 71 demandes honnêtes sur 515.</a:t>
+            </a:r>
+            <a:endParaRPr lang="en-US" sz="1600" dirty="0"/>
           </a:p>
         </p:txBody>
       </p:sp>
@@ -3246,8 +3129,8 @@
         </p:nvSpPr>
         <p:spPr>
           <a:xfrm>
-            <a:off x="457200" y="2359152"/>
-            <a:ext cx="1143000" cy="457200"/>
+            <a:off x="457200" y="3931920"/>
+            <a:ext cx="8229600" cy="365760"/>
           </a:xfrm>
           <a:prstGeom prst="rect">
             <a:avLst/>
@@ -3256,53 +3139,14 @@
           <a:ln/>
         </p:spPr>
         <p:txBody>
-          <a:bodyPr wrap="square" lIns="0" tIns="0" rIns="0" bIns="0" rtlCol="0" anchor="ctr"/>
-          <a:lstStyle/>
-          <a:p>
-            <a:pPr indent="0" marL="0">
-              <a:buNone/>
-            </a:pPr>
-            <a:r>
-              <a:rPr lang="en-US" sz="2600" dirty="0">
-                <a:solidFill>
-                  <a:srgbClr val="FFFFFF"/>
-                </a:solidFill>
-                <a:latin typeface="Segoe UI Variable Text Semibold" pitchFamily="34" charset="0"/>
-                <a:ea typeface="Segoe UI Variable Text Semibold" pitchFamily="34" charset="-122"/>
-                <a:cs typeface="Segoe UI Variable Text Semibold" pitchFamily="34" charset="-120"/>
-              </a:rPr>
-              <a:t>0</a:t>
-            </a:r>
-            <a:endParaRPr lang="en-US" sz="2600" dirty="0"/>
-          </a:p>
-        </p:txBody>
-      </p:sp>
-      <p:sp>
-        <p:nvSpPr>
-          <p:cNvPr id="10" name="Text 7"/>
-          <p:cNvSpPr txBox="1"/>
-          <p:nvPr/>
-        </p:nvSpPr>
-        <p:spPr>
-          <a:xfrm>
-            <a:off x="1645920" y="2359152"/>
-            <a:ext cx="2697480" cy="457200"/>
-          </a:xfrm>
-          <a:prstGeom prst="rect">
-            <a:avLst/>
-          </a:prstGeom>
-          <a:noFill/>
-          <a:ln/>
-        </p:spPr>
-        <p:txBody>
-          <a:bodyPr wrap="square" lIns="0" tIns="0" rIns="0" bIns="0" rtlCol="0" anchor="ctr"/>
-          <a:lstStyle/>
-          <a:p>
-            <a:pPr indent="0" marL="0">
-              <a:buNone/>
-            </a:pPr>
-            <a:r>
-              <a:rPr lang="en-US" sz="1300" dirty="0">
+          <a:bodyPr wrap="square" lIns="0" tIns="0" rIns="0" bIns="0" rtlCol="0" anchor="t"/>
+          <a:lstStyle/>
+          <a:p>
+            <a:pPr indent="0" marL="0">
+              <a:buNone/>
+            </a:pPr>
+            <a:r>
+              <a:rPr lang="en-US" sz="1400" dirty="0">
                 <a:solidFill>
                   <a:srgbClr val="B3B3B3"/>
                 </a:solidFill>
@@ -3310,516 +3154,9 @@
                 <a:ea typeface="Segoe UI Variable Text" pitchFamily="34" charset="-122"/>
                 <a:cs typeface="Segoe UI Variable Text" pitchFamily="34" charset="-120"/>
               </a:rPr>
-              <a:t>laissée passer sans alerte</a:t>
-            </a:r>
-            <a:endParaRPr lang="en-US" sz="1300" dirty="0"/>
-          </a:p>
-        </p:txBody>
-      </p:sp>
-      <p:sp>
-        <p:nvSpPr>
-          <p:cNvPr id="11" name="Text 8"/>
-          <p:cNvSpPr txBox="1"/>
-          <p:nvPr/>
-        </p:nvSpPr>
-        <p:spPr>
-          <a:xfrm>
-            <a:off x="457200" y="2889504"/>
-            <a:ext cx="1143000" cy="457200"/>
-          </a:xfrm>
-          <a:prstGeom prst="rect">
-            <a:avLst/>
-          </a:prstGeom>
-          <a:noFill/>
-          <a:ln/>
-        </p:spPr>
-        <p:txBody>
-          <a:bodyPr wrap="square" lIns="0" tIns="0" rIns="0" bIns="0" rtlCol="0" anchor="ctr"/>
-          <a:lstStyle/>
-          <a:p>
-            <a:pPr indent="0" marL="0">
-              <a:buNone/>
-            </a:pPr>
-            <a:r>
-              <a:rPr lang="en-US" sz="2600" dirty="0">
-                <a:solidFill>
-                  <a:srgbClr val="FFFFFF"/>
-                </a:solidFill>
-                <a:latin typeface="Segoe UI Variable Text Semibold" pitchFamily="34" charset="0"/>
-                <a:ea typeface="Segoe UI Variable Text Semibold" pitchFamily="34" charset="-122"/>
-                <a:cs typeface="Segoe UI Variable Text Semibold" pitchFamily="34" charset="-120"/>
-              </a:rPr>
-              <a:t>25 %</a:t>
-            </a:r>
-            <a:endParaRPr lang="en-US" sz="2600" dirty="0"/>
-          </a:p>
-        </p:txBody>
-      </p:sp>
-      <p:sp>
-        <p:nvSpPr>
-          <p:cNvPr id="12" name="Text 9"/>
-          <p:cNvSpPr txBox="1"/>
-          <p:nvPr/>
-        </p:nvSpPr>
-        <p:spPr>
-          <a:xfrm>
-            <a:off x="1645920" y="2889504"/>
-            <a:ext cx="2697480" cy="457200"/>
-          </a:xfrm>
-          <a:prstGeom prst="rect">
-            <a:avLst/>
-          </a:prstGeom>
-          <a:noFill/>
-          <a:ln/>
-        </p:spPr>
-        <p:txBody>
-          <a:bodyPr wrap="square" lIns="0" tIns="0" rIns="0" bIns="0" rtlCol="0" anchor="ctr"/>
-          <a:lstStyle/>
-          <a:p>
-            <a:pPr indent="0" marL="0">
-              <a:buNone/>
-            </a:pPr>
-            <a:r>
-              <a:rPr lang="en-US" sz="1300" dirty="0">
-                <a:solidFill>
-                  <a:srgbClr val="B3B3B3"/>
-                </a:solidFill>
-                <a:latin typeface="Segoe UI Variable Text" pitchFamily="34" charset="0"/>
-                <a:ea typeface="Segoe UI Variable Text" pitchFamily="34" charset="-122"/>
-                <a:cs typeface="Segoe UI Variable Text" pitchFamily="34" charset="-120"/>
-              </a:rPr>
-              <a:t>« Je n’ai pas pu vérifier »</a:t>
-            </a:r>
-            <a:endParaRPr lang="en-US" sz="1300" dirty="0"/>
-          </a:p>
-        </p:txBody>
-      </p:sp>
-      <p:sp>
-        <p:nvSpPr>
-          <p:cNvPr id="13" name="Text 10"/>
-          <p:cNvSpPr txBox="1"/>
-          <p:nvPr/>
-        </p:nvSpPr>
-        <p:spPr>
-          <a:xfrm>
-            <a:off x="457200" y="3419856"/>
-            <a:ext cx="1143000" cy="457200"/>
-          </a:xfrm>
-          <a:prstGeom prst="rect">
-            <a:avLst/>
-          </a:prstGeom>
-          <a:noFill/>
-          <a:ln/>
-        </p:spPr>
-        <p:txBody>
-          <a:bodyPr wrap="square" lIns="0" tIns="0" rIns="0" bIns="0" rtlCol="0" anchor="ctr"/>
-          <a:lstStyle/>
-          <a:p>
-            <a:pPr indent="0" marL="0">
-              <a:buNone/>
-            </a:pPr>
-            <a:r>
-              <a:rPr lang="en-US" sz="2600" dirty="0">
-                <a:solidFill>
-                  <a:srgbClr val="FFFFFF"/>
-                </a:solidFill>
-                <a:latin typeface="Segoe UI Variable Text Semibold" pitchFamily="34" charset="0"/>
-                <a:ea typeface="Segoe UI Variable Text Semibold" pitchFamily="34" charset="-122"/>
-                <a:cs typeface="Segoe UI Variable Text Semibold" pitchFamily="34" charset="-120"/>
-              </a:rPr>
-              <a:t>14 %</a:t>
-            </a:r>
-            <a:endParaRPr lang="en-US" sz="2600" dirty="0"/>
-          </a:p>
-        </p:txBody>
-      </p:sp>
-      <p:sp>
-        <p:nvSpPr>
-          <p:cNvPr id="14" name="Text 11"/>
-          <p:cNvSpPr txBox="1"/>
-          <p:nvPr/>
-        </p:nvSpPr>
-        <p:spPr>
-          <a:xfrm>
-            <a:off x="1645920" y="3419856"/>
-            <a:ext cx="2697480" cy="457200"/>
-          </a:xfrm>
-          <a:prstGeom prst="rect">
-            <a:avLst/>
-          </a:prstGeom>
-          <a:noFill/>
-          <a:ln/>
-        </p:spPr>
-        <p:txBody>
-          <a:bodyPr wrap="square" lIns="0" tIns="0" rIns="0" bIns="0" rtlCol="0" anchor="ctr"/>
-          <a:lstStyle/>
-          <a:p>
-            <a:pPr indent="0" marL="0">
-              <a:buNone/>
-            </a:pPr>
-            <a:r>
-              <a:rPr lang="en-US" sz="1300" dirty="0">
-                <a:solidFill>
-                  <a:srgbClr val="B3B3B3"/>
-                </a:solidFill>
-                <a:latin typeface="Segoe UI Variable Text" pitchFamily="34" charset="0"/>
-                <a:ea typeface="Segoe UI Variable Text" pitchFamily="34" charset="-122"/>
-                <a:cs typeface="Segoe UI Variable Text" pitchFamily="34" charset="-120"/>
-              </a:rPr>
-              <a:t>de fausses alertes (71 sur 515 demandes conformes)</a:t>
-            </a:r>
-            <a:endParaRPr lang="en-US" sz="1300" dirty="0"/>
-          </a:p>
-        </p:txBody>
-      </p:sp>
-      <p:sp>
-        <p:nvSpPr>
-          <p:cNvPr id="15" name="Text 12"/>
-          <p:cNvSpPr txBox="1"/>
-          <p:nvPr/>
-        </p:nvSpPr>
-        <p:spPr>
-          <a:xfrm>
-            <a:off x="4846320" y="1097280"/>
-            <a:ext cx="3840480" cy="320040"/>
-          </a:xfrm>
-          <a:prstGeom prst="rect">
-            <a:avLst/>
-          </a:prstGeom>
-          <a:noFill/>
-          <a:ln/>
-        </p:spPr>
-        <p:txBody>
-          <a:bodyPr wrap="square" lIns="0" tIns="0" rIns="0" bIns="0" rtlCol="0" anchor="t"/>
-          <a:lstStyle/>
-          <a:p>
-            <a:pPr indent="0" marL="0">
-              <a:buNone/>
-            </a:pPr>
-            <a:r>
-              <a:rPr lang="en-US" sz="1800" dirty="0">
-                <a:solidFill>
-                  <a:srgbClr val="FFFFFF"/>
-                </a:solidFill>
-                <a:latin typeface="Segoe UI Variable Text Semibold" pitchFamily="34" charset="0"/>
-                <a:ea typeface="Segoe UI Variable Text Semibold" pitchFamily="34" charset="-122"/>
-                <a:cs typeface="Segoe UI Variable Text Semibold" pitchFamily="34" charset="-120"/>
-              </a:rPr>
-              <a:t>Le moteur de comparaison</a:t>
-            </a:r>
-            <a:endParaRPr lang="en-US" sz="1800" dirty="0"/>
-          </a:p>
-        </p:txBody>
-      </p:sp>
-      <p:sp>
-        <p:nvSpPr>
-          <p:cNvPr id="16" name="Text 13"/>
-          <p:cNvSpPr txBox="1"/>
-          <p:nvPr/>
-        </p:nvSpPr>
-        <p:spPr>
-          <a:xfrm>
-            <a:off x="4846320" y="1444752"/>
-            <a:ext cx="3840480" cy="274320"/>
-          </a:xfrm>
-          <a:prstGeom prst="rect">
-            <a:avLst/>
-          </a:prstGeom>
-          <a:noFill/>
-          <a:ln/>
-        </p:spPr>
-        <p:txBody>
-          <a:bodyPr wrap="square" lIns="0" tIns="0" rIns="0" bIns="0" rtlCol="0" anchor="t"/>
-          <a:lstStyle/>
-          <a:p>
-            <a:pPr indent="0" marL="0">
-              <a:buNone/>
-            </a:pPr>
-            <a:r>
-              <a:rPr lang="en-US" sz="1300" dirty="0">
-                <a:solidFill>
-                  <a:srgbClr val="B3B3B3"/>
-                </a:solidFill>
-                <a:latin typeface="Segoe UI Variable Text" pitchFamily="34" charset="0"/>
-                <a:ea typeface="Segoe UI Variable Text" pitchFamily="34" charset="-122"/>
-                <a:cs typeface="Segoe UI Variable Text" pitchFamily="34" charset="-120"/>
-              </a:rPr>
-              <a:t>Jeu aveugle de 250 cas, écrits sans voir nos règles.</a:t>
-            </a:r>
-            <a:endParaRPr lang="en-US" sz="1300" dirty="0"/>
-          </a:p>
-        </p:txBody>
-      </p:sp>
-      <p:sp>
-        <p:nvSpPr>
-          <p:cNvPr id="17" name="Text 14"/>
-          <p:cNvSpPr txBox="1"/>
-          <p:nvPr/>
-        </p:nvSpPr>
-        <p:spPr>
-          <a:xfrm>
-            <a:off x="4846320" y="1828800"/>
-            <a:ext cx="1143000" cy="457200"/>
-          </a:xfrm>
-          <a:prstGeom prst="rect">
-            <a:avLst/>
-          </a:prstGeom>
-          <a:noFill/>
-          <a:ln/>
-        </p:spPr>
-        <p:txBody>
-          <a:bodyPr wrap="square" lIns="0" tIns="0" rIns="0" bIns="0" rtlCol="0" anchor="ctr"/>
-          <a:lstStyle/>
-          <a:p>
-            <a:pPr indent="0" marL="0">
-              <a:buNone/>
-            </a:pPr>
-            <a:r>
-              <a:rPr lang="en-US" sz="2600" dirty="0">
-                <a:solidFill>
-                  <a:srgbClr val="FFFFFF"/>
-                </a:solidFill>
-                <a:latin typeface="Segoe UI Variable Text Semibold" pitchFamily="34" charset="0"/>
-                <a:ea typeface="Segoe UI Variable Text Semibold" pitchFamily="34" charset="-122"/>
-                <a:cs typeface="Segoe UI Variable Text Semibold" pitchFamily="34" charset="-120"/>
-              </a:rPr>
-              <a:t>87 %</a:t>
-            </a:r>
-            <a:endParaRPr lang="en-US" sz="2600" dirty="0"/>
-          </a:p>
-        </p:txBody>
-      </p:sp>
-      <p:sp>
-        <p:nvSpPr>
-          <p:cNvPr id="18" name="Text 15"/>
-          <p:cNvSpPr txBox="1"/>
-          <p:nvPr/>
-        </p:nvSpPr>
-        <p:spPr>
-          <a:xfrm>
-            <a:off x="6035040" y="1828800"/>
-            <a:ext cx="2697480" cy="457200"/>
-          </a:xfrm>
-          <a:prstGeom prst="rect">
-            <a:avLst/>
-          </a:prstGeom>
-          <a:noFill/>
-          <a:ln/>
-        </p:spPr>
-        <p:txBody>
-          <a:bodyPr wrap="square" lIns="0" tIns="0" rIns="0" bIns="0" rtlCol="0" anchor="ctr"/>
-          <a:lstStyle/>
-          <a:p>
-            <a:pPr indent="0" marL="0">
-              <a:buNone/>
-            </a:pPr>
-            <a:r>
-              <a:rPr lang="en-US" sz="1300" dirty="0">
-                <a:solidFill>
-                  <a:srgbClr val="B3B3B3"/>
-                </a:solidFill>
-                <a:latin typeface="Segoe UI Variable Text" pitchFamily="34" charset="0"/>
-                <a:ea typeface="Segoe UI Variable Text" pitchFamily="34" charset="-122"/>
-                <a:cs typeface="Segoe UI Variable Text" pitchFamily="34" charset="-120"/>
-              </a:rPr>
-              <a:t>des arnaques signalées avec la phrase</a:t>
-            </a:r>
-            <a:endParaRPr lang="en-US" sz="1300" dirty="0"/>
-          </a:p>
-        </p:txBody>
-      </p:sp>
-      <p:sp>
-        <p:nvSpPr>
-          <p:cNvPr id="19" name="Text 16"/>
-          <p:cNvSpPr txBox="1"/>
-          <p:nvPr/>
-        </p:nvSpPr>
-        <p:spPr>
-          <a:xfrm>
-            <a:off x="4846320" y="2359152"/>
-            <a:ext cx="1143000" cy="457200"/>
-          </a:xfrm>
-          <a:prstGeom prst="rect">
-            <a:avLst/>
-          </a:prstGeom>
-          <a:noFill/>
-          <a:ln/>
-        </p:spPr>
-        <p:txBody>
-          <a:bodyPr wrap="square" lIns="0" tIns="0" rIns="0" bIns="0" rtlCol="0" anchor="ctr"/>
-          <a:lstStyle/>
-          <a:p>
-            <a:pPr indent="0" marL="0">
-              <a:buNone/>
-            </a:pPr>
-            <a:r>
-              <a:rPr lang="en-US" sz="2600" dirty="0">
-                <a:solidFill>
-                  <a:srgbClr val="FFFFFF"/>
-                </a:solidFill>
-                <a:latin typeface="Segoe UI Variable Text Semibold" pitchFamily="34" charset="0"/>
-                <a:ea typeface="Segoe UI Variable Text Semibold" pitchFamily="34" charset="-122"/>
-                <a:cs typeface="Segoe UI Variable Text Semibold" pitchFamily="34" charset="-120"/>
-              </a:rPr>
-              <a:t>65 %</a:t>
-            </a:r>
-            <a:endParaRPr lang="en-US" sz="2600" dirty="0"/>
-          </a:p>
-        </p:txBody>
-      </p:sp>
-      <p:sp>
-        <p:nvSpPr>
-          <p:cNvPr id="20" name="Text 17"/>
-          <p:cNvSpPr txBox="1"/>
-          <p:nvPr/>
-        </p:nvSpPr>
-        <p:spPr>
-          <a:xfrm>
-            <a:off x="6035040" y="2359152"/>
-            <a:ext cx="2697480" cy="457200"/>
-          </a:xfrm>
-          <a:prstGeom prst="rect">
-            <a:avLst/>
-          </a:prstGeom>
-          <a:noFill/>
-          <a:ln/>
-        </p:spPr>
-        <p:txBody>
-          <a:bodyPr wrap="square" lIns="0" tIns="0" rIns="0" bIns="0" rtlCol="0" anchor="ctr"/>
-          <a:lstStyle/>
-          <a:p>
-            <a:pPr indent="0" marL="0">
-              <a:buNone/>
-            </a:pPr>
-            <a:r>
-              <a:rPr lang="en-US" sz="1300" dirty="0">
-                <a:solidFill>
-                  <a:srgbClr val="B3B3B3"/>
-                </a:solidFill>
-                <a:latin typeface="Segoe UI Variable Text" pitchFamily="34" charset="0"/>
-                <a:ea typeface="Segoe UI Variable Text" pitchFamily="34" charset="-122"/>
-                <a:cs typeface="Segoe UI Variable Text" pitchFamily="34" charset="-120"/>
-              </a:rPr>
-              <a:t>sans la phrase</a:t>
-            </a:r>
-            <a:endParaRPr lang="en-US" sz="1300" dirty="0"/>
-          </a:p>
-        </p:txBody>
-      </p:sp>
-      <p:sp>
-        <p:nvSpPr>
-          <p:cNvPr id="21" name="Text 18"/>
-          <p:cNvSpPr txBox="1"/>
-          <p:nvPr/>
-        </p:nvSpPr>
-        <p:spPr>
-          <a:xfrm>
-            <a:off x="4846320" y="2889504"/>
-            <a:ext cx="1143000" cy="457200"/>
-          </a:xfrm>
-          <a:prstGeom prst="rect">
-            <a:avLst/>
-          </a:prstGeom>
-          <a:noFill/>
-          <a:ln/>
-        </p:spPr>
-        <p:txBody>
-          <a:bodyPr wrap="square" lIns="0" tIns="0" rIns="0" bIns="0" rtlCol="0" anchor="ctr"/>
-          <a:lstStyle/>
-          <a:p>
-            <a:pPr indent="0" marL="0">
-              <a:buNone/>
-            </a:pPr>
-            <a:r>
-              <a:rPr lang="en-US" sz="2600" dirty="0">
-                <a:solidFill>
-                  <a:srgbClr val="FFFFFF"/>
-                </a:solidFill>
-                <a:latin typeface="Segoe UI Variable Text Semibold" pitchFamily="34" charset="0"/>
-                <a:ea typeface="Segoe UI Variable Text Semibold" pitchFamily="34" charset="-122"/>
-                <a:cs typeface="Segoe UI Variable Text Semibold" pitchFamily="34" charset="-120"/>
-              </a:rPr>
-              <a:t>15 %</a:t>
-            </a:r>
-            <a:endParaRPr lang="en-US" sz="2600" dirty="0"/>
-          </a:p>
-        </p:txBody>
-      </p:sp>
-      <p:sp>
-        <p:nvSpPr>
-          <p:cNvPr id="22" name="Text 19"/>
-          <p:cNvSpPr txBox="1"/>
-          <p:nvPr/>
-        </p:nvSpPr>
-        <p:spPr>
-          <a:xfrm>
-            <a:off x="6035040" y="2889504"/>
-            <a:ext cx="2697480" cy="457200"/>
-          </a:xfrm>
-          <a:prstGeom prst="rect">
-            <a:avLst/>
-          </a:prstGeom>
-          <a:noFill/>
-          <a:ln/>
-        </p:spPr>
-        <p:txBody>
-          <a:bodyPr wrap="square" lIns="0" tIns="0" rIns="0" bIns="0" rtlCol="0" anchor="ctr"/>
-          <a:lstStyle/>
-          <a:p>
-            <a:pPr indent="0" marL="0">
-              <a:buNone/>
-            </a:pPr>
-            <a:r>
-              <a:rPr lang="en-US" sz="1300" dirty="0">
-                <a:solidFill>
-                  <a:srgbClr val="B3B3B3"/>
-                </a:solidFill>
-                <a:latin typeface="Segoe UI Variable Text" pitchFamily="34" charset="0"/>
-                <a:ea typeface="Segoe UI Variable Text" pitchFamily="34" charset="-122"/>
-                <a:cs typeface="Segoe UI Variable Text" pitchFamily="34" charset="-120"/>
-              </a:rPr>
-              <a:t>d’opérations honnêtes arrêtées à tort (seuil fixé avant : 10 %)</a:t>
-            </a:r>
-            <a:endParaRPr lang="en-US" sz="1300" dirty="0"/>
-          </a:p>
-        </p:txBody>
-      </p:sp>
-      <p:sp>
-        <p:nvSpPr>
-          <p:cNvPr id="23" name="Text 20"/>
-          <p:cNvSpPr txBox="1"/>
-          <p:nvPr/>
-        </p:nvSpPr>
-        <p:spPr>
-          <a:xfrm>
-            <a:off x="457200" y="4041648"/>
-            <a:ext cx="8229600" cy="457200"/>
-          </a:xfrm>
-          <a:prstGeom prst="rect">
-            <a:avLst/>
-          </a:prstGeom>
-          <a:noFill/>
-          <a:ln/>
-        </p:spPr>
-        <p:txBody>
-          <a:bodyPr wrap="square" lIns="0" tIns="0" rIns="0" bIns="0" rtlCol="0" anchor="t"/>
-          <a:lstStyle/>
-          <a:p>
-            <a:pPr indent="0" marL="0">
-              <a:buNone/>
-            </a:pPr>
-            <a:r>
-              <a:rPr lang="en-US" sz="1200" dirty="0">
-                <a:solidFill>
-                  <a:srgbClr val="B3B3B3"/>
-                </a:solidFill>
-                <a:latin typeface="Segoe UI Variable Text" pitchFamily="34" charset="0"/>
-                <a:ea typeface="Segoe UI Variable Text" pitchFamily="34" charset="-122"/>
-                <a:cs typeface="Segoe UI Variable Text" pitchFamily="34" charset="-120"/>
-              </a:rPr>
-              <a:t>Extension mesurée sans modèle (mots-clés seuls), sur le build 6b9de2f d’avant le nouvel habillage, avec un fichier de décision modifié hors commit.</a:t>
-            </a:r>
-            <a:endParaRPr lang="en-US" sz="1200" dirty="0"/>
+              <a:t>Banc d’essai scellé, ouvert une seule fois. Extension sans modèle.</a:t>
+            </a:r>
+            <a:endParaRPr lang="en-US" sz="1400" dirty="0"/>
           </a:p>
         </p:txBody>
       </p:sp>
@@ -4000,7 +3337,7 @@
         <p:spPr>
           <a:xfrm>
             <a:off x="457200" y="1463040"/>
-            <a:ext cx="4937760" cy="1097280"/>
+            <a:ext cx="4937760" cy="822960"/>
           </a:xfrm>
           <a:prstGeom prst="rect">
             <a:avLst/>
@@ -4016,7 +3353,7 @@
               <a:buNone/>
             </a:pPr>
             <a:r>
-              <a:rPr lang="en-US" sz="1400" dirty="0">
+              <a:rPr lang="en-US" sz="1600" dirty="0">
                 <a:solidFill>
                   <a:srgbClr val="B3B3B3"/>
                 </a:solidFill>
@@ -4024,9 +3361,9 @@
                 <a:ea typeface="Segoe UI Variable Text" pitchFamily="34" charset="-122"/>
                 <a:cs typeface="Segoe UI Variable Text" pitchFamily="34" charset="-120"/>
               </a:rPr>
-              <a:t>Les 4 fois, elle avait lu « Ça ne correspond pas » et appuyé sur « Continuer » quand même. Jamais piégée sans ce geste. La testeuse est un agent qui joue une personne prudente, au clavier.</a:t>
-            </a:r>
-            <a:endParaRPr lang="en-US" sz="1400" dirty="0"/>
+              <a:t>Les 4 fois : « Continuer » malgré l’alerte. La testeuse est un agent qui joue une personne prudente.</a:t>
+            </a:r>
+            <a:endParaRPr lang="en-US" sz="1600" dirty="0"/>
           </a:p>
         </p:txBody>
       </p:sp>

</xml_diff>

<commit_message>
deck: 11:46 (business model slide, 8 slides)
Co-Authored-By: Claude Opus 5.5 <noreply@anthropic.com>
</commit_message>
<xml_diff>
--- a/livrables/deck/holdup.pptx
+++ b/livrables/deck/holdup.pptx
@@ -12,9 +12,10 @@
     <p:sldId id="260" r:id="rId6"/>
     <p:sldId id="261" r:id="rId7"/>
     <p:sldId id="262" r:id="rId8"/>
+    <p:sldId id="263" r:id="rId9"/>
   </p:sldIdLst>
   <p:notesMasterIdLst>
-    <p:notesMasterId r:id="rId9"/>
+    <p:notesMasterId r:id="rId10"/>
   </p:notesMasterIdLst>
   <p:sldSz cx="9144000" cy="5143500"/>
   <p:notesSz cx="5143500" cy="9144000"/>
@@ -1036,7 +1037,7 @@
           <a:p>
             <a:r>
               <a:rPr lang="en-US" dirty="0"/>
-              <a:t>Modèle : gratuit pour la personne. Paient ceux qui portent la perte : API « verdict avant retrait » pour exchanges et fintechs ; licence SDK pour portefeuilles ; mandats pour agents qui dépensent (prospectif, à 2 ans). Piste étudiée (BM_LABEL.md) : mesurer les plateformes qui ne demandent que le nécessaire ; la mesure est gratuite, publique, et ne s'achète pas. Ne pas dire « certification ». Prix : hypothèses, aucun client. Pilotes recherchés. Promesse de Titouan : cesser de donner plus que nécessaire. Fin d'Adem : on ne sait pas quel site sera piraté, on décide de ce qu'on lui laisse.</a:t>
+              <a:t>Modèle économique de Titouan (commit bf06f8b, repris dans README.md, PRODUCT.md, FICHE_DEFENSE.md, PITCH_5MIN.md, PITCH_3MIN.md, QR_JURY.md), à dire tel quel : « Gratuit pour les personnes. Plus tard, une plateforme qui demande l'autorisation exacte (50 USDC pour un échange de 50, pas tout, pour toujours) pourra afficher Vérifié par Hold up. C'est elle qui paie. Critères publics, mesurés sur ses vraies demandes, pas de classement payé. » Hypothèse à valider avec des pilotes : aucun client, aucun revenu aujourd'hui, jamais présentée comme un revenu existant. Ne pas dire « certification » (étude : research/titouan/BM2/BM_LABEL.md).</a:t>
             </a:r>
             <a:endParaRPr lang="en-US" dirty="0"/>
           </a:p>
@@ -1060,6 +1061,94 @@
             <a:fld id="{F7021451-1387-4CA6-816F-3879F97B5CBC}" type="slidenum">
               <a:rPr lang="en-US"/>
               <a:t>7</a:t>
+            </a:fld>
+            <a:endParaRPr lang="en-US"/>
+          </a:p>
+        </p:txBody>
+      </p:sp>
+    </p:spTree>
+    <p:extLst>
+      <p:ext uri="{BB962C8B-B14F-4D97-AF65-F5344CB8AC3E}">
+        <p14:creationId xmlns:p14="http://schemas.microsoft.com/office/powerpoint/2010/main" val="1024086991"/>
+      </p:ext>
+    </p:extLst>
+  </p:cSld>
+  <p:clrMapOvr>
+    <a:masterClrMapping/>
+  </p:clrMapOvr>
+</p:notes>
+</file>
+
+<file path=ppt/notesSlides/notesSlide8.xml><?xml version="1.0" encoding="utf-8"?>
+<p:notes xmlns:a="http://schemas.openxmlformats.org/drawingml/2006/main" xmlns:r="http://schemas.openxmlformats.org/officeDocument/2006/relationships" xmlns:p="http://schemas.openxmlformats.org/presentationml/2006/main">
+  <p:cSld>
+    <p:spTree>
+      <p:nvGrpSpPr>
+        <p:cNvPr id="1" name=""/>
+        <p:cNvGrpSpPr/>
+        <p:nvPr/>
+      </p:nvGrpSpPr>
+      <p:grpSpPr>
+        <a:xfrm>
+          <a:off x="0" y="0"/>
+          <a:ext cx="0" cy="0"/>
+          <a:chOff x="0" y="0"/>
+          <a:chExt cx="0" cy="0"/>
+        </a:xfrm>
+      </p:grpSpPr>
+      <p:sp>
+        <p:nvSpPr>
+          <p:cNvPr id="2" name="Slide Image Placeholder 1"/>
+          <p:cNvSpPr>
+            <a:spLocks noGrp="1" noRot="1" noChangeAspect="1"/>
+          </p:cNvSpPr>
+          <p:nvPr>
+            <p:ph type="sldImg"/>
+          </p:nvPr>
+        </p:nvSpPr>
+        <p:spPr/>
+      </p:sp>
+      <p:sp>
+        <p:nvSpPr>
+          <p:cNvPr id="3" name="Notes Placeholder 2"/>
+          <p:cNvSpPr>
+            <a:spLocks noGrp="1"/>
+          </p:cNvSpPr>
+          <p:nvPr>
+            <p:ph type="body" idx="1"/>
+          </p:nvPr>
+        </p:nvSpPr>
+        <p:spPr/>
+        <p:txBody>
+          <a:bodyPr/>
+          <a:lstStyle/>
+          <a:p>
+            <a:r>
+              <a:rPr lang="en-US" dirty="0"/>
+              <a:t>Modèle : gratuit pour la personne. Paient ceux qui portent la perte : API « verdict avant retrait » pour exchanges et fintechs ; licence SDK pour portefeuilles ; mandats pour agents qui dépensent (prospectif, à 2 ans). Piste étudiée (BM_LABEL.md) : mesurer les plateformes qui ne demandent que le nécessaire ; la mesure est gratuite, publique, et ne s'achète pas. Ne pas dire « certification ». Prix : hypothèses, aucun client. Pilotes recherchés. Promesse de Titouan : cesser de donner plus que nécessaire. Fin d'Adem : on ne sait pas quel site sera piraté, on décide de ce qu'on lui laisse.</a:t>
+            </a:r>
+            <a:endParaRPr lang="en-US" dirty="0"/>
+          </a:p>
+        </p:txBody>
+      </p:sp>
+      <p:sp>
+        <p:nvSpPr>
+          <p:cNvPr id="4" name="Slide Number Placeholder 3"/>
+          <p:cNvSpPr>
+            <a:spLocks noGrp="1"/>
+          </p:cNvSpPr>
+          <p:nvPr>
+            <p:ph type="sldNum" sz="quarter" idx="10"/>
+          </p:nvPr>
+        </p:nvSpPr>
+        <p:spPr/>
+        <p:txBody>
+          <a:bodyPr/>
+          <a:lstStyle/>
+          <a:p>
+            <a:fld id="{F7021451-1387-4CA6-816F-3879F97B5CBC}" type="slidenum">
+              <a:rPr lang="en-US"/>
+              <a:t>8</a:t>
             </a:fld>
             <a:endParaRPr lang="en-US"/>
           </a:p>
@@ -3612,6 +3701,45 @@
         </p:nvSpPr>
         <p:spPr>
           <a:xfrm>
+            <a:off x="457200" y="365760"/>
+            <a:ext cx="8229600" cy="548640"/>
+          </a:xfrm>
+          <a:prstGeom prst="rect">
+            <a:avLst/>
+          </a:prstGeom>
+          <a:noFill/>
+          <a:ln/>
+        </p:spPr>
+        <p:txBody>
+          <a:bodyPr wrap="square" lIns="0" tIns="0" rIns="0" bIns="0" rtlCol="0" anchor="t"/>
+          <a:lstStyle/>
+          <a:p>
+            <a:pPr indent="0" marL="0">
+              <a:buNone/>
+            </a:pPr>
+            <a:r>
+              <a:rPr lang="en-US" sz="2800" dirty="0">
+                <a:solidFill>
+                  <a:srgbClr val="FFFFFF"/>
+                </a:solidFill>
+                <a:latin typeface="Segoe UI Variable Text Semibold" pitchFamily="34" charset="0"/>
+                <a:ea typeface="Segoe UI Variable Text Semibold" pitchFamily="34" charset="-122"/>
+                <a:cs typeface="Segoe UI Variable Text Semibold" pitchFamily="34" charset="-120"/>
+              </a:rPr>
+              <a:t>Gratuit pour les personnes. La plateforme paie.</a:t>
+            </a:r>
+            <a:endParaRPr lang="en-US" sz="2800" dirty="0"/>
+          </a:p>
+        </p:txBody>
+      </p:sp>
+      <p:sp>
+        <p:nvSpPr>
+          <p:cNvPr id="3" name="Text 1"/>
+          <p:cNvSpPr txBox="1"/>
+          <p:nvPr/>
+        </p:nvSpPr>
+        <p:spPr>
+          <a:xfrm>
             <a:off x="457200" y="4663440"/>
             <a:ext cx="7680960" cy="228600"/>
           </a:xfrm>
@@ -3637,7 +3765,7 @@
                 <a:ea typeface="Segoe UI Variable Text" pitchFamily="34" charset="-122"/>
                 <a:cs typeface="Segoe UI Variable Text" pitchFamily="34" charset="-120"/>
               </a:rPr>
-              <a:t>Dans le dépôt : research/titouan/BM2/BM_MODELE.md, BM_LABEL.md</a:t>
+              <a:t>Dans le dépôt : README.md, livrables/PITCH_5MIN.md, research/titouan/BM2/BM_LABEL.md</a:t>
             </a:r>
             <a:endParaRPr lang="en-US" sz="1100" dirty="0"/>
           </a:p>
@@ -3645,30 +3773,30 @@
       </p:sp>
       <p:sp>
         <p:nvSpPr>
-          <p:cNvPr id="4" name="Text 1"/>
-          <p:cNvSpPr txBox="1"/>
-          <p:nvPr/>
-        </p:nvSpPr>
-        <p:spPr>
-          <a:xfrm>
-            <a:off x="457200" y="1737360"/>
-            <a:ext cx="8229600" cy="1463040"/>
-          </a:xfrm>
-          <a:prstGeom prst="rect">
-            <a:avLst/>
-          </a:prstGeom>
-          <a:noFill/>
-          <a:ln/>
-        </p:spPr>
-        <p:txBody>
-          <a:bodyPr wrap="square" lIns="0" tIns="0" rIns="0" bIns="0" rtlCol="0" anchor="t"/>
-          <a:lstStyle/>
-          <a:p>
-            <a:pPr indent="0" marL="0">
-              <a:buNone/>
-            </a:pPr>
-            <a:r>
-              <a:rPr lang="en-US" sz="4000" dirty="0">
+          <p:cNvPr id="5" name="Text 2"/>
+          <p:cNvSpPr txBox="1"/>
+          <p:nvPr/>
+        </p:nvSpPr>
+        <p:spPr>
+          <a:xfrm>
+            <a:off x="457200" y="1325880"/>
+            <a:ext cx="8229600" cy="1005840"/>
+          </a:xfrm>
+          <a:prstGeom prst="rect">
+            <a:avLst/>
+          </a:prstGeom>
+          <a:noFill/>
+          <a:ln/>
+        </p:spPr>
+        <p:txBody>
+          <a:bodyPr wrap="square" lIns="0" tIns="0" rIns="0" bIns="0" rtlCol="0" anchor="t"/>
+          <a:lstStyle/>
+          <a:p>
+            <a:pPr indent="0" marL="0">
+              <a:buNone/>
+            </a:pPr>
+            <a:r>
+              <a:rPr lang="en-US" sz="5400" dirty="0">
                 <a:solidFill>
                   <a:srgbClr val="FFFFFF"/>
                 </a:solidFill>
@@ -3676,26 +3804,126 @@
                 <a:ea typeface="Segoe UI Variable Text Semibold" pitchFamily="34" charset="-122"/>
                 <a:cs typeface="Segoe UI Variable Text Semibold" pitchFamily="34" charset="-120"/>
               </a:rPr>
-              <a:t>On ne sait pas quel site sera piraté.</a:t>
-            </a:r>
-            <a:endParaRPr lang="en-US" sz="4000" dirty="0"/>
-          </a:p>
-          <a:p>
-            <a:pPr indent="0" marL="0">
-              <a:buNone/>
-            </a:pPr>
-            <a:r>
-              <a:rPr lang="en-US" sz="4000" dirty="0">
+              <a:t>« Vérifié par Hold up »</a:t>
+            </a:r>
+            <a:endParaRPr lang="en-US" sz="5400" dirty="0"/>
+          </a:p>
+        </p:txBody>
+      </p:sp>
+      <p:sp>
+        <p:nvSpPr>
+          <p:cNvPr id="6" name="Text 3"/>
+          <p:cNvSpPr txBox="1"/>
+          <p:nvPr/>
+        </p:nvSpPr>
+        <p:spPr>
+          <a:xfrm>
+            <a:off x="457200" y="2606040"/>
+            <a:ext cx="7498080" cy="731520"/>
+          </a:xfrm>
+          <a:prstGeom prst="rect">
+            <a:avLst/>
+          </a:prstGeom>
+          <a:noFill/>
+          <a:ln/>
+        </p:spPr>
+        <p:txBody>
+          <a:bodyPr wrap="square" lIns="0" tIns="0" rIns="0" bIns="0" rtlCol="0" anchor="t"/>
+          <a:lstStyle/>
+          <a:p>
+            <a:pPr indent="0" marL="0">
+              <a:buNone/>
+            </a:pPr>
+            <a:r>
+              <a:rPr lang="en-US" sz="1800" dirty="0">
                 <a:solidFill>
                   <a:srgbClr val="FFFFFF"/>
                 </a:solidFill>
-                <a:latin typeface="Segoe UI Variable Text Semibold" pitchFamily="34" charset="0"/>
-                <a:ea typeface="Segoe UI Variable Text Semibold" pitchFamily="34" charset="-122"/>
-                <a:cs typeface="Segoe UI Variable Text Semibold" pitchFamily="34" charset="-120"/>
-              </a:rPr>
-              <a:t>On décide de ce qu'on lui laisse.</a:t>
-            </a:r>
-            <a:endParaRPr lang="en-US" sz="4000" dirty="0"/>
+                <a:latin typeface="Segoe UI Variable Text" pitchFamily="34" charset="0"/>
+                <a:ea typeface="Segoe UI Variable Text" pitchFamily="34" charset="-122"/>
+                <a:cs typeface="Segoe UI Variable Text" pitchFamily="34" charset="-120"/>
+              </a:rPr>
+              <a:t>Une plateforme qui demande l’autorisation exacte, 50 USDC pour un échange de 50, pourra l’afficher. C’est elle qui paie.</a:t>
+            </a:r>
+            <a:endParaRPr lang="en-US" sz="1800" dirty="0"/>
+          </a:p>
+        </p:txBody>
+      </p:sp>
+      <p:sp>
+        <p:nvSpPr>
+          <p:cNvPr id="7" name="Text 4"/>
+          <p:cNvSpPr txBox="1"/>
+          <p:nvPr/>
+        </p:nvSpPr>
+        <p:spPr>
+          <a:xfrm>
+            <a:off x="457200" y="3429000"/>
+            <a:ext cx="7498080" cy="365760"/>
+          </a:xfrm>
+          <a:prstGeom prst="rect">
+            <a:avLst/>
+          </a:prstGeom>
+          <a:noFill/>
+          <a:ln/>
+        </p:spPr>
+        <p:txBody>
+          <a:bodyPr wrap="square" lIns="0" tIns="0" rIns="0" bIns="0" rtlCol="0" anchor="t"/>
+          <a:lstStyle/>
+          <a:p>
+            <a:pPr indent="0" marL="0">
+              <a:buNone/>
+            </a:pPr>
+            <a:r>
+              <a:rPr lang="en-US" sz="1600" dirty="0">
+                <a:solidFill>
+                  <a:srgbClr val="B3B3B3"/>
+                </a:solidFill>
+                <a:latin typeface="Segoe UI Variable Text" pitchFamily="34" charset="0"/>
+                <a:ea typeface="Segoe UI Variable Text" pitchFamily="34" charset="-122"/>
+                <a:cs typeface="Segoe UI Variable Text" pitchFamily="34" charset="-120"/>
+              </a:rPr>
+              <a:t>Critères publics, mesurés sur ses vraies demandes. Pas de classement payé.</a:t>
+            </a:r>
+            <a:endParaRPr lang="en-US" sz="1600" dirty="0"/>
+          </a:p>
+        </p:txBody>
+      </p:sp>
+      <p:sp>
+        <p:nvSpPr>
+          <p:cNvPr id="8" name="Text 5"/>
+          <p:cNvSpPr txBox="1"/>
+          <p:nvPr/>
+        </p:nvSpPr>
+        <p:spPr>
+          <a:xfrm>
+            <a:off x="457200" y="3931920"/>
+            <a:ext cx="7498080" cy="365760"/>
+          </a:xfrm>
+          <a:prstGeom prst="rect">
+            <a:avLst/>
+          </a:prstGeom>
+          <a:noFill/>
+          <a:ln/>
+        </p:spPr>
+        <p:txBody>
+          <a:bodyPr wrap="square" lIns="0" tIns="0" rIns="0" bIns="0" rtlCol="0" anchor="t"/>
+          <a:lstStyle/>
+          <a:p>
+            <a:pPr indent="0" marL="0">
+              <a:buNone/>
+            </a:pPr>
+            <a:r>
+              <a:rPr lang="en-US" sz="1400" dirty="0">
+                <a:solidFill>
+                  <a:srgbClr val="B3B3B3"/>
+                </a:solidFill>
+                <a:latin typeface="Segoe UI Variable Text" pitchFamily="34" charset="0"/>
+                <a:ea typeface="Segoe UI Variable Text" pitchFamily="34" charset="-122"/>
+                <a:cs typeface="Segoe UI Variable Text" pitchFamily="34" charset="-120"/>
+              </a:rPr>
+              <a:t>Hypothèse à valider avec des pilotes. Aucun revenu aujourd’hui.</a:t>
+            </a:r>
+            <a:endParaRPr lang="en-US" sz="1400" dirty="0"/>
           </a:p>
         </p:txBody>
       </p:sp>
@@ -3742,6 +3970,174 @@
             <a:fld id="{F7021451-1387-4CA6-816F-3879F97B5CBC}" type="slidenum">
               <a:rPr b="0" lang="en-US"/>
               <a:t>7</a:t>
+            </a:fld>
+            <a:endParaRPr lang="en-US"/>
+          </a:p>
+        </p:txBody>
+      </p:sp>
+    </p:spTree>
+  </p:cSld>
+  <p:clrMapOvr>
+    <a:masterClrMapping/>
+  </p:clrMapOvr>
+</p:sld>
+</file>
+
+<file path=ppt/slides/slide8.xml><?xml version="1.0" encoding="utf-8"?>
+<p:sld xmlns:a="http://schemas.openxmlformats.org/drawingml/2006/main" xmlns:r="http://schemas.openxmlformats.org/officeDocument/2006/relationships" xmlns:p="http://schemas.openxmlformats.org/presentationml/2006/main">
+  <p:cSld name="Slide 8">
+    <p:spTree>
+      <p:nvGrpSpPr>
+        <p:cNvPr id="1" name=""/>
+        <p:cNvGrpSpPr/>
+        <p:nvPr/>
+      </p:nvGrpSpPr>
+      <p:grpSpPr>
+        <a:xfrm>
+          <a:off x="0" y="0"/>
+          <a:ext cx="0" cy="0"/>
+          <a:chOff x="0" y="0"/>
+          <a:chExt cx="0" cy="0"/>
+        </a:xfrm>
+      </p:grpSpPr>
+      <p:sp>
+        <p:nvSpPr>
+          <p:cNvPr id="2" name="Text 0"/>
+          <p:cNvSpPr txBox="1"/>
+          <p:nvPr/>
+        </p:nvSpPr>
+        <p:spPr>
+          <a:xfrm>
+            <a:off x="457200" y="4663440"/>
+            <a:ext cx="7680960" cy="228600"/>
+          </a:xfrm>
+          <a:prstGeom prst="rect">
+            <a:avLst/>
+          </a:prstGeom>
+          <a:noFill/>
+          <a:ln/>
+        </p:spPr>
+        <p:txBody>
+          <a:bodyPr wrap="square" lIns="0" tIns="0" rIns="0" bIns="0" rtlCol="0" anchor="t"/>
+          <a:lstStyle/>
+          <a:p>
+            <a:pPr indent="0" marL="0">
+              <a:buNone/>
+            </a:pPr>
+            <a:r>
+              <a:rPr lang="en-US" sz="1100" dirty="0">
+                <a:solidFill>
+                  <a:srgbClr val="B3B3B3"/>
+                </a:solidFill>
+                <a:latin typeface="Segoe UI Variable Text" pitchFamily="34" charset="0"/>
+                <a:ea typeface="Segoe UI Variable Text" pitchFamily="34" charset="-122"/>
+                <a:cs typeface="Segoe UI Variable Text" pitchFamily="34" charset="-120"/>
+              </a:rPr>
+              <a:t>Dans le dépôt : research/titouan/BM2/BM_MODELE.md, BM_LABEL.md</a:t>
+            </a:r>
+            <a:endParaRPr lang="en-US" sz="1100" dirty="0"/>
+          </a:p>
+        </p:txBody>
+      </p:sp>
+      <p:sp>
+        <p:nvSpPr>
+          <p:cNvPr id="4" name="Text 1"/>
+          <p:cNvSpPr txBox="1"/>
+          <p:nvPr/>
+        </p:nvSpPr>
+        <p:spPr>
+          <a:xfrm>
+            <a:off x="457200" y="1737360"/>
+            <a:ext cx="8229600" cy="1463040"/>
+          </a:xfrm>
+          <a:prstGeom prst="rect">
+            <a:avLst/>
+          </a:prstGeom>
+          <a:noFill/>
+          <a:ln/>
+        </p:spPr>
+        <p:txBody>
+          <a:bodyPr wrap="square" lIns="0" tIns="0" rIns="0" bIns="0" rtlCol="0" anchor="t"/>
+          <a:lstStyle/>
+          <a:p>
+            <a:pPr indent="0" marL="0">
+              <a:buNone/>
+            </a:pPr>
+            <a:r>
+              <a:rPr lang="en-US" sz="4000" dirty="0">
+                <a:solidFill>
+                  <a:srgbClr val="FFFFFF"/>
+                </a:solidFill>
+                <a:latin typeface="Segoe UI Variable Text Semibold" pitchFamily="34" charset="0"/>
+                <a:ea typeface="Segoe UI Variable Text Semibold" pitchFamily="34" charset="-122"/>
+                <a:cs typeface="Segoe UI Variable Text Semibold" pitchFamily="34" charset="-120"/>
+              </a:rPr>
+              <a:t>On ne sait pas quel site sera piraté.</a:t>
+            </a:r>
+            <a:endParaRPr lang="en-US" sz="4000" dirty="0"/>
+          </a:p>
+          <a:p>
+            <a:pPr indent="0" marL="0">
+              <a:buNone/>
+            </a:pPr>
+            <a:r>
+              <a:rPr lang="en-US" sz="4000" dirty="0">
+                <a:solidFill>
+                  <a:srgbClr val="FFFFFF"/>
+                </a:solidFill>
+                <a:latin typeface="Segoe UI Variable Text Semibold" pitchFamily="34" charset="0"/>
+                <a:ea typeface="Segoe UI Variable Text Semibold" pitchFamily="34" charset="-122"/>
+                <a:cs typeface="Segoe UI Variable Text Semibold" pitchFamily="34" charset="-120"/>
+              </a:rPr>
+              <a:t>On décide de ce qu'on lui laisse.</a:t>
+            </a:r>
+            <a:endParaRPr lang="en-US" sz="4000" dirty="0"/>
+          </a:p>
+        </p:txBody>
+      </p:sp>
+      <p:sp>
+        <p:nvSpPr>
+          <p:cNvPr id="25" name="Slide Number Placeholder 0"/>
+          <p:cNvSpPr>
+            <a:spLocks noGrp="1"/>
+          </p:cNvSpPr>
+          <p:nvPr>
+            <p:ph type="sldNum" sz="quarter" idx="4294967295"/>
+          </p:nvPr>
+        </p:nvSpPr>
+        <p:spPr>
+          <a:xfrm>
+            <a:off x="8229600" y="4681728"/>
+            <a:ext cx="457200" cy="228600"/>
+          </a:xfrm>
+          <a:prstGeom prst="rect">
+            <a:avLst/>
+          </a:prstGeom>
+          <a:extLst>
+            <a:ext uri="{C572A759-6A51-4108-AA02-DFA0A04FC94B}">
+              <ma14:wrappingTextBoxFlag xmlns:ma14="http://schemas.microsoft.com/office/mac/drawingml/2011/main" val="0"/>
+            </a:ext>
+          </a:extLst>
+        </p:spPr>
+        <p:txBody>
+          <a:bodyPr/>
+          <a:lstStyle>
+            <a:lvl1pPr>
+              <a:defRPr sz="1000">
+                <a:solidFill>
+                  <a:srgbClr val="808080"/>
+                </a:solidFill>
+                <a:latin typeface="Segoe UI Variable Text"/>
+                <a:ea typeface="Segoe UI Variable Text"/>
+                <a:cs typeface="Segoe UI Variable Text"/>
+              </a:defRPr>
+            </a:lvl1pPr>
+          </a:lstStyle>
+          <a:p>
+            <a:pPr algn="r"/>
+            <a:fld id="{F7021451-1387-4CA6-816F-3879F97B5CBC}" type="slidenum">
+              <a:rPr b="0" lang="en-US"/>
+              <a:t>8</a:t>
             </a:fld>
             <a:endParaRPr lang="en-US"/>
           </a:p>

</xml_diff>

<commit_message>
deck: 11:48 (slide 7 rewritten, 8 slides)
Co-Authored-By: Claude Opus 5.5 <noreply@anthropic.com>
</commit_message>
<xml_diff>
--- a/livrables/deck/holdup.pptx
+++ b/livrables/deck/holdup.pptx
@@ -3726,7 +3726,7 @@
                 <a:ea typeface="Segoe UI Variable Text Semibold" pitchFamily="34" charset="-122"/>
                 <a:cs typeface="Segoe UI Variable Text Semibold" pitchFamily="34" charset="-120"/>
               </a:rPr>
-              <a:t>Gratuit pour les personnes. La plateforme paie.</a:t>
+              <a:t>Qui paie ?</a:t>
             </a:r>
             <a:endParaRPr lang="en-US" sz="2800" dirty="0"/>
           </a:p>
@@ -3779,24 +3779,63 @@
         </p:nvSpPr>
         <p:spPr>
           <a:xfrm>
-            <a:off x="457200" y="1325880"/>
-            <a:ext cx="8229600" cy="1005840"/>
-          </a:xfrm>
-          <a:prstGeom prst="rect">
-            <a:avLst/>
-          </a:prstGeom>
-          <a:noFill/>
-          <a:ln/>
-        </p:spPr>
-        <p:txBody>
-          <a:bodyPr wrap="square" lIns="0" tIns="0" rIns="0" bIns="0" rtlCol="0" anchor="t"/>
-          <a:lstStyle/>
-          <a:p>
-            <a:pPr indent="0" marL="0">
-              <a:buNone/>
-            </a:pPr>
-            <a:r>
-              <a:rPr lang="en-US" sz="5400" dirty="0">
+            <a:off x="457200" y="1280160"/>
+            <a:ext cx="3840480" cy="365760"/>
+          </a:xfrm>
+          <a:prstGeom prst="rect">
+            <a:avLst/>
+          </a:prstGeom>
+          <a:noFill/>
+          <a:ln/>
+        </p:spPr>
+        <p:txBody>
+          <a:bodyPr wrap="square" lIns="0" tIns="0" rIns="0" bIns="0" rtlCol="0" anchor="t"/>
+          <a:lstStyle/>
+          <a:p>
+            <a:pPr indent="0" marL="0">
+              <a:buNone/>
+            </a:pPr>
+            <a:r>
+              <a:rPr lang="en-US" sz="1600" dirty="0">
+                <a:solidFill>
+                  <a:srgbClr val="B3B3B3"/>
+                </a:solidFill>
+                <a:latin typeface="Segoe UI Variable Text" pitchFamily="34" charset="0"/>
+                <a:ea typeface="Segoe UI Variable Text" pitchFamily="34" charset="-122"/>
+                <a:cs typeface="Segoe UI Variable Text" pitchFamily="34" charset="-120"/>
+              </a:rPr>
+              <a:t>Pour toi</a:t>
+            </a:r>
+            <a:endParaRPr lang="en-US" sz="1600" dirty="0"/>
+          </a:p>
+        </p:txBody>
+      </p:sp>
+      <p:sp>
+        <p:nvSpPr>
+          <p:cNvPr id="6" name="Text 3"/>
+          <p:cNvSpPr txBox="1"/>
+          <p:nvPr/>
+        </p:nvSpPr>
+        <p:spPr>
+          <a:xfrm>
+            <a:off x="457200" y="1645920"/>
+            <a:ext cx="3931920" cy="1097280"/>
+          </a:xfrm>
+          <a:prstGeom prst="rect">
+            <a:avLst/>
+          </a:prstGeom>
+          <a:noFill/>
+          <a:ln/>
+        </p:spPr>
+        <p:txBody>
+          <a:bodyPr wrap="square" lIns="0" tIns="0" rIns="0" bIns="0" rtlCol="0" anchor="t"/>
+          <a:lstStyle/>
+          <a:p>
+            <a:pPr indent="0" marL="0">
+              <a:buNone/>
+            </a:pPr>
+            <a:r>
+              <a:rPr lang="en-US" sz="6600" dirty="0">
                 <a:solidFill>
                   <a:srgbClr val="FFFFFF"/>
                 </a:solidFill>
@@ -3804,61 +3843,61 @@
                 <a:ea typeface="Segoe UI Variable Text Semibold" pitchFamily="34" charset="-122"/>
                 <a:cs typeface="Segoe UI Variable Text Semibold" pitchFamily="34" charset="-120"/>
               </a:rPr>
-              <a:t>« Vérifié par Hold up »</a:t>
-            </a:r>
-            <a:endParaRPr lang="en-US" sz="5400" dirty="0"/>
-          </a:p>
-        </p:txBody>
-      </p:sp>
-      <p:sp>
-        <p:nvSpPr>
-          <p:cNvPr id="6" name="Text 3"/>
-          <p:cNvSpPr txBox="1"/>
-          <p:nvPr/>
-        </p:nvSpPr>
-        <p:spPr>
-          <a:xfrm>
-            <a:off x="457200" y="2606040"/>
-            <a:ext cx="7498080" cy="731520"/>
-          </a:xfrm>
-          <a:prstGeom prst="rect">
-            <a:avLst/>
-          </a:prstGeom>
-          <a:noFill/>
-          <a:ln/>
-        </p:spPr>
-        <p:txBody>
-          <a:bodyPr wrap="square" lIns="0" tIns="0" rIns="0" bIns="0" rtlCol="0" anchor="t"/>
-          <a:lstStyle/>
-          <a:p>
-            <a:pPr indent="0" marL="0">
-              <a:buNone/>
-            </a:pPr>
-            <a:r>
-              <a:rPr lang="en-US" sz="1800" dirty="0">
-                <a:solidFill>
-                  <a:srgbClr val="FFFFFF"/>
+              <a:t>gratuit</a:t>
+            </a:r>
+            <a:endParaRPr lang="en-US" sz="6600" dirty="0"/>
+          </a:p>
+        </p:txBody>
+      </p:sp>
+      <p:sp>
+        <p:nvSpPr>
+          <p:cNvPr id="7" name="Text 4"/>
+          <p:cNvSpPr txBox="1"/>
+          <p:nvPr/>
+        </p:nvSpPr>
+        <p:spPr>
+          <a:xfrm>
+            <a:off x="457200" y="2880360"/>
+            <a:ext cx="3657600" cy="731520"/>
+          </a:xfrm>
+          <a:prstGeom prst="rect">
+            <a:avLst/>
+          </a:prstGeom>
+          <a:noFill/>
+          <a:ln/>
+        </p:spPr>
+        <p:txBody>
+          <a:bodyPr wrap="square" lIns="0" tIns="0" rIns="0" bIns="0" rtlCol="0" anchor="t"/>
+          <a:lstStyle/>
+          <a:p>
+            <a:pPr indent="0" marL="0">
+              <a:buNone/>
+            </a:pPr>
+            <a:r>
+              <a:rPr lang="en-US" sz="1600" dirty="0">
+                <a:solidFill>
+                  <a:srgbClr val="B3B3B3"/>
                 </a:solidFill>
                 <a:latin typeface="Segoe UI Variable Text" pitchFamily="34" charset="0"/>
                 <a:ea typeface="Segoe UI Variable Text" pitchFamily="34" charset="-122"/>
                 <a:cs typeface="Segoe UI Variable Text" pitchFamily="34" charset="-120"/>
               </a:rPr>
-              <a:t>Une plateforme qui demande l’autorisation exacte, 50 USDC pour un échange de 50, pourra l’afficher. C’est elle qui paie.</a:t>
-            </a:r>
-            <a:endParaRPr lang="en-US" sz="1800" dirty="0"/>
-          </a:p>
-        </p:txBody>
-      </p:sp>
-      <p:sp>
-        <p:nvSpPr>
-          <p:cNvPr id="7" name="Text 4"/>
-          <p:cNvSpPr txBox="1"/>
-          <p:nvPr/>
-        </p:nvSpPr>
-        <p:spPr>
-          <a:xfrm>
-            <a:off x="457200" y="3429000"/>
-            <a:ext cx="7498080" cy="365760"/>
+              <a:t>L’extension ne coûte rien aux personnes.</a:t>
+            </a:r>
+            <a:endParaRPr lang="en-US" sz="1600" dirty="0"/>
+          </a:p>
+        </p:txBody>
+      </p:sp>
+      <p:sp>
+        <p:nvSpPr>
+          <p:cNvPr id="8" name="Text 5"/>
+          <p:cNvSpPr txBox="1"/>
+          <p:nvPr/>
+        </p:nvSpPr>
+        <p:spPr>
+          <a:xfrm>
+            <a:off x="4846320" y="1280160"/>
+            <a:ext cx="3840480" cy="365760"/>
           </a:xfrm>
           <a:prstGeom prst="rect">
             <a:avLst/>
@@ -3882,7 +3921,7 @@
                 <a:ea typeface="Segoe UI Variable Text" pitchFamily="34" charset="-122"/>
                 <a:cs typeface="Segoe UI Variable Text" pitchFamily="34" charset="-120"/>
               </a:rPr>
-              <a:t>Critères publics, mesurés sur ses vraies demandes. Pas de classement payé.</a:t>
+              <a:t>Pour les sites</a:t>
             </a:r>
             <a:endParaRPr lang="en-US" sz="1600" dirty="0"/>
           </a:p>
@@ -3890,30 +3929,69 @@
       </p:sp>
       <p:sp>
         <p:nvSpPr>
-          <p:cNvPr id="8" name="Text 5"/>
-          <p:cNvSpPr txBox="1"/>
-          <p:nvPr/>
-        </p:nvSpPr>
-        <p:spPr>
-          <a:xfrm>
-            <a:off x="457200" y="3931920"/>
-            <a:ext cx="7498080" cy="365760"/>
-          </a:xfrm>
-          <a:prstGeom prst="rect">
-            <a:avLst/>
-          </a:prstGeom>
-          <a:noFill/>
-          <a:ln/>
-        </p:spPr>
-        <p:txBody>
-          <a:bodyPr wrap="square" lIns="0" tIns="0" rIns="0" bIns="0" rtlCol="0" anchor="t"/>
-          <a:lstStyle/>
-          <a:p>
-            <a:pPr indent="0" marL="0">
-              <a:buNone/>
-            </a:pPr>
-            <a:r>
-              <a:rPr lang="en-US" sz="1400" dirty="0">
+          <p:cNvPr id="9" name="Text 6"/>
+          <p:cNvSpPr txBox="1"/>
+          <p:nvPr/>
+        </p:nvSpPr>
+        <p:spPr>
+          <a:xfrm>
+            <a:off x="4846320" y="1645920"/>
+            <a:ext cx="3931920" cy="1097280"/>
+          </a:xfrm>
+          <a:prstGeom prst="rect">
+            <a:avLst/>
+          </a:prstGeom>
+          <a:noFill/>
+          <a:ln/>
+        </p:spPr>
+        <p:txBody>
+          <a:bodyPr wrap="square" lIns="0" tIns="0" rIns="0" bIns="0" rtlCol="0" anchor="t"/>
+          <a:lstStyle/>
+          <a:p>
+            <a:pPr indent="0" marL="0">
+              <a:buNone/>
+            </a:pPr>
+            <a:r>
+              <a:rPr lang="en-US" sz="6600" dirty="0">
+                <a:solidFill>
+                  <a:srgbClr val="FFFFFF"/>
+                </a:solidFill>
+                <a:latin typeface="Segoe UI Variable Text Semibold" pitchFamily="34" charset="0"/>
+                <a:ea typeface="Segoe UI Variable Text Semibold" pitchFamily="34" charset="-122"/>
+                <a:cs typeface="Segoe UI Variable Text Semibold" pitchFamily="34" charset="-120"/>
+              </a:rPr>
+              <a:t>payant</a:t>
+            </a:r>
+            <a:endParaRPr lang="en-US" sz="6600" dirty="0"/>
+          </a:p>
+        </p:txBody>
+      </p:sp>
+      <p:sp>
+        <p:nvSpPr>
+          <p:cNvPr id="10" name="Text 7"/>
+          <p:cNvSpPr txBox="1"/>
+          <p:nvPr/>
+        </p:nvSpPr>
+        <p:spPr>
+          <a:xfrm>
+            <a:off x="4846320" y="2880360"/>
+            <a:ext cx="3840480" cy="914400"/>
+          </a:xfrm>
+          <a:prstGeom prst="rect">
+            <a:avLst/>
+          </a:prstGeom>
+          <a:noFill/>
+          <a:ln/>
+        </p:spPr>
+        <p:txBody>
+          <a:bodyPr wrap="square" lIns="0" tIns="0" rIns="0" bIns="0" rtlCol="0" anchor="t"/>
+          <a:lstStyle/>
+          <a:p>
+            <a:pPr indent="0" marL="0">
+              <a:buNone/>
+            </a:pPr>
+            <a:r>
+              <a:rPr lang="en-US" sz="1600" dirty="0">
                 <a:solidFill>
                   <a:srgbClr val="B3B3B3"/>
                 </a:solidFill>
@@ -3921,7 +3999,46 @@
                 <a:ea typeface="Segoe UI Variable Text" pitchFamily="34" charset="-122"/>
                 <a:cs typeface="Segoe UI Variable Text" pitchFamily="34" charset="-120"/>
               </a:rPr>
-              <a:t>Hypothèse à valider avec des pilotes. Aucun revenu aujourd’hui.</a:t>
+              <a:t>Un site qui ne te demande que le nécessaire peut afficher « Vérifié par Hold up ». Il paie pour l’afficher.</a:t>
+            </a:r>
+            <a:endParaRPr lang="en-US" sz="1600" dirty="0"/>
+          </a:p>
+        </p:txBody>
+      </p:sp>
+      <p:sp>
+        <p:nvSpPr>
+          <p:cNvPr id="11" name="Text 8"/>
+          <p:cNvSpPr txBox="1"/>
+          <p:nvPr/>
+        </p:nvSpPr>
+        <p:spPr>
+          <a:xfrm>
+            <a:off x="457200" y="4023360"/>
+            <a:ext cx="8229600" cy="365760"/>
+          </a:xfrm>
+          <a:prstGeom prst="rect">
+            <a:avLst/>
+          </a:prstGeom>
+          <a:noFill/>
+          <a:ln/>
+        </p:spPr>
+        <p:txBody>
+          <a:bodyPr wrap="square" lIns="0" tIns="0" rIns="0" bIns="0" rtlCol="0" anchor="t"/>
+          <a:lstStyle/>
+          <a:p>
+            <a:pPr indent="0" marL="0">
+              <a:buNone/>
+            </a:pPr>
+            <a:r>
+              <a:rPr lang="en-US" sz="1400" dirty="0">
+                <a:solidFill>
+                  <a:srgbClr val="B3B3B3"/>
+                </a:solidFill>
+                <a:latin typeface="Segoe UI Variable Text" pitchFamily="34" charset="0"/>
+                <a:ea typeface="Segoe UI Variable Text" pitchFamily="34" charset="-122"/>
+                <a:cs typeface="Segoe UI Variable Text" pitchFamily="34" charset="-120"/>
+              </a:rPr>
+              <a:t>Les critères sont publics, le label ne s’achète pas. Aucun client aujourd’hui.</a:t>
             </a:r>
             <a:endParaRPr lang="en-US" sz="1400" dirty="0"/>
           </a:p>

</xml_diff>